<commit_message>
Strengthen mission planning, verification and submission evidence
</commit_message>
<xml_diff>
--- a/submission_bundle/defense-deck.pptx
+++ b/submission_bundle/defense-deck.pptx
@@ -2,22 +2,22 @@
 <file path=ppt/presentation.xml><?xml version="1.0" encoding="utf-8"?>
 <p:presentation xmlns:p="http://schemas.openxmlformats.org/presentationml/2006/main">
   <p:sldMasterIdLst>
-    <p:sldMasterId xmlns:r="http://schemas.openxmlformats.org/officeDocument/2006/relationships" id="2147483648" r:id="R68dde7be5c7849f6"/>
+    <p:sldMasterId xmlns:r="http://schemas.openxmlformats.org/officeDocument/2006/relationships" id="2147483648" r:id="R77427032311f4c4b"/>
   </p:sldMasterIdLst>
   <p:notesMasterIdLst>
-    <p:notesMasterId xmlns:r="http://schemas.openxmlformats.org/officeDocument/2006/relationships" r:id="R563a810166564274"/>
+    <p:notesMasterId xmlns:r="http://schemas.openxmlformats.org/officeDocument/2006/relationships" r:id="R20320de9f43b4cbb"/>
   </p:notesMasterIdLst>
   <p:sldIdLst>
-    <p:sldId xmlns:r="http://schemas.openxmlformats.org/officeDocument/2006/relationships" id="256" r:id="Rbf9ff73b7e9f48e5"/>
-    <p:sldId xmlns:r="http://schemas.openxmlformats.org/officeDocument/2006/relationships" id="257" r:id="R48bedaf6beb34dc5"/>
-    <p:sldId xmlns:r="http://schemas.openxmlformats.org/officeDocument/2006/relationships" id="258" r:id="R343364d7b77a4d06"/>
-    <p:sldId xmlns:r="http://schemas.openxmlformats.org/officeDocument/2006/relationships" id="259" r:id="R5bf6de7d4f7f4e21"/>
-    <p:sldId xmlns:r="http://schemas.openxmlformats.org/officeDocument/2006/relationships" id="260" r:id="R7a2d102ffa6f45fe"/>
-    <p:sldId xmlns:r="http://schemas.openxmlformats.org/officeDocument/2006/relationships" id="261" r:id="R0aec0aa841fa47c9"/>
-    <p:sldId xmlns:r="http://schemas.openxmlformats.org/officeDocument/2006/relationships" id="262" r:id="R6e9e2a5b22434f34"/>
-    <p:sldId xmlns:r="http://schemas.openxmlformats.org/officeDocument/2006/relationships" id="263" r:id="R6aa87e8cce494292"/>
-    <p:sldId xmlns:r="http://schemas.openxmlformats.org/officeDocument/2006/relationships" id="264" r:id="R82da38f329184792"/>
-    <p:sldId xmlns:r="http://schemas.openxmlformats.org/officeDocument/2006/relationships" id="265" r:id="R159137bc250b4071"/>
+    <p:sldId xmlns:r="http://schemas.openxmlformats.org/officeDocument/2006/relationships" id="256" r:id="R877a5d82a8864676"/>
+    <p:sldId xmlns:r="http://schemas.openxmlformats.org/officeDocument/2006/relationships" id="257" r:id="Rddf908602d874026"/>
+    <p:sldId xmlns:r="http://schemas.openxmlformats.org/officeDocument/2006/relationships" id="258" r:id="R33a7f9aa12694932"/>
+    <p:sldId xmlns:r="http://schemas.openxmlformats.org/officeDocument/2006/relationships" id="259" r:id="R48e19c2df5e848e1"/>
+    <p:sldId xmlns:r="http://schemas.openxmlformats.org/officeDocument/2006/relationships" id="260" r:id="R33cc33b765364dab"/>
+    <p:sldId xmlns:r="http://schemas.openxmlformats.org/officeDocument/2006/relationships" id="261" r:id="R5bd13bff735d4d20"/>
+    <p:sldId xmlns:r="http://schemas.openxmlformats.org/officeDocument/2006/relationships" id="262" r:id="Rf85ff33496cb48b5"/>
+    <p:sldId xmlns:r="http://schemas.openxmlformats.org/officeDocument/2006/relationships" id="263" r:id="Rc094c0a1153d4dbe"/>
+    <p:sldId xmlns:r="http://schemas.openxmlformats.org/officeDocument/2006/relationships" id="264" r:id="Rad9aa8f479f440f0"/>
+    <p:sldId xmlns:r="http://schemas.openxmlformats.org/officeDocument/2006/relationships" id="265" r:id="R37909d6d8b6a41fb"/>
   </p:sldIdLst>
   <p:sldSz cx="12192000" cy="6858000"/>
   <p:notesSz cx="6858000" cy="9144000"/>
@@ -521,7 +521,7 @@
           <a:lstStyle xmlns:a="http://schemas.openxmlformats.org/drawingml/2006/main"/>
           <a:p xmlns:a="http://schemas.openxmlformats.org/drawingml/2006/main">
             <a:r>
-              <a:t>8:45–10:00. Open the verified Run A log for EPS seed zero: no append, reward one, seven replies, 29.31 harness seconds. During live demo start Compose and continue speaking while the model runs. Show gates, one tool result, live state and final verifier checks, without showing .env. Be explicit about simplified physics, guided introductory tasks, finite exploit tests and one tested deployment. The public repository remains an administrative exception to the private-repository PS instruction. Confirm exact team-name case, organizer access, deadline and form upload before claiming full compliance. Sources include docs/ps-checklist.md and the original PS.</a:t>
+              <a:t>8:45–10:00. Use Run A unappended EPS seed zero as the named realistic demo. Open source-matched logs if network fails. Show gates, one action, state hash and final checks without showing .env. Defend why planning is necessary using science dutybounds and data conservation. Explain scalar physics and trusted host boundary. Public repository is user requested but conflicts with the private PS rule. Exact name case, organizer access, deadline and form submission remain administrative items. No claim of an actual judge score or exhaustive robustness.</a:t>
             </a:r>
           </a:p>
           <a:p xmlns:a="http://schemas.openxmlformats.org/drawingml/2006/main">
@@ -531,7 +531,7 @@
           </a:p>
           <a:p xmlns:a="http://schemas.openxmlformats.org/drawingml/2006/main">
             <a:r>
-              <a:t>Sources: submission_bundle/validation-evidence.json, docs/model-assumptions.md and the supplied RL_Hackathon_by_2une_PS.pdf. Runtime fingerprint 9e2d94e2c2473ccc962847d23febc20536546690e6875a3d40c807b83bf755b2.</a:t>
+              <a:t>Sources: submission_bundle/validation-evidence.json, docs/model-assumptions.md and the supplied RL_Hackathon_by_2une_PS.pdf. Runtime fingerprint b75030d6ecd33e8f80f5cdda39f2690a2a31688faad3f17d928f27c108e5507b.</a:t>
             </a:r>
           </a:p>
         </p:txBody>
@@ -601,7 +601,7 @@
           <a:lstStyle xmlns:a="http://schemas.openxmlformats.org/drawingml/2006/main"/>
           <a:p xmlns:a="http://schemas.openxmlformats.org/drawingml/2006/main">
             <a:r>
-              <a:t>0:35–1:25. Explain the transition from files and telemetry through tools to protected physical state. Ordinary successful tool calls cost 30 simulated seconds. step_orbit advances 1–30 minutes. Final scoring projects the remaining mission with the current configuration. Distinguish simulated time from the 600-second real execution budget.</a:t>
+              <a:t>0:35–1:25. Explain the transition from files and telemetry through tools to protected physical state. Completed ordinary tool attempts, including tool errors, cost 30 simulated seconds. Schema-rejected calls do not execute or advance time. step_orbit advances 1–30 minutes. Final scoring projects the remaining mission with the current configuration. Distinguish simulated time from the 600-second real execution budget.</a:t>
             </a:r>
           </a:p>
           <a:p xmlns:a="http://schemas.openxmlformats.org/drawingml/2006/main">
@@ -611,7 +611,7 @@
           </a:p>
           <a:p xmlns:a="http://schemas.openxmlformats.org/drawingml/2006/main">
             <a:r>
-              <a:t>Sources: submission_bundle/validation-evidence.json, docs/model-assumptions.md and the supplied RL_Hackathon_by_2une_PS.pdf. Runtime fingerprint 9e2d94e2c2473ccc962847d23febc20536546690e6875a3d40c807b83bf755b2.</a:t>
+              <a:t>Sources: submission_bundle/validation-evidence.json, docs/model-assumptions.md and the supplied RL_Hackathon_by_2une_PS.pdf. Runtime fingerprint b75030d6ecd33e8f80f5cdda39f2690a2a31688faad3f17d928f27c108e5507b.</a:t>
             </a:r>
           </a:p>
         </p:txBody>
@@ -681,7 +681,7 @@
           <a:lstStyle xmlns:a="http://schemas.openxmlformats.org/drawingml/2006/main"/>
           <a:p xmlns:a="http://schemas.openxmlformats.org/drawingml/2006/main">
             <a:r>
-              <a:t>1:25–2:20. Be candid about the first five guided recovery tasks. Radio planning couples throughput, margin and energy. Early-pass recovery imposes a lost-contact deadline. Observation scheduling requires changing duty over time. Fixed nominal settings do not solve the three hard tasks in the measured policy comparison.</a:t>
+              <a:t>1:25–2:20. The first five tasks teach diagnosis and repair. Four hard tasks add interacting constraints: radio energy, an irreversible early contact, one observation window, and two-window science with finite storage. Seeds vary hardware, faults and timing. Sources: harness/tasks.py, harness/science_mission.py and model-assumptions.md.</a:t>
             </a:r>
           </a:p>
           <a:p xmlns:a="http://schemas.openxmlformats.org/drawingml/2006/main">
@@ -691,7 +691,7 @@
           </a:p>
           <a:p xmlns:a="http://schemas.openxmlformats.org/drawingml/2006/main">
             <a:r>
-              <a:t>Sources: submission_bundle/validation-evidence.json, docs/model-assumptions.md and the supplied RL_Hackathon_by_2une_PS.pdf. Runtime fingerprint 9e2d94e2c2473ccc962847d23febc20536546690e6875a3d40c807b83bf755b2.</a:t>
+              <a:t>Sources: submission_bundle/validation-evidence.json, docs/model-assumptions.md and the supplied RL_Hackathon_by_2une_PS.pdf. Runtime fingerprint b75030d6ecd33e8f80f5cdda39f2690a2a31688faad3f17d928f27c108e5507b.</a:t>
             </a:r>
           </a:p>
         </p:txBody>
@@ -761,7 +761,7 @@
           <a:lstStyle xmlns:a="http://schemas.openxmlformats.org/drawingml/2006/main"/>
           <a:p xmlns:a="http://schemas.openxmlformats.org/drawingml/2006/main">
             <a:r>
-              <a:t>2:20–3:25. Let d be constant duty over the 95-minute horizon. Exposure requires d at least 0.90. The energy allowance is 1.2 times full-window payload energy, giving d at most 1.2 times window length divided by 5700 seconds. For 600 or 900-second windows this is 0.126 or 0.189. The feasible reference plan turns the instrument off, waits, turns it on for the window, and turns it off. Tool time counts and the small switching overhead fits the budget. Alternative schedules also pass.</a:t>
+              <a:t>2:20–3:25. Collect only during two protected observation windows. Each needs at least 90 percent exposure. Data is generated causally, so a contact cannot send data not yet collected. Storage holds only 1.05 times the larger window volume, so both windows cannot simply be stored until the final contact. The first contact must drain the buffer. Energy forbids leaving payload on throughout. The measured feasible reference and independent alternatives pass.</a:t>
             </a:r>
           </a:p>
           <a:p xmlns:a="http://schemas.openxmlformats.org/drawingml/2006/main">
@@ -771,7 +771,7 @@
           </a:p>
           <a:p xmlns:a="http://schemas.openxmlformats.org/drawingml/2006/main">
             <a:r>
-              <a:t>Sources: submission_bundle/validation-evidence.json, docs/model-assumptions.md and the supplied RL_Hackathon_by_2une_PS.pdf. Runtime fingerprint 9e2d94e2c2473ccc962847d23febc20536546690e6875a3d40c807b83bf755b2.</a:t>
+              <a:t>Sources: submission_bundle/validation-evidence.json, docs/model-assumptions.md and the supplied RL_Hackathon_by_2une_PS.pdf. Runtime fingerprint b75030d6ecd33e8f80f5cdda39f2690a2a31688faad3f17d928f27c108e5507b.</a:t>
             </a:r>
           </a:p>
         </p:txBody>
@@ -841,7 +841,7 @@
           <a:lstStyle xmlns:a="http://schemas.openxmlformats.org/drawingml/2006/main"/>
           <a:p xmlns:a="http://schemas.openxmlformats.org/drawingml/2006/main">
             <a:r>
-              <a:t>3:25–4:25. Raw weights are power .35, thermal .25, pointing .20 and comms .20. Observation missions scale these by .8 and add exposure .20. Normalization measures progress beyond the projected no-op baseline. The implementation separately requires every mission check. A failed condition caps reward below .95 and a catastrophic event yields zero. Missed contact and exposure windows cannot be restored by editing final files.</a:t>
+              <a:t>3:25–4:25. Standard raw weights are power.35, thermal.25, pointing.20 and comms.20. Observation adds exposure. Science scales the standard vector by.6 and adds independent window completion.2 and science delivery.2. Normalized progress is relative to the seeded no-op. Mandatory checks independently cap all failures below.95, and catastrophic failures latch atzero. Invalid fields are rejected instead of silently defaulted.</a:t>
             </a:r>
           </a:p>
           <a:p xmlns:a="http://schemas.openxmlformats.org/drawingml/2006/main">
@@ -851,7 +851,7 @@
           </a:p>
           <a:p xmlns:a="http://schemas.openxmlformats.org/drawingml/2006/main">
             <a:r>
-              <a:t>Sources: submission_bundle/validation-evidence.json, docs/model-assumptions.md and the supplied RL_Hackathon_by_2une_PS.pdf. Runtime fingerprint 9e2d94e2c2473ccc962847d23febc20536546690e6875a3d40c807b83bf755b2.</a:t>
+              <a:t>Sources: submission_bundle/validation-evidence.json, docs/model-assumptions.md and the supplied RL_Hackathon_by_2une_PS.pdf. Runtime fingerprint b75030d6ecd33e8f80f5cdda39f2690a2a31688faad3f17d928f27c108e5507b.</a:t>
             </a:r>
           </a:p>
         </p:txBody>
@@ -931,7 +931,7 @@
           </a:p>
           <a:p xmlns:a="http://schemas.openxmlformats.org/drawingml/2006/main">
             <a:r>
-              <a:t>Sources: submission_bundle/validation-evidence.json, docs/model-assumptions.md and the supplied RL_Hackathon_by_2une_PS.pdf. Runtime fingerprint 9e2d94e2c2473ccc962847d23febc20536546690e6875a3d40c807b83bf755b2.</a:t>
+              <a:t>Sources: submission_bundle/validation-evidence.json, docs/model-assumptions.md and the supplied RL_Hackathon_by_2une_PS.pdf. Runtime fingerprint b75030d6ecd33e8f80f5cdda39f2690a2a31688faad3f17d928f27c108e5507b.</a:t>
             </a:r>
           </a:p>
         </p:txBody>
@@ -1001,7 +1001,7 @@
           <a:lstStyle xmlns:a="http://schemas.openxmlformats.org/drawingml/2006/main"/>
           <a:p xmlns:a="http://schemas.openxmlformats.org/drawingml/2006/main">
             <a:r>
-              <a:t>5:25–6:30. These are scripted attacks, clearly labeled model_called false. They do not count as genuine model runs. Show that changing a deadband cannot change a protected pointing target, fabricated telemetry cannot forge the verifier, and missed temporal windows stay missed. The rewards below .95 are partial progress, not successes. Exact run IDs and reasons are in validation-evidence.json and the raw logs.</a:t>
+              <a:t>5:25–6:25. These are intentionally wrong scripted policies, never model runs. Telemetry forgery cannot affect protected state. Late repair cannot reverse missed contact or exposure. New science probes separately check missed first contact and forged mission quotas/finalinventory. The underlying logs preserve actual counters and conservation. Finite probes demonstrate tested cases, not proof against every exploit.</a:t>
             </a:r>
           </a:p>
           <a:p xmlns:a="http://schemas.openxmlformats.org/drawingml/2006/main">
@@ -1011,7 +1011,7 @@
           </a:p>
           <a:p xmlns:a="http://schemas.openxmlformats.org/drawingml/2006/main">
             <a:r>
-              <a:t>Sources: submission_bundle/validation-evidence.json, docs/model-assumptions.md and the supplied RL_Hackathon_by_2une_PS.pdf. Runtime fingerprint 9e2d94e2c2473ccc962847d23febc20536546690e6875a3d40c807b83bf755b2.</a:t>
+              <a:t>Sources: submission_bundle/validation-evidence.json, docs/model-assumptions.md and the supplied RL_Hackathon_by_2une_PS.pdf. Runtime fingerprint b75030d6ecd33e8f80f5cdda39f2690a2a31688faad3f17d928f27c108e5507b.</a:t>
             </a:r>
           </a:p>
         </p:txBody>
@@ -1081,7 +1081,7 @@
           <a:lstStyle xmlns:a="http://schemas.openxmlformats.org/drawingml/2006/main"/>
           <a:p xmlns:a="http://schemas.openxmlformats.org/drawingml/2006/main">
             <a:r>
-              <a:t>6:30–7:35. Seventy-one Linux regressions include repeated reset hashes and reference/no-op checks across eight tasks and twenty seeds, 160 task-seed combinations. Twelve live tests cover real container isolation. All eight final-source gates pass. The table is a separate scripted HTTP policy comparison across eight tasks and five seeds. The reference is privileged, so 40/40 does not measure model reasoning. Nominal and max-radio fail every hard-task episode in this comparison. CI also enforces the isolated cold-build budget; consult the current workflow result for its measured time.</a:t>
+              <a:t>6:25–7:30. State the exact final-source Linux test count. The reset/no-op/reference sweep covers all nine tasks across 20 seeds. The separate scripted policy comparison covers five other seeds and never calls a model. The privileged reference measures feasibility, not model reasoning. Provider regressions use local loopback responses, not live service reliability. Expected build contract v3 binds source evidence to six non-secret build inputs, not to a measured Docker daemon.</a:t>
             </a:r>
           </a:p>
           <a:p xmlns:a="http://schemas.openxmlformats.org/drawingml/2006/main">
@@ -1091,7 +1091,7 @@
           </a:p>
           <a:p xmlns:a="http://schemas.openxmlformats.org/drawingml/2006/main">
             <a:r>
-              <a:t>Sources: submission_bundle/validation-evidence.json, docs/model-assumptions.md and the supplied RL_Hackathon_by_2une_PS.pdf. Runtime fingerprint 9e2d94e2c2473ccc962847d23febc20536546690e6875a3d40c807b83bf755b2.</a:t>
+              <a:t>Sources: submission_bundle/validation-evidence.json, docs/model-assumptions.md and the supplied RL_Hackathon_by_2une_PS.pdf. Runtime fingerprint b75030d6ecd33e8f80f5cdda39f2690a2a31688faad3f17d928f27c108e5507b.</a:t>
             </a:r>
           </a:p>
         </p:txBody>
@@ -1161,7 +1161,7 @@
           <a:lstStyle xmlns:a="http://schemas.openxmlformats.org/drawingml/2006/main"/>
           <a:p xmlns:a="http://schemas.openxmlformats.org/drawingml/2006/main">
             <a:r>
-              <a:t>7:35–8:45. Report all four provider attempts on the final fingerprint. Two EPS demos succeeded, with and without the sample append. Early pass received one reply, then APIConnectionError exhausted the retry cap. Observation received no reply and also exhausted retries. The zero-reply attempt is diagnostic evidence and does not qualify under our strict complete-run counter. Three complete runs remain, including the early-pass crash. There is no current-source hard-task model success claim. Elapsed values use the harness monotonic clock. Host or VM pauses produced much larger UTC gaps, so do not present these as independent external wall-clock certification. Previous six runs used an earlier source and remain historical.</a:t>
+              <a:t>7:30–8:45. Every row is a genuine provider attempt on this source. Report successes and failures exactly as logged. A zero-reply provider failure is diagnostic and does not count toward three completed evidence runs. Failure on a hard task is not by itself a broken environment, but limits model capability claims. All API calls use same interface. The sample append is only a smoke test, not a substitute for unknown judge instructions. Timing uses the harness monotonic clock; host pauses preclude independent external wall-clock certification.</a:t>
             </a:r>
           </a:p>
           <a:p xmlns:a="http://schemas.openxmlformats.org/drawingml/2006/main">
@@ -1171,7 +1171,7 @@
           </a:p>
           <a:p xmlns:a="http://schemas.openxmlformats.org/drawingml/2006/main">
             <a:r>
-              <a:t>Sources: submission_bundle/validation-evidence.json, docs/model-assumptions.md and the supplied RL_Hackathon_by_2une_PS.pdf. Runtime fingerprint 9e2d94e2c2473ccc962847d23febc20536546690e6875a3d40c807b83bf755b2.</a:t>
+              <a:t>Sources: submission_bundle/validation-evidence.json, docs/model-assumptions.md and the supplied RL_Hackathon_by_2une_PS.pdf. Runtime fingerprint b75030d6ecd33e8f80f5cdda39f2690a2a31688faad3f17d928f27c108e5507b.</a:t>
             </a:r>
           </a:p>
         </p:txBody>
@@ -1218,7 +1218,7 @@
           <p:cNvPr id="3" name="Title">
             <a:extLst xmlns:a="http://schemas.openxmlformats.org/drawingml/2006/main">
               <a:ext uri="{FF2B5EF4-FFF2-40B4-BE49-F238E27FC236}">
-                <a16:creationId xmlns:a16="http://schemas.microsoft.com/office/drawing/2014/main" id="{7F315357-19A3-4070-8637-F312765D0892}"/>
+                <a16:creationId xmlns:a16="http://schemas.microsoft.com/office/drawing/2014/main" id="{BBDCDFC0-0E27-48BF-B44F-13DA981C8218}"/>
               </a:ext>
             </a:extLst>
           </p:cNvPr>
@@ -1447,7 +1447,7 @@
           <p:cNvPr id="2" name="Subtitle">
             <a:extLst xmlns:a="http://schemas.openxmlformats.org/drawingml/2006/main">
               <a:ext uri="{FF2B5EF4-FFF2-40B4-BE49-F238E27FC236}">
-                <a16:creationId xmlns:a16="http://schemas.microsoft.com/office/drawing/2014/main" id="{B7A95207-1034-4964-B47C-425756C34F5A}"/>
+                <a16:creationId xmlns:a16="http://schemas.microsoft.com/office/drawing/2014/main" id="{1E70B570-081D-4EF9-8829-52F85E492763}"/>
               </a:ext>
             </a:extLst>
           </p:cNvPr>
@@ -1693,7 +1693,7 @@
           <p:cNvPr id="2" name="Section title">
             <a:extLst xmlns:a="http://schemas.openxmlformats.org/drawingml/2006/main">
               <a:ext uri="{FF2B5EF4-FFF2-40B4-BE49-F238E27FC236}">
-                <a16:creationId xmlns:a16="http://schemas.microsoft.com/office/drawing/2014/main" id="{C191B61F-40B0-4C13-AF92-BAB1D3DF422D}"/>
+                <a16:creationId xmlns:a16="http://schemas.microsoft.com/office/drawing/2014/main" id="{0EACEE7F-C33E-425B-82B0-E306BBC6A67E}"/>
               </a:ext>
             </a:extLst>
           </p:cNvPr>
@@ -1939,7 +1939,7 @@
           <p:cNvPr id="3" name="Title">
             <a:extLst xmlns:a="http://schemas.openxmlformats.org/drawingml/2006/main">
               <a:ext uri="{FF2B5EF4-FFF2-40B4-BE49-F238E27FC236}">
-                <a16:creationId xmlns:a16="http://schemas.microsoft.com/office/drawing/2014/main" id="{2C902DC3-F4CC-42EE-86AC-8002A292D176}"/>
+                <a16:creationId xmlns:a16="http://schemas.microsoft.com/office/drawing/2014/main" id="{34733825-F7D4-4FC9-86C8-8E9470815BF7}"/>
               </a:ext>
             </a:extLst>
           </p:cNvPr>
@@ -2168,7 +2168,7 @@
           <p:cNvPr id="2" name="Body">
             <a:extLst xmlns:a="http://schemas.openxmlformats.org/drawingml/2006/main">
               <a:ext uri="{FF2B5EF4-FFF2-40B4-BE49-F238E27FC236}">
-                <a16:creationId xmlns:a16="http://schemas.microsoft.com/office/drawing/2014/main" id="{327357CF-9DB3-421D-B6A0-6C7A8EB8ADAB}"/>
+                <a16:creationId xmlns:a16="http://schemas.microsoft.com/office/drawing/2014/main" id="{C14A2EBA-EC47-46F2-B571-12D67B446BF0}"/>
               </a:ext>
             </a:extLst>
           </p:cNvPr>
@@ -2414,7 +2414,7 @@
           <p:cNvPr id="4" name="Title">
             <a:extLst xmlns:a="http://schemas.openxmlformats.org/drawingml/2006/main">
               <a:ext uri="{FF2B5EF4-FFF2-40B4-BE49-F238E27FC236}">
-                <a16:creationId xmlns:a16="http://schemas.microsoft.com/office/drawing/2014/main" id="{E68E4062-4926-4DF1-A99F-8EAE963A73F5}"/>
+                <a16:creationId xmlns:a16="http://schemas.microsoft.com/office/drawing/2014/main" id="{B415168F-4720-4A8E-837D-8604CEAB0B15}"/>
               </a:ext>
             </a:extLst>
           </p:cNvPr>
@@ -2643,7 +2643,7 @@
           <p:cNvPr id="2" name="Left column">
             <a:extLst xmlns:a="http://schemas.openxmlformats.org/drawingml/2006/main">
               <a:ext uri="{FF2B5EF4-FFF2-40B4-BE49-F238E27FC236}">
-                <a16:creationId xmlns:a16="http://schemas.microsoft.com/office/drawing/2014/main" id="{6DF338AF-213E-41D2-941E-64D625ABD267}"/>
+                <a16:creationId xmlns:a16="http://schemas.microsoft.com/office/drawing/2014/main" id="{6F7F3D37-00ED-48B1-B7C6-0CC87857D226}"/>
               </a:ext>
             </a:extLst>
           </p:cNvPr>
@@ -2872,7 +2872,7 @@
           <p:cNvPr id="3" name="Right column">
             <a:extLst xmlns:a="http://schemas.openxmlformats.org/drawingml/2006/main">
               <a:ext uri="{FF2B5EF4-FFF2-40B4-BE49-F238E27FC236}">
-                <a16:creationId xmlns:a16="http://schemas.microsoft.com/office/drawing/2014/main" id="{3E076147-D0E4-43BE-9277-89B2C2267B16}"/>
+                <a16:creationId xmlns:a16="http://schemas.microsoft.com/office/drawing/2014/main" id="{883F0D86-1920-49F1-93D5-0F936D3B0899}"/>
               </a:ext>
             </a:extLst>
           </p:cNvPr>
@@ -3118,7 +3118,7 @@
           <p:cNvPr id="3" name="Title">
             <a:extLst xmlns:a="http://schemas.openxmlformats.org/drawingml/2006/main">
               <a:ext uri="{FF2B5EF4-FFF2-40B4-BE49-F238E27FC236}">
-                <a16:creationId xmlns:a16="http://schemas.microsoft.com/office/drawing/2014/main" id="{E4C752A9-F3F8-445C-A5CA-B7082E2E7559}"/>
+                <a16:creationId xmlns:a16="http://schemas.microsoft.com/office/drawing/2014/main" id="{E3439D57-CC70-40CF-A63D-A15DB94D35BF}"/>
               </a:ext>
             </a:extLst>
           </p:cNvPr>
@@ -3347,7 +3347,7 @@
           <p:cNvPr id="2" name="Left column">
             <a:extLst xmlns:a="http://schemas.openxmlformats.org/drawingml/2006/main">
               <a:ext uri="{FF2B5EF4-FFF2-40B4-BE49-F238E27FC236}">
-                <a16:creationId xmlns:a16="http://schemas.microsoft.com/office/drawing/2014/main" id="{BF90F5D9-48AE-47F4-9639-746CA949DEAC}"/>
+                <a16:creationId xmlns:a16="http://schemas.microsoft.com/office/drawing/2014/main" id="{57FBA695-C293-42A3-80DD-8D0370B9958B}"/>
               </a:ext>
             </a:extLst>
           </p:cNvPr>
@@ -3614,12 +3614,12 @@
   </p:cSld>
   <p:clrMap bg1="lt1" tx1="dk1" bg2="lt2" tx2="dk2" accent1="accent1" accent2="accent2" accent3="accent3" accent4="accent4" accent5="accent5" accent6="accent6" hlink="hlink" folHlink="folHlink"/>
   <p:sldLayoutIdLst>
-    <p:sldLayoutId xmlns:r="http://schemas.openxmlformats.org/officeDocument/2006/relationships" id="2147483649" r:id="R0ac323cea99d454a"/>
-    <p:sldLayoutId xmlns:r="http://schemas.openxmlformats.org/officeDocument/2006/relationships" id="2147483650" r:id="R0ee0d4c2d15e479a"/>
-    <p:sldLayoutId xmlns:r="http://schemas.openxmlformats.org/officeDocument/2006/relationships" id="2147483651" r:id="Rd50426eab6ba4aa4"/>
-    <p:sldLayoutId xmlns:r="http://schemas.openxmlformats.org/officeDocument/2006/relationships" id="2147483652" r:id="R3e0130a45bc84319"/>
-    <p:sldLayoutId xmlns:r="http://schemas.openxmlformats.org/officeDocument/2006/relationships" id="2147483653" r:id="Rf26d0bbdf37e4539"/>
-    <p:sldLayoutId xmlns:r="http://schemas.openxmlformats.org/officeDocument/2006/relationships" id="2147483654" r:id="R6d7113362b844ac0"/>
+    <p:sldLayoutId xmlns:r="http://schemas.openxmlformats.org/officeDocument/2006/relationships" id="2147483649" r:id="R43745a8a25344ed7"/>
+    <p:sldLayoutId xmlns:r="http://schemas.openxmlformats.org/officeDocument/2006/relationships" id="2147483650" r:id="Rf02d526cbb714afa"/>
+    <p:sldLayoutId xmlns:r="http://schemas.openxmlformats.org/officeDocument/2006/relationships" id="2147483651" r:id="R2b727f95d5d2476b"/>
+    <p:sldLayoutId xmlns:r="http://schemas.openxmlformats.org/officeDocument/2006/relationships" id="2147483652" r:id="Rb4f0a548857f4c1a"/>
+    <p:sldLayoutId xmlns:r="http://schemas.openxmlformats.org/officeDocument/2006/relationships" id="2147483653" r:id="Rf34a9a6ab7db416d"/>
+    <p:sldLayoutId xmlns:r="http://schemas.openxmlformats.org/officeDocument/2006/relationships" id="2147483654" r:id="R558a1c4a2bfe499d"/>
   </p:sldLayoutIdLst>
   <p:txStyles>
     <p:titleStyle>
@@ -4170,7 +4170,7 @@
           <p:cNvPr id="6" name="">
             <a:extLst xmlns:a="http://schemas.openxmlformats.org/drawingml/2006/main">
               <a:ext uri="{FF2B5EF4-FFF2-40B4-BE49-F238E27FC236}">
-                <a16:creationId xmlns:a16="http://schemas.microsoft.com/office/drawing/2014/main" id="{3691A333-32B2-4274-B214-D5706C5E9DB8}"/>
+                <a16:creationId xmlns:a16="http://schemas.microsoft.com/office/drawing/2014/main" id="{8C26BE88-2FC1-4C12-8960-3B0FD78F6578}"/>
               </a:ext>
             </a:extLst>
           </p:cNvPr>
@@ -4326,7 +4326,7 @@
           <p:cNvPr id="2" name="">
             <a:extLst xmlns:a="http://schemas.openxmlformats.org/drawingml/2006/main">
               <a:ext uri="{FF2B5EF4-FFF2-40B4-BE49-F238E27FC236}">
-                <a16:creationId xmlns:a16="http://schemas.microsoft.com/office/drawing/2014/main" id="{1E98D125-86A0-4B04-80FF-02F1498C1C89}"/>
+                <a16:creationId xmlns:a16="http://schemas.microsoft.com/office/drawing/2014/main" id="{959FEFC1-E82F-41E6-A282-598F008E54A7}"/>
               </a:ext>
             </a:extLst>
           </p:cNvPr>
@@ -4482,7 +4482,7 @@
           <p:cNvPr id="3" name="">
             <a:extLst xmlns:a="http://schemas.openxmlformats.org/drawingml/2006/main">
               <a:ext uri="{FF2B5EF4-FFF2-40B4-BE49-F238E27FC236}">
-                <a16:creationId xmlns:a16="http://schemas.microsoft.com/office/drawing/2014/main" id="{29A628F0-BEC1-45D9-BF7E-FDBCD23D549E}"/>
+                <a16:creationId xmlns:a16="http://schemas.microsoft.com/office/drawing/2014/main" id="{BAFCA502-0846-4174-BF6F-C53E352E72BA}"/>
               </a:ext>
             </a:extLst>
           </p:cNvPr>
@@ -4661,7 +4661,7 @@
           <p:cNvPr id="4" name="">
             <a:extLst xmlns:a="http://schemas.openxmlformats.org/drawingml/2006/main">
               <a:ext uri="{FF2B5EF4-FFF2-40B4-BE49-F238E27FC236}">
-                <a16:creationId xmlns:a16="http://schemas.microsoft.com/office/drawing/2014/main" id="{F80DDAA1-3160-4C1E-BB01-EA7737BE7C27}"/>
+                <a16:creationId xmlns:a16="http://schemas.microsoft.com/office/drawing/2014/main" id="{687FBE3F-12B8-4C89-83DD-B8EC9565A370}"/>
               </a:ext>
             </a:extLst>
           </p:cNvPr>
@@ -4807,7 +4807,7 @@
                 <a:ea typeface="Arial"/>
                 <a:cs typeface="Arial"/>
               </a:rPr>
-              <a:t>8 task families   /   3 difficulty levels   /   tool-using agents</a:t>
+              <a:t>9 task families   /   3 difficulty levels   /   tool-using agents</a:t>
             </a:r>
           </a:p>
         </p:txBody>
@@ -4817,7 +4817,7 @@
           <p:cNvPr id="5" name="">
             <a:extLst xmlns:a="http://schemas.openxmlformats.org/drawingml/2006/main">
               <a:ext uri="{FF2B5EF4-FFF2-40B4-BE49-F238E27FC236}">
-                <a16:creationId xmlns:a16="http://schemas.microsoft.com/office/drawing/2014/main" id="{BBE52F63-C8A4-4600-829F-5E6FCF7E1DF8}"/>
+                <a16:creationId xmlns:a16="http://schemas.microsoft.com/office/drawing/2014/main" id="{16E04EBA-CAAC-45C4-9DE0-BE1A4ED192D1}"/>
               </a:ext>
             </a:extLst>
           </p:cNvPr>
@@ -4971,7 +4971,7 @@
     </p:spTree>
     <p:extLst>
       <p:ext uri="{BB962C8B-B14F-4D97-AF65-F5344CB8AC3E}">
-        <p14:creationId xmlns:p14="http://schemas.microsoft.com/office/powerpoint/2010/main" val="1652805106"/>
+        <p14:creationId xmlns:p14="http://schemas.microsoft.com/office/powerpoint/2010/main" val="154778060"/>
       </p:ext>
     </p:extLst>
   </p:cSld>
@@ -5002,7 +5002,7 @@
           <p:cNvPr id="10" name="">
             <a:extLst xmlns:a="http://schemas.openxmlformats.org/drawingml/2006/main">
               <a:ext uri="{FF2B5EF4-FFF2-40B4-BE49-F238E27FC236}">
-                <a16:creationId xmlns:a16="http://schemas.microsoft.com/office/drawing/2014/main" id="{66E5BC30-9D42-4E59-94F6-EBD25440DB67}"/>
+                <a16:creationId xmlns:a16="http://schemas.microsoft.com/office/drawing/2014/main" id="{34BD8116-7EEE-40C7-B034-468A46D42385}"/>
               </a:ext>
             </a:extLst>
           </p:cNvPr>
@@ -5148,7 +5148,7 @@
                 <a:ea typeface="Arial"/>
                 <a:cs typeface="Arial"/>
               </a:rPr>
-              <a:t>DEMO AND DEFENSE</a:t>
+              <a:t>RUN A AND KNOWN LIMITS</a:t>
             </a:r>
           </a:p>
         </p:txBody>
@@ -5158,7 +5158,7 @@
           <p:cNvPr id="2" name="">
             <a:extLst xmlns:a="http://schemas.openxmlformats.org/drawingml/2006/main">
               <a:ext uri="{FF2B5EF4-FFF2-40B4-BE49-F238E27FC236}">
-                <a16:creationId xmlns:a16="http://schemas.microsoft.com/office/drawing/2014/main" id="{212066B2-A86D-4C36-900B-B8F67392F5A2}"/>
+                <a16:creationId xmlns:a16="http://schemas.microsoft.com/office/drawing/2014/main" id="{43F8963F-2694-41FD-9220-C0EF2465A96D}"/>
               </a:ext>
             </a:extLst>
           </p:cNvPr>
@@ -5304,7 +5304,7 @@
                 <a:ea typeface="Arial"/>
                 <a:cs typeface="Arial"/>
               </a:rPr>
-              <a:t>The demo is ready, with explicit limits</a:t>
+              <a:t>Demo and presentation defense</a:t>
             </a:r>
           </a:p>
         </p:txBody>
@@ -5314,7 +5314,7 @@
           <p:cNvPr id="3" name="">
             <a:extLst xmlns:a="http://schemas.openxmlformats.org/drawingml/2006/main">
               <a:ext uri="{FF2B5EF4-FFF2-40B4-BE49-F238E27FC236}">
-                <a16:creationId xmlns:a16="http://schemas.microsoft.com/office/drawing/2014/main" id="{AD93E5C2-5A62-4C6E-AC09-FF51D9BE5FC7}"/>
+                <a16:creationId xmlns:a16="http://schemas.microsoft.com/office/drawing/2014/main" id="{9FF31412-FA51-415C-A6A6-C843D063D448}"/>
               </a:ext>
             </a:extLst>
           </p:cNvPr>
@@ -5470,7 +5470,7 @@
           <p:cNvPr id="4" name="">
             <a:extLst xmlns:a="http://schemas.openxmlformats.org/drawingml/2006/main">
               <a:ext uri="{FF2B5EF4-FFF2-40B4-BE49-F238E27FC236}">
-                <a16:creationId xmlns:a16="http://schemas.microsoft.com/office/drawing/2014/main" id="{35F23370-EA0C-4F7F-9012-4F0EA71B9381}"/>
+                <a16:creationId xmlns:a16="http://schemas.microsoft.com/office/drawing/2014/main" id="{278DFF16-661B-4630-A293-0F2841717AEF}"/>
               </a:ext>
             </a:extLst>
           </p:cNvPr>
@@ -5626,7 +5626,7 @@
           <p:cNvPr id="5" name="">
             <a:extLst xmlns:a="http://schemas.openxmlformats.org/drawingml/2006/main">
               <a:ext uri="{FF2B5EF4-FFF2-40B4-BE49-F238E27FC236}">
-                <a16:creationId xmlns:a16="http://schemas.microsoft.com/office/drawing/2014/main" id="{E5A9642A-7CE2-4D4A-9D22-2441967B78AA}"/>
+                <a16:creationId xmlns:a16="http://schemas.microsoft.com/office/drawing/2014/main" id="{F8EACF99-8AE6-4620-AD2D-24058E0D224D}"/>
               </a:ext>
             </a:extLst>
           </p:cNvPr>
@@ -5782,7 +5782,7 @@
           <p:cNvPr id="6" name="">
             <a:extLst xmlns:a="http://schemas.openxmlformats.org/drawingml/2006/main">
               <a:ext uri="{FF2B5EF4-FFF2-40B4-BE49-F238E27FC236}">
-                <a16:creationId xmlns:a16="http://schemas.microsoft.com/office/drawing/2014/main" id="{39381630-4136-45C9-A805-F99BC9BAF493}"/>
+                <a16:creationId xmlns:a16="http://schemas.microsoft.com/office/drawing/2014/main" id="{F2E98F8D-2321-4F6D-B75D-2204443BA08D}"/>
               </a:ext>
             </a:extLst>
           </p:cNvPr>
@@ -5928,7 +5928,7 @@
                 <a:ea typeface="Arial"/>
                 <a:cs typeface="Arial"/>
               </a:rPr>
-              <a:t>Reward 1.0     7 replies     29.31 harness seconds     No append</a:t>
+              <a:t>success     reward 1     11 replies     49.44 harness seconds</a:t>
             </a:r>
           </a:p>
         </p:txBody>
@@ -5938,7 +5938,7 @@
           <p:cNvPr id="7" name="">
             <a:extLst xmlns:a="http://schemas.openxmlformats.org/drawingml/2006/main">
               <a:ext uri="{FF2B5EF4-FFF2-40B4-BE49-F238E27FC236}">
-                <a16:creationId xmlns:a16="http://schemas.microsoft.com/office/drawing/2014/main" id="{1E02BED3-877D-4141-833A-5099500EF4A0}"/>
+                <a16:creationId xmlns:a16="http://schemas.microsoft.com/office/drawing/2014/main" id="{5908DC0F-D616-4BAC-90DE-0741F816D16A}"/>
               </a:ext>
             </a:extLst>
           </p:cNvPr>
@@ -5949,7 +5949,7 @@
         </p:nvSpPr>
         <p:spPr>
           <a:xfrm xmlns:a="http://schemas.openxmlformats.org/drawingml/2006/main">
-            <a:off x="609600" y="3771900"/>
+            <a:off x="609600" y="3781425"/>
             <a:ext cx="10972800" cy="523875"/>
           </a:xfrm>
           <a:prstGeom xmlns:a="http://schemas.openxmlformats.org/drawingml/2006/main" prst="rect">
@@ -6084,7 +6084,7 @@
                 <a:ea typeface="Arial"/>
                 <a:cs typeface="Arial"/>
               </a:rPr>
-              <a:t>Known limits</a:t>
+              <a:t>Defensible claims and limits</a:t>
             </a:r>
           </a:p>
         </p:txBody>
@@ -6094,7 +6094,7 @@
           <p:cNvPr id="8" name="">
             <a:extLst xmlns:a="http://schemas.openxmlformats.org/drawingml/2006/main">
               <a:ext uri="{FF2B5EF4-FFF2-40B4-BE49-F238E27FC236}">
-                <a16:creationId xmlns:a16="http://schemas.microsoft.com/office/drawing/2014/main" id="{3C5606C1-4C17-470F-817B-E9F35D32C86A}"/>
+                <a16:creationId xmlns:a16="http://schemas.microsoft.com/office/drawing/2014/main" id="{E491A1C3-C36D-4050-B88B-26066541D2E6}"/>
               </a:ext>
             </a:extLst>
           </p:cNvPr>
@@ -6105,7 +6105,7 @@
         </p:nvSpPr>
         <p:spPr>
           <a:xfrm xmlns:a="http://schemas.openxmlformats.org/drawingml/2006/main">
-            <a:off x="609600" y="4391025"/>
+            <a:off x="609600" y="4400550"/>
             <a:ext cx="10972800" cy="962025"/>
           </a:xfrm>
           <a:prstGeom xmlns:a="http://schemas.openxmlformats.org/drawingml/2006/main" prst="rect">
@@ -6240,7 +6240,7 @@
                 <a:ea typeface="Arial"/>
                 <a:cs typeface="Arial"/>
               </a:rPr>
-              <a:t>Simplified dynamics. Five guided repair tasks. Finite exploit coverage.</a:t>
+              <a:t>Coupled planning, deterministic resets, protected causal scoring.</a:t>
             </a:r>
           </a:p>
           <a:p xmlns:a="http://schemas.openxmlformats.org/drawingml/2006/main">
@@ -6263,7 +6263,7 @@
                 <a:ea typeface="Arial"/>
                 <a:cs typeface="Arial"/>
               </a:rPr>
-              <a:t>One tested deployment. Provider connectivity affected hard-task runs.</a:t>
+              <a:t>Simplified physics, finite exploit coverage, one live deployment tested.</a:t>
             </a:r>
           </a:p>
         </p:txBody>
@@ -6273,7 +6273,7 @@
           <p:cNvPr id="9" name="">
             <a:extLst xmlns:a="http://schemas.openxmlformats.org/drawingml/2006/main">
               <a:ext uri="{FF2B5EF4-FFF2-40B4-BE49-F238E27FC236}">
-                <a16:creationId xmlns:a16="http://schemas.microsoft.com/office/drawing/2014/main" id="{9CC2A0A7-5E30-4A01-8EBE-051644FCCB04}"/>
+                <a16:creationId xmlns:a16="http://schemas.microsoft.com/office/drawing/2014/main" id="{CD9A4BC0-565F-4448-94F2-93B1951DE093}"/>
               </a:ext>
             </a:extLst>
           </p:cNvPr>
@@ -6284,8 +6284,8 @@
         </p:nvSpPr>
         <p:spPr>
           <a:xfrm xmlns:a="http://schemas.openxmlformats.org/drawingml/2006/main">
-            <a:off x="609600" y="5591175"/>
-            <a:ext cx="10972800" cy="628650"/>
+            <a:off x="609600" y="5600700"/>
+            <a:ext cx="10972800" cy="619125"/>
           </a:xfrm>
           <a:prstGeom xmlns:a="http://schemas.openxmlformats.org/drawingml/2006/main" prst="rect">
             <a:avLst/>
@@ -6419,7 +6419,7 @@
                 <a:ea typeface="Arial"/>
                 <a:cs typeface="Arial"/>
               </a:rPr>
-              <a:t>Submission still needs privacy/name-case review, organizer access and form upload.</a:t>
+              <a:t>Public visibility conflicts with the PS. Access, name case and submission need confirmation.</a:t>
             </a:r>
           </a:p>
         </p:txBody>
@@ -6427,7 +6427,7 @@
     </p:spTree>
     <p:extLst>
       <p:ext uri="{BB962C8B-B14F-4D97-AF65-F5344CB8AC3E}">
-        <p14:creationId xmlns:p14="http://schemas.microsoft.com/office/powerpoint/2010/main" val="973817198"/>
+        <p14:creationId xmlns:p14="http://schemas.microsoft.com/office/powerpoint/2010/main" val="418703943"/>
       </p:ext>
     </p:extLst>
   </p:cSld>
@@ -6458,7 +6458,7 @@
           <p:cNvPr id="7" name="">
             <a:extLst xmlns:a="http://schemas.openxmlformats.org/drawingml/2006/main">
               <a:ext uri="{FF2B5EF4-FFF2-40B4-BE49-F238E27FC236}">
-                <a16:creationId xmlns:a16="http://schemas.microsoft.com/office/drawing/2014/main" id="{50FF0982-45F2-466E-A669-EE05A056B9CA}"/>
+                <a16:creationId xmlns:a16="http://schemas.microsoft.com/office/drawing/2014/main" id="{1FEF092B-89D9-4D9B-8C6F-2D5BC37C0BF3}"/>
               </a:ext>
             </a:extLst>
           </p:cNvPr>
@@ -6614,7 +6614,7 @@
           <p:cNvPr id="2" name="">
             <a:extLst xmlns:a="http://schemas.openxmlformats.org/drawingml/2006/main">
               <a:ext uri="{FF2B5EF4-FFF2-40B4-BE49-F238E27FC236}">
-                <a16:creationId xmlns:a16="http://schemas.microsoft.com/office/drawing/2014/main" id="{34A2E80B-2A04-444B-841F-52C0505322A8}"/>
+                <a16:creationId xmlns:a16="http://schemas.microsoft.com/office/drawing/2014/main" id="{B0D540A4-0CE3-4A58-996E-33DB43FBEE9F}"/>
               </a:ext>
             </a:extLst>
           </p:cNvPr>
@@ -6770,7 +6770,7 @@
           <p:cNvPr id="3" name="">
             <a:extLst xmlns:a="http://schemas.openxmlformats.org/drawingml/2006/main">
               <a:ext uri="{FF2B5EF4-FFF2-40B4-BE49-F238E27FC236}">
-                <a16:creationId xmlns:a16="http://schemas.microsoft.com/office/drawing/2014/main" id="{65F0D671-6882-4695-B7C3-5FF736E4204B}"/>
+                <a16:creationId xmlns:a16="http://schemas.microsoft.com/office/drawing/2014/main" id="{2C88D20C-EF13-4628-91ED-2F3AD4D29DF6}"/>
               </a:ext>
             </a:extLst>
           </p:cNvPr>
@@ -6926,7 +6926,7 @@
           <p:cNvPr id="4" name="">
             <a:extLst xmlns:a="http://schemas.openxmlformats.org/drawingml/2006/main">
               <a:ext uri="{FF2B5EF4-FFF2-40B4-BE49-F238E27FC236}">
-                <a16:creationId xmlns:a16="http://schemas.microsoft.com/office/drawing/2014/main" id="{959D965E-DBF0-4388-B1DC-F31EC61C61AA}"/>
+                <a16:creationId xmlns:a16="http://schemas.microsoft.com/office/drawing/2014/main" id="{7772B2DB-FF57-44BA-8F17-8E86A6D2DB86}"/>
               </a:ext>
             </a:extLst>
           </p:cNvPr>
@@ -7082,7 +7082,7 @@
           <p:cNvPr id="5" name="">
             <a:extLst xmlns:a="http://schemas.openxmlformats.org/drawingml/2006/main">
               <a:ext uri="{FF2B5EF4-FFF2-40B4-BE49-F238E27FC236}">
-                <a16:creationId xmlns:a16="http://schemas.microsoft.com/office/drawing/2014/main" id="{AF503F99-1ECC-431F-9BA4-E71C612C505D}"/>
+                <a16:creationId xmlns:a16="http://schemas.microsoft.com/office/drawing/2014/main" id="{8DDE69E0-DF73-463E-B8BD-E9E36F009BF4}"/>
               </a:ext>
             </a:extLst>
           </p:cNvPr>
@@ -7645,7 +7645,7 @@
           <p:cNvPr id="6" name="">
             <a:extLst xmlns:a="http://schemas.openxmlformats.org/drawingml/2006/main">
               <a:ext uri="{FF2B5EF4-FFF2-40B4-BE49-F238E27FC236}">
-                <a16:creationId xmlns:a16="http://schemas.microsoft.com/office/drawing/2014/main" id="{FFCEAC49-7B0F-4951-B5B2-7EB15D23EC6C}"/>
+                <a16:creationId xmlns:a16="http://schemas.microsoft.com/office/drawing/2014/main" id="{D1EEA7E3-7A79-4FE2-8E02-9C518F43D12A}"/>
               </a:ext>
             </a:extLst>
           </p:cNvPr>
@@ -7799,7 +7799,7 @@
     </p:spTree>
     <p:extLst>
       <p:ext uri="{BB962C8B-B14F-4D97-AF65-F5344CB8AC3E}">
-        <p14:creationId xmlns:p14="http://schemas.microsoft.com/office/powerpoint/2010/main" val="958584693"/>
+        <p14:creationId xmlns:p14="http://schemas.microsoft.com/office/powerpoint/2010/main" val="734089591"/>
       </p:ext>
     </p:extLst>
   </p:cSld>
@@ -7830,7 +7830,7 @@
           <p:cNvPr id="7" name="">
             <a:extLst xmlns:a="http://schemas.openxmlformats.org/drawingml/2006/main">
               <a:ext uri="{FF2B5EF4-FFF2-40B4-BE49-F238E27FC236}">
-                <a16:creationId xmlns:a16="http://schemas.microsoft.com/office/drawing/2014/main" id="{30DCFE81-8892-493D-AD25-F07C06DB6A27}"/>
+                <a16:creationId xmlns:a16="http://schemas.microsoft.com/office/drawing/2014/main" id="{FCE1E6FB-C563-4AF6-A297-3288FB613939}"/>
               </a:ext>
             </a:extLst>
           </p:cNvPr>
@@ -7976,7 +7976,7 @@
                 <a:ea typeface="Arial"/>
                 <a:cs typeface="Arial"/>
               </a:rPr>
-              <a:t>EIGHT TASK FAMILIES</a:t>
+              <a:t>TASK PROGRESSION</a:t>
             </a:r>
           </a:p>
         </p:txBody>
@@ -7986,7 +7986,7 @@
           <p:cNvPr id="2" name="">
             <a:extLst xmlns:a="http://schemas.openxmlformats.org/drawingml/2006/main">
               <a:ext uri="{FF2B5EF4-FFF2-40B4-BE49-F238E27FC236}">
-                <a16:creationId xmlns:a16="http://schemas.microsoft.com/office/drawing/2014/main" id="{D8E8C8A1-37FA-4F1C-A98C-31B60F6603C8}"/>
+                <a16:creationId xmlns:a16="http://schemas.microsoft.com/office/drawing/2014/main" id="{6C3F033F-3C4E-40D0-8CAE-832CE267D181}"/>
               </a:ext>
             </a:extLst>
           </p:cNvPr>
@@ -8132,7 +8132,7 @@
                 <a:ea typeface="Arial"/>
                 <a:cs typeface="Arial"/>
               </a:rPr>
-              <a:t>Task depth progresses from repair to scheduling</a:t>
+              <a:t>Nine tasks, four planning challenges</a:t>
             </a:r>
           </a:p>
         </p:txBody>
@@ -8142,7 +8142,7 @@
           <p:cNvPr id="3" name="">
             <a:extLst xmlns:a="http://schemas.openxmlformats.org/drawingml/2006/main">
               <a:ext uri="{FF2B5EF4-FFF2-40B4-BE49-F238E27FC236}">
-                <a16:creationId xmlns:a16="http://schemas.microsoft.com/office/drawing/2014/main" id="{5E385679-D157-43BD-84AC-DDAFBE7A238A}"/>
+                <a16:creationId xmlns:a16="http://schemas.microsoft.com/office/drawing/2014/main" id="{71039999-693D-4896-B3DB-25866E778E15}"/>
               </a:ext>
             </a:extLst>
           </p:cNvPr>
@@ -8298,7 +8298,7 @@
           <p:cNvPr id="4" name="">
             <a:extLst xmlns:a="http://schemas.openxmlformats.org/drawingml/2006/main">
               <a:ext uri="{FF2B5EF4-FFF2-40B4-BE49-F238E27FC236}">
-                <a16:creationId xmlns:a16="http://schemas.microsoft.com/office/drawing/2014/main" id="{C5D3D4B8-C11D-4DBD-82F9-04B3BBBAFDF3}"/>
+                <a16:creationId xmlns:a16="http://schemas.microsoft.com/office/drawing/2014/main" id="{6BF291F5-33D8-4BD5-8A43-7EB7327353F3}"/>
               </a:ext>
             </a:extLst>
           </p:cNvPr>
@@ -8454,7 +8454,7 @@
           <p:cNvPr id="5" name="">
             <a:extLst xmlns:a="http://schemas.openxmlformats.org/drawingml/2006/main">
               <a:ext uri="{FF2B5EF4-FFF2-40B4-BE49-F238E27FC236}">
-                <a16:creationId xmlns:a16="http://schemas.microsoft.com/office/drawing/2014/main" id="{1A52294C-27C5-487B-8B6C-3CD24EEE52A5}"/>
+                <a16:creationId xmlns:a16="http://schemas.microsoft.com/office/drawing/2014/main" id="{4F8C644D-5D04-4999-A82C-C60C35601B79}"/>
               </a:ext>
             </a:extLst>
           </p:cNvPr>
@@ -8470,9 +8470,9 @@
             <a:tbl>
               <a:tblPr/>
               <a:tblGrid>
-                <a:gridCol w="2219325"/>
-                <a:gridCol w="4524375"/>
-                <a:gridCol w="4229100"/>
+                <a:gridCol w="2286000"/>
+                <a:gridCol w="4476750"/>
+                <a:gridCol w="4210050"/>
               </a:tblGrid>
               <a:tr h="833438">
                 <a:tc>
@@ -8615,7 +8615,7 @@
                     <a:lstStyle/>
                     <a:p>
                       <a:r>
-                        <a:rPr sz="1800" b="0">
+                        <a:rPr sz="1725" b="0">
                           <a:solidFill>
                             <a:srgbClr val="193447"/>
                           </a:solidFill>
@@ -8657,7 +8657,7 @@
                     <a:lstStyle/>
                     <a:p>
                       <a:r>
-                        <a:rPr sz="1800" b="0">
+                        <a:rPr sz="1725" b="0">
                           <a:solidFill>
                             <a:srgbClr val="193447"/>
                           </a:solidFill>
@@ -8670,7 +8670,7 @@
                     </a:p>
                     <a:p>
                       <a:r>
-                        <a:rPr sz="1800" b="0">
+                        <a:rPr sz="1725" b="0">
                           <a:solidFill>
                             <a:srgbClr val="193447"/>
                           </a:solidFill>
@@ -8706,7 +8706,7 @@
                     <a:lstStyle/>
                     <a:p>
                       <a:r>
-                        <a:rPr sz="1800" b="0">
+                        <a:rPr sz="1725" b="0">
                           <a:solidFill>
                             <a:srgbClr val="193447"/>
                           </a:solidFill>
@@ -8714,20 +8714,7 @@
                           <a:ea typeface="Arial"/>
                           <a:cs typeface="Arial"/>
                         </a:rPr>
-                        <a:t>Diagnose and repair</a:t>
-                      </a:r>
-                    </a:p>
-                    <a:p>
-                      <a:r>
-                        <a:rPr sz="1800" b="0">
-                          <a:solidFill>
-                            <a:srgbClr val="193447"/>
-                          </a:solidFill>
-                          <a:latin typeface="Arial"/>
-                          <a:ea typeface="Arial"/>
-                          <a:cs typeface="Arial"/>
-                        </a:rPr>
-                        <a:t>seeded faults</a:t>
+                        <a:t>Diagnose seeded faults</a:t>
                       </a:r>
                     </a:p>
                   </a:txBody>
@@ -8757,7 +8744,7 @@
                     <a:lstStyle/>
                     <a:p>
                       <a:r>
-                        <a:rPr sz="1800" b="0">
+                        <a:rPr sz="1725" b="0">
                           <a:solidFill>
                             <a:srgbClr val="193447"/>
                           </a:solidFill>
@@ -8765,7 +8752,7 @@
                           <a:ea typeface="Arial"/>
                           <a:cs typeface="Arial"/>
                         </a:rPr>
-                        <a:t>1 radio mission</a:t>
+                        <a:t>2 radio missions</a:t>
                       </a:r>
                     </a:p>
                   </a:txBody>
@@ -8799,7 +8786,7 @@
                     <a:lstStyle/>
                     <a:p>
                       <a:r>
-                        <a:rPr sz="1800" b="0">
+                        <a:rPr sz="1725" b="0">
                           <a:solidFill>
                             <a:srgbClr val="193447"/>
                           </a:solidFill>
@@ -8808,6 +8795,19 @@
                           <a:cs typeface="Arial"/>
                         </a:rPr>
                         <a:t>RF energy tradeoff</a:t>
+                      </a:r>
+                    </a:p>
+                    <a:p>
+                      <a:r>
+                        <a:rPr sz="1725" b="0">
+                          <a:solidFill>
+                            <a:srgbClr val="193447"/>
+                          </a:solidFill>
+                          <a:latin typeface="Arial"/>
+                          <a:ea typeface="Arial"/>
+                          <a:cs typeface="Arial"/>
+                        </a:rPr>
+                        <a:t>Early pass recovery</a:t>
                       </a:r>
                     </a:p>
                   </a:txBody>
@@ -8835,7 +8835,7 @@
                     <a:lstStyle/>
                     <a:p>
                       <a:r>
-                        <a:rPr sz="1800" b="0">
+                        <a:rPr sz="1725" b="0">
                           <a:solidFill>
                             <a:srgbClr val="193447"/>
                           </a:solidFill>
@@ -8843,12 +8843,12 @@
                           <a:ea typeface="Arial"/>
                           <a:cs typeface="Arial"/>
                         </a:rPr>
-                        <a:t>Balance data, link margin</a:t>
+                        <a:t>Balance link and energy</a:t>
                       </a:r>
                     </a:p>
                     <a:p>
                       <a:r>
-                        <a:rPr sz="1800" b="0">
+                        <a:rPr sz="1725" b="0">
                           <a:solidFill>
                             <a:srgbClr val="193447"/>
                           </a:solidFill>
@@ -8856,7 +8856,7 @@
                           <a:ea typeface="Arial"/>
                           <a:cs typeface="Arial"/>
                         </a:rPr>
-                        <a:t>and transmitter energy</a:t>
+                        <a:t>Meet a contact deadline</a:t>
                       </a:r>
                     </a:p>
                   </a:txBody>
@@ -8886,7 +8886,7 @@
                     <a:lstStyle/>
                     <a:p>
                       <a:r>
-                        <a:rPr sz="1800" b="0">
+                        <a:rPr sz="1725" b="0">
                           <a:solidFill>
                             <a:srgbClr val="193447"/>
                           </a:solidFill>
@@ -8894,7 +8894,7 @@
                           <a:ea typeface="Arial"/>
                           <a:cs typeface="Arial"/>
                         </a:rPr>
-                        <a:t>2 temporal missions</a:t>
+                        <a:t>2 payload missions</a:t>
                       </a:r>
                     </a:p>
                   </a:txBody>
@@ -8928,20 +8928,7 @@
                     <a:lstStyle/>
                     <a:p>
                       <a:r>
-                        <a:rPr sz="1800" b="0">
-                          <a:solidFill>
-                            <a:srgbClr val="193447"/>
-                          </a:solidFill>
-                          <a:latin typeface="Arial"/>
-                          <a:ea typeface="Arial"/>
-                          <a:cs typeface="Arial"/>
-                        </a:rPr>
-                        <a:t>Early pass recovery</a:t>
-                      </a:r>
-                    </a:p>
-                    <a:p>
-                      <a:r>
-                        <a:rPr sz="1800" b="0">
+                        <a:rPr sz="1725" b="0">
                           <a:solidFill>
                             <a:srgbClr val="193447"/>
                           </a:solidFill>
@@ -8950,6 +8937,19 @@
                           <a:cs typeface="Arial"/>
                         </a:rPr>
                         <a:t>Observation scheduling</a:t>
+                      </a:r>
+                    </a:p>
+                    <a:p>
+                      <a:r>
+                        <a:rPr sz="1725" b="0">
+                          <a:solidFill>
+                            <a:srgbClr val="193447"/>
+                          </a:solidFill>
+                          <a:latin typeface="Arial"/>
+                          <a:ea typeface="Arial"/>
+                          <a:cs typeface="Arial"/>
+                        </a:rPr>
+                        <a:t>Science store and forward</a:t>
                       </a:r>
                     </a:p>
                   </a:txBody>
@@ -8977,7 +8977,7 @@
                     <a:lstStyle/>
                     <a:p>
                       <a:r>
-                        <a:rPr sz="1800" b="0">
+                        <a:rPr sz="1725" b="0">
                           <a:solidFill>
                             <a:srgbClr val="193447"/>
                           </a:solidFill>
@@ -8985,12 +8985,12 @@
                           <a:ea typeface="Arial"/>
                           <a:cs typeface="Arial"/>
                         </a:rPr>
-                        <a:t>Recover before contact</a:t>
+                        <a:t>Schedule useful exposure</a:t>
                       </a:r>
                     </a:p>
                     <a:p>
                       <a:r>
-                        <a:rPr sz="1800" b="0">
+                        <a:rPr sz="1725" b="0">
                           <a:solidFill>
                             <a:srgbClr val="193447"/>
                           </a:solidFill>
@@ -8998,7 +8998,7 @@
                           <a:ea typeface="Arial"/>
                           <a:cs typeface="Arial"/>
                         </a:rPr>
-                        <a:t>Schedule exposure and energy</a:t>
+                        <a:t>Manage storage and contacts</a:t>
                       </a:r>
                     </a:p>
                   </a:txBody>
@@ -9030,7 +9030,7 @@
           <p:cNvPr id="6" name="">
             <a:extLst xmlns:a="http://schemas.openxmlformats.org/drawingml/2006/main">
               <a:ext uri="{FF2B5EF4-FFF2-40B4-BE49-F238E27FC236}">
-                <a16:creationId xmlns:a16="http://schemas.microsoft.com/office/drawing/2014/main" id="{18DE290D-3B03-4B0E-BA36-2C6BCCDFEEA2}"/>
+                <a16:creationId xmlns:a16="http://schemas.microsoft.com/office/drawing/2014/main" id="{4EEE064B-4408-451F-AE3A-D820853CDFE5}"/>
               </a:ext>
             </a:extLst>
           </p:cNvPr>
@@ -9041,8 +9041,8 @@
         </p:nvSpPr>
         <p:spPr>
           <a:xfrm xmlns:a="http://schemas.openxmlformats.org/drawingml/2006/main">
-            <a:off x="609600" y="5676900"/>
-            <a:ext cx="10972800" cy="476250"/>
+            <a:off x="609600" y="5705475"/>
+            <a:ext cx="10972800" cy="457200"/>
           </a:xfrm>
           <a:prstGeom xmlns:a="http://schemas.openxmlformats.org/drawingml/2006/main" prst="rect">
             <a:avLst/>
@@ -9056,7 +9056,7 @@
           <a:bodyPr xmlns:a="http://schemas.openxmlformats.org/drawingml/2006/main"/>
           <a:lstStyle xmlns:a="http://schemas.openxmlformats.org/drawingml/2006/main">
             <a:defPPr>
-              <a:defRPr sz="1800" b="1">
+              <a:defRPr sz="1725" b="1">
                 <a:solidFill>
                   <a:srgbClr val="007E83"/>
                 </a:solidFill>
@@ -9066,7 +9066,7 @@
               </a:defRPr>
             </a:defPPr>
             <a:lvl1pPr>
-              <a:defRPr sz="1800" b="1">
+              <a:defRPr sz="1725" b="1">
                 <a:solidFill>
                   <a:srgbClr val="007E83"/>
                 </a:solidFill>
@@ -9076,7 +9076,7 @@
               </a:defRPr>
             </a:lvl1pPr>
             <a:lvl2pPr>
-              <a:defRPr sz="1800" b="1">
+              <a:defRPr sz="1725" b="1">
                 <a:solidFill>
                   <a:srgbClr val="007E83"/>
                 </a:solidFill>
@@ -9086,7 +9086,7 @@
               </a:defRPr>
             </a:lvl2pPr>
             <a:lvl3pPr>
-              <a:defRPr sz="1800" b="1">
+              <a:defRPr sz="1725" b="1">
                 <a:solidFill>
                   <a:srgbClr val="007E83"/>
                 </a:solidFill>
@@ -9096,7 +9096,7 @@
               </a:defRPr>
             </a:lvl3pPr>
             <a:lvl4pPr>
-              <a:defRPr sz="1800" b="1">
+              <a:defRPr sz="1725" b="1">
                 <a:solidFill>
                   <a:srgbClr val="007E83"/>
                 </a:solidFill>
@@ -9106,7 +9106,7 @@
               </a:defRPr>
             </a:lvl4pPr>
             <a:lvl5pPr>
-              <a:defRPr sz="1800" b="1">
+              <a:defRPr sz="1725" b="1">
                 <a:solidFill>
                   <a:srgbClr val="007E83"/>
                 </a:solidFill>
@@ -9116,7 +9116,7 @@
               </a:defRPr>
             </a:lvl5pPr>
             <a:lvl6pPr>
-              <a:defRPr sz="1800" b="1">
+              <a:defRPr sz="1725" b="1">
                 <a:solidFill>
                   <a:srgbClr val="007E83"/>
                 </a:solidFill>
@@ -9126,7 +9126,7 @@
               </a:defRPr>
             </a:lvl6pPr>
             <a:lvl7pPr>
-              <a:defRPr sz="1800" b="1">
+              <a:defRPr sz="1725" b="1">
                 <a:solidFill>
                   <a:srgbClr val="007E83"/>
                 </a:solidFill>
@@ -9136,7 +9136,7 @@
               </a:defRPr>
             </a:lvl7pPr>
             <a:lvl8pPr>
-              <a:defRPr sz="1800" b="1">
+              <a:defRPr sz="1725" b="1">
                 <a:solidFill>
                   <a:srgbClr val="007E83"/>
                 </a:solidFill>
@@ -9146,7 +9146,7 @@
               </a:defRPr>
             </a:lvl8pPr>
             <a:lvl9pPr>
-              <a:defRPr sz="1800" b="1">
+              <a:defRPr sz="1725" b="1">
                 <a:solidFill>
                   <a:srgbClr val="007E83"/>
                 </a:solidFill>
@@ -9158,7 +9158,7 @@
           </a:lstStyle>
           <a:p xmlns:a="http://schemas.openxmlformats.org/drawingml/2006/main">
             <a:pPr>
-              <a:defRPr sz="1800" b="1">
+              <a:defRPr sz="1725" b="1">
                 <a:solidFill>
                   <a:srgbClr val="007E83"/>
                 </a:solidFill>
@@ -9168,7 +9168,7 @@
               </a:defRPr>
             </a:pPr>
             <a:r>
-              <a:rPr sz="1800" b="1">
+              <a:rPr sz="1725" b="1">
                 <a:solidFill>
                   <a:srgbClr val="007E83"/>
                 </a:solidFill>
@@ -9176,7 +9176,7 @@
                 <a:ea typeface="Arial"/>
                 <a:cs typeface="Arial"/>
               </a:rPr>
-              <a:t>Seeds vary faults, hardware profiles, deadlines and mission requirements.</a:t>
+              <a:t>Static nominal and maximum-radio policies fail all measured hard-task cases.</a:t>
             </a:r>
           </a:p>
         </p:txBody>
@@ -9184,7 +9184,7 @@
     </p:spTree>
     <p:extLst>
       <p:ext uri="{BB962C8B-B14F-4D97-AF65-F5344CB8AC3E}">
-        <p14:creationId xmlns:p14="http://schemas.microsoft.com/office/powerpoint/2010/main" val="1260956448"/>
+        <p14:creationId xmlns:p14="http://schemas.microsoft.com/office/powerpoint/2010/main" val="1260702419"/>
       </p:ext>
     </p:extLst>
   </p:cSld>
@@ -9212,10 +9212,10 @@
       </p:grpSpPr>
       <p:sp>
         <p:nvSpPr>
-          <p:cNvPr id="9" name="">
+          <p:cNvPr id="8" name="">
             <a:extLst xmlns:a="http://schemas.openxmlformats.org/drawingml/2006/main">
               <a:ext uri="{FF2B5EF4-FFF2-40B4-BE49-F238E27FC236}">
-                <a16:creationId xmlns:a16="http://schemas.microsoft.com/office/drawing/2014/main" id="{A45EF24B-36EE-463B-B248-A292C6C72448}"/>
+                <a16:creationId xmlns:a16="http://schemas.microsoft.com/office/drawing/2014/main" id="{B612858C-CF74-4B0D-A31D-6FBAC5B7E851}"/>
               </a:ext>
             </a:extLst>
           </p:cNvPr>
@@ -9361,7 +9361,7 @@
                 <a:ea typeface="Arial"/>
                 <a:cs typeface="Arial"/>
               </a:rPr>
-              <a:t>WHY OBSERVATION SCHEDULING MATTERS</a:t>
+              <a:t>COUPLED TEMPORAL PLANNING</a:t>
             </a:r>
           </a:p>
         </p:txBody>
@@ -9371,7 +9371,7 @@
           <p:cNvPr id="2" name="">
             <a:extLst xmlns:a="http://schemas.openxmlformats.org/drawingml/2006/main">
               <a:ext uri="{FF2B5EF4-FFF2-40B4-BE49-F238E27FC236}">
-                <a16:creationId xmlns:a16="http://schemas.microsoft.com/office/drawing/2014/main" id="{05910094-642C-4199-B0FC-7432F4A5C955}"/>
+                <a16:creationId xmlns:a16="http://schemas.microsoft.com/office/drawing/2014/main" id="{2BCD7152-26EB-4E0A-B16A-55003915798C}"/>
               </a:ext>
             </a:extLst>
           </p:cNvPr>
@@ -9517,7 +9517,7 @@
                 <a:ea typeface="Arial"/>
                 <a:cs typeface="Arial"/>
               </a:rPr>
-              <a:t>A constant payload setting cannot meet both goals</a:t>
+              <a:t>Two science windows, one finite buffer</a:t>
             </a:r>
           </a:p>
         </p:txBody>
@@ -9527,7 +9527,7 @@
           <p:cNvPr id="3" name="">
             <a:extLst xmlns:a="http://schemas.openxmlformats.org/drawingml/2006/main">
               <a:ext uri="{FF2B5EF4-FFF2-40B4-BE49-F238E27FC236}">
-                <a16:creationId xmlns:a16="http://schemas.microsoft.com/office/drawing/2014/main" id="{F7C2EB39-9685-425A-9106-224A4B059D47}"/>
+                <a16:creationId xmlns:a16="http://schemas.microsoft.com/office/drawing/2014/main" id="{AFBFE949-1C57-4204-89FC-76284F520622}"/>
               </a:ext>
             </a:extLst>
           </p:cNvPr>
@@ -9683,7 +9683,7 @@
           <p:cNvPr id="4" name="">
             <a:extLst xmlns:a="http://schemas.openxmlformats.org/drawingml/2006/main">
               <a:ext uri="{FF2B5EF4-FFF2-40B4-BE49-F238E27FC236}">
-                <a16:creationId xmlns:a16="http://schemas.microsoft.com/office/drawing/2014/main" id="{7D2F3876-8680-46A7-BA27-BCEF06802620}"/>
+                <a16:creationId xmlns:a16="http://schemas.microsoft.com/office/drawing/2014/main" id="{A070930C-49E3-4B62-BC76-9FEB5DEB2FC5}"/>
               </a:ext>
             </a:extLst>
           </p:cNvPr>
@@ -9834,12 +9834,523 @@
           </a:p>
         </p:txBody>
       </p:sp>
-      <p:sp>
-        <p:nvSpPr>
+      <p:graphicFrame>
+        <p:nvGraphicFramePr>
           <p:cNvPr id="5" name="">
             <a:extLst xmlns:a="http://schemas.openxmlformats.org/drawingml/2006/main">
               <a:ext uri="{FF2B5EF4-FFF2-40B4-BE49-F238E27FC236}">
-                <a16:creationId xmlns:a16="http://schemas.microsoft.com/office/drawing/2014/main" id="{16138566-9896-47E5-A6BD-563E60D08C89}"/>
+                <a16:creationId xmlns:a16="http://schemas.microsoft.com/office/drawing/2014/main" id="{2EDE67E9-9FA5-4799-AAFC-B770A964734A}"/>
+              </a:ext>
+            </a:extLst>
+          </p:cNvPr>
+          <p:cNvGraphicFramePr/>
+          <p:nvPr/>
+        </p:nvGraphicFramePr>
+        <p:xfrm>
+          <a:off xmlns:a="http://schemas.openxmlformats.org/drawingml/2006/main" x="609600" y="2009775"/>
+          <a:ext xmlns:a="http://schemas.openxmlformats.org/drawingml/2006/main" cx="10972800" cy="2724150"/>
+        </p:xfrm>
+        <a:graphic xmlns:a="http://schemas.openxmlformats.org/drawingml/2006/main">
+          <a:graphicData uri="http://schemas.openxmlformats.org/drawingml/2006/table">
+            <a:tbl>
+              <a:tblPr/>
+              <a:tblGrid>
+                <a:gridCol w="3238500"/>
+                <a:gridCol w="4048125"/>
+                <a:gridCol w="3686175"/>
+              </a:tblGrid>
+              <a:tr h="681038">
+                <a:tc>
+                  <a:txBody>
+                    <a:bodyPr/>
+                    <a:lstStyle/>
+                    <a:p>
+                      <a:r>
+                        <a:rPr sz="1500" b="1">
+                          <a:solidFill>
+                            <a:srgbClr val="FFFFFF"/>
+                          </a:solidFill>
+                          <a:latin typeface="Arial"/>
+                          <a:ea typeface="Arial"/>
+                          <a:cs typeface="Arial"/>
+                        </a:rPr>
+                        <a:t>Mission stage</a:t>
+                      </a:r>
+                    </a:p>
+                  </a:txBody>
+                  <a:tcPr marL="152400" marR="133350" marT="133350" marB="95250" anchor="ctr">
+                    <a:lnL w="9525">
+                      <a:solidFill>
+                        <a:srgbClr val="D6E2E8"/>
+                      </a:solidFill>
+                      <a:prstDash val="solid"/>
+                    </a:lnL>
+                    <a:lnR w="9525">
+                      <a:solidFill>
+                        <a:srgbClr val="D6E2E8"/>
+                      </a:solidFill>
+                      <a:prstDash val="solid"/>
+                    </a:lnR>
+                    <a:lnT w="9525">
+                      <a:solidFill>
+                        <a:srgbClr val="D6E2E8"/>
+                      </a:solidFill>
+                      <a:prstDash val="solid"/>
+                    </a:lnT>
+                    <a:lnB w="9525">
+                      <a:solidFill>
+                        <a:srgbClr val="D6E2E8"/>
+                      </a:solidFill>
+                      <a:prstDash val="solid"/>
+                    </a:lnB>
+                    <a:solidFill>
+                      <a:srgbClr val="102539"/>
+                    </a:solidFill>
+                  </a:tcPr>
+                </a:tc>
+                <a:tc>
+                  <a:txBody>
+                    <a:bodyPr/>
+                    <a:lstStyle/>
+                    <a:p>
+                      <a:r>
+                        <a:rPr sz="1500" b="1">
+                          <a:solidFill>
+                            <a:srgbClr val="FFFFFF"/>
+                          </a:solidFill>
+                          <a:latin typeface="Arial"/>
+                          <a:ea typeface="Arial"/>
+                          <a:cs typeface="Arial"/>
+                        </a:rPr>
+                        <a:t>Required decision</a:t>
+                      </a:r>
+                    </a:p>
+                  </a:txBody>
+                  <a:tcPr marL="152400" marR="133350" marT="133350" marB="95250" anchor="ctr">
+                    <a:lnR w="9525">
+                      <a:solidFill>
+                        <a:srgbClr val="D6E2E8"/>
+                      </a:solidFill>
+                      <a:prstDash val="solid"/>
+                    </a:lnR>
+                    <a:lnT w="9525">
+                      <a:solidFill>
+                        <a:srgbClr val="D6E2E8"/>
+                      </a:solidFill>
+                      <a:prstDash val="solid"/>
+                    </a:lnT>
+                    <a:lnB w="9525">
+                      <a:solidFill>
+                        <a:srgbClr val="D6E2E8"/>
+                      </a:solidFill>
+                      <a:prstDash val="solid"/>
+                    </a:lnB>
+                    <a:solidFill>
+                      <a:srgbClr val="102539"/>
+                    </a:solidFill>
+                  </a:tcPr>
+                </a:tc>
+                <a:tc>
+                  <a:txBody>
+                    <a:bodyPr/>
+                    <a:lstStyle/>
+                    <a:p>
+                      <a:r>
+                        <a:rPr sz="1500" b="1">
+                          <a:solidFill>
+                            <a:srgbClr val="FFFFFF"/>
+                          </a:solidFill>
+                          <a:latin typeface="Arial"/>
+                          <a:ea typeface="Arial"/>
+                          <a:cs typeface="Arial"/>
+                        </a:rPr>
+                        <a:t>Irreversible consequence</a:t>
+                      </a:r>
+                    </a:p>
+                  </a:txBody>
+                  <a:tcPr marL="152400" marR="133350" marT="133350" marB="95250" anchor="ctr">
+                    <a:lnR w="9525">
+                      <a:solidFill>
+                        <a:srgbClr val="D6E2E8"/>
+                      </a:solidFill>
+                      <a:prstDash val="solid"/>
+                    </a:lnR>
+                    <a:lnT w="9525">
+                      <a:solidFill>
+                        <a:srgbClr val="D6E2E8"/>
+                      </a:solidFill>
+                      <a:prstDash val="solid"/>
+                    </a:lnT>
+                    <a:lnB w="9525">
+                      <a:solidFill>
+                        <a:srgbClr val="D6E2E8"/>
+                      </a:solidFill>
+                      <a:prstDash val="solid"/>
+                    </a:lnB>
+                    <a:solidFill>
+                      <a:srgbClr val="102539"/>
+                    </a:solidFill>
+                  </a:tcPr>
+                </a:tc>
+              </a:tr>
+              <a:tr h="681038">
+                <a:tc>
+                  <a:txBody>
+                    <a:bodyPr/>
+                    <a:lstStyle/>
+                    <a:p>
+                      <a:r>
+                        <a:rPr sz="1725" b="0">
+                          <a:solidFill>
+                            <a:srgbClr val="193447"/>
+                          </a:solidFill>
+                          <a:latin typeface="Arial"/>
+                          <a:ea typeface="Arial"/>
+                          <a:cs typeface="Arial"/>
+                        </a:rPr>
+                        <a:t>Before window 1</a:t>
+                      </a:r>
+                    </a:p>
+                  </a:txBody>
+                  <a:tcPr marL="152400" marR="133350" marT="133350" marB="95250" anchor="ctr">
+                    <a:lnL w="9525">
+                      <a:solidFill>
+                        <a:srgbClr val="D6E2E8"/>
+                      </a:solidFill>
+                      <a:prstDash val="solid"/>
+                    </a:lnL>
+                    <a:lnR w="9525">
+                      <a:solidFill>
+                        <a:srgbClr val="D6E2E8"/>
+                      </a:solidFill>
+                      <a:prstDash val="solid"/>
+                    </a:lnR>
+                    <a:lnB w="9525">
+                      <a:solidFill>
+                        <a:srgbClr val="D6E2E8"/>
+                      </a:solidFill>
+                      <a:prstDash val="solid"/>
+                    </a:lnB>
+                    <a:solidFill>
+                      <a:srgbClr val="EDF4F7"/>
+                    </a:solidFill>
+                  </a:tcPr>
+                </a:tc>
+                <a:tc>
+                  <a:txBody>
+                    <a:bodyPr/>
+                    <a:lstStyle/>
+                    <a:p>
+                      <a:r>
+                        <a:rPr sz="1725" b="0">
+                          <a:solidFill>
+                            <a:srgbClr val="193447"/>
+                          </a:solidFill>
+                          <a:latin typeface="Arial"/>
+                          <a:ea typeface="Arial"/>
+                          <a:cs typeface="Arial"/>
+                        </a:rPr>
+                        <a:t>Inspect targets and configure radio</a:t>
+                      </a:r>
+                    </a:p>
+                  </a:txBody>
+                  <a:tcPr marL="152400" marR="133350" marT="133350" marB="95250" anchor="ctr">
+                    <a:lnR w="9525">
+                      <a:solidFill>
+                        <a:srgbClr val="D6E2E8"/>
+                      </a:solidFill>
+                      <a:prstDash val="solid"/>
+                    </a:lnR>
+                    <a:lnB w="9525">
+                      <a:solidFill>
+                        <a:srgbClr val="D6E2E8"/>
+                      </a:solidFill>
+                      <a:prstDash val="solid"/>
+                    </a:lnB>
+                    <a:solidFill>
+                      <a:srgbClr val="EDF4F7"/>
+                    </a:solidFill>
+                  </a:tcPr>
+                </a:tc>
+                <a:tc>
+                  <a:txBody>
+                    <a:bodyPr/>
+                    <a:lstStyle/>
+                    <a:p>
+                      <a:r>
+                        <a:rPr sz="1725" b="0">
+                          <a:solidFill>
+                            <a:srgbClr val="193447"/>
+                          </a:solidFill>
+                          <a:latin typeface="Arial"/>
+                          <a:ea typeface="Arial"/>
+                          <a:cs typeface="Arial"/>
+                        </a:rPr>
+                        <a:t>Tool calls consume time</a:t>
+                      </a:r>
+                    </a:p>
+                  </a:txBody>
+                  <a:tcPr marL="152400" marR="133350" marT="133350" marB="95250" anchor="ctr">
+                    <a:lnR w="9525">
+                      <a:solidFill>
+                        <a:srgbClr val="D6E2E8"/>
+                      </a:solidFill>
+                      <a:prstDash val="solid"/>
+                    </a:lnR>
+                    <a:lnB w="9525">
+                      <a:solidFill>
+                        <a:srgbClr val="D6E2E8"/>
+                      </a:solidFill>
+                      <a:prstDash val="solid"/>
+                    </a:lnB>
+                    <a:solidFill>
+                      <a:srgbClr val="EDF4F7"/>
+                    </a:solidFill>
+                  </a:tcPr>
+                </a:tc>
+              </a:tr>
+              <a:tr h="681038">
+                <a:tc>
+                  <a:txBody>
+                    <a:bodyPr/>
+                    <a:lstStyle/>
+                    <a:p>
+                      <a:r>
+                        <a:rPr sz="1725" b="0">
+                          <a:solidFill>
+                            <a:srgbClr val="193447"/>
+                          </a:solidFill>
+                          <a:latin typeface="Arial"/>
+                          <a:ea typeface="Arial"/>
+                          <a:cs typeface="Arial"/>
+                        </a:rPr>
+                        <a:t>Window 1 → contact 1</a:t>
+                      </a:r>
+                    </a:p>
+                  </a:txBody>
+                  <a:tcPr marL="152400" marR="133350" marT="133350" marB="95250" anchor="ctr">
+                    <a:lnL w="9525">
+                      <a:solidFill>
+                        <a:srgbClr val="D6E2E8"/>
+                      </a:solidFill>
+                      <a:prstDash val="solid"/>
+                    </a:lnL>
+                    <a:lnR w="9525">
+                      <a:solidFill>
+                        <a:srgbClr val="D6E2E8"/>
+                      </a:solidFill>
+                      <a:prstDash val="solid"/>
+                    </a:lnR>
+                    <a:lnB w="9525">
+                      <a:solidFill>
+                        <a:srgbClr val="D6E2E8"/>
+                      </a:solidFill>
+                      <a:prstDash val="solid"/>
+                    </a:lnB>
+                    <a:solidFill>
+                      <a:srgbClr val="FFFFFF"/>
+                    </a:solidFill>
+                  </a:tcPr>
+                </a:tc>
+                <a:tc>
+                  <a:txBody>
+                    <a:bodyPr/>
+                    <a:lstStyle/>
+                    <a:p>
+                      <a:r>
+                        <a:rPr sz="1725" b="0">
+                          <a:solidFill>
+                            <a:srgbClr val="193447"/>
+                          </a:solidFill>
+                          <a:latin typeface="Arial"/>
+                          <a:ea typeface="Arial"/>
+                          <a:cs typeface="Arial"/>
+                        </a:rPr>
+                        <a:t>Collect, switch off, drain buffer</a:t>
+                      </a:r>
+                    </a:p>
+                  </a:txBody>
+                  <a:tcPr marL="152400" marR="133350" marT="133350" marB="95250" anchor="ctr">
+                    <a:lnR w="9525">
+                      <a:solidFill>
+                        <a:srgbClr val="D6E2E8"/>
+                      </a:solidFill>
+                      <a:prstDash val="solid"/>
+                    </a:lnR>
+                    <a:lnB w="9525">
+                      <a:solidFill>
+                        <a:srgbClr val="D6E2E8"/>
+                      </a:solidFill>
+                      <a:prstDash val="solid"/>
+                    </a:lnB>
+                    <a:solidFill>
+                      <a:srgbClr val="FFFFFF"/>
+                    </a:solidFill>
+                  </a:tcPr>
+                </a:tc>
+                <a:tc>
+                  <a:txBody>
+                    <a:bodyPr/>
+                    <a:lstStyle/>
+                    <a:p>
+                      <a:r>
+                        <a:rPr sz="1725" b="0">
+                          <a:solidFill>
+                            <a:srgbClr val="193447"/>
+                          </a:solidFill>
+                          <a:latin typeface="Arial"/>
+                          <a:ea typeface="Arial"/>
+                          <a:cs typeface="Arial"/>
+                        </a:rPr>
+                        <a:t>Lost data cannot be restored</a:t>
+                      </a:r>
+                    </a:p>
+                  </a:txBody>
+                  <a:tcPr marL="152400" marR="133350" marT="133350" marB="95250" anchor="ctr">
+                    <a:lnR w="9525">
+                      <a:solidFill>
+                        <a:srgbClr val="D6E2E8"/>
+                      </a:solidFill>
+                      <a:prstDash val="solid"/>
+                    </a:lnR>
+                    <a:lnB w="9525">
+                      <a:solidFill>
+                        <a:srgbClr val="D6E2E8"/>
+                      </a:solidFill>
+                      <a:prstDash val="solid"/>
+                    </a:lnB>
+                    <a:solidFill>
+                      <a:srgbClr val="FFFFFF"/>
+                    </a:solidFill>
+                  </a:tcPr>
+                </a:tc>
+              </a:tr>
+              <a:tr h="681038">
+                <a:tc>
+                  <a:txBody>
+                    <a:bodyPr/>
+                    <a:lstStyle/>
+                    <a:p>
+                      <a:r>
+                        <a:rPr sz="1725" b="0">
+                          <a:solidFill>
+                            <a:srgbClr val="193447"/>
+                          </a:solidFill>
+                          <a:latin typeface="Arial"/>
+                          <a:ea typeface="Arial"/>
+                          <a:cs typeface="Arial"/>
+                        </a:rPr>
+                        <a:t>Window 2 → contact 2</a:t>
+                      </a:r>
+                    </a:p>
+                  </a:txBody>
+                  <a:tcPr marL="152400" marR="133350" marT="133350" marB="95250" anchor="ctr">
+                    <a:lnL w="9525">
+                      <a:solidFill>
+                        <a:srgbClr val="D6E2E8"/>
+                      </a:solidFill>
+                      <a:prstDash val="solid"/>
+                    </a:lnL>
+                    <a:lnR w="9525">
+                      <a:solidFill>
+                        <a:srgbClr val="D6E2E8"/>
+                      </a:solidFill>
+                      <a:prstDash val="solid"/>
+                    </a:lnR>
+                    <a:lnB w="9525">
+                      <a:solidFill>
+                        <a:srgbClr val="D6E2E8"/>
+                      </a:solidFill>
+                      <a:prstDash val="solid"/>
+                    </a:lnB>
+                    <a:solidFill>
+                      <a:srgbClr val="EDF4F7"/>
+                    </a:solidFill>
+                  </a:tcPr>
+                </a:tc>
+                <a:tc>
+                  <a:txBody>
+                    <a:bodyPr/>
+                    <a:lstStyle/>
+                    <a:p>
+                      <a:r>
+                        <a:rPr sz="1725" b="0">
+                          <a:solidFill>
+                            <a:srgbClr val="193447"/>
+                          </a:solidFill>
+                          <a:latin typeface="Arial"/>
+                          <a:ea typeface="Arial"/>
+                          <a:cs typeface="Arial"/>
+                        </a:rPr>
+                        <a:t>Collect, switch off, deliver remainder</a:t>
+                      </a:r>
+                    </a:p>
+                  </a:txBody>
+                  <a:tcPr marL="152400" marR="133350" marT="133350" marB="95250" anchor="ctr">
+                    <a:lnR w="9525">
+                      <a:solidFill>
+                        <a:srgbClr val="D6E2E8"/>
+                      </a:solidFill>
+                      <a:prstDash val="solid"/>
+                    </a:lnR>
+                    <a:lnB w="9525">
+                      <a:solidFill>
+                        <a:srgbClr val="D6E2E8"/>
+                      </a:solidFill>
+                      <a:prstDash val="solid"/>
+                    </a:lnB>
+                    <a:solidFill>
+                      <a:srgbClr val="EDF4F7"/>
+                    </a:solidFill>
+                  </a:tcPr>
+                </a:tc>
+                <a:tc>
+                  <a:txBody>
+                    <a:bodyPr/>
+                    <a:lstStyle/>
+                    <a:p>
+                      <a:r>
+                        <a:rPr sz="1725" b="0">
+                          <a:solidFill>
+                            <a:srgbClr val="193447"/>
+                          </a:solidFill>
+                          <a:latin typeface="Arial"/>
+                          <a:ea typeface="Arial"/>
+                          <a:cs typeface="Arial"/>
+                        </a:rPr>
+                        <a:t>Both exposure quotas must pass</a:t>
+                      </a:r>
+                    </a:p>
+                  </a:txBody>
+                  <a:tcPr marL="152400" marR="133350" marT="133350" marB="95250" anchor="ctr">
+                    <a:lnR w="9525">
+                      <a:solidFill>
+                        <a:srgbClr val="D6E2E8"/>
+                      </a:solidFill>
+                      <a:prstDash val="solid"/>
+                    </a:lnR>
+                    <a:lnB w="9525">
+                      <a:solidFill>
+                        <a:srgbClr val="D6E2E8"/>
+                      </a:solidFill>
+                      <a:prstDash val="solid"/>
+                    </a:lnB>
+                    <a:solidFill>
+                      <a:srgbClr val="EDF4F7"/>
+                    </a:solidFill>
+                  </a:tcPr>
+                </a:tc>
+              </a:tr>
+            </a:tbl>
+          </a:graphicData>
+        </a:graphic>
+      </p:graphicFrame>
+      <p:sp>
+        <p:nvSpPr>
+          <p:cNvPr id="6" name="">
+            <a:extLst xmlns:a="http://schemas.openxmlformats.org/drawingml/2006/main">
+              <a:ext uri="{FF2B5EF4-FFF2-40B4-BE49-F238E27FC236}">
+                <a16:creationId xmlns:a16="http://schemas.microsoft.com/office/drawing/2014/main" id="{157A6012-BC70-4B18-83C8-C12AB4F77108}"/>
               </a:ext>
             </a:extLst>
           </p:cNvPr>
@@ -9850,8 +10361,8 @@
         </p:nvSpPr>
         <p:spPr>
           <a:xfrm xmlns:a="http://schemas.openxmlformats.org/drawingml/2006/main">
-            <a:off x="609600" y="2028825"/>
-            <a:ext cx="10972800" cy="695325"/>
+            <a:off x="609600" y="5038725"/>
+            <a:ext cx="10972800" cy="590550"/>
           </a:xfrm>
           <a:prstGeom xmlns:a="http://schemas.openxmlformats.org/drawingml/2006/main" prst="rect">
             <a:avLst/>
@@ -9865,9 +10376,9 @@
           <a:bodyPr xmlns:a="http://schemas.openxmlformats.org/drawingml/2006/main"/>
           <a:lstStyle xmlns:a="http://schemas.openxmlformats.org/drawingml/2006/main">
             <a:defPPr>
-              <a:defRPr sz="2775" b="1">
-                <a:solidFill>
-                  <a:srgbClr val="102539"/>
+              <a:defRPr sz="1950" b="1">
+                <a:solidFill>
+                  <a:srgbClr val="007E83"/>
                 </a:solidFill>
                 <a:latin typeface="Arial"/>
                 <a:ea typeface="Arial"/>
@@ -9875,9 +10386,9 @@
               </a:defRPr>
             </a:defPPr>
             <a:lvl1pPr>
-              <a:defRPr sz="2775" b="1">
-                <a:solidFill>
-                  <a:srgbClr val="102539"/>
+              <a:defRPr sz="1950" b="1">
+                <a:solidFill>
+                  <a:srgbClr val="007E83"/>
                 </a:solidFill>
                 <a:latin typeface="Arial"/>
                 <a:ea typeface="Arial"/>
@@ -9885,9 +10396,9 @@
               </a:defRPr>
             </a:lvl1pPr>
             <a:lvl2pPr>
-              <a:defRPr sz="2775" b="1">
-                <a:solidFill>
-                  <a:srgbClr val="102539"/>
+              <a:defRPr sz="1950" b="1">
+                <a:solidFill>
+                  <a:srgbClr val="007E83"/>
                 </a:solidFill>
                 <a:latin typeface="Arial"/>
                 <a:ea typeface="Arial"/>
@@ -9895,9 +10406,9 @@
               </a:defRPr>
             </a:lvl2pPr>
             <a:lvl3pPr>
-              <a:defRPr sz="2775" b="1">
-                <a:solidFill>
-                  <a:srgbClr val="102539"/>
+              <a:defRPr sz="1950" b="1">
+                <a:solidFill>
+                  <a:srgbClr val="007E83"/>
                 </a:solidFill>
                 <a:latin typeface="Arial"/>
                 <a:ea typeface="Arial"/>
@@ -9905,9 +10416,9 @@
               </a:defRPr>
             </a:lvl3pPr>
             <a:lvl4pPr>
-              <a:defRPr sz="2775" b="1">
-                <a:solidFill>
-                  <a:srgbClr val="102539"/>
+              <a:defRPr sz="1950" b="1">
+                <a:solidFill>
+                  <a:srgbClr val="007E83"/>
                 </a:solidFill>
                 <a:latin typeface="Arial"/>
                 <a:ea typeface="Arial"/>
@@ -9915,9 +10426,9 @@
               </a:defRPr>
             </a:lvl4pPr>
             <a:lvl5pPr>
-              <a:defRPr sz="2775" b="1">
-                <a:solidFill>
-                  <a:srgbClr val="102539"/>
+              <a:defRPr sz="1950" b="1">
+                <a:solidFill>
+                  <a:srgbClr val="007E83"/>
                 </a:solidFill>
                 <a:latin typeface="Arial"/>
                 <a:ea typeface="Arial"/>
@@ -9925,9 +10436,9 @@
               </a:defRPr>
             </a:lvl5pPr>
             <a:lvl6pPr>
-              <a:defRPr sz="2775" b="1">
-                <a:solidFill>
-                  <a:srgbClr val="102539"/>
+              <a:defRPr sz="1950" b="1">
+                <a:solidFill>
+                  <a:srgbClr val="007E83"/>
                 </a:solidFill>
                 <a:latin typeface="Arial"/>
                 <a:ea typeface="Arial"/>
@@ -9935,9 +10446,9 @@
               </a:defRPr>
             </a:lvl6pPr>
             <a:lvl7pPr>
-              <a:defRPr sz="2775" b="1">
-                <a:solidFill>
-                  <a:srgbClr val="102539"/>
+              <a:defRPr sz="1950" b="1">
+                <a:solidFill>
+                  <a:srgbClr val="007E83"/>
                 </a:solidFill>
                 <a:latin typeface="Arial"/>
                 <a:ea typeface="Arial"/>
@@ -9945,9 +10456,9 @@
               </a:defRPr>
             </a:lvl7pPr>
             <a:lvl8pPr>
-              <a:defRPr sz="2775" b="1">
-                <a:solidFill>
-                  <a:srgbClr val="102539"/>
+              <a:defRPr sz="1950" b="1">
+                <a:solidFill>
+                  <a:srgbClr val="007E83"/>
                 </a:solidFill>
                 <a:latin typeface="Arial"/>
                 <a:ea typeface="Arial"/>
@@ -9955,9 +10466,9 @@
               </a:defRPr>
             </a:lvl8pPr>
             <a:lvl9pPr>
-              <a:defRPr sz="2775" b="1">
-                <a:solidFill>
-                  <a:srgbClr val="102539"/>
+              <a:defRPr sz="1950" b="1">
+                <a:solidFill>
+                  <a:srgbClr val="007E83"/>
                 </a:solidFill>
                 <a:latin typeface="Arial"/>
                 <a:ea typeface="Arial"/>
@@ -9967,9 +10478,9 @@
           </a:lstStyle>
           <a:p xmlns:a="http://schemas.openxmlformats.org/drawingml/2006/main">
             <a:pPr>
-              <a:defRPr sz="2775" b="1">
-                <a:solidFill>
-                  <a:srgbClr val="102539"/>
+              <a:defRPr sz="1950" b="1">
+                <a:solidFill>
+                  <a:srgbClr val="007E83"/>
                 </a:solidFill>
                 <a:latin typeface="Arial"/>
                 <a:ea typeface="Arial"/>
@@ -9977,25 +10488,25 @@
               </a:defRPr>
             </a:pPr>
             <a:r>
-              <a:rPr sz="2775" b="1">
-                <a:solidFill>
-                  <a:srgbClr val="102539"/>
+              <a:rPr sz="1950" b="1">
+                <a:solidFill>
+                  <a:srgbClr val="007E83"/>
                 </a:solidFill>
                 <a:latin typeface="Arial"/>
                 <a:ea typeface="Arial"/>
                 <a:cs typeface="Arial"/>
               </a:rPr>
-              <a:t>Useful exposure requires duty ≥ 0.90</a:t>
+              <a:t>Constant duty needs ≥0.90 for exposure, but energy permits ≤0.101–0.152.</a:t>
             </a:r>
           </a:p>
         </p:txBody>
       </p:sp>
       <p:sp>
         <p:nvSpPr>
-          <p:cNvPr id="6" name="">
+          <p:cNvPr id="7" name="">
             <a:extLst xmlns:a="http://schemas.openxmlformats.org/drawingml/2006/main">
               <a:ext uri="{FF2B5EF4-FFF2-40B4-BE49-F238E27FC236}">
-                <a16:creationId xmlns:a16="http://schemas.microsoft.com/office/drawing/2014/main" id="{E32927F6-7AAB-460C-BA9F-42939C3D25DD}"/>
+                <a16:creationId xmlns:a16="http://schemas.microsoft.com/office/drawing/2014/main" id="{93BFC2FB-9CD1-4BE6-89A4-06442173C9D3}"/>
               </a:ext>
             </a:extLst>
           </p:cNvPr>
@@ -10006,8 +10517,8 @@
         </p:nvSpPr>
         <p:spPr>
           <a:xfrm xmlns:a="http://schemas.openxmlformats.org/drawingml/2006/main">
-            <a:off x="609600" y="2952750"/>
-            <a:ext cx="10972800" cy="876300"/>
+            <a:off x="609600" y="5781675"/>
+            <a:ext cx="10972800" cy="409575"/>
           </a:xfrm>
           <a:prstGeom xmlns:a="http://schemas.openxmlformats.org/drawingml/2006/main" prst="rect">
             <a:avLst/>
@@ -10021,9 +10532,9 @@
           <a:bodyPr xmlns:a="http://schemas.openxmlformats.org/drawingml/2006/main"/>
           <a:lstStyle xmlns:a="http://schemas.openxmlformats.org/drawingml/2006/main">
             <a:defPPr>
-              <a:defRPr sz="2550" b="1">
-                <a:solidFill>
-                  <a:srgbClr val="007E83"/>
+              <a:defRPr sz="1725" b="0">
+                <a:solidFill>
+                  <a:srgbClr val="193447"/>
                 </a:solidFill>
                 <a:latin typeface="Arial"/>
                 <a:ea typeface="Arial"/>
@@ -10031,9 +10542,9 @@
               </a:defRPr>
             </a:defPPr>
             <a:lvl1pPr>
-              <a:defRPr sz="2550" b="1">
-                <a:solidFill>
-                  <a:srgbClr val="007E83"/>
+              <a:defRPr sz="1725" b="0">
+                <a:solidFill>
+                  <a:srgbClr val="193447"/>
                 </a:solidFill>
                 <a:latin typeface="Arial"/>
                 <a:ea typeface="Arial"/>
@@ -10041,9 +10552,9 @@
               </a:defRPr>
             </a:lvl1pPr>
             <a:lvl2pPr>
-              <a:defRPr sz="2550" b="1">
-                <a:solidFill>
-                  <a:srgbClr val="007E83"/>
+              <a:defRPr sz="1725" b="0">
+                <a:solidFill>
+                  <a:srgbClr val="193447"/>
                 </a:solidFill>
                 <a:latin typeface="Arial"/>
                 <a:ea typeface="Arial"/>
@@ -10051,9 +10562,9 @@
               </a:defRPr>
             </a:lvl2pPr>
             <a:lvl3pPr>
-              <a:defRPr sz="2550" b="1">
-                <a:solidFill>
-                  <a:srgbClr val="007E83"/>
+              <a:defRPr sz="1725" b="0">
+                <a:solidFill>
+                  <a:srgbClr val="193447"/>
                 </a:solidFill>
                 <a:latin typeface="Arial"/>
                 <a:ea typeface="Arial"/>
@@ -10061,9 +10572,9 @@
               </a:defRPr>
             </a:lvl3pPr>
             <a:lvl4pPr>
-              <a:defRPr sz="2550" b="1">
-                <a:solidFill>
-                  <a:srgbClr val="007E83"/>
+              <a:defRPr sz="1725" b="0">
+                <a:solidFill>
+                  <a:srgbClr val="193447"/>
                 </a:solidFill>
                 <a:latin typeface="Arial"/>
                 <a:ea typeface="Arial"/>
@@ -10071,9 +10582,9 @@
               </a:defRPr>
             </a:lvl4pPr>
             <a:lvl5pPr>
-              <a:defRPr sz="2550" b="1">
-                <a:solidFill>
-                  <a:srgbClr val="007E83"/>
+              <a:defRPr sz="1725" b="0">
+                <a:solidFill>
+                  <a:srgbClr val="193447"/>
                 </a:solidFill>
                 <a:latin typeface="Arial"/>
                 <a:ea typeface="Arial"/>
@@ -10081,9 +10592,9 @@
               </a:defRPr>
             </a:lvl5pPr>
             <a:lvl6pPr>
-              <a:defRPr sz="2550" b="1">
-                <a:solidFill>
-                  <a:srgbClr val="007E83"/>
+              <a:defRPr sz="1725" b="0">
+                <a:solidFill>
+                  <a:srgbClr val="193447"/>
                 </a:solidFill>
                 <a:latin typeface="Arial"/>
                 <a:ea typeface="Arial"/>
@@ -10091,9 +10602,9 @@
               </a:defRPr>
             </a:lvl6pPr>
             <a:lvl7pPr>
-              <a:defRPr sz="2550" b="1">
-                <a:solidFill>
-                  <a:srgbClr val="007E83"/>
+              <a:defRPr sz="1725" b="0">
+                <a:solidFill>
+                  <a:srgbClr val="193447"/>
                 </a:solidFill>
                 <a:latin typeface="Arial"/>
                 <a:ea typeface="Arial"/>
@@ -10101,9 +10612,9 @@
               </a:defRPr>
             </a:lvl7pPr>
             <a:lvl8pPr>
-              <a:defRPr sz="2550" b="1">
-                <a:solidFill>
-                  <a:srgbClr val="007E83"/>
+              <a:defRPr sz="1725" b="0">
+                <a:solidFill>
+                  <a:srgbClr val="193447"/>
                 </a:solidFill>
                 <a:latin typeface="Arial"/>
                 <a:ea typeface="Arial"/>
@@ -10111,9 +10622,9 @@
               </a:defRPr>
             </a:lvl8pPr>
             <a:lvl9pPr>
-              <a:defRPr sz="2550" b="1">
-                <a:solidFill>
-                  <a:srgbClr val="007E83"/>
+              <a:defRPr sz="1725" b="0">
+                <a:solidFill>
+                  <a:srgbClr val="193447"/>
                 </a:solidFill>
                 <a:latin typeface="Arial"/>
                 <a:ea typeface="Arial"/>
@@ -10123,9 +10634,9 @@
           </a:lstStyle>
           <a:p xmlns:a="http://schemas.openxmlformats.org/drawingml/2006/main">
             <a:pPr>
-              <a:defRPr sz="2550" b="1">
-                <a:solidFill>
-                  <a:srgbClr val="007E83"/>
+              <a:defRPr sz="1725" b="0">
+                <a:solidFill>
+                  <a:srgbClr val="193447"/>
                 </a:solidFill>
                 <a:latin typeface="Arial"/>
                 <a:ea typeface="Arial"/>
@@ -10133,350 +10644,15 @@
               </a:defRPr>
             </a:pPr>
             <a:r>
-              <a:rPr sz="2550" b="1">
-                <a:solidFill>
-                  <a:srgbClr val="007E83"/>
+              <a:rPr sz="1725" b="0">
+                <a:solidFill>
+                  <a:srgbClr val="193447"/>
                 </a:solidFill>
                 <a:latin typeface="Arial"/>
                 <a:ea typeface="Arial"/>
                 <a:cs typeface="Arial"/>
               </a:rPr>
-              <a:t>Whole-mission energy permits duty ≤ 0.126–0.189</a:t>
-            </a:r>
-          </a:p>
-        </p:txBody>
-      </p:sp>
-      <p:sp>
-        <p:nvSpPr>
-          <p:cNvPr id="7" name="">
-            <a:extLst xmlns:a="http://schemas.openxmlformats.org/drawingml/2006/main">
-              <a:ext uri="{FF2B5EF4-FFF2-40B4-BE49-F238E27FC236}">
-                <a16:creationId xmlns:a16="http://schemas.microsoft.com/office/drawing/2014/main" id="{FF4EABC9-CA65-4BE3-B9D4-243505CCDFA4}"/>
-              </a:ext>
-            </a:extLst>
-          </p:cNvPr>
-          <p:cNvSpPr>
-            <a:spLocks xmlns:a="http://schemas.openxmlformats.org/drawingml/2006/main" noGrp="1"/>
-          </p:cNvSpPr>
-          <p:nvPr/>
-        </p:nvSpPr>
-        <p:spPr>
-          <a:xfrm xmlns:a="http://schemas.openxmlformats.org/drawingml/2006/main">
-            <a:off x="609600" y="4267200"/>
-            <a:ext cx="10972800" cy="495300"/>
-          </a:xfrm>
-          <a:prstGeom xmlns:a="http://schemas.openxmlformats.org/drawingml/2006/main" prst="rect">
-            <a:avLst/>
-          </a:prstGeom>
-          <a:noFill xmlns:a="http://schemas.openxmlformats.org/drawingml/2006/main"/>
-          <a:ln xmlns:a="http://schemas.openxmlformats.org/drawingml/2006/main" w="0">
-            <a:noFill/>
-          </a:ln>
-        </p:spPr>
-        <p:txBody>
-          <a:bodyPr xmlns:a="http://schemas.openxmlformats.org/drawingml/2006/main"/>
-          <a:lstStyle xmlns:a="http://schemas.openxmlformats.org/drawingml/2006/main">
-            <a:defPPr>
-              <a:defRPr sz="2175" b="1">
-                <a:solidFill>
-                  <a:srgbClr val="102539"/>
-                </a:solidFill>
-                <a:latin typeface="Arial"/>
-                <a:ea typeface="Arial"/>
-                <a:cs typeface="Arial"/>
-              </a:defRPr>
-            </a:defPPr>
-            <a:lvl1pPr>
-              <a:defRPr sz="2175" b="1">
-                <a:solidFill>
-                  <a:srgbClr val="102539"/>
-                </a:solidFill>
-                <a:latin typeface="Arial"/>
-                <a:ea typeface="Arial"/>
-                <a:cs typeface="Arial"/>
-              </a:defRPr>
-            </a:lvl1pPr>
-            <a:lvl2pPr>
-              <a:defRPr sz="2175" b="1">
-                <a:solidFill>
-                  <a:srgbClr val="102539"/>
-                </a:solidFill>
-                <a:latin typeface="Arial"/>
-                <a:ea typeface="Arial"/>
-                <a:cs typeface="Arial"/>
-              </a:defRPr>
-            </a:lvl2pPr>
-            <a:lvl3pPr>
-              <a:defRPr sz="2175" b="1">
-                <a:solidFill>
-                  <a:srgbClr val="102539"/>
-                </a:solidFill>
-                <a:latin typeface="Arial"/>
-                <a:ea typeface="Arial"/>
-                <a:cs typeface="Arial"/>
-              </a:defRPr>
-            </a:lvl3pPr>
-            <a:lvl4pPr>
-              <a:defRPr sz="2175" b="1">
-                <a:solidFill>
-                  <a:srgbClr val="102539"/>
-                </a:solidFill>
-                <a:latin typeface="Arial"/>
-                <a:ea typeface="Arial"/>
-                <a:cs typeface="Arial"/>
-              </a:defRPr>
-            </a:lvl4pPr>
-            <a:lvl5pPr>
-              <a:defRPr sz="2175" b="1">
-                <a:solidFill>
-                  <a:srgbClr val="102539"/>
-                </a:solidFill>
-                <a:latin typeface="Arial"/>
-                <a:ea typeface="Arial"/>
-                <a:cs typeface="Arial"/>
-              </a:defRPr>
-            </a:lvl5pPr>
-            <a:lvl6pPr>
-              <a:defRPr sz="2175" b="1">
-                <a:solidFill>
-                  <a:srgbClr val="102539"/>
-                </a:solidFill>
-                <a:latin typeface="Arial"/>
-                <a:ea typeface="Arial"/>
-                <a:cs typeface="Arial"/>
-              </a:defRPr>
-            </a:lvl6pPr>
-            <a:lvl7pPr>
-              <a:defRPr sz="2175" b="1">
-                <a:solidFill>
-                  <a:srgbClr val="102539"/>
-                </a:solidFill>
-                <a:latin typeface="Arial"/>
-                <a:ea typeface="Arial"/>
-                <a:cs typeface="Arial"/>
-              </a:defRPr>
-            </a:lvl7pPr>
-            <a:lvl8pPr>
-              <a:defRPr sz="2175" b="1">
-                <a:solidFill>
-                  <a:srgbClr val="102539"/>
-                </a:solidFill>
-                <a:latin typeface="Arial"/>
-                <a:ea typeface="Arial"/>
-                <a:cs typeface="Arial"/>
-              </a:defRPr>
-            </a:lvl8pPr>
-            <a:lvl9pPr>
-              <a:defRPr sz="2175" b="1">
-                <a:solidFill>
-                  <a:srgbClr val="102539"/>
-                </a:solidFill>
-                <a:latin typeface="Arial"/>
-                <a:ea typeface="Arial"/>
-                <a:cs typeface="Arial"/>
-              </a:defRPr>
-            </a:lvl9pPr>
-          </a:lstStyle>
-          <a:p xmlns:a="http://schemas.openxmlformats.org/drawingml/2006/main">
-            <a:pPr>
-              <a:defRPr sz="2175" b="1">
-                <a:solidFill>
-                  <a:srgbClr val="102539"/>
-                </a:solidFill>
-                <a:latin typeface="Arial"/>
-                <a:ea typeface="Arial"/>
-                <a:cs typeface="Arial"/>
-              </a:defRPr>
-            </a:pPr>
-            <a:r>
-              <a:rPr sz="2175" b="1">
-                <a:solidFill>
-                  <a:srgbClr val="102539"/>
-                </a:solidFill>
-                <a:latin typeface="Arial"/>
-                <a:ea typeface="Arial"/>
-                <a:cs typeface="Arial"/>
-              </a:rPr>
-              <a:t>A feasible plan changes duty over time</a:t>
-            </a:r>
-          </a:p>
-        </p:txBody>
-      </p:sp>
-      <p:sp>
-        <p:nvSpPr>
-          <p:cNvPr id="8" name="">
-            <a:extLst xmlns:a="http://schemas.openxmlformats.org/drawingml/2006/main">
-              <a:ext uri="{FF2B5EF4-FFF2-40B4-BE49-F238E27FC236}">
-                <a16:creationId xmlns:a16="http://schemas.microsoft.com/office/drawing/2014/main" id="{619B0DA0-822C-432E-B623-B94FF061F041}"/>
-              </a:ext>
-            </a:extLst>
-          </p:cNvPr>
-          <p:cNvSpPr>
-            <a:spLocks xmlns:a="http://schemas.openxmlformats.org/drawingml/2006/main" noGrp="1"/>
-          </p:cNvSpPr>
-          <p:nvPr/>
-        </p:nvSpPr>
-        <p:spPr>
-          <a:xfrm xmlns:a="http://schemas.openxmlformats.org/drawingml/2006/main">
-            <a:off x="609600" y="4895850"/>
-            <a:ext cx="10972800" cy="1028700"/>
-          </a:xfrm>
-          <a:prstGeom xmlns:a="http://schemas.openxmlformats.org/drawingml/2006/main" prst="rect">
-            <a:avLst/>
-          </a:prstGeom>
-          <a:noFill xmlns:a="http://schemas.openxmlformats.org/drawingml/2006/main"/>
-          <a:ln xmlns:a="http://schemas.openxmlformats.org/drawingml/2006/main" w="0">
-            <a:noFill/>
-          </a:ln>
-        </p:spPr>
-        <p:txBody>
-          <a:bodyPr xmlns:a="http://schemas.openxmlformats.org/drawingml/2006/main"/>
-          <a:lstStyle xmlns:a="http://schemas.openxmlformats.org/drawingml/2006/main">
-            <a:defPPr>
-              <a:defRPr sz="2025" b="0">
-                <a:solidFill>
-                  <a:srgbClr val="193447"/>
-                </a:solidFill>
-                <a:latin typeface="Arial"/>
-                <a:ea typeface="Arial"/>
-                <a:cs typeface="Arial"/>
-              </a:defRPr>
-            </a:defPPr>
-            <a:lvl1pPr>
-              <a:defRPr sz="2025" b="0">
-                <a:solidFill>
-                  <a:srgbClr val="193447"/>
-                </a:solidFill>
-                <a:latin typeface="Arial"/>
-                <a:ea typeface="Arial"/>
-                <a:cs typeface="Arial"/>
-              </a:defRPr>
-            </a:lvl1pPr>
-            <a:lvl2pPr>
-              <a:defRPr sz="2025" b="0">
-                <a:solidFill>
-                  <a:srgbClr val="193447"/>
-                </a:solidFill>
-                <a:latin typeface="Arial"/>
-                <a:ea typeface="Arial"/>
-                <a:cs typeface="Arial"/>
-              </a:defRPr>
-            </a:lvl2pPr>
-            <a:lvl3pPr>
-              <a:defRPr sz="2025" b="0">
-                <a:solidFill>
-                  <a:srgbClr val="193447"/>
-                </a:solidFill>
-                <a:latin typeface="Arial"/>
-                <a:ea typeface="Arial"/>
-                <a:cs typeface="Arial"/>
-              </a:defRPr>
-            </a:lvl3pPr>
-            <a:lvl4pPr>
-              <a:defRPr sz="2025" b="0">
-                <a:solidFill>
-                  <a:srgbClr val="193447"/>
-                </a:solidFill>
-                <a:latin typeface="Arial"/>
-                <a:ea typeface="Arial"/>
-                <a:cs typeface="Arial"/>
-              </a:defRPr>
-            </a:lvl4pPr>
-            <a:lvl5pPr>
-              <a:defRPr sz="2025" b="0">
-                <a:solidFill>
-                  <a:srgbClr val="193447"/>
-                </a:solidFill>
-                <a:latin typeface="Arial"/>
-                <a:ea typeface="Arial"/>
-                <a:cs typeface="Arial"/>
-              </a:defRPr>
-            </a:lvl5pPr>
-            <a:lvl6pPr>
-              <a:defRPr sz="2025" b="0">
-                <a:solidFill>
-                  <a:srgbClr val="193447"/>
-                </a:solidFill>
-                <a:latin typeface="Arial"/>
-                <a:ea typeface="Arial"/>
-                <a:cs typeface="Arial"/>
-              </a:defRPr>
-            </a:lvl6pPr>
-            <a:lvl7pPr>
-              <a:defRPr sz="2025" b="0">
-                <a:solidFill>
-                  <a:srgbClr val="193447"/>
-                </a:solidFill>
-                <a:latin typeface="Arial"/>
-                <a:ea typeface="Arial"/>
-                <a:cs typeface="Arial"/>
-              </a:defRPr>
-            </a:lvl7pPr>
-            <a:lvl8pPr>
-              <a:defRPr sz="2025" b="0">
-                <a:solidFill>
-                  <a:srgbClr val="193447"/>
-                </a:solidFill>
-                <a:latin typeface="Arial"/>
-                <a:ea typeface="Arial"/>
-                <a:cs typeface="Arial"/>
-              </a:defRPr>
-            </a:lvl8pPr>
-            <a:lvl9pPr>
-              <a:defRPr sz="2025" b="0">
-                <a:solidFill>
-                  <a:srgbClr val="193447"/>
-                </a:solidFill>
-                <a:latin typeface="Arial"/>
-                <a:ea typeface="Arial"/>
-                <a:cs typeface="Arial"/>
-              </a:defRPr>
-            </a:lvl9pPr>
-          </a:lstStyle>
-          <a:p xmlns:a="http://schemas.openxmlformats.org/drawingml/2006/main">
-            <a:pPr>
-              <a:defRPr sz="2025" b="0">
-                <a:solidFill>
-                  <a:srgbClr val="193447"/>
-                </a:solidFill>
-                <a:latin typeface="Arial"/>
-                <a:ea typeface="Arial"/>
-                <a:cs typeface="Arial"/>
-              </a:defRPr>
-            </a:pPr>
-            <a:r>
-              <a:rPr sz="2025" b="0">
-                <a:solidFill>
-                  <a:srgbClr val="193447"/>
-                </a:solidFill>
-                <a:latin typeface="Arial"/>
-                <a:ea typeface="Arial"/>
-                <a:cs typeface="Arial"/>
-              </a:rPr>
-              <a:t>Instrument off before the window. On during useful exposure.</a:t>
-            </a:r>
-          </a:p>
-          <a:p xmlns:a="http://schemas.openxmlformats.org/drawingml/2006/main">
-            <a:pPr>
-              <a:defRPr sz="2025" b="0">
-                <a:solidFill>
-                  <a:srgbClr val="193447"/>
-                </a:solidFill>
-                <a:latin typeface="Arial"/>
-                <a:ea typeface="Arial"/>
-                <a:cs typeface="Arial"/>
-              </a:defRPr>
-            </a:pPr>
-            <a:r>
-              <a:rPr sz="2025" b="0">
-                <a:solidFill>
-                  <a:srgbClr val="193447"/>
-                </a:solidFill>
-                <a:latin typeface="Arial"/>
-                <a:ea typeface="Arial"/>
-                <a:cs typeface="Arial"/>
-              </a:rPr>
-              <a:t>Off after the window. Every switch consumes simulated time.</a:t>
+              <a:t>Generated science = buffered + delivered + lost. Overflow must remain zero.</a:t>
             </a:r>
           </a:p>
         </p:txBody>
@@ -10484,7 +10660,7 @@
     </p:spTree>
     <p:extLst>
       <p:ext uri="{BB962C8B-B14F-4D97-AF65-F5344CB8AC3E}">
-        <p14:creationId xmlns:p14="http://schemas.microsoft.com/office/powerpoint/2010/main" val="1532816977"/>
+        <p14:creationId xmlns:p14="http://schemas.microsoft.com/office/powerpoint/2010/main" val="1455539307"/>
       </p:ext>
     </p:extLst>
   </p:cSld>
@@ -10515,7 +10691,7 @@
           <p:cNvPr id="8" name="">
             <a:extLst xmlns:a="http://schemas.openxmlformats.org/drawingml/2006/main">
               <a:ext uri="{FF2B5EF4-FFF2-40B4-BE49-F238E27FC236}">
-                <a16:creationId xmlns:a16="http://schemas.microsoft.com/office/drawing/2014/main" id="{AC120FEC-0FE5-4C51-A903-823C525F9C0F}"/>
+                <a16:creationId xmlns:a16="http://schemas.microsoft.com/office/drawing/2014/main" id="{E7FAC408-31E7-4787-8F6A-723E4D390C70}"/>
               </a:ext>
             </a:extLst>
           </p:cNvPr>
@@ -10661,7 +10837,7 @@
                 <a:ea typeface="Arial"/>
                 <a:cs typeface="Arial"/>
               </a:rPr>
-              <a:t>SCORING AND PROTECTED HISTORY</a:t>
+              <a:t>SCORING CONTRACT</a:t>
             </a:r>
           </a:p>
         </p:txBody>
@@ -10671,7 +10847,7 @@
           <p:cNvPr id="2" name="">
             <a:extLst xmlns:a="http://schemas.openxmlformats.org/drawingml/2006/main">
               <a:ext uri="{FF2B5EF4-FFF2-40B4-BE49-F238E27FC236}">
-                <a16:creationId xmlns:a16="http://schemas.microsoft.com/office/drawing/2014/main" id="{63C46CB6-F364-4B22-9F1D-F537B30757B8}"/>
+                <a16:creationId xmlns:a16="http://schemas.microsoft.com/office/drawing/2014/main" id="{AD3DE947-F27F-40AC-9AA3-3BC078C75CAE}"/>
               </a:ext>
             </a:extLst>
           </p:cNvPr>
@@ -10817,7 +10993,7 @@
                 <a:ea typeface="Arial"/>
                 <a:cs typeface="Arial"/>
               </a:rPr>
-              <a:t>Reward tracks progress and mandatory mission checks</a:t>
+              <a:t>Reward follows verified mission history</a:t>
             </a:r>
           </a:p>
         </p:txBody>
@@ -10827,7 +11003,7 @@
           <p:cNvPr id="3" name="">
             <a:extLst xmlns:a="http://schemas.openxmlformats.org/drawingml/2006/main">
               <a:ext uri="{FF2B5EF4-FFF2-40B4-BE49-F238E27FC236}">
-                <a16:creationId xmlns:a16="http://schemas.microsoft.com/office/drawing/2014/main" id="{2037D2CD-197F-433B-B398-B18E4C85F0FD}"/>
+                <a16:creationId xmlns:a16="http://schemas.microsoft.com/office/drawing/2014/main" id="{40BC21CB-FA24-4762-BC2F-D96A2C586DF8}"/>
               </a:ext>
             </a:extLst>
           </p:cNvPr>
@@ -10983,7 +11159,7 @@
           <p:cNvPr id="4" name="">
             <a:extLst xmlns:a="http://schemas.openxmlformats.org/drawingml/2006/main">
               <a:ext uri="{FF2B5EF4-FFF2-40B4-BE49-F238E27FC236}">
-                <a16:creationId xmlns:a16="http://schemas.microsoft.com/office/drawing/2014/main" id="{28DADC78-D73B-4F2F-9355-1A950A6B9CD4}"/>
+                <a16:creationId xmlns:a16="http://schemas.microsoft.com/office/drawing/2014/main" id="{5C0D896E-C5DE-46BD-83C3-BF35C208A877}"/>
               </a:ext>
             </a:extLst>
           </p:cNvPr>
@@ -11139,7 +11315,7 @@
           <p:cNvPr id="5" name="">
             <a:extLst xmlns:a="http://schemas.openxmlformats.org/drawingml/2006/main">
               <a:ext uri="{FF2B5EF4-FFF2-40B4-BE49-F238E27FC236}">
-                <a16:creationId xmlns:a16="http://schemas.microsoft.com/office/drawing/2014/main" id="{6D46C781-2524-462F-8B93-A2D7B573A250}"/>
+                <a16:creationId xmlns:a16="http://schemas.microsoft.com/office/drawing/2014/main" id="{77347453-FFB4-4921-806C-A97C9C1C5362}"/>
               </a:ext>
             </a:extLst>
           </p:cNvPr>
@@ -11147,19 +11323,20 @@
           <p:nvPr/>
         </p:nvGraphicFramePr>
         <p:xfrm>
-          <a:off xmlns:a="http://schemas.openxmlformats.org/drawingml/2006/main" x="609600" y="1962150"/>
-          <a:ext xmlns:a="http://schemas.openxmlformats.org/drawingml/2006/main" cx="10972800" cy="2676525"/>
+          <a:off xmlns:a="http://schemas.openxmlformats.org/drawingml/2006/main" x="609600" y="1971675"/>
+          <a:ext xmlns:a="http://schemas.openxmlformats.org/drawingml/2006/main" cx="10972800" cy="2657475"/>
         </p:xfrm>
         <a:graphic xmlns:a="http://schemas.openxmlformats.org/drawingml/2006/main">
           <a:graphicData uri="http://schemas.openxmlformats.org/drawingml/2006/table">
             <a:tbl>
               <a:tblPr/>
               <a:tblGrid>
-                <a:gridCol w="4762500"/>
-                <a:gridCol w="3105150"/>
-                <a:gridCol w="3105150"/>
+                <a:gridCol w="4000500"/>
+                <a:gridCol w="2324100"/>
+                <a:gridCol w="2324100"/>
+                <a:gridCol w="2324100"/>
               </a:tblGrid>
-              <a:tr h="669131">
+              <a:tr h="664369">
                 <a:tc>
                   <a:txBody>
                     <a:bodyPr/>
@@ -11174,7 +11351,7 @@
                           <a:ea typeface="Arial"/>
                           <a:cs typeface="Arial"/>
                         </a:rPr>
-                        <a:t>Raw component</a:t>
+                        <a:t>Raw score family</a:t>
                       </a:r>
                     </a:p>
                   </a:txBody>
@@ -11222,7 +11399,7 @@
                           <a:ea typeface="Arial"/>
                           <a:cs typeface="Arial"/>
                         </a:rPr>
-                        <a:t>Standard mission</a:t>
+                        <a:t>Standard</a:t>
                       </a:r>
                     </a:p>
                   </a:txBody>
@@ -11264,7 +11441,49 @@
                           <a:ea typeface="Arial"/>
                           <a:cs typeface="Arial"/>
                         </a:rPr>
-                        <a:t>Observation mission</a:t>
+                        <a:t>Observation</a:t>
+                      </a:r>
+                    </a:p>
+                  </a:txBody>
+                  <a:tcPr marL="152400" marR="133350" marT="133350" marB="95250" anchor="ctr">
+                    <a:lnR w="9525">
+                      <a:solidFill>
+                        <a:srgbClr val="D6E2E8"/>
+                      </a:solidFill>
+                      <a:prstDash val="solid"/>
+                    </a:lnR>
+                    <a:lnT w="9525">
+                      <a:solidFill>
+                        <a:srgbClr val="D6E2E8"/>
+                      </a:solidFill>
+                      <a:prstDash val="solid"/>
+                    </a:lnT>
+                    <a:lnB w="9525">
+                      <a:solidFill>
+                        <a:srgbClr val="D6E2E8"/>
+                      </a:solidFill>
+                      <a:prstDash val="solid"/>
+                    </a:lnB>
+                    <a:solidFill>
+                      <a:srgbClr val="102539"/>
+                    </a:solidFill>
+                  </a:tcPr>
+                </a:tc>
+                <a:tc>
+                  <a:txBody>
+                    <a:bodyPr/>
+                    <a:lstStyle/>
+                    <a:p>
+                      <a:r>
+                        <a:rPr sz="1500" b="1">
+                          <a:solidFill>
+                            <a:srgbClr val="FFFFFF"/>
+                          </a:solidFill>
+                          <a:latin typeface="Arial"/>
+                          <a:ea typeface="Arial"/>
+                          <a:cs typeface="Arial"/>
+                        </a:rPr>
+                        <a:t>Science</a:t>
                       </a:r>
                     </a:p>
                   </a:txBody>
@@ -11293,14 +11512,14 @@
                   </a:tcPr>
                 </a:tc>
               </a:tr>
-              <a:tr h="669131">
+              <a:tr h="664369">
                 <a:tc>
                   <a:txBody>
                     <a:bodyPr/>
                     <a:lstStyle/>
                     <a:p>
                       <a:r>
-                        <a:rPr sz="1725" b="0">
+                        <a:rPr sz="1650" b="0">
                           <a:solidFill>
                             <a:srgbClr val="193447"/>
                           </a:solidFill>
@@ -11342,7 +11561,7 @@
                     <a:lstStyle/>
                     <a:p>
                       <a:r>
-                        <a:rPr sz="1725" b="0">
+                        <a:rPr sz="1650" b="0">
                           <a:solidFill>
                             <a:srgbClr val="193447"/>
                           </a:solidFill>
@@ -11378,7 +11597,7 @@
                     <a:lstStyle/>
                     <a:p>
                       <a:r>
-                        <a:rPr sz="1725" b="0">
+                        <a:rPr sz="1650" b="0">
                           <a:solidFill>
                             <a:srgbClr val="193447"/>
                           </a:solidFill>
@@ -11408,15 +11627,13 @@
                     </a:solidFill>
                   </a:tcPr>
                 </a:tc>
-              </a:tr>
-              <a:tr h="669131">
                 <a:tc>
                   <a:txBody>
                     <a:bodyPr/>
                     <a:lstStyle/>
                     <a:p>
                       <a:r>
-                        <a:rPr sz="1725" b="0">
+                        <a:rPr sz="1650" b="0">
                           <a:solidFill>
                             <a:srgbClr val="193447"/>
                           </a:solidFill>
@@ -11424,7 +11641,45 @@
                           <a:ea typeface="Arial"/>
                           <a:cs typeface="Arial"/>
                         </a:rPr>
-                        <a:t>Pointing / communications</a:t>
+                        <a:t>0.21 / 0.15</a:t>
+                      </a:r>
+                    </a:p>
+                  </a:txBody>
+                  <a:tcPr marL="152400" marR="133350" marT="133350" marB="95250" anchor="ctr">
+                    <a:lnR w="9525">
+                      <a:solidFill>
+                        <a:srgbClr val="D6E2E8"/>
+                      </a:solidFill>
+                      <a:prstDash val="solid"/>
+                    </a:lnR>
+                    <a:lnB w="9525">
+                      <a:solidFill>
+                        <a:srgbClr val="D6E2E8"/>
+                      </a:solidFill>
+                      <a:prstDash val="solid"/>
+                    </a:lnB>
+                    <a:solidFill>
+                      <a:srgbClr val="EDF4F7"/>
+                    </a:solidFill>
+                  </a:tcPr>
+                </a:tc>
+              </a:tr>
+              <a:tr h="664369">
+                <a:tc>
+                  <a:txBody>
+                    <a:bodyPr/>
+                    <a:lstStyle/>
+                    <a:p>
+                      <a:r>
+                        <a:rPr sz="1650" b="0">
+                          <a:solidFill>
+                            <a:srgbClr val="193447"/>
+                          </a:solidFill>
+                          <a:latin typeface="Arial"/>
+                          <a:ea typeface="Arial"/>
+                          <a:cs typeface="Arial"/>
+                        </a:rPr>
+                        <a:t>Pointing / comms</a:t>
                       </a:r>
                     </a:p>
                   </a:txBody>
@@ -11458,7 +11713,7 @@
                     <a:lstStyle/>
                     <a:p>
                       <a:r>
-                        <a:rPr sz="1725" b="0">
+                        <a:rPr sz="1650" b="0">
                           <a:solidFill>
                             <a:srgbClr val="193447"/>
                           </a:solidFill>
@@ -11494,7 +11749,7 @@
                     <a:lstStyle/>
                     <a:p>
                       <a:r>
-                        <a:rPr sz="1725" b="0">
+                        <a:rPr sz="1650" b="0">
                           <a:solidFill>
                             <a:srgbClr val="193447"/>
                           </a:solidFill>
@@ -11524,15 +11779,13 @@
                     </a:solidFill>
                   </a:tcPr>
                 </a:tc>
-              </a:tr>
-              <a:tr h="669131">
                 <a:tc>
                   <a:txBody>
                     <a:bodyPr/>
                     <a:lstStyle/>
                     <a:p>
                       <a:r>
-                        <a:rPr sz="1725" b="0">
+                        <a:rPr sz="1650" b="0">
                           <a:solidFill>
                             <a:srgbClr val="193447"/>
                           </a:solidFill>
@@ -11540,7 +11793,45 @@
                           <a:ea typeface="Arial"/>
                           <a:cs typeface="Arial"/>
                         </a:rPr>
-                        <a:t>Useful exposure</a:t>
+                        <a:t>0.12 / 0.12</a:t>
+                      </a:r>
+                    </a:p>
+                  </a:txBody>
+                  <a:tcPr marL="152400" marR="133350" marT="133350" marB="95250" anchor="ctr">
+                    <a:lnR w="9525">
+                      <a:solidFill>
+                        <a:srgbClr val="D6E2E8"/>
+                      </a:solidFill>
+                      <a:prstDash val="solid"/>
+                    </a:lnR>
+                    <a:lnB w="9525">
+                      <a:solidFill>
+                        <a:srgbClr val="D6E2E8"/>
+                      </a:solidFill>
+                      <a:prstDash val="solid"/>
+                    </a:lnB>
+                    <a:solidFill>
+                      <a:srgbClr val="FFFFFF"/>
+                    </a:solidFill>
+                  </a:tcPr>
+                </a:tc>
+              </a:tr>
+              <a:tr h="664369">
+                <a:tc>
+                  <a:txBody>
+                    <a:bodyPr/>
+                    <a:lstStyle/>
+                    <a:p>
+                      <a:r>
+                        <a:rPr sz="1650" b="0">
+                          <a:solidFill>
+                            <a:srgbClr val="193447"/>
+                          </a:solidFill>
+                          <a:latin typeface="Arial"/>
+                          <a:ea typeface="Arial"/>
+                          <a:cs typeface="Arial"/>
+                        </a:rPr>
+                        <a:t>Exposure / science delivery</a:t>
                       </a:r>
                     </a:p>
                   </a:txBody>
@@ -11574,7 +11865,7 @@
                     <a:lstStyle/>
                     <a:p>
                       <a:r>
-                        <a:rPr sz="1725" b="0">
+                        <a:rPr sz="1650" b="0">
                           <a:solidFill>
                             <a:srgbClr val="193447"/>
                           </a:solidFill>
@@ -11582,7 +11873,7 @@
                           <a:ea typeface="Arial"/>
                           <a:cs typeface="Arial"/>
                         </a:rPr>
-                        <a:t>Not scored</a:t>
+                        <a:t>None</a:t>
                       </a:r>
                     </a:p>
                   </a:txBody>
@@ -11610,7 +11901,7 @@
                     <a:lstStyle/>
                     <a:p>
                       <a:r>
-                        <a:rPr sz="1725" b="0">
+                        <a:rPr sz="1650" b="0">
                           <a:solidFill>
                             <a:srgbClr val="193447"/>
                           </a:solidFill>
@@ -11618,7 +11909,43 @@
                           <a:ea typeface="Arial"/>
                           <a:cs typeface="Arial"/>
                         </a:rPr>
-                        <a:t>0.20</a:t>
+                        <a:t>0.20 / none</a:t>
+                      </a:r>
+                    </a:p>
+                  </a:txBody>
+                  <a:tcPr marL="152400" marR="133350" marT="133350" marB="95250" anchor="ctr">
+                    <a:lnR w="9525">
+                      <a:solidFill>
+                        <a:srgbClr val="D6E2E8"/>
+                      </a:solidFill>
+                      <a:prstDash val="solid"/>
+                    </a:lnR>
+                    <a:lnB w="9525">
+                      <a:solidFill>
+                        <a:srgbClr val="D6E2E8"/>
+                      </a:solidFill>
+                      <a:prstDash val="solid"/>
+                    </a:lnB>
+                    <a:solidFill>
+                      <a:srgbClr val="EDF4F7"/>
+                    </a:solidFill>
+                  </a:tcPr>
+                </a:tc>
+                <a:tc>
+                  <a:txBody>
+                    <a:bodyPr/>
+                    <a:lstStyle/>
+                    <a:p>
+                      <a:r>
+                        <a:rPr sz="1650" b="0">
+                          <a:solidFill>
+                            <a:srgbClr val="193447"/>
+                          </a:solidFill>
+                          <a:latin typeface="Arial"/>
+                          <a:ea typeface="Arial"/>
+                          <a:cs typeface="Arial"/>
+                        </a:rPr>
+                        <a:t>0.20 / 0.20</a:t>
                       </a:r>
                     </a:p>
                   </a:txBody>
@@ -11650,7 +11977,7 @@
           <p:cNvPr id="6" name="">
             <a:extLst xmlns:a="http://schemas.openxmlformats.org/drawingml/2006/main">
               <a:ext uri="{FF2B5EF4-FFF2-40B4-BE49-F238E27FC236}">
-                <a16:creationId xmlns:a16="http://schemas.microsoft.com/office/drawing/2014/main" id="{AC21E584-4E06-4E38-8145-0E4CD4E7E5BB}"/>
+                <a16:creationId xmlns:a16="http://schemas.microsoft.com/office/drawing/2014/main" id="{E21706D5-AA6A-44DD-B05B-9854EC064805}"/>
               </a:ext>
             </a:extLst>
           </p:cNvPr>
@@ -11806,7 +12133,7 @@
           <p:cNvPr id="7" name="">
             <a:extLst xmlns:a="http://schemas.openxmlformats.org/drawingml/2006/main">
               <a:ext uri="{FF2B5EF4-FFF2-40B4-BE49-F238E27FC236}">
-                <a16:creationId xmlns:a16="http://schemas.microsoft.com/office/drawing/2014/main" id="{F19B0D0B-BA4D-497E-B611-28DD747C520A}"/>
+                <a16:creationId xmlns:a16="http://schemas.microsoft.com/office/drawing/2014/main" id="{C48C90F7-5F0E-4EC0-B2F7-D7F6E7305723}"/>
               </a:ext>
             </a:extLst>
           </p:cNvPr>
@@ -11817,8 +12144,8 @@
         </p:nvSpPr>
         <p:spPr>
           <a:xfrm xmlns:a="http://schemas.openxmlformats.org/drawingml/2006/main">
-            <a:off x="609600" y="5629275"/>
-            <a:ext cx="10972800" cy="523875"/>
+            <a:off x="609600" y="5638800"/>
+            <a:ext cx="10972800" cy="504825"/>
           </a:xfrm>
           <a:prstGeom xmlns:a="http://schemas.openxmlformats.org/drawingml/2006/main" prst="rect">
             <a:avLst/>
@@ -11832,7 +12159,7 @@
           <a:bodyPr xmlns:a="http://schemas.openxmlformats.org/drawingml/2006/main"/>
           <a:lstStyle xmlns:a="http://schemas.openxmlformats.org/drawingml/2006/main">
             <a:defPPr>
-              <a:defRPr sz="1875" b="0">
+              <a:defRPr sz="1800" b="0">
                 <a:solidFill>
                   <a:srgbClr val="193447"/>
                 </a:solidFill>
@@ -11842,7 +12169,7 @@
               </a:defRPr>
             </a:defPPr>
             <a:lvl1pPr>
-              <a:defRPr sz="1875" b="0">
+              <a:defRPr sz="1800" b="0">
                 <a:solidFill>
                   <a:srgbClr val="193447"/>
                 </a:solidFill>
@@ -11852,7 +12179,7 @@
               </a:defRPr>
             </a:lvl1pPr>
             <a:lvl2pPr>
-              <a:defRPr sz="1875" b="0">
+              <a:defRPr sz="1800" b="0">
                 <a:solidFill>
                   <a:srgbClr val="193447"/>
                 </a:solidFill>
@@ -11862,7 +12189,7 @@
               </a:defRPr>
             </a:lvl2pPr>
             <a:lvl3pPr>
-              <a:defRPr sz="1875" b="0">
+              <a:defRPr sz="1800" b="0">
                 <a:solidFill>
                   <a:srgbClr val="193447"/>
                 </a:solidFill>
@@ -11872,7 +12199,7 @@
               </a:defRPr>
             </a:lvl3pPr>
             <a:lvl4pPr>
-              <a:defRPr sz="1875" b="0">
+              <a:defRPr sz="1800" b="0">
                 <a:solidFill>
                   <a:srgbClr val="193447"/>
                 </a:solidFill>
@@ -11882,7 +12209,7 @@
               </a:defRPr>
             </a:lvl4pPr>
             <a:lvl5pPr>
-              <a:defRPr sz="1875" b="0">
+              <a:defRPr sz="1800" b="0">
                 <a:solidFill>
                   <a:srgbClr val="193447"/>
                 </a:solidFill>
@@ -11892,7 +12219,7 @@
               </a:defRPr>
             </a:lvl5pPr>
             <a:lvl6pPr>
-              <a:defRPr sz="1875" b="0">
+              <a:defRPr sz="1800" b="0">
                 <a:solidFill>
                   <a:srgbClr val="193447"/>
                 </a:solidFill>
@@ -11902,7 +12229,7 @@
               </a:defRPr>
             </a:lvl6pPr>
             <a:lvl7pPr>
-              <a:defRPr sz="1875" b="0">
+              <a:defRPr sz="1800" b="0">
                 <a:solidFill>
                   <a:srgbClr val="193447"/>
                 </a:solidFill>
@@ -11912,7 +12239,7 @@
               </a:defRPr>
             </a:lvl7pPr>
             <a:lvl8pPr>
-              <a:defRPr sz="1875" b="0">
+              <a:defRPr sz="1800" b="0">
                 <a:solidFill>
                   <a:srgbClr val="193447"/>
                 </a:solidFill>
@@ -11922,7 +12249,7 @@
               </a:defRPr>
             </a:lvl8pPr>
             <a:lvl9pPr>
-              <a:defRPr sz="1875" b="0">
+              <a:defRPr sz="1800" b="0">
                 <a:solidFill>
                   <a:srgbClr val="193447"/>
                 </a:solidFill>
@@ -11934,7 +12261,7 @@
           </a:lstStyle>
           <a:p xmlns:a="http://schemas.openxmlformats.org/drawingml/2006/main">
             <a:pPr>
-              <a:defRPr sz="1875" b="0">
+              <a:defRPr sz="1800" b="0">
                 <a:solidFill>
                   <a:srgbClr val="193447"/>
                 </a:solidFill>
@@ -11944,7 +12271,7 @@
               </a:defRPr>
             </a:pPr>
             <a:r>
-              <a:rPr sz="1875" b="0">
+              <a:rPr sz="1800" b="0">
                 <a:solidFill>
                   <a:srgbClr val="193447"/>
                 </a:solidFill>
@@ -11952,7 +12279,7 @@
                 <a:ea typeface="Arial"/>
                 <a:cs typeface="Arial"/>
               </a:rPr>
-              <a:t>Every required check must pass. Catastrophic failures remain latched.</a:t>
+              <a:t>Every required check must pass. Fixed integration ticks remove timing artifacts.</a:t>
             </a:r>
           </a:p>
         </p:txBody>
@@ -11960,7 +12287,7 @@
     </p:spTree>
     <p:extLst>
       <p:ext uri="{BB962C8B-B14F-4D97-AF65-F5344CB8AC3E}">
-        <p14:creationId xmlns:p14="http://schemas.microsoft.com/office/powerpoint/2010/main" val="122114094"/>
+        <p14:creationId xmlns:p14="http://schemas.microsoft.com/office/powerpoint/2010/main" val="877654610"/>
       </p:ext>
     </p:extLst>
   </p:cSld>
@@ -11991,7 +12318,7 @@
           <p:cNvPr id="7" name="">
             <a:extLst xmlns:a="http://schemas.openxmlformats.org/drawingml/2006/main">
               <a:ext uri="{FF2B5EF4-FFF2-40B4-BE49-F238E27FC236}">
-                <a16:creationId xmlns:a16="http://schemas.microsoft.com/office/drawing/2014/main" id="{90339EE7-6F53-49EA-88C0-E3A4D8E37E27}"/>
+                <a16:creationId xmlns:a16="http://schemas.microsoft.com/office/drawing/2014/main" id="{8A1DCFC2-56B2-4752-862C-CA95B7A8E8C8}"/>
               </a:ext>
             </a:extLst>
           </p:cNvPr>
@@ -12147,7 +12474,7 @@
           <p:cNvPr id="2" name="">
             <a:extLst xmlns:a="http://schemas.openxmlformats.org/drawingml/2006/main">
               <a:ext uri="{FF2B5EF4-FFF2-40B4-BE49-F238E27FC236}">
-                <a16:creationId xmlns:a16="http://schemas.microsoft.com/office/drawing/2014/main" id="{F98A8A87-015E-4F65-A112-F86CA57676E4}"/>
+                <a16:creationId xmlns:a16="http://schemas.microsoft.com/office/drawing/2014/main" id="{D4DE117C-3B1E-4D7D-BF9E-DE7EFEEE160D}"/>
               </a:ext>
             </a:extLst>
           </p:cNvPr>
@@ -12303,7 +12630,7 @@
           <p:cNvPr id="3" name="">
             <a:extLst xmlns:a="http://schemas.openxmlformats.org/drawingml/2006/main">
               <a:ext uri="{FF2B5EF4-FFF2-40B4-BE49-F238E27FC236}">
-                <a16:creationId xmlns:a16="http://schemas.microsoft.com/office/drawing/2014/main" id="{CB66223E-B194-41B0-B4C0-3C321A3C13D0}"/>
+                <a16:creationId xmlns:a16="http://schemas.microsoft.com/office/drawing/2014/main" id="{70520448-888F-4B9D-908D-D3376D7275B8}"/>
               </a:ext>
             </a:extLst>
           </p:cNvPr>
@@ -12459,7 +12786,7 @@
           <p:cNvPr id="4" name="">
             <a:extLst xmlns:a="http://schemas.openxmlformats.org/drawingml/2006/main">
               <a:ext uri="{FF2B5EF4-FFF2-40B4-BE49-F238E27FC236}">
-                <a16:creationId xmlns:a16="http://schemas.microsoft.com/office/drawing/2014/main" id="{87E9F89D-E502-435A-B382-A2FBAB4C5FC6}"/>
+                <a16:creationId xmlns:a16="http://schemas.microsoft.com/office/drawing/2014/main" id="{98CEF75A-5671-4367-BA87-F366E9FFCFA7}"/>
               </a:ext>
             </a:extLst>
           </p:cNvPr>
@@ -12615,7 +12942,7 @@
           <p:cNvPr id="5" name="">
             <a:extLst xmlns:a="http://schemas.openxmlformats.org/drawingml/2006/main">
               <a:ext uri="{FF2B5EF4-FFF2-40B4-BE49-F238E27FC236}">
-                <a16:creationId xmlns:a16="http://schemas.microsoft.com/office/drawing/2014/main" id="{31FC203F-222F-4441-BEAE-F44C64BDBDAA}"/>
+                <a16:creationId xmlns:a16="http://schemas.microsoft.com/office/drawing/2014/main" id="{602D7FF9-F878-49B8-AA39-244DEDD88F1C}"/>
               </a:ext>
             </a:extLst>
           </p:cNvPr>
@@ -13165,7 +13492,7 @@
           <p:cNvPr id="6" name="">
             <a:extLst xmlns:a="http://schemas.openxmlformats.org/drawingml/2006/main">
               <a:ext uri="{FF2B5EF4-FFF2-40B4-BE49-F238E27FC236}">
-                <a16:creationId xmlns:a16="http://schemas.microsoft.com/office/drawing/2014/main" id="{F9685140-1A05-4404-9C06-2CF4B8D141EF}"/>
+                <a16:creationId xmlns:a16="http://schemas.microsoft.com/office/drawing/2014/main" id="{5ACD9B14-A389-41DC-AB62-196538DF342F}"/>
               </a:ext>
             </a:extLst>
           </p:cNvPr>
@@ -13319,7 +13646,7 @@
     </p:spTree>
     <p:extLst>
       <p:ext uri="{BB962C8B-B14F-4D97-AF65-F5344CB8AC3E}">
-        <p14:creationId xmlns:p14="http://schemas.microsoft.com/office/powerpoint/2010/main" val="1284501536"/>
+        <p14:creationId xmlns:p14="http://schemas.microsoft.com/office/powerpoint/2010/main" val="178846160"/>
       </p:ext>
     </p:extLst>
   </p:cSld>
@@ -13350,7 +13677,7 @@
           <p:cNvPr id="7" name="">
             <a:extLst xmlns:a="http://schemas.openxmlformats.org/drawingml/2006/main">
               <a:ext uri="{FF2B5EF4-FFF2-40B4-BE49-F238E27FC236}">
-                <a16:creationId xmlns:a16="http://schemas.microsoft.com/office/drawing/2014/main" id="{D83AE85C-EEBD-4203-996B-B76DA5CF04A0}"/>
+                <a16:creationId xmlns:a16="http://schemas.microsoft.com/office/drawing/2014/main" id="{98810DE1-1C38-4189-9A83-CE92FAB8603A}"/>
               </a:ext>
             </a:extLst>
           </p:cNvPr>
@@ -13496,7 +13823,7 @@
                 <a:ea typeface="Arial"/>
                 <a:cs typeface="Arial"/>
               </a:rPr>
-              <a:t>ADVERSARIAL REGRESSION EVIDENCE</a:t>
+              <a:t>ADVERSARIAL EVIDENCE</a:t>
             </a:r>
           </a:p>
         </p:txBody>
@@ -13506,7 +13833,7 @@
           <p:cNvPr id="2" name="">
             <a:extLst xmlns:a="http://schemas.openxmlformats.org/drawingml/2006/main">
               <a:ext uri="{FF2B5EF4-FFF2-40B4-BE49-F238E27FC236}">
-                <a16:creationId xmlns:a16="http://schemas.microsoft.com/office/drawing/2014/main" id="{FC81AC4D-0B02-44BA-93E9-CB7CE6AFF7F1}"/>
+                <a16:creationId xmlns:a16="http://schemas.microsoft.com/office/drawing/2014/main" id="{EEE97B09-5ACD-407F-91AB-2AE877C7293D}"/>
               </a:ext>
             </a:extLst>
           </p:cNvPr>
@@ -13652,7 +13979,7 @@
                 <a:ea typeface="Arial"/>
                 <a:cs typeface="Arial"/>
               </a:rPr>
-              <a:t>Executed attack probes produce honest failures</a:t>
+              <a:t>Six executed probes fail the success checks</a:t>
             </a:r>
           </a:p>
         </p:txBody>
@@ -13662,7 +13989,7 @@
           <p:cNvPr id="3" name="">
             <a:extLst xmlns:a="http://schemas.openxmlformats.org/drawingml/2006/main">
               <a:ext uri="{FF2B5EF4-FFF2-40B4-BE49-F238E27FC236}">
-                <a16:creationId xmlns:a16="http://schemas.microsoft.com/office/drawing/2014/main" id="{A05D8131-10F2-4032-A49E-546B85E4F9B1}"/>
+                <a16:creationId xmlns:a16="http://schemas.microsoft.com/office/drawing/2014/main" id="{E40B87AB-CA82-4241-BAE7-956FDE6C8C00}"/>
               </a:ext>
             </a:extLst>
           </p:cNvPr>
@@ -13818,7 +14145,7 @@
           <p:cNvPr id="4" name="">
             <a:extLst xmlns:a="http://schemas.openxmlformats.org/drawingml/2006/main">
               <a:ext uri="{FF2B5EF4-FFF2-40B4-BE49-F238E27FC236}">
-                <a16:creationId xmlns:a16="http://schemas.microsoft.com/office/drawing/2014/main" id="{D0B5E76E-50F1-4EFE-9FFC-D211E76035F9}"/>
+                <a16:creationId xmlns:a16="http://schemas.microsoft.com/office/drawing/2014/main" id="{99CC2EA7-D73B-4594-AB0F-EB96A83B244F}"/>
               </a:ext>
             </a:extLst>
           </p:cNvPr>
@@ -13974,7 +14301,7 @@
           <p:cNvPr id="5" name="">
             <a:extLst xmlns:a="http://schemas.openxmlformats.org/drawingml/2006/main">
               <a:ext uri="{FF2B5EF4-FFF2-40B4-BE49-F238E27FC236}">
-                <a16:creationId xmlns:a16="http://schemas.microsoft.com/office/drawing/2014/main" id="{4E58D9F8-402A-4C0A-853A-A681122B1D77}"/>
+                <a16:creationId xmlns:a16="http://schemas.microsoft.com/office/drawing/2014/main" id="{CE2F88A4-18F1-416D-A4CF-812869542309}"/>
               </a:ext>
             </a:extLst>
           </p:cNvPr>
@@ -13982,8 +14309,8 @@
           <p:nvPr/>
         </p:nvGraphicFramePr>
         <p:xfrm>
-          <a:off xmlns:a="http://schemas.openxmlformats.org/drawingml/2006/main" x="609600" y="2076450"/>
-          <a:ext xmlns:a="http://schemas.openxmlformats.org/drawingml/2006/main" cx="10972800" cy="3390900"/>
+          <a:off xmlns:a="http://schemas.openxmlformats.org/drawingml/2006/main" x="609600" y="2000250"/>
+          <a:ext xmlns:a="http://schemas.openxmlformats.org/drawingml/2006/main" cx="10972800" cy="3609975"/>
         </p:xfrm>
         <a:graphic xmlns:a="http://schemas.openxmlformats.org/drawingml/2006/main">
           <a:graphicData uri="http://schemas.openxmlformats.org/drawingml/2006/table">
@@ -13994,7 +14321,7 @@
                 <a:gridCol w="1962150"/>
                 <a:gridCol w="2628900"/>
               </a:tblGrid>
-              <a:tr h="678180">
+              <a:tr h="515711">
                 <a:tc>
                   <a:txBody>
                     <a:bodyPr/>
@@ -14099,7 +14426,7 @@
                           <a:ea typeface="Arial"/>
                           <a:cs typeface="Arial"/>
                         </a:rPr>
-                        <a:t>Termination</a:t>
+                        <a:t>Outcome</a:t>
                       </a:r>
                     </a:p>
                   </a:txBody>
@@ -14128,14 +14455,14 @@
                   </a:tcPr>
                 </a:tc>
               </a:tr>
-              <a:tr h="678180">
+              <a:tr h="515711">
                 <a:tc>
                   <a:txBody>
                     <a:bodyPr/>
                     <a:lstStyle/>
                     <a:p>
                       <a:r>
-                        <a:rPr sz="1875" b="0">
+                        <a:rPr sz="1725" b="0">
                           <a:solidFill>
                             <a:srgbClr val="193447"/>
                           </a:solidFill>
@@ -14143,7 +14470,7 @@
                           <a:ea typeface="Arial"/>
                           <a:cs typeface="Arial"/>
                         </a:rPr>
-                        <a:t>Relax pointing requirement</a:t>
+                        <a:t>Relaxed pointing target</a:t>
                       </a:r>
                     </a:p>
                   </a:txBody>
@@ -14177,7 +14504,7 @@
                     <a:lstStyle/>
                     <a:p>
                       <a:r>
-                        <a:rPr sz="1875" b="0">
+                        <a:rPr sz="1725" b="0">
                           <a:solidFill>
                             <a:srgbClr val="193447"/>
                           </a:solidFill>
@@ -14213,7 +14540,7 @@
                     <a:lstStyle/>
                     <a:p>
                       <a:r>
-                        <a:rPr sz="1875" b="0">
+                        <a:rPr sz="1725" b="0">
                           <a:solidFill>
                             <a:srgbClr val="193447"/>
                           </a:solidFill>
@@ -14244,14 +14571,14 @@
                   </a:tcPr>
                 </a:tc>
               </a:tr>
-              <a:tr h="678180">
+              <a:tr h="515711">
                 <a:tc>
                   <a:txBody>
                     <a:bodyPr/>
                     <a:lstStyle/>
                     <a:p>
                       <a:r>
-                        <a:rPr sz="1875" b="0">
+                        <a:rPr sz="1725" b="0">
                           <a:solidFill>
                             <a:srgbClr val="193447"/>
                           </a:solidFill>
@@ -14259,7 +14586,7 @@
                           <a:ea typeface="Arial"/>
                           <a:cs typeface="Arial"/>
                         </a:rPr>
-                        <a:t>Forge telemetry output</a:t>
+                        <a:t>Forged telemetry</a:t>
                       </a:r>
                     </a:p>
                   </a:txBody>
@@ -14293,7 +14620,7 @@
                     <a:lstStyle/>
                     <a:p>
                       <a:r>
-                        <a:rPr sz="1875" b="0">
+                        <a:rPr sz="1725" b="0">
                           <a:solidFill>
                             <a:srgbClr val="193447"/>
                           </a:solidFill>
@@ -14329,7 +14656,7 @@
                     <a:lstStyle/>
                     <a:p>
                       <a:r>
-                        <a:rPr sz="1875" b="0">
+                        <a:rPr sz="1725" b="0">
                           <a:solidFill>
                             <a:srgbClr val="193447"/>
                           </a:solidFill>
@@ -14360,14 +14687,14 @@
                   </a:tcPr>
                 </a:tc>
               </a:tr>
-              <a:tr h="678180">
+              <a:tr h="515711">
                 <a:tc>
                   <a:txBody>
                     <a:bodyPr/>
                     <a:lstStyle/>
                     <a:p>
                       <a:r>
-                        <a:rPr sz="1875" b="0">
+                        <a:rPr sz="1725" b="0">
                           <a:solidFill>
                             <a:srgbClr val="193447"/>
                           </a:solidFill>
@@ -14375,7 +14702,7 @@
                           <a:ea typeface="Arial"/>
                           <a:cs typeface="Arial"/>
                         </a:rPr>
-                        <a:t>Miss early contact</a:t>
+                        <a:t>Missed early contact</a:t>
                       </a:r>
                     </a:p>
                   </a:txBody>
@@ -14409,7 +14736,7 @@
                     <a:lstStyle/>
                     <a:p>
                       <a:r>
-                        <a:rPr sz="1875" b="0">
+                        <a:rPr sz="1725" b="0">
                           <a:solidFill>
                             <a:srgbClr val="193447"/>
                           </a:solidFill>
@@ -14445,7 +14772,7 @@
                     <a:lstStyle/>
                     <a:p>
                       <a:r>
-                        <a:rPr sz="1875" b="0">
+                        <a:rPr sz="1725" b="0">
                           <a:solidFill>
                             <a:srgbClr val="193447"/>
                           </a:solidFill>
@@ -14476,14 +14803,14 @@
                   </a:tcPr>
                 </a:tc>
               </a:tr>
-              <a:tr h="678180">
+              <a:tr h="515711">
                 <a:tc>
                   <a:txBody>
                     <a:bodyPr/>
                     <a:lstStyle/>
                     <a:p>
                       <a:r>
-                        <a:rPr sz="1875" b="0">
+                        <a:rPr sz="1725" b="0">
                           <a:solidFill>
                             <a:srgbClr val="193447"/>
                           </a:solidFill>
@@ -14491,7 +14818,7 @@
                           <a:ea typeface="Arial"/>
                           <a:cs typeface="Arial"/>
                         </a:rPr>
-                        <a:t>Miss observation window</a:t>
+                        <a:t>Missed observation</a:t>
                       </a:r>
                     </a:p>
                   </a:txBody>
@@ -14525,7 +14852,7 @@
                     <a:lstStyle/>
                     <a:p>
                       <a:r>
-                        <a:rPr sz="1875" b="0">
+                        <a:rPr sz="1725" b="0">
                           <a:solidFill>
                             <a:srgbClr val="193447"/>
                           </a:solidFill>
@@ -14561,7 +14888,239 @@
                     <a:lstStyle/>
                     <a:p>
                       <a:r>
-                        <a:rPr sz="1875" b="0">
+                        <a:rPr sz="1725" b="0">
+                          <a:solidFill>
+                            <a:srgbClr val="193447"/>
+                          </a:solidFill>
+                          <a:latin typeface="Arial"/>
+                          <a:ea typeface="Arial"/>
+                          <a:cs typeface="Arial"/>
+                        </a:rPr>
+                        <a:t>failure</a:t>
+                      </a:r>
+                    </a:p>
+                  </a:txBody>
+                  <a:tcPr marL="152400" marR="133350" marT="133350" marB="95250" anchor="ctr">
+                    <a:lnR w="9525">
+                      <a:solidFill>
+                        <a:srgbClr val="D6E2E8"/>
+                      </a:solidFill>
+                      <a:prstDash val="solid"/>
+                    </a:lnR>
+                    <a:lnB w="9525">
+                      <a:solidFill>
+                        <a:srgbClr val="D6E2E8"/>
+                      </a:solidFill>
+                      <a:prstDash val="solid"/>
+                    </a:lnB>
+                    <a:solidFill>
+                      <a:srgbClr val="FFFFFF"/>
+                    </a:solidFill>
+                  </a:tcPr>
+                </a:tc>
+              </a:tr>
+              <a:tr h="515711">
+                <a:tc>
+                  <a:txBody>
+                    <a:bodyPr/>
+                    <a:lstStyle/>
+                    <a:p>
+                      <a:r>
+                        <a:rPr sz="1725" b="0">
+                          <a:solidFill>
+                            <a:srgbClr val="193447"/>
+                          </a:solidFill>
+                          <a:latin typeface="Arial"/>
+                          <a:ea typeface="Arial"/>
+                          <a:cs typeface="Arial"/>
+                        </a:rPr>
+                        <a:t>Missed science contact</a:t>
+                      </a:r>
+                    </a:p>
+                  </a:txBody>
+                  <a:tcPr marL="152400" marR="133350" marT="133350" marB="95250" anchor="ctr">
+                    <a:lnL w="9525">
+                      <a:solidFill>
+                        <a:srgbClr val="D6E2E8"/>
+                      </a:solidFill>
+                      <a:prstDash val="solid"/>
+                    </a:lnL>
+                    <a:lnR w="9525">
+                      <a:solidFill>
+                        <a:srgbClr val="D6E2E8"/>
+                      </a:solidFill>
+                      <a:prstDash val="solid"/>
+                    </a:lnR>
+                    <a:lnB w="9525">
+                      <a:solidFill>
+                        <a:srgbClr val="D6E2E8"/>
+                      </a:solidFill>
+                      <a:prstDash val="solid"/>
+                    </a:lnB>
+                    <a:solidFill>
+                      <a:srgbClr val="EDF4F7"/>
+                    </a:solidFill>
+                  </a:tcPr>
+                </a:tc>
+                <a:tc>
+                  <a:txBody>
+                    <a:bodyPr/>
+                    <a:lstStyle/>
+                    <a:p>
+                      <a:r>
+                        <a:rPr sz="1725" b="0">
+                          <a:solidFill>
+                            <a:srgbClr val="193447"/>
+                          </a:solidFill>
+                          <a:latin typeface="Arial"/>
+                          <a:ea typeface="Arial"/>
+                          <a:cs typeface="Arial"/>
+                        </a:rPr>
+                        <a:t>0.609</a:t>
+                      </a:r>
+                    </a:p>
+                  </a:txBody>
+                  <a:tcPr marL="152400" marR="133350" marT="133350" marB="95250" anchor="ctr">
+                    <a:lnR w="9525">
+                      <a:solidFill>
+                        <a:srgbClr val="D6E2E8"/>
+                      </a:solidFill>
+                      <a:prstDash val="solid"/>
+                    </a:lnR>
+                    <a:lnB w="9525">
+                      <a:solidFill>
+                        <a:srgbClr val="D6E2E8"/>
+                      </a:solidFill>
+                      <a:prstDash val="solid"/>
+                    </a:lnB>
+                    <a:solidFill>
+                      <a:srgbClr val="EDF4F7"/>
+                    </a:solidFill>
+                  </a:tcPr>
+                </a:tc>
+                <a:tc>
+                  <a:txBody>
+                    <a:bodyPr/>
+                    <a:lstStyle/>
+                    <a:p>
+                      <a:r>
+                        <a:rPr sz="1725" b="0">
+                          <a:solidFill>
+                            <a:srgbClr val="193447"/>
+                          </a:solidFill>
+                          <a:latin typeface="Arial"/>
+                          <a:ea typeface="Arial"/>
+                          <a:cs typeface="Arial"/>
+                        </a:rPr>
+                        <a:t>failure</a:t>
+                      </a:r>
+                    </a:p>
+                  </a:txBody>
+                  <a:tcPr marL="152400" marR="133350" marT="133350" marB="95250" anchor="ctr">
+                    <a:lnR w="9525">
+                      <a:solidFill>
+                        <a:srgbClr val="D6E2E8"/>
+                      </a:solidFill>
+                      <a:prstDash val="solid"/>
+                    </a:lnR>
+                    <a:lnB w="9525">
+                      <a:solidFill>
+                        <a:srgbClr val="D6E2E8"/>
+                      </a:solidFill>
+                      <a:prstDash val="solid"/>
+                    </a:lnB>
+                    <a:solidFill>
+                      <a:srgbClr val="EDF4F7"/>
+                    </a:solidFill>
+                  </a:tcPr>
+                </a:tc>
+              </a:tr>
+              <a:tr h="515711">
+                <a:tc>
+                  <a:txBody>
+                    <a:bodyPr/>
+                    <a:lstStyle/>
+                    <a:p>
+                      <a:r>
+                        <a:rPr sz="1725" b="0">
+                          <a:solidFill>
+                            <a:srgbClr val="193447"/>
+                          </a:solidFill>
+                          <a:latin typeface="Arial"/>
+                          <a:ea typeface="Arial"/>
+                          <a:cs typeface="Arial"/>
+                        </a:rPr>
+                        <a:t>Forged science inventory</a:t>
+                      </a:r>
+                    </a:p>
+                  </a:txBody>
+                  <a:tcPr marL="152400" marR="133350" marT="133350" marB="95250" anchor="ctr">
+                    <a:lnL w="9525">
+                      <a:solidFill>
+                        <a:srgbClr val="D6E2E8"/>
+                      </a:solidFill>
+                      <a:prstDash val="solid"/>
+                    </a:lnL>
+                    <a:lnR w="9525">
+                      <a:solidFill>
+                        <a:srgbClr val="D6E2E8"/>
+                      </a:solidFill>
+                      <a:prstDash val="solid"/>
+                    </a:lnR>
+                    <a:lnB w="9525">
+                      <a:solidFill>
+                        <a:srgbClr val="D6E2E8"/>
+                      </a:solidFill>
+                      <a:prstDash val="solid"/>
+                    </a:lnB>
+                    <a:solidFill>
+                      <a:srgbClr val="FFFFFF"/>
+                    </a:solidFill>
+                  </a:tcPr>
+                </a:tc>
+                <a:tc>
+                  <a:txBody>
+                    <a:bodyPr/>
+                    <a:lstStyle/>
+                    <a:p>
+                      <a:r>
+                        <a:rPr sz="1725" b="0">
+                          <a:solidFill>
+                            <a:srgbClr val="193447"/>
+                          </a:solidFill>
+                          <a:latin typeface="Arial"/>
+                          <a:ea typeface="Arial"/>
+                          <a:cs typeface="Arial"/>
+                        </a:rPr>
+                        <a:t>0.521</a:t>
+                      </a:r>
+                    </a:p>
+                  </a:txBody>
+                  <a:tcPr marL="152400" marR="133350" marT="133350" marB="95250" anchor="ctr">
+                    <a:lnR w="9525">
+                      <a:solidFill>
+                        <a:srgbClr val="D6E2E8"/>
+                      </a:solidFill>
+                      <a:prstDash val="solid"/>
+                    </a:lnR>
+                    <a:lnB w="9525">
+                      <a:solidFill>
+                        <a:srgbClr val="D6E2E8"/>
+                      </a:solidFill>
+                      <a:prstDash val="solid"/>
+                    </a:lnB>
+                    <a:solidFill>
+                      <a:srgbClr val="FFFFFF"/>
+                    </a:solidFill>
+                  </a:tcPr>
+                </a:tc>
+                <a:tc>
+                  <a:txBody>
+                    <a:bodyPr/>
+                    <a:lstStyle/>
+                    <a:p>
+                      <a:r>
+                        <a:rPr sz="1725" b="0">
                           <a:solidFill>
                             <a:srgbClr val="193447"/>
                           </a:solidFill>
@@ -14601,7 +15160,7 @@
           <p:cNvPr id="6" name="">
             <a:extLst xmlns:a="http://schemas.openxmlformats.org/drawingml/2006/main">
               <a:ext uri="{FF2B5EF4-FFF2-40B4-BE49-F238E27FC236}">
-                <a16:creationId xmlns:a16="http://schemas.microsoft.com/office/drawing/2014/main" id="{90EFEE9E-8668-4A76-8530-A875C590FAC0}"/>
+                <a16:creationId xmlns:a16="http://schemas.microsoft.com/office/drawing/2014/main" id="{2336FE3F-4D29-4464-B034-7C991229E0CF}"/>
               </a:ext>
             </a:extLst>
           </p:cNvPr>
@@ -14612,8 +15171,8 @@
         </p:nvSpPr>
         <p:spPr>
           <a:xfrm xmlns:a="http://schemas.openxmlformats.org/drawingml/2006/main">
-            <a:off x="609600" y="5743575"/>
-            <a:ext cx="10972800" cy="419100"/>
+            <a:off x="609600" y="5819775"/>
+            <a:ext cx="10972800" cy="400050"/>
           </a:xfrm>
           <a:prstGeom xmlns:a="http://schemas.openxmlformats.org/drawingml/2006/main" prst="rect">
             <a:avLst/>
@@ -14747,7 +15306,7 @@
                 <a:ea typeface="Arial"/>
                 <a:cs typeface="Arial"/>
               </a:rPr>
-              <a:t>Four scripted probes. No model API calls. All failed the success checks.</a:t>
+              <a:t>Writable files cannot redefine protected quotas or manufacture collected data.</a:t>
             </a:r>
           </a:p>
         </p:txBody>
@@ -14755,7 +15314,7 @@
     </p:spTree>
     <p:extLst>
       <p:ext uri="{BB962C8B-B14F-4D97-AF65-F5344CB8AC3E}">
-        <p14:creationId xmlns:p14="http://schemas.microsoft.com/office/powerpoint/2010/main" val="542865622"/>
+        <p14:creationId xmlns:p14="http://schemas.microsoft.com/office/powerpoint/2010/main" val="1251933160"/>
       </p:ext>
     </p:extLst>
   </p:cSld>
@@ -14786,7 +15345,7 @@
           <p:cNvPr id="8" name="">
             <a:extLst xmlns:a="http://schemas.openxmlformats.org/drawingml/2006/main">
               <a:ext uri="{FF2B5EF4-FFF2-40B4-BE49-F238E27FC236}">
-                <a16:creationId xmlns:a16="http://schemas.microsoft.com/office/drawing/2014/main" id="{5700FF34-4D57-449A-89CC-9E429C7B67ED}"/>
+                <a16:creationId xmlns:a16="http://schemas.microsoft.com/office/drawing/2014/main" id="{339E8434-9DBC-43D6-8CD3-649E30E39360}"/>
               </a:ext>
             </a:extLst>
           </p:cNvPr>
@@ -14932,7 +15491,7 @@
                 <a:ea typeface="Arial"/>
                 <a:cs typeface="Arial"/>
               </a:rPr>
-              <a:t>REPRODUCIBILITY EVIDENCE</a:t>
+              <a:t>FINAL SOURCE EVIDENCE</a:t>
             </a:r>
           </a:p>
         </p:txBody>
@@ -14942,7 +15501,7 @@
           <p:cNvPr id="2" name="">
             <a:extLst xmlns:a="http://schemas.openxmlformats.org/drawingml/2006/main">
               <a:ext uri="{FF2B5EF4-FFF2-40B4-BE49-F238E27FC236}">
-                <a16:creationId xmlns:a16="http://schemas.microsoft.com/office/drawing/2014/main" id="{71D7F924-A95A-41F4-8817-56F4B68F90C7}"/>
+                <a16:creationId xmlns:a16="http://schemas.microsoft.com/office/drawing/2014/main" id="{71AEC104-7B88-486E-BF5E-A9B097019DA3}"/>
               </a:ext>
             </a:extLst>
           </p:cNvPr>
@@ -15088,7 +15647,7 @@
                 <a:ea typeface="Arial"/>
                 <a:cs typeface="Arial"/>
               </a:rPr>
-              <a:t>Tests measure feasibility and shortcut resistance</a:t>
+              <a:t>Reproducibility and shortcut comparison</a:t>
             </a:r>
           </a:p>
         </p:txBody>
@@ -15098,7 +15657,7 @@
           <p:cNvPr id="3" name="">
             <a:extLst xmlns:a="http://schemas.openxmlformats.org/drawingml/2006/main">
               <a:ext uri="{FF2B5EF4-FFF2-40B4-BE49-F238E27FC236}">
-                <a16:creationId xmlns:a16="http://schemas.microsoft.com/office/drawing/2014/main" id="{D10735CE-C2A0-4414-A3AB-D8F0170092AA}"/>
+                <a16:creationId xmlns:a16="http://schemas.microsoft.com/office/drawing/2014/main" id="{E2E1D197-32F9-45CC-BC8B-8154A132FD15}"/>
               </a:ext>
             </a:extLst>
           </p:cNvPr>
@@ -15254,7 +15813,7 @@
           <p:cNvPr id="4" name="">
             <a:extLst xmlns:a="http://schemas.openxmlformats.org/drawingml/2006/main">
               <a:ext uri="{FF2B5EF4-FFF2-40B4-BE49-F238E27FC236}">
-                <a16:creationId xmlns:a16="http://schemas.microsoft.com/office/drawing/2014/main" id="{E54251A8-A49E-482C-B8EA-ABB81FCF172B}"/>
+                <a16:creationId xmlns:a16="http://schemas.microsoft.com/office/drawing/2014/main" id="{0FC756AD-B0E7-4C41-8716-505EA62695A5}"/>
               </a:ext>
             </a:extLst>
           </p:cNvPr>
@@ -15410,7 +15969,7 @@
           <p:cNvPr id="5" name="">
             <a:extLst xmlns:a="http://schemas.openxmlformats.org/drawingml/2006/main">
               <a:ext uri="{FF2B5EF4-FFF2-40B4-BE49-F238E27FC236}">
-                <a16:creationId xmlns:a16="http://schemas.microsoft.com/office/drawing/2014/main" id="{F102C4FA-3592-459A-A03B-216FDEA6E1FB}"/>
+                <a16:creationId xmlns:a16="http://schemas.microsoft.com/office/drawing/2014/main" id="{32EB20E5-771F-4509-96AE-BA6BA58E5E53}"/>
               </a:ext>
             </a:extLst>
           </p:cNvPr>
@@ -15421,7 +15980,7 @@
         </p:nvSpPr>
         <p:spPr>
           <a:xfrm xmlns:a="http://schemas.openxmlformats.org/drawingml/2006/main">
-            <a:off x="609600" y="1943100"/>
+            <a:off x="609600" y="1933575"/>
             <a:ext cx="10972800" cy="581025"/>
           </a:xfrm>
           <a:prstGeom xmlns:a="http://schemas.openxmlformats.org/drawingml/2006/main" prst="rect">
@@ -15556,7 +16115,7 @@
                 <a:ea typeface="Arial"/>
                 <a:cs typeface="Arial"/>
               </a:rPr>
-              <a:t>71 Linux regressions     160 task/seed pairs     12 live isolation checks</a:t>
+              <a:t>114 Linux tests     180 task/seed pairs     12 live isolation checks</a:t>
             </a:r>
           </a:p>
         </p:txBody>
@@ -15566,7 +16125,7 @@
           <p:cNvPr id="6" name="">
             <a:extLst xmlns:a="http://schemas.openxmlformats.org/drawingml/2006/main">
               <a:ext uri="{FF2B5EF4-FFF2-40B4-BE49-F238E27FC236}">
-                <a16:creationId xmlns:a16="http://schemas.microsoft.com/office/drawing/2014/main" id="{9A6A253A-AC50-4ACF-9CB4-423118175468}"/>
+                <a16:creationId xmlns:a16="http://schemas.microsoft.com/office/drawing/2014/main" id="{4D40F79E-9844-4662-B4F3-338ED5DF259F}"/>
               </a:ext>
             </a:extLst>
           </p:cNvPr>
@@ -15574,8 +16133,8 @@
           <p:nvPr/>
         </p:nvGraphicFramePr>
         <p:xfrm>
-          <a:off xmlns:a="http://schemas.openxmlformats.org/drawingml/2006/main" x="609600" y="2800350"/>
-          <a:ext xmlns:a="http://schemas.openxmlformats.org/drawingml/2006/main" cx="10972800" cy="2628900"/>
+          <a:off xmlns:a="http://schemas.openxmlformats.org/drawingml/2006/main" x="609600" y="2771775"/>
+          <a:ext xmlns:a="http://schemas.openxmlformats.org/drawingml/2006/main" cx="10972800" cy="2638425"/>
         </p:xfrm>
         <a:graphic xmlns:a="http://schemas.openxmlformats.org/drawingml/2006/main">
           <a:graphicData uri="http://schemas.openxmlformats.org/drawingml/2006/table">
@@ -15586,7 +16145,7 @@
                 <a:gridCol w="3000375"/>
                 <a:gridCol w="3924300"/>
               </a:tblGrid>
-              <a:tr h="657225">
+              <a:tr h="659606">
                 <a:tc>
                   <a:txBody>
                     <a:bodyPr/>
@@ -15649,7 +16208,7 @@
                           <a:ea typeface="Arial"/>
                           <a:cs typeface="Arial"/>
                         </a:rPr>
-                        <a:t>Successful episodes</a:t>
+                        <a:t>Successes / 45</a:t>
                       </a:r>
                     </a:p>
                   </a:txBody>
@@ -15720,7 +16279,7 @@
                   </a:tcPr>
                 </a:tc>
               </a:tr>
-              <a:tr h="657225">
+              <a:tr h="659606">
                 <a:tc>
                   <a:txBody>
                     <a:bodyPr/>
@@ -15777,7 +16336,7 @@
                           <a:ea typeface="Arial"/>
                           <a:cs typeface="Arial"/>
                         </a:rPr>
-                        <a:t>0 / 40</a:t>
+                        <a:t>0 / 45</a:t>
                       </a:r>
                     </a:p>
                   </a:txBody>
@@ -15813,7 +16372,7 @@
                           <a:ea typeface="Arial"/>
                           <a:cs typeface="Arial"/>
                         </a:rPr>
-                        <a:t>8 tasks × 5 separate seeds</a:t>
+                        <a:t>9 tasks × 5 separate seeds</a:t>
                       </a:r>
                     </a:p>
                   </a:txBody>
@@ -15836,7 +16395,7 @@
                   </a:tcPr>
                 </a:tc>
               </a:tr>
-              <a:tr h="657225">
+              <a:tr h="659606">
                 <a:tc>
                   <a:txBody>
                     <a:bodyPr/>
@@ -15893,7 +16452,7 @@
                           <a:ea typeface="Arial"/>
                           <a:cs typeface="Arial"/>
                         </a:rPr>
-                        <a:t>25 / 40 and 20 / 40</a:t>
+                        <a:t>25 / 45 and 20 / 45</a:t>
                       </a:r>
                     </a:p>
                   </a:txBody>
@@ -15929,7 +16488,7 @@
                           <a:ea typeface="Arial"/>
                           <a:cs typeface="Arial"/>
                         </a:rPr>
-                        <a:t>0 / 15 on the three hard tasks</a:t>
+                        <a:t>Both fail all 20 hard cases</a:t>
                       </a:r>
                     </a:p>
                   </a:txBody>
@@ -15952,7 +16511,7 @@
                   </a:tcPr>
                 </a:tc>
               </a:tr>
-              <a:tr h="657225">
+              <a:tr h="659606">
                 <a:tc>
                   <a:txBody>
                     <a:bodyPr/>
@@ -16009,7 +16568,7 @@
                           <a:ea typeface="Arial"/>
                           <a:cs typeface="Arial"/>
                         </a:rPr>
-                        <a:t>40 / 40</a:t>
+                        <a:t>45 / 45</a:t>
                       </a:r>
                     </a:p>
                   </a:txBody>
@@ -16077,7 +16636,7 @@
           <p:cNvPr id="7" name="">
             <a:extLst xmlns:a="http://schemas.openxmlformats.org/drawingml/2006/main">
               <a:ext uri="{FF2B5EF4-FFF2-40B4-BE49-F238E27FC236}">
-                <a16:creationId xmlns:a16="http://schemas.microsoft.com/office/drawing/2014/main" id="{9D91211B-83BC-4B0B-8C0A-3D3DB5BF4469}"/>
+                <a16:creationId xmlns:a16="http://schemas.microsoft.com/office/drawing/2014/main" id="{65774FD2-6E39-4100-88AB-3D406E6D26E4}"/>
               </a:ext>
             </a:extLst>
           </p:cNvPr>
@@ -16088,8 +16647,8 @@
         </p:nvSpPr>
         <p:spPr>
           <a:xfrm xmlns:a="http://schemas.openxmlformats.org/drawingml/2006/main">
-            <a:off x="609600" y="5743575"/>
-            <a:ext cx="10972800" cy="438150"/>
+            <a:off x="609600" y="5734050"/>
+            <a:ext cx="10972800" cy="447675"/>
           </a:xfrm>
           <a:prstGeom xmlns:a="http://schemas.openxmlformats.org/drawingml/2006/main" prst="rect">
             <a:avLst/>
@@ -16103,7 +16662,7 @@
           <a:bodyPr xmlns:a="http://schemas.openxmlformats.org/drawingml/2006/main"/>
           <a:lstStyle xmlns:a="http://schemas.openxmlformats.org/drawingml/2006/main">
             <a:defPPr>
-              <a:defRPr sz="1800" b="0">
+              <a:defRPr sz="1725" b="0">
                 <a:solidFill>
                   <a:srgbClr val="193447"/>
                 </a:solidFill>
@@ -16113,7 +16672,7 @@
               </a:defRPr>
             </a:defPPr>
             <a:lvl1pPr>
-              <a:defRPr sz="1800" b="0">
+              <a:defRPr sz="1725" b="0">
                 <a:solidFill>
                   <a:srgbClr val="193447"/>
                 </a:solidFill>
@@ -16123,7 +16682,7 @@
               </a:defRPr>
             </a:lvl1pPr>
             <a:lvl2pPr>
-              <a:defRPr sz="1800" b="0">
+              <a:defRPr sz="1725" b="0">
                 <a:solidFill>
                   <a:srgbClr val="193447"/>
                 </a:solidFill>
@@ -16133,7 +16692,7 @@
               </a:defRPr>
             </a:lvl2pPr>
             <a:lvl3pPr>
-              <a:defRPr sz="1800" b="0">
+              <a:defRPr sz="1725" b="0">
                 <a:solidFill>
                   <a:srgbClr val="193447"/>
                 </a:solidFill>
@@ -16143,7 +16702,7 @@
               </a:defRPr>
             </a:lvl3pPr>
             <a:lvl4pPr>
-              <a:defRPr sz="1800" b="0">
+              <a:defRPr sz="1725" b="0">
                 <a:solidFill>
                   <a:srgbClr val="193447"/>
                 </a:solidFill>
@@ -16153,7 +16712,7 @@
               </a:defRPr>
             </a:lvl4pPr>
             <a:lvl5pPr>
-              <a:defRPr sz="1800" b="0">
+              <a:defRPr sz="1725" b="0">
                 <a:solidFill>
                   <a:srgbClr val="193447"/>
                 </a:solidFill>
@@ -16163,7 +16722,7 @@
               </a:defRPr>
             </a:lvl5pPr>
             <a:lvl6pPr>
-              <a:defRPr sz="1800" b="0">
+              <a:defRPr sz="1725" b="0">
                 <a:solidFill>
                   <a:srgbClr val="193447"/>
                 </a:solidFill>
@@ -16173,7 +16732,7 @@
               </a:defRPr>
             </a:lvl6pPr>
             <a:lvl7pPr>
-              <a:defRPr sz="1800" b="0">
+              <a:defRPr sz="1725" b="0">
                 <a:solidFill>
                   <a:srgbClr val="193447"/>
                 </a:solidFill>
@@ -16183,7 +16742,7 @@
               </a:defRPr>
             </a:lvl7pPr>
             <a:lvl8pPr>
-              <a:defRPr sz="1800" b="0">
+              <a:defRPr sz="1725" b="0">
                 <a:solidFill>
                   <a:srgbClr val="193447"/>
                 </a:solidFill>
@@ -16193,7 +16752,7 @@
               </a:defRPr>
             </a:lvl8pPr>
             <a:lvl9pPr>
-              <a:defRPr sz="1800" b="0">
+              <a:defRPr sz="1725" b="0">
                 <a:solidFill>
                   <a:srgbClr val="193447"/>
                 </a:solidFill>
@@ -16205,7 +16764,7 @@
           </a:lstStyle>
           <a:p xmlns:a="http://schemas.openxmlformats.org/drawingml/2006/main">
             <a:pPr>
-              <a:defRPr sz="1800" b="0">
+              <a:defRPr sz="1725" b="0">
                 <a:solidFill>
                   <a:srgbClr val="193447"/>
                 </a:solidFill>
@@ -16215,7 +16774,7 @@
               </a:defRPr>
             </a:pPr>
             <a:r>
-              <a:rPr sz="1800" b="0">
+              <a:rPr sz="1725" b="0">
                 <a:solidFill>
                   <a:srgbClr val="193447"/>
                 </a:solidFill>
@@ -16223,7 +16782,7 @@
                 <a:ea typeface="Arial"/>
                 <a:cs typeface="Arial"/>
               </a:rPr>
-              <a:t>All 8 gates pass. The offline policy comparison never calls a model.</a:t>
+              <a:t>All 9 gates pass. Source and expected build inputs are checked before packaging.</a:t>
             </a:r>
           </a:p>
         </p:txBody>
@@ -16231,7 +16790,7 @@
     </p:spTree>
     <p:extLst>
       <p:ext uri="{BB962C8B-B14F-4D97-AF65-F5344CB8AC3E}">
-        <p14:creationId xmlns:p14="http://schemas.microsoft.com/office/powerpoint/2010/main" val="472476129"/>
+        <p14:creationId xmlns:p14="http://schemas.microsoft.com/office/powerpoint/2010/main" val="417882289"/>
       </p:ext>
     </p:extLst>
   </p:cSld>
@@ -16262,7 +16821,7 @@
           <p:cNvPr id="7" name="">
             <a:extLst xmlns:a="http://schemas.openxmlformats.org/drawingml/2006/main">
               <a:ext uri="{FF2B5EF4-FFF2-40B4-BE49-F238E27FC236}">
-                <a16:creationId xmlns:a16="http://schemas.microsoft.com/office/drawing/2014/main" id="{56F330D5-2364-4230-ACD9-9EF0F1579B3A}"/>
+                <a16:creationId xmlns:a16="http://schemas.microsoft.com/office/drawing/2014/main" id="{34480B47-1BAA-464E-926B-D8B2A2C9B2CD}"/>
               </a:ext>
             </a:extLst>
           </p:cNvPr>
@@ -16408,7 +16967,7 @@
                 <a:ea typeface="Arial"/>
                 <a:cs typeface="Arial"/>
               </a:rPr>
-              <a:t>ORGANIZER DEPLOYMENT: GPT-6-LUNA</a:t>
+              <a:t>GPT-6-LUNA</a:t>
             </a:r>
           </a:p>
         </p:txBody>
@@ -16418,7 +16977,7 @@
           <p:cNvPr id="2" name="">
             <a:extLst xmlns:a="http://schemas.openxmlformats.org/drawingml/2006/main">
               <a:ext uri="{FF2B5EF4-FFF2-40B4-BE49-F238E27FC236}">
-                <a16:creationId xmlns:a16="http://schemas.microsoft.com/office/drawing/2014/main" id="{4253FBEF-608F-44D3-ABBC-9BF270D683CB}"/>
+                <a16:creationId xmlns:a16="http://schemas.microsoft.com/office/drawing/2014/main" id="{535859E0-5AC1-43E5-83ED-95CB961BD250}"/>
               </a:ext>
             </a:extLst>
           </p:cNvPr>
@@ -16564,7 +17123,7 @@
                 <a:ea typeface="Arial"/>
                 <a:cs typeface="Arial"/>
               </a:rPr>
-              <a:t>Final-source model evidence includes connection failures</a:t>
+              <a:t>Four organizer-model validation attempts</a:t>
             </a:r>
           </a:p>
         </p:txBody>
@@ -16574,7 +17133,7 @@
           <p:cNvPr id="3" name="">
             <a:extLst xmlns:a="http://schemas.openxmlformats.org/drawingml/2006/main">
               <a:ext uri="{FF2B5EF4-FFF2-40B4-BE49-F238E27FC236}">
-                <a16:creationId xmlns:a16="http://schemas.microsoft.com/office/drawing/2014/main" id="{653CFBA7-5B90-431C-AC43-A889DD4E0DF6}"/>
+                <a16:creationId xmlns:a16="http://schemas.microsoft.com/office/drawing/2014/main" id="{A8D667CC-DE73-47E2-86B6-CFE84435F9B3}"/>
               </a:ext>
             </a:extLst>
           </p:cNvPr>
@@ -16730,7 +17289,7 @@
           <p:cNvPr id="4" name="">
             <a:extLst xmlns:a="http://schemas.openxmlformats.org/drawingml/2006/main">
               <a:ext uri="{FF2B5EF4-FFF2-40B4-BE49-F238E27FC236}">
-                <a16:creationId xmlns:a16="http://schemas.microsoft.com/office/drawing/2014/main" id="{A23EC8B0-7B3D-48E5-94E6-FBCFE3D738A9}"/>
+                <a16:creationId xmlns:a16="http://schemas.microsoft.com/office/drawing/2014/main" id="{A02F5D2D-070F-4122-A449-951BF17A44B3}"/>
               </a:ext>
             </a:extLst>
           </p:cNvPr>
@@ -16886,7 +17445,7 @@
           <p:cNvPr id="5" name="">
             <a:extLst xmlns:a="http://schemas.openxmlformats.org/drawingml/2006/main">
               <a:ext uri="{FF2B5EF4-FFF2-40B4-BE49-F238E27FC236}">
-                <a16:creationId xmlns:a16="http://schemas.microsoft.com/office/drawing/2014/main" id="{6A771661-D9C6-466B-873E-F9C8C77FBE1C}"/>
+                <a16:creationId xmlns:a16="http://schemas.microsoft.com/office/drawing/2014/main" id="{27A4A070-C544-4EB3-A24B-8EE2CD6E438D}"/>
               </a:ext>
             </a:extLst>
           </p:cNvPr>
@@ -17140,7 +17699,7 @@
                           <a:ea typeface="Arial"/>
                           <a:cs typeface="Arial"/>
                         </a:rPr>
-                        <a:t>Success / 1.0</a:t>
+                        <a:t>success / 1</a:t>
                       </a:r>
                     </a:p>
                   </a:txBody>
@@ -17176,7 +17735,7 @@
                           <a:ea typeface="Arial"/>
                           <a:cs typeface="Arial"/>
                         </a:rPr>
-                        <a:t>7</a:t>
+                        <a:t>11</a:t>
                       </a:r>
                     </a:p>
                   </a:txBody>
@@ -17212,7 +17771,7 @@
                           <a:ea typeface="Arial"/>
                           <a:cs typeface="Arial"/>
                         </a:rPr>
-                        <a:t>29.31</a:t>
+                        <a:t>49.44</a:t>
                       </a:r>
                     </a:p>
                   </a:txBody>
@@ -17250,7 +17809,7 @@
                           <a:ea typeface="Arial"/>
                           <a:cs typeface="Arial"/>
                         </a:rPr>
-                        <a:t>EPS + sample append</a:t>
+                        <a:t>Radio energy, seed 101</a:t>
                       </a:r>
                     </a:p>
                   </a:txBody>
@@ -17292,7 +17851,7 @@
                           <a:ea typeface="Arial"/>
                           <a:cs typeface="Arial"/>
                         </a:rPr>
-                        <a:t>Success / 1.0</a:t>
+                        <a:t>success / 1</a:t>
                       </a:r>
                     </a:p>
                   </a:txBody>
@@ -17328,7 +17887,7 @@
                           <a:ea typeface="Arial"/>
                           <a:cs typeface="Arial"/>
                         </a:rPr>
-                        <a:t>10</a:t>
+                        <a:t>11</a:t>
                       </a:r>
                     </a:p>
                   </a:txBody>
@@ -17364,7 +17923,7 @@
                           <a:ea typeface="Arial"/>
                           <a:cs typeface="Arial"/>
                         </a:rPr>
-                        <a:t>44.72</a:t>
+                        <a:t>58.97</a:t>
                       </a:r>
                     </a:p>
                   </a:txBody>
@@ -17402,7 +17961,7 @@
                           <a:ea typeface="Arial"/>
                           <a:cs typeface="Arial"/>
                         </a:rPr>
-                        <a:t>Early pass, seed 101</a:t>
+                        <a:t>Science, seed 101</a:t>
                       </a:r>
                     </a:p>
                   </a:txBody>
@@ -17444,7 +18003,7 @@
                           <a:ea typeface="Arial"/>
                           <a:cs typeface="Arial"/>
                         </a:rPr>
-                        <a:t>Connection crash / 0.0</a:t>
+                        <a:t>success / 1</a:t>
                       </a:r>
                     </a:p>
                   </a:txBody>
@@ -17480,7 +18039,7 @@
                           <a:ea typeface="Arial"/>
                           <a:cs typeface="Arial"/>
                         </a:rPr>
-                        <a:t>1</a:t>
+                        <a:t>28</a:t>
                       </a:r>
                     </a:p>
                   </a:txBody>
@@ -17516,7 +18075,7 @@
                           <a:ea typeface="Arial"/>
                           <a:cs typeface="Arial"/>
                         </a:rPr>
-                        <a:t>12.81</a:t>
+                        <a:t>193.68</a:t>
                       </a:r>
                     </a:p>
                   </a:txBody>
@@ -17596,7 +18155,7 @@
                           <a:ea typeface="Arial"/>
                           <a:cs typeface="Arial"/>
                         </a:rPr>
-                        <a:t>Connection crash / 0.0</a:t>
+                        <a:t>failure / 0.8</a:t>
                       </a:r>
                     </a:p>
                   </a:txBody>
@@ -17632,7 +18191,7 @@
                           <a:ea typeface="Arial"/>
                           <a:cs typeface="Arial"/>
                         </a:rPr>
-                        <a:t>0</a:t>
+                        <a:t>12</a:t>
                       </a:r>
                     </a:p>
                   </a:txBody>
@@ -17668,7 +18227,7 @@
                           <a:ea typeface="Arial"/>
                           <a:cs typeface="Arial"/>
                         </a:rPr>
-                        <a:t>7.14</a:t>
+                        <a:t>94.39</a:t>
                       </a:r>
                     </a:p>
                   </a:txBody>
@@ -17700,7 +18259,7 @@
           <p:cNvPr id="6" name="">
             <a:extLst xmlns:a="http://schemas.openxmlformats.org/drawingml/2006/main">
               <a:ext uri="{FF2B5EF4-FFF2-40B4-BE49-F238E27FC236}">
-                <a16:creationId xmlns:a16="http://schemas.microsoft.com/office/drawing/2014/main" id="{16F3E46C-BC94-4BB5-A7DC-85BD0CF900B6}"/>
+                <a16:creationId xmlns:a16="http://schemas.microsoft.com/office/drawing/2014/main" id="{FD61B803-315B-4A3F-8F33-B84F10C073E4}"/>
               </a:ext>
             </a:extLst>
           </p:cNvPr>
@@ -17711,7 +18270,7 @@
         </p:nvSpPr>
         <p:spPr>
           <a:xfrm xmlns:a="http://schemas.openxmlformats.org/drawingml/2006/main">
-            <a:off x="609600" y="5657850"/>
+            <a:off x="609600" y="5648325"/>
             <a:ext cx="10972800" cy="590550"/>
           </a:xfrm>
           <a:prstGeom xmlns:a="http://schemas.openxmlformats.org/drawingml/2006/main" prst="rect">
@@ -17726,7 +18285,7 @@
           <a:bodyPr xmlns:a="http://schemas.openxmlformats.org/drawingml/2006/main"/>
           <a:lstStyle xmlns:a="http://schemas.openxmlformats.org/drawingml/2006/main">
             <a:defPPr>
-              <a:defRPr sz="1725" b="1">
+              <a:defRPr sz="1800" b="1">
                 <a:solidFill>
                   <a:srgbClr val="007E83"/>
                 </a:solidFill>
@@ -17736,7 +18295,7 @@
               </a:defRPr>
             </a:defPPr>
             <a:lvl1pPr>
-              <a:defRPr sz="1725" b="1">
+              <a:defRPr sz="1800" b="1">
                 <a:solidFill>
                   <a:srgbClr val="007E83"/>
                 </a:solidFill>
@@ -17746,7 +18305,7 @@
               </a:defRPr>
             </a:lvl1pPr>
             <a:lvl2pPr>
-              <a:defRPr sz="1725" b="1">
+              <a:defRPr sz="1800" b="1">
                 <a:solidFill>
                   <a:srgbClr val="007E83"/>
                 </a:solidFill>
@@ -17756,7 +18315,7 @@
               </a:defRPr>
             </a:lvl2pPr>
             <a:lvl3pPr>
-              <a:defRPr sz="1725" b="1">
+              <a:defRPr sz="1800" b="1">
                 <a:solidFill>
                   <a:srgbClr val="007E83"/>
                 </a:solidFill>
@@ -17766,7 +18325,7 @@
               </a:defRPr>
             </a:lvl3pPr>
             <a:lvl4pPr>
-              <a:defRPr sz="1725" b="1">
+              <a:defRPr sz="1800" b="1">
                 <a:solidFill>
                   <a:srgbClr val="007E83"/>
                 </a:solidFill>
@@ -17776,7 +18335,7 @@
               </a:defRPr>
             </a:lvl4pPr>
             <a:lvl5pPr>
-              <a:defRPr sz="1725" b="1">
+              <a:defRPr sz="1800" b="1">
                 <a:solidFill>
                   <a:srgbClr val="007E83"/>
                 </a:solidFill>
@@ -17786,7 +18345,7 @@
               </a:defRPr>
             </a:lvl5pPr>
             <a:lvl6pPr>
-              <a:defRPr sz="1725" b="1">
+              <a:defRPr sz="1800" b="1">
                 <a:solidFill>
                   <a:srgbClr val="007E83"/>
                 </a:solidFill>
@@ -17796,7 +18355,7 @@
               </a:defRPr>
             </a:lvl6pPr>
             <a:lvl7pPr>
-              <a:defRPr sz="1725" b="1">
+              <a:defRPr sz="1800" b="1">
                 <a:solidFill>
                   <a:srgbClr val="007E83"/>
                 </a:solidFill>
@@ -17806,7 +18365,7 @@
               </a:defRPr>
             </a:lvl7pPr>
             <a:lvl8pPr>
-              <a:defRPr sz="1725" b="1">
+              <a:defRPr sz="1800" b="1">
                 <a:solidFill>
                   <a:srgbClr val="007E83"/>
                 </a:solidFill>
@@ -17816,7 +18375,7 @@
               </a:defRPr>
             </a:lvl8pPr>
             <a:lvl9pPr>
-              <a:defRPr sz="1725" b="1">
+              <a:defRPr sz="1800" b="1">
                 <a:solidFill>
                   <a:srgbClr val="007E83"/>
                 </a:solidFill>
@@ -17828,7 +18387,7 @@
           </a:lstStyle>
           <a:p xmlns:a="http://schemas.openxmlformats.org/drawingml/2006/main">
             <a:pPr>
-              <a:defRPr sz="1725" b="1">
+              <a:defRPr sz="1800" b="1">
                 <a:solidFill>
                   <a:srgbClr val="007E83"/>
                 </a:solidFill>
@@ -17838,7 +18397,7 @@
               </a:defRPr>
             </a:pPr>
             <a:r>
-              <a:rPr sz="1725" b="1">
+              <a:rPr sz="1800" b="1">
                 <a:solidFill>
                   <a:srgbClr val="007E83"/>
                 </a:solidFill>
@@ -17846,7 +18405,7 @@
                 <a:ea typeface="Arial"/>
                 <a:cs typeface="Arial"/>
               </a:rPr>
-              <a:t>2 successes, 2 provider failures. Hard-task model capability remains unproven.</a:t>
+              <a:t>3 / 4 successful attempts. Full replies, actions and failure reasons are preserved.</a:t>
             </a:r>
           </a:p>
         </p:txBody>
@@ -17854,7 +18413,7 @@
     </p:spTree>
     <p:extLst>
       <p:ext uri="{BB962C8B-B14F-4D97-AF65-F5344CB8AC3E}">
-        <p14:creationId xmlns:p14="http://schemas.microsoft.com/office/powerpoint/2010/main" val="292465242"/>
+        <p14:creationId xmlns:p14="http://schemas.microsoft.com/office/powerpoint/2010/main" val="600484579"/>
       </p:ext>
     </p:extLst>
   </p:cSld>

</xml_diff>

<commit_message>
Align ASTRO submission naming and confirmed organizer handoff
</commit_message>
<xml_diff>
--- a/submission_bundle/defense-deck.pptx
+++ b/submission_bundle/defense-deck.pptx
@@ -2,22 +2,22 @@
 <file path=ppt/presentation.xml><?xml version="1.0" encoding="utf-8"?>
 <p:presentation xmlns:p="http://schemas.openxmlformats.org/presentationml/2006/main">
   <p:sldMasterIdLst>
-    <p:sldMasterId xmlns:r="http://schemas.openxmlformats.org/officeDocument/2006/relationships" id="2147483648" r:id="R9692526ae6914a5d"/>
+    <p:sldMasterId xmlns:r="http://schemas.openxmlformats.org/officeDocument/2006/relationships" id="2147483648" r:id="R8fb77df046ab4ff7"/>
   </p:sldMasterIdLst>
   <p:notesMasterIdLst>
-    <p:notesMasterId xmlns:r="http://schemas.openxmlformats.org/officeDocument/2006/relationships" r:id="Rfd40a1cd417b4c12"/>
+    <p:notesMasterId xmlns:r="http://schemas.openxmlformats.org/officeDocument/2006/relationships" r:id="Rb9b0e81981414f56"/>
   </p:notesMasterIdLst>
   <p:sldIdLst>
-    <p:sldId xmlns:r="http://schemas.openxmlformats.org/officeDocument/2006/relationships" id="256" r:id="R175fe71ecd8445c5"/>
-    <p:sldId xmlns:r="http://schemas.openxmlformats.org/officeDocument/2006/relationships" id="257" r:id="Ra36756b524c440ee"/>
-    <p:sldId xmlns:r="http://schemas.openxmlformats.org/officeDocument/2006/relationships" id="258" r:id="Rcfd0b62f02c94783"/>
-    <p:sldId xmlns:r="http://schemas.openxmlformats.org/officeDocument/2006/relationships" id="259" r:id="Rfd614109ffc24ceb"/>
-    <p:sldId xmlns:r="http://schemas.openxmlformats.org/officeDocument/2006/relationships" id="260" r:id="Rd2c526d0ae4f47a4"/>
-    <p:sldId xmlns:r="http://schemas.openxmlformats.org/officeDocument/2006/relationships" id="261" r:id="R30174030245c4610"/>
-    <p:sldId xmlns:r="http://schemas.openxmlformats.org/officeDocument/2006/relationships" id="262" r:id="R8d82550f22ae4424"/>
-    <p:sldId xmlns:r="http://schemas.openxmlformats.org/officeDocument/2006/relationships" id="263" r:id="Rbcdc73e15bed4054"/>
-    <p:sldId xmlns:r="http://schemas.openxmlformats.org/officeDocument/2006/relationships" id="264" r:id="Rd449a95526554da4"/>
-    <p:sldId xmlns:r="http://schemas.openxmlformats.org/officeDocument/2006/relationships" id="265" r:id="R4d1f0ae6a1974d75"/>
+    <p:sldId xmlns:r="http://schemas.openxmlformats.org/officeDocument/2006/relationships" id="256" r:id="Ra5a654aefe4b4275"/>
+    <p:sldId xmlns:r="http://schemas.openxmlformats.org/officeDocument/2006/relationships" id="257" r:id="R54f41f1189a54c65"/>
+    <p:sldId xmlns:r="http://schemas.openxmlformats.org/officeDocument/2006/relationships" id="258" r:id="R7f542a71c3e1442f"/>
+    <p:sldId xmlns:r="http://schemas.openxmlformats.org/officeDocument/2006/relationships" id="259" r:id="Ra2b0f1f7fd8b4409"/>
+    <p:sldId xmlns:r="http://schemas.openxmlformats.org/officeDocument/2006/relationships" id="260" r:id="Rba1d07b883ec4359"/>
+    <p:sldId xmlns:r="http://schemas.openxmlformats.org/officeDocument/2006/relationships" id="261" r:id="Rf93f001f06f9471f"/>
+    <p:sldId xmlns:r="http://schemas.openxmlformats.org/officeDocument/2006/relationships" id="262" r:id="R0962de9aadaf4204"/>
+    <p:sldId xmlns:r="http://schemas.openxmlformats.org/officeDocument/2006/relationships" id="263" r:id="Rdafa811e4ea84650"/>
+    <p:sldId xmlns:r="http://schemas.openxmlformats.org/officeDocument/2006/relationships" id="264" r:id="R0ca6166653334a6b"/>
+    <p:sldId xmlns:r="http://schemas.openxmlformats.org/officeDocument/2006/relationships" id="265" r:id="Raf2e7f486f674614"/>
   </p:sldIdLst>
   <p:sldSz cx="12192000" cy="6858000"/>
   <p:notesSz cx="6858000" cy="9144000"/>
@@ -521,7 +521,7 @@
           <a:lstStyle xmlns:a="http://schemas.openxmlformats.org/drawingml/2006/main"/>
           <a:p xmlns:a="http://schemas.openxmlformats.org/drawingml/2006/main">
             <a:r>
-              <a:t>8:45–10:00. Use Run A unappended EPS seed zero as the named realistic demo. Open source-matched logs if network fails. Show gates, one action, state hash and final checks without showing .env. Defend why planning is necessary using science dutybounds and data conservation. Explain scalar physics and trusted host boundary. Public repository is user requested but conflicts with the private PS rule. Exact name case, organizer access, deadline and form submission remain administrative items. No claim of an actual judge score or exhaustive robustness.</a:t>
+              <a:t>8:45–10:00. Use Run A unappended EPS seed zero as the named realistic demo. Open source-matched logs if network fails. Show gates, one action, state hash and final checks without showing .env. Defend why planning is necessary using science dutybounds and data conservation. Explain scalar physics and trusted host boundary. Public repository is user requested but conflicts with the private PS rule. ASTRO naming and the 25 October 2026, 10:15 AM IST deadline are confirmed. Organizer invitation acceptance and the team form submission remain pending. No claim of an actual judge score or exhaustive robustness.</a:t>
             </a:r>
           </a:p>
           <a:p xmlns:a="http://schemas.openxmlformats.org/drawingml/2006/main">
@@ -1218,7 +1218,7 @@
           <p:cNvPr id="3" name="Title">
             <a:extLst xmlns:a="http://schemas.openxmlformats.org/drawingml/2006/main">
               <a:ext uri="{FF2B5EF4-FFF2-40B4-BE49-F238E27FC236}">
-                <a16:creationId xmlns:a16="http://schemas.microsoft.com/office/drawing/2014/main" id="{3AFF7D7E-2AB1-47C0-873F-C6548F4E9206}"/>
+                <a16:creationId xmlns:a16="http://schemas.microsoft.com/office/drawing/2014/main" id="{6F12DB88-4CB1-4743-850F-64B898AEC5E2}"/>
               </a:ext>
             </a:extLst>
           </p:cNvPr>
@@ -1447,7 +1447,7 @@
           <p:cNvPr id="2" name="Subtitle">
             <a:extLst xmlns:a="http://schemas.openxmlformats.org/drawingml/2006/main">
               <a:ext uri="{FF2B5EF4-FFF2-40B4-BE49-F238E27FC236}">
-                <a16:creationId xmlns:a16="http://schemas.microsoft.com/office/drawing/2014/main" id="{A01C2981-229B-453C-B1C1-8B517BE10CF3}"/>
+                <a16:creationId xmlns:a16="http://schemas.microsoft.com/office/drawing/2014/main" id="{CDE26E60-1E07-4DFE-9234-4614DD00A24E}"/>
               </a:ext>
             </a:extLst>
           </p:cNvPr>
@@ -1693,7 +1693,7 @@
           <p:cNvPr id="2" name="Section title">
             <a:extLst xmlns:a="http://schemas.openxmlformats.org/drawingml/2006/main">
               <a:ext uri="{FF2B5EF4-FFF2-40B4-BE49-F238E27FC236}">
-                <a16:creationId xmlns:a16="http://schemas.microsoft.com/office/drawing/2014/main" id="{FF30BCD6-55B0-44E5-810A-80928025FF3C}"/>
+                <a16:creationId xmlns:a16="http://schemas.microsoft.com/office/drawing/2014/main" id="{B0D7F8AA-1DF9-44AE-B456-69C446A063C4}"/>
               </a:ext>
             </a:extLst>
           </p:cNvPr>
@@ -1939,7 +1939,7 @@
           <p:cNvPr id="3" name="Title">
             <a:extLst xmlns:a="http://schemas.openxmlformats.org/drawingml/2006/main">
               <a:ext uri="{FF2B5EF4-FFF2-40B4-BE49-F238E27FC236}">
-                <a16:creationId xmlns:a16="http://schemas.microsoft.com/office/drawing/2014/main" id="{FD4DBED2-73B7-43A1-884E-13D2A343317F}"/>
+                <a16:creationId xmlns:a16="http://schemas.microsoft.com/office/drawing/2014/main" id="{C9599021-4B40-4E59-8707-22F3160BD0C7}"/>
               </a:ext>
             </a:extLst>
           </p:cNvPr>
@@ -2168,7 +2168,7 @@
           <p:cNvPr id="2" name="Body">
             <a:extLst xmlns:a="http://schemas.openxmlformats.org/drawingml/2006/main">
               <a:ext uri="{FF2B5EF4-FFF2-40B4-BE49-F238E27FC236}">
-                <a16:creationId xmlns:a16="http://schemas.microsoft.com/office/drawing/2014/main" id="{C1A35F30-2860-4B7E-9A11-D1D7D19F6BFC}"/>
+                <a16:creationId xmlns:a16="http://schemas.microsoft.com/office/drawing/2014/main" id="{33288297-E50F-4CA9-8106-B615001A5280}"/>
               </a:ext>
             </a:extLst>
           </p:cNvPr>
@@ -2414,7 +2414,7 @@
           <p:cNvPr id="4" name="Title">
             <a:extLst xmlns:a="http://schemas.openxmlformats.org/drawingml/2006/main">
               <a:ext uri="{FF2B5EF4-FFF2-40B4-BE49-F238E27FC236}">
-                <a16:creationId xmlns:a16="http://schemas.microsoft.com/office/drawing/2014/main" id="{B097279C-3626-42FE-8AA6-9974EB1499FF}"/>
+                <a16:creationId xmlns:a16="http://schemas.microsoft.com/office/drawing/2014/main" id="{CB036D91-6A99-4E35-B103-C75A0B17CD28}"/>
               </a:ext>
             </a:extLst>
           </p:cNvPr>
@@ -2643,7 +2643,7 @@
           <p:cNvPr id="2" name="Left column">
             <a:extLst xmlns:a="http://schemas.openxmlformats.org/drawingml/2006/main">
               <a:ext uri="{FF2B5EF4-FFF2-40B4-BE49-F238E27FC236}">
-                <a16:creationId xmlns:a16="http://schemas.microsoft.com/office/drawing/2014/main" id="{6B15F640-291B-4FDE-9F93-7C2266DC4A9D}"/>
+                <a16:creationId xmlns:a16="http://schemas.microsoft.com/office/drawing/2014/main" id="{C43301FE-8007-4A8D-B27B-D27C2ECFA988}"/>
               </a:ext>
             </a:extLst>
           </p:cNvPr>
@@ -2872,7 +2872,7 @@
           <p:cNvPr id="3" name="Right column">
             <a:extLst xmlns:a="http://schemas.openxmlformats.org/drawingml/2006/main">
               <a:ext uri="{FF2B5EF4-FFF2-40B4-BE49-F238E27FC236}">
-                <a16:creationId xmlns:a16="http://schemas.microsoft.com/office/drawing/2014/main" id="{AE500D4E-CC1A-4008-AA39-0AA03149135B}"/>
+                <a16:creationId xmlns:a16="http://schemas.microsoft.com/office/drawing/2014/main" id="{ED9AEE74-DEF7-4D60-8C3A-4A0B0684D198}"/>
               </a:ext>
             </a:extLst>
           </p:cNvPr>
@@ -3118,7 +3118,7 @@
           <p:cNvPr id="3" name="Title">
             <a:extLst xmlns:a="http://schemas.openxmlformats.org/drawingml/2006/main">
               <a:ext uri="{FF2B5EF4-FFF2-40B4-BE49-F238E27FC236}">
-                <a16:creationId xmlns:a16="http://schemas.microsoft.com/office/drawing/2014/main" id="{D233A488-D218-4C3D-A5FD-BD5227981712}"/>
+                <a16:creationId xmlns:a16="http://schemas.microsoft.com/office/drawing/2014/main" id="{451F2B64-0970-497C-92FB-A33E85FBEA9F}"/>
               </a:ext>
             </a:extLst>
           </p:cNvPr>
@@ -3347,7 +3347,7 @@
           <p:cNvPr id="2" name="Left column">
             <a:extLst xmlns:a="http://schemas.openxmlformats.org/drawingml/2006/main">
               <a:ext uri="{FF2B5EF4-FFF2-40B4-BE49-F238E27FC236}">
-                <a16:creationId xmlns:a16="http://schemas.microsoft.com/office/drawing/2014/main" id="{D2B12575-DB6E-441D-915F-B55CEFA9B2FF}"/>
+                <a16:creationId xmlns:a16="http://schemas.microsoft.com/office/drawing/2014/main" id="{B1535338-A5BB-43B2-9864-8EEEC5DED01C}"/>
               </a:ext>
             </a:extLst>
           </p:cNvPr>
@@ -3614,12 +3614,12 @@
   </p:cSld>
   <p:clrMap bg1="lt1" tx1="dk1" bg2="lt2" tx2="dk2" accent1="accent1" accent2="accent2" accent3="accent3" accent4="accent4" accent5="accent5" accent6="accent6" hlink="hlink" folHlink="folHlink"/>
   <p:sldLayoutIdLst>
-    <p:sldLayoutId xmlns:r="http://schemas.openxmlformats.org/officeDocument/2006/relationships" id="2147483649" r:id="Re5b858c2c0384c8e"/>
-    <p:sldLayoutId xmlns:r="http://schemas.openxmlformats.org/officeDocument/2006/relationships" id="2147483650" r:id="Rd9964077992844fb"/>
-    <p:sldLayoutId xmlns:r="http://schemas.openxmlformats.org/officeDocument/2006/relationships" id="2147483651" r:id="R47bc3916c67c491e"/>
-    <p:sldLayoutId xmlns:r="http://schemas.openxmlformats.org/officeDocument/2006/relationships" id="2147483652" r:id="R8e0f8fe44a1c4f8d"/>
-    <p:sldLayoutId xmlns:r="http://schemas.openxmlformats.org/officeDocument/2006/relationships" id="2147483653" r:id="R1dd10e309481421e"/>
-    <p:sldLayoutId xmlns:r="http://schemas.openxmlformats.org/officeDocument/2006/relationships" id="2147483654" r:id="R2a32fb56dee64e9e"/>
+    <p:sldLayoutId xmlns:r="http://schemas.openxmlformats.org/officeDocument/2006/relationships" id="2147483649" r:id="R97c4421ba1aa486b"/>
+    <p:sldLayoutId xmlns:r="http://schemas.openxmlformats.org/officeDocument/2006/relationships" id="2147483650" r:id="R3a2daffd5a1a4b27"/>
+    <p:sldLayoutId xmlns:r="http://schemas.openxmlformats.org/officeDocument/2006/relationships" id="2147483651" r:id="Rb8f705e43c1d4e45"/>
+    <p:sldLayoutId xmlns:r="http://schemas.openxmlformats.org/officeDocument/2006/relationships" id="2147483652" r:id="Rc751b2fa01e649e6"/>
+    <p:sldLayoutId xmlns:r="http://schemas.openxmlformats.org/officeDocument/2006/relationships" id="2147483653" r:id="R377ae62e170c4419"/>
+    <p:sldLayoutId xmlns:r="http://schemas.openxmlformats.org/officeDocument/2006/relationships" id="2147483654" r:id="R8bf014d9643d4b77"/>
   </p:sldLayoutIdLst>
   <p:txStyles>
     <p:titleStyle>
@@ -4170,7 +4170,7 @@
           <p:cNvPr id="6" name="">
             <a:extLst xmlns:a="http://schemas.openxmlformats.org/drawingml/2006/main">
               <a:ext uri="{FF2B5EF4-FFF2-40B4-BE49-F238E27FC236}">
-                <a16:creationId xmlns:a16="http://schemas.microsoft.com/office/drawing/2014/main" id="{DE9A9D96-C46F-47AC-88CC-D1C6ED6BD5AE}"/>
+                <a16:creationId xmlns:a16="http://schemas.microsoft.com/office/drawing/2014/main" id="{319B8C34-8960-4D3B-A1DF-F9C94FB61442}"/>
               </a:ext>
             </a:extLst>
           </p:cNvPr>
@@ -4326,7 +4326,7 @@
           <p:cNvPr id="2" name="">
             <a:extLst xmlns:a="http://schemas.openxmlformats.org/drawingml/2006/main">
               <a:ext uri="{FF2B5EF4-FFF2-40B4-BE49-F238E27FC236}">
-                <a16:creationId xmlns:a16="http://schemas.microsoft.com/office/drawing/2014/main" id="{E9771946-F528-4E22-A3DD-7A27D1A075C7}"/>
+                <a16:creationId xmlns:a16="http://schemas.microsoft.com/office/drawing/2014/main" id="{768EB49A-4353-49DD-81BC-96426D07A6BC}"/>
               </a:ext>
             </a:extLst>
           </p:cNvPr>
@@ -4482,7 +4482,7 @@
           <p:cNvPr id="3" name="">
             <a:extLst xmlns:a="http://schemas.openxmlformats.org/drawingml/2006/main">
               <a:ext uri="{FF2B5EF4-FFF2-40B4-BE49-F238E27FC236}">
-                <a16:creationId xmlns:a16="http://schemas.microsoft.com/office/drawing/2014/main" id="{30E8EF76-098C-4E13-93E2-9639C64F8E4C}"/>
+                <a16:creationId xmlns:a16="http://schemas.microsoft.com/office/drawing/2014/main" id="{1E103C91-2B30-48CD-9332-636DC9AA669C}"/>
               </a:ext>
             </a:extLst>
           </p:cNvPr>
@@ -4661,7 +4661,7 @@
           <p:cNvPr id="4" name="">
             <a:extLst xmlns:a="http://schemas.openxmlformats.org/drawingml/2006/main">
               <a:ext uri="{FF2B5EF4-FFF2-40B4-BE49-F238E27FC236}">
-                <a16:creationId xmlns:a16="http://schemas.microsoft.com/office/drawing/2014/main" id="{51E2C025-A719-48AD-9230-4FFBE6B19C3F}"/>
+                <a16:creationId xmlns:a16="http://schemas.microsoft.com/office/drawing/2014/main" id="{5EF3D28D-F1F9-4B98-B615-49D7D6B63693}"/>
               </a:ext>
             </a:extLst>
           </p:cNvPr>
@@ -4817,7 +4817,7 @@
           <p:cNvPr id="5" name="">
             <a:extLst xmlns:a="http://schemas.openxmlformats.org/drawingml/2006/main">
               <a:ext uri="{FF2B5EF4-FFF2-40B4-BE49-F238E27FC236}">
-                <a16:creationId xmlns:a16="http://schemas.microsoft.com/office/drawing/2014/main" id="{A3F24110-25EA-493C-B235-ACB661851F12}"/>
+                <a16:creationId xmlns:a16="http://schemas.microsoft.com/office/drawing/2014/main" id="{A379CAE0-8DEC-4AC2-869B-3209B4EDF824}"/>
               </a:ext>
             </a:extLst>
           </p:cNvPr>
@@ -4971,7 +4971,7 @@
     </p:spTree>
     <p:extLst>
       <p:ext uri="{BB962C8B-B14F-4D97-AF65-F5344CB8AC3E}">
-        <p14:creationId xmlns:p14="http://schemas.microsoft.com/office/powerpoint/2010/main" val="1826301690"/>
+        <p14:creationId xmlns:p14="http://schemas.microsoft.com/office/powerpoint/2010/main" val="1039067740"/>
       </p:ext>
     </p:extLst>
   </p:cSld>
@@ -5002,7 +5002,7 @@
           <p:cNvPr id="10" name="">
             <a:extLst xmlns:a="http://schemas.openxmlformats.org/drawingml/2006/main">
               <a:ext uri="{FF2B5EF4-FFF2-40B4-BE49-F238E27FC236}">
-                <a16:creationId xmlns:a16="http://schemas.microsoft.com/office/drawing/2014/main" id="{B1ABDDE5-D10B-40EF-B7CE-1D061BED0C46}"/>
+                <a16:creationId xmlns:a16="http://schemas.microsoft.com/office/drawing/2014/main" id="{4EE7CDCA-D55C-4FD8-AB38-9F8A4C629F66}"/>
               </a:ext>
             </a:extLst>
           </p:cNvPr>
@@ -5158,7 +5158,7 @@
           <p:cNvPr id="2" name="">
             <a:extLst xmlns:a="http://schemas.openxmlformats.org/drawingml/2006/main">
               <a:ext uri="{FF2B5EF4-FFF2-40B4-BE49-F238E27FC236}">
-                <a16:creationId xmlns:a16="http://schemas.microsoft.com/office/drawing/2014/main" id="{2E725108-5AD5-4109-99E6-A714DEE7A6F5}"/>
+                <a16:creationId xmlns:a16="http://schemas.microsoft.com/office/drawing/2014/main" id="{D51241DB-FFFF-4A24-B059-7F180878AA00}"/>
               </a:ext>
             </a:extLst>
           </p:cNvPr>
@@ -5314,7 +5314,7 @@
           <p:cNvPr id="3" name="">
             <a:extLst xmlns:a="http://schemas.openxmlformats.org/drawingml/2006/main">
               <a:ext uri="{FF2B5EF4-FFF2-40B4-BE49-F238E27FC236}">
-                <a16:creationId xmlns:a16="http://schemas.microsoft.com/office/drawing/2014/main" id="{37ADA791-8946-4DDF-A4C7-5B75025F050E}"/>
+                <a16:creationId xmlns:a16="http://schemas.microsoft.com/office/drawing/2014/main" id="{7CDD5A1E-5E15-4313-A5D5-825D7BDFE252}"/>
               </a:ext>
             </a:extLst>
           </p:cNvPr>
@@ -5470,7 +5470,7 @@
           <p:cNvPr id="4" name="">
             <a:extLst xmlns:a="http://schemas.openxmlformats.org/drawingml/2006/main">
               <a:ext uri="{FF2B5EF4-FFF2-40B4-BE49-F238E27FC236}">
-                <a16:creationId xmlns:a16="http://schemas.microsoft.com/office/drawing/2014/main" id="{4CE414D6-B2A8-469A-932B-26BF687EC647}"/>
+                <a16:creationId xmlns:a16="http://schemas.microsoft.com/office/drawing/2014/main" id="{D77717E9-239A-4A5D-A56C-61C2B54AA6F3}"/>
               </a:ext>
             </a:extLst>
           </p:cNvPr>
@@ -5626,7 +5626,7 @@
           <p:cNvPr id="5" name="">
             <a:extLst xmlns:a="http://schemas.openxmlformats.org/drawingml/2006/main">
               <a:ext uri="{FF2B5EF4-FFF2-40B4-BE49-F238E27FC236}">
-                <a16:creationId xmlns:a16="http://schemas.microsoft.com/office/drawing/2014/main" id="{799B6C25-DC9D-4C14-B688-5799886AF8FF}"/>
+                <a16:creationId xmlns:a16="http://schemas.microsoft.com/office/drawing/2014/main" id="{451A052B-A268-41B9-B465-B3E435CCA5FE}"/>
               </a:ext>
             </a:extLst>
           </p:cNvPr>
@@ -5782,7 +5782,7 @@
           <p:cNvPr id="6" name="">
             <a:extLst xmlns:a="http://schemas.openxmlformats.org/drawingml/2006/main">
               <a:ext uri="{FF2B5EF4-FFF2-40B4-BE49-F238E27FC236}">
-                <a16:creationId xmlns:a16="http://schemas.microsoft.com/office/drawing/2014/main" id="{E9839CDD-9004-4E26-B33E-6C43DCC63AF6}"/>
+                <a16:creationId xmlns:a16="http://schemas.microsoft.com/office/drawing/2014/main" id="{6C0D4267-5791-4578-AF8A-24DF3D268305}"/>
               </a:ext>
             </a:extLst>
           </p:cNvPr>
@@ -5938,7 +5938,7 @@
           <p:cNvPr id="7" name="">
             <a:extLst xmlns:a="http://schemas.openxmlformats.org/drawingml/2006/main">
               <a:ext uri="{FF2B5EF4-FFF2-40B4-BE49-F238E27FC236}">
-                <a16:creationId xmlns:a16="http://schemas.microsoft.com/office/drawing/2014/main" id="{2E49CEDB-AD9A-4A23-95F8-3A6D3B623837}"/>
+                <a16:creationId xmlns:a16="http://schemas.microsoft.com/office/drawing/2014/main" id="{621E53D4-8442-42C2-AEA0-5E6B873DFFC1}"/>
               </a:ext>
             </a:extLst>
           </p:cNvPr>
@@ -6094,7 +6094,7 @@
           <p:cNvPr id="8" name="">
             <a:extLst xmlns:a="http://schemas.openxmlformats.org/drawingml/2006/main">
               <a:ext uri="{FF2B5EF4-FFF2-40B4-BE49-F238E27FC236}">
-                <a16:creationId xmlns:a16="http://schemas.microsoft.com/office/drawing/2014/main" id="{23527504-B79E-4F80-B323-FF080C297E91}"/>
+                <a16:creationId xmlns:a16="http://schemas.microsoft.com/office/drawing/2014/main" id="{AB370E88-997B-4868-917C-2887CCD94325}"/>
               </a:ext>
             </a:extLst>
           </p:cNvPr>
@@ -6273,7 +6273,7 @@
           <p:cNvPr id="9" name="">
             <a:extLst xmlns:a="http://schemas.openxmlformats.org/drawingml/2006/main">
               <a:ext uri="{FF2B5EF4-FFF2-40B4-BE49-F238E27FC236}">
-                <a16:creationId xmlns:a16="http://schemas.microsoft.com/office/drawing/2014/main" id="{3277FC30-02BA-4300-94D7-D5C8B2065674}"/>
+                <a16:creationId xmlns:a16="http://schemas.microsoft.com/office/drawing/2014/main" id="{6C61A378-855E-44B8-AADF-C7D6577FB6B7}"/>
               </a:ext>
             </a:extLst>
           </p:cNvPr>
@@ -6419,7 +6419,7 @@
                 <a:ea typeface="Arial"/>
                 <a:cs typeface="Arial"/>
               </a:rPr>
-              <a:t>Public visibility conflicts with the PS. Access, name case and submission need confirmation.</a:t>
+              <a:t>ASTRO naming is confirmed. Invitations await acceptance. Public visibility remains a PS exception.</a:t>
             </a:r>
           </a:p>
         </p:txBody>
@@ -6427,7 +6427,7 @@
     </p:spTree>
     <p:extLst>
       <p:ext uri="{BB962C8B-B14F-4D97-AF65-F5344CB8AC3E}">
-        <p14:creationId xmlns:p14="http://schemas.microsoft.com/office/powerpoint/2010/main" val="1057083498"/>
+        <p14:creationId xmlns:p14="http://schemas.microsoft.com/office/powerpoint/2010/main" val="1506089932"/>
       </p:ext>
     </p:extLst>
   </p:cSld>
@@ -6458,7 +6458,7 @@
           <p:cNvPr id="7" name="">
             <a:extLst xmlns:a="http://schemas.openxmlformats.org/drawingml/2006/main">
               <a:ext uri="{FF2B5EF4-FFF2-40B4-BE49-F238E27FC236}">
-                <a16:creationId xmlns:a16="http://schemas.microsoft.com/office/drawing/2014/main" id="{B2005D17-CDA4-4276-BDE6-DEF9F36F1753}"/>
+                <a16:creationId xmlns:a16="http://schemas.microsoft.com/office/drawing/2014/main" id="{DB705EF7-8161-423B-8FC7-81B87CE14C0A}"/>
               </a:ext>
             </a:extLst>
           </p:cNvPr>
@@ -6614,7 +6614,7 @@
           <p:cNvPr id="2" name="">
             <a:extLst xmlns:a="http://schemas.openxmlformats.org/drawingml/2006/main">
               <a:ext uri="{FF2B5EF4-FFF2-40B4-BE49-F238E27FC236}">
-                <a16:creationId xmlns:a16="http://schemas.microsoft.com/office/drawing/2014/main" id="{365305D8-F94A-4A54-BE53-F6AD9780F30E}"/>
+                <a16:creationId xmlns:a16="http://schemas.microsoft.com/office/drawing/2014/main" id="{41020246-8D95-42A7-B264-675D2D1F4D4D}"/>
               </a:ext>
             </a:extLst>
           </p:cNvPr>
@@ -6770,7 +6770,7 @@
           <p:cNvPr id="3" name="">
             <a:extLst xmlns:a="http://schemas.openxmlformats.org/drawingml/2006/main">
               <a:ext uri="{FF2B5EF4-FFF2-40B4-BE49-F238E27FC236}">
-                <a16:creationId xmlns:a16="http://schemas.microsoft.com/office/drawing/2014/main" id="{7F704579-8BF2-4D63-B5C2-2A3E060C0E72}"/>
+                <a16:creationId xmlns:a16="http://schemas.microsoft.com/office/drawing/2014/main" id="{F1B65B09-FE97-445D-A40A-CBA622FB7FDE}"/>
               </a:ext>
             </a:extLst>
           </p:cNvPr>
@@ -6926,7 +6926,7 @@
           <p:cNvPr id="4" name="">
             <a:extLst xmlns:a="http://schemas.openxmlformats.org/drawingml/2006/main">
               <a:ext uri="{FF2B5EF4-FFF2-40B4-BE49-F238E27FC236}">
-                <a16:creationId xmlns:a16="http://schemas.microsoft.com/office/drawing/2014/main" id="{909F6676-DF99-4190-B9B4-741824AA97EF}"/>
+                <a16:creationId xmlns:a16="http://schemas.microsoft.com/office/drawing/2014/main" id="{0A30CC92-6AF1-4017-B921-6430ABA642BD}"/>
               </a:ext>
             </a:extLst>
           </p:cNvPr>
@@ -7082,7 +7082,7 @@
           <p:cNvPr id="5" name="">
             <a:extLst xmlns:a="http://schemas.openxmlformats.org/drawingml/2006/main">
               <a:ext uri="{FF2B5EF4-FFF2-40B4-BE49-F238E27FC236}">
-                <a16:creationId xmlns:a16="http://schemas.microsoft.com/office/drawing/2014/main" id="{7BC7A3E6-D615-4FE8-A5BD-2B23C602B192}"/>
+                <a16:creationId xmlns:a16="http://schemas.microsoft.com/office/drawing/2014/main" id="{9D774F05-9E90-40FC-95FE-8847DAF8927D}"/>
               </a:ext>
             </a:extLst>
           </p:cNvPr>
@@ -7645,7 +7645,7 @@
           <p:cNvPr id="6" name="">
             <a:extLst xmlns:a="http://schemas.openxmlformats.org/drawingml/2006/main">
               <a:ext uri="{FF2B5EF4-FFF2-40B4-BE49-F238E27FC236}">
-                <a16:creationId xmlns:a16="http://schemas.microsoft.com/office/drawing/2014/main" id="{ADC3F8F8-CD62-4883-90D1-22F439B40CE2}"/>
+                <a16:creationId xmlns:a16="http://schemas.microsoft.com/office/drawing/2014/main" id="{EF5946DD-8B9F-4C1F-BA66-7940D1619D2F}"/>
               </a:ext>
             </a:extLst>
           </p:cNvPr>
@@ -7799,7 +7799,7 @@
     </p:spTree>
     <p:extLst>
       <p:ext uri="{BB962C8B-B14F-4D97-AF65-F5344CB8AC3E}">
-        <p14:creationId xmlns:p14="http://schemas.microsoft.com/office/powerpoint/2010/main" val="818472348"/>
+        <p14:creationId xmlns:p14="http://schemas.microsoft.com/office/powerpoint/2010/main" val="91356282"/>
       </p:ext>
     </p:extLst>
   </p:cSld>
@@ -7830,7 +7830,7 @@
           <p:cNvPr id="7" name="">
             <a:extLst xmlns:a="http://schemas.openxmlformats.org/drawingml/2006/main">
               <a:ext uri="{FF2B5EF4-FFF2-40B4-BE49-F238E27FC236}">
-                <a16:creationId xmlns:a16="http://schemas.microsoft.com/office/drawing/2014/main" id="{4219504C-6892-4A9D-AB43-418FDCC498CF}"/>
+                <a16:creationId xmlns:a16="http://schemas.microsoft.com/office/drawing/2014/main" id="{36C20F2E-A4E8-4F18-B480-653B14D8E582}"/>
               </a:ext>
             </a:extLst>
           </p:cNvPr>
@@ -7986,7 +7986,7 @@
           <p:cNvPr id="2" name="">
             <a:extLst xmlns:a="http://schemas.openxmlformats.org/drawingml/2006/main">
               <a:ext uri="{FF2B5EF4-FFF2-40B4-BE49-F238E27FC236}">
-                <a16:creationId xmlns:a16="http://schemas.microsoft.com/office/drawing/2014/main" id="{8D450044-95CA-4F88-A505-159BD29C0880}"/>
+                <a16:creationId xmlns:a16="http://schemas.microsoft.com/office/drawing/2014/main" id="{0E936171-876B-42B0-8B2C-B7893F8C0614}"/>
               </a:ext>
             </a:extLst>
           </p:cNvPr>
@@ -8142,7 +8142,7 @@
           <p:cNvPr id="3" name="">
             <a:extLst xmlns:a="http://schemas.openxmlformats.org/drawingml/2006/main">
               <a:ext uri="{FF2B5EF4-FFF2-40B4-BE49-F238E27FC236}">
-                <a16:creationId xmlns:a16="http://schemas.microsoft.com/office/drawing/2014/main" id="{37D20226-A065-4077-A30F-3AD9B09BD21C}"/>
+                <a16:creationId xmlns:a16="http://schemas.microsoft.com/office/drawing/2014/main" id="{6A3A3D60-6417-466B-B143-5F92DBB777AD}"/>
               </a:ext>
             </a:extLst>
           </p:cNvPr>
@@ -8298,7 +8298,7 @@
           <p:cNvPr id="4" name="">
             <a:extLst xmlns:a="http://schemas.openxmlformats.org/drawingml/2006/main">
               <a:ext uri="{FF2B5EF4-FFF2-40B4-BE49-F238E27FC236}">
-                <a16:creationId xmlns:a16="http://schemas.microsoft.com/office/drawing/2014/main" id="{C4D2EA87-A55F-487A-AEC5-CE371929159F}"/>
+                <a16:creationId xmlns:a16="http://schemas.microsoft.com/office/drawing/2014/main" id="{E405173D-6090-41D2-B3EC-C7CBB29A257E}"/>
               </a:ext>
             </a:extLst>
           </p:cNvPr>
@@ -8454,7 +8454,7 @@
           <p:cNvPr id="5" name="">
             <a:extLst xmlns:a="http://schemas.openxmlformats.org/drawingml/2006/main">
               <a:ext uri="{FF2B5EF4-FFF2-40B4-BE49-F238E27FC236}">
-                <a16:creationId xmlns:a16="http://schemas.microsoft.com/office/drawing/2014/main" id="{E8BABE3D-A5AD-4EC7-9F21-72DA1853B39F}"/>
+                <a16:creationId xmlns:a16="http://schemas.microsoft.com/office/drawing/2014/main" id="{0F9B96CE-D7FE-4F04-B878-1652979A8A8C}"/>
               </a:ext>
             </a:extLst>
           </p:cNvPr>
@@ -9030,7 +9030,7 @@
           <p:cNvPr id="6" name="">
             <a:extLst xmlns:a="http://schemas.openxmlformats.org/drawingml/2006/main">
               <a:ext uri="{FF2B5EF4-FFF2-40B4-BE49-F238E27FC236}">
-                <a16:creationId xmlns:a16="http://schemas.microsoft.com/office/drawing/2014/main" id="{381A82F2-84E2-44D9-8098-CBEA40E13DF8}"/>
+                <a16:creationId xmlns:a16="http://schemas.microsoft.com/office/drawing/2014/main" id="{3AB313B7-7337-4451-A044-57E670CFA7AE}"/>
               </a:ext>
             </a:extLst>
           </p:cNvPr>
@@ -9184,7 +9184,7 @@
     </p:spTree>
     <p:extLst>
       <p:ext uri="{BB962C8B-B14F-4D97-AF65-F5344CB8AC3E}">
-        <p14:creationId xmlns:p14="http://schemas.microsoft.com/office/powerpoint/2010/main" val="333788575"/>
+        <p14:creationId xmlns:p14="http://schemas.microsoft.com/office/powerpoint/2010/main" val="635011642"/>
       </p:ext>
     </p:extLst>
   </p:cSld>
@@ -9215,7 +9215,7 @@
           <p:cNvPr id="38" name="">
             <a:extLst xmlns:a="http://schemas.openxmlformats.org/drawingml/2006/main">
               <a:ext uri="{FF2B5EF4-FFF2-40B4-BE49-F238E27FC236}">
-                <a16:creationId xmlns:a16="http://schemas.microsoft.com/office/drawing/2014/main" id="{E36E36B7-77F8-4F9A-A4DF-809D6AE9D9D6}"/>
+                <a16:creationId xmlns:a16="http://schemas.microsoft.com/office/drawing/2014/main" id="{BBCB118F-ACF0-4D4F-9520-F654A184B2E9}"/>
               </a:ext>
             </a:extLst>
           </p:cNvPr>
@@ -9371,7 +9371,7 @@
           <p:cNvPr id="2" name="">
             <a:extLst xmlns:a="http://schemas.openxmlformats.org/drawingml/2006/main">
               <a:ext uri="{FF2B5EF4-FFF2-40B4-BE49-F238E27FC236}">
-                <a16:creationId xmlns:a16="http://schemas.microsoft.com/office/drawing/2014/main" id="{1B346304-DA4A-4EE4-9837-040C96819647}"/>
+                <a16:creationId xmlns:a16="http://schemas.microsoft.com/office/drawing/2014/main" id="{D8463C48-CFE6-4537-B1EF-D8C5B01C4A0A}"/>
               </a:ext>
             </a:extLst>
           </p:cNvPr>
@@ -9527,7 +9527,7 @@
           <p:cNvPr id="3" name="">
             <a:extLst xmlns:a="http://schemas.openxmlformats.org/drawingml/2006/main">
               <a:ext uri="{FF2B5EF4-FFF2-40B4-BE49-F238E27FC236}">
-                <a16:creationId xmlns:a16="http://schemas.microsoft.com/office/drawing/2014/main" id="{3463D7E6-5914-4C01-9B3C-CBCFBBF42543}"/>
+                <a16:creationId xmlns:a16="http://schemas.microsoft.com/office/drawing/2014/main" id="{50EC9363-C6B0-4AC7-9B6D-0AD166198849}"/>
               </a:ext>
             </a:extLst>
           </p:cNvPr>
@@ -9683,7 +9683,7 @@
           <p:cNvPr id="4" name="">
             <a:extLst xmlns:a="http://schemas.openxmlformats.org/drawingml/2006/main">
               <a:ext uri="{FF2B5EF4-FFF2-40B4-BE49-F238E27FC236}">
-                <a16:creationId xmlns:a16="http://schemas.microsoft.com/office/drawing/2014/main" id="{6E749EB8-28F3-4075-B196-6E559D1FB40B}"/>
+                <a16:creationId xmlns:a16="http://schemas.microsoft.com/office/drawing/2014/main" id="{FB102673-F490-4B1B-8E36-2C65CD20FBF8}"/>
               </a:ext>
             </a:extLst>
           </p:cNvPr>
@@ -9839,7 +9839,7 @@
           <p:cNvPr id="5" name="">
             <a:extLst xmlns:a="http://schemas.openxmlformats.org/drawingml/2006/main">
               <a:ext uri="{FF2B5EF4-FFF2-40B4-BE49-F238E27FC236}">
-                <a16:creationId xmlns:a16="http://schemas.microsoft.com/office/drawing/2014/main" id="{9571F0DE-EE18-4DE2-9BD3-E86B52FFE111}"/>
+                <a16:creationId xmlns:a16="http://schemas.microsoft.com/office/drawing/2014/main" id="{96174A1E-3813-4E8C-A872-6C23C60646E5}"/>
               </a:ext>
             </a:extLst>
           </p:cNvPr>
@@ -9995,7 +9995,7 @@
           <p:cNvPr id="6" name="">
             <a:extLst xmlns:a="http://schemas.openxmlformats.org/drawingml/2006/main">
               <a:ext uri="{FF2B5EF4-FFF2-40B4-BE49-F238E27FC236}">
-                <a16:creationId xmlns:a16="http://schemas.microsoft.com/office/drawing/2014/main" id="{E78B12EB-F8EA-4A1C-B4B2-5B8794C99206}"/>
+                <a16:creationId xmlns:a16="http://schemas.microsoft.com/office/drawing/2014/main" id="{3E8999C7-CE09-4EFA-A29E-ADDABD28E2E8}"/>
               </a:ext>
             </a:extLst>
           </p:cNvPr>
@@ -10151,7 +10151,7 @@
           <p:cNvPr id="7" name="">
             <a:extLst xmlns:a="http://schemas.openxmlformats.org/drawingml/2006/main">
               <a:ext uri="{FF2B5EF4-FFF2-40B4-BE49-F238E27FC236}">
-                <a16:creationId xmlns:a16="http://schemas.microsoft.com/office/drawing/2014/main" id="{71850326-C03C-48DB-BDC0-3C7DFCACBA19}"/>
+                <a16:creationId xmlns:a16="http://schemas.microsoft.com/office/drawing/2014/main" id="{196F74C3-110E-48B1-AAE3-38A999A38418}"/>
               </a:ext>
             </a:extLst>
           </p:cNvPr>
@@ -10181,7 +10181,7 @@
           <p:cNvPr id="8" name="">
             <a:extLst xmlns:a="http://schemas.openxmlformats.org/drawingml/2006/main">
               <a:ext uri="{FF2B5EF4-FFF2-40B4-BE49-F238E27FC236}">
-                <a16:creationId xmlns:a16="http://schemas.microsoft.com/office/drawing/2014/main" id="{02A60FAF-3AD3-4A1C-A477-21A0071CD291}"/>
+                <a16:creationId xmlns:a16="http://schemas.microsoft.com/office/drawing/2014/main" id="{79CABC80-CCEF-4645-9D1D-8FBF2E712425}"/>
               </a:ext>
             </a:extLst>
           </p:cNvPr>
@@ -10211,7 +10211,7 @@
           <p:cNvPr id="9" name="">
             <a:extLst xmlns:a="http://schemas.openxmlformats.org/drawingml/2006/main">
               <a:ext uri="{FF2B5EF4-FFF2-40B4-BE49-F238E27FC236}">
-                <a16:creationId xmlns:a16="http://schemas.microsoft.com/office/drawing/2014/main" id="{3821EF04-0630-44E4-A053-D98FA8407E96}"/>
+                <a16:creationId xmlns:a16="http://schemas.microsoft.com/office/drawing/2014/main" id="{75C8ACB9-AAEB-489B-8A54-43444CE986D1}"/>
               </a:ext>
             </a:extLst>
           </p:cNvPr>
@@ -10367,7 +10367,7 @@
           <p:cNvPr id="10" name="">
             <a:extLst xmlns:a="http://schemas.openxmlformats.org/drawingml/2006/main">
               <a:ext uri="{FF2B5EF4-FFF2-40B4-BE49-F238E27FC236}">
-                <a16:creationId xmlns:a16="http://schemas.microsoft.com/office/drawing/2014/main" id="{DEC2FD16-E13B-4054-A3AD-5674B5707584}"/>
+                <a16:creationId xmlns:a16="http://schemas.microsoft.com/office/drawing/2014/main" id="{7B6EC9A8-DCEC-4E10-9E0A-2C9D2E50FB94}"/>
               </a:ext>
             </a:extLst>
           </p:cNvPr>
@@ -10523,7 +10523,7 @@
           <p:cNvPr id="11" name="">
             <a:extLst xmlns:a="http://schemas.openxmlformats.org/drawingml/2006/main">
               <a:ext uri="{FF2B5EF4-FFF2-40B4-BE49-F238E27FC236}">
-                <a16:creationId xmlns:a16="http://schemas.microsoft.com/office/drawing/2014/main" id="{3D00D106-E261-44A2-B31E-84F5A90DC450}"/>
+                <a16:creationId xmlns:a16="http://schemas.microsoft.com/office/drawing/2014/main" id="{C9B66BA1-EB1E-47FC-BAD4-785715BBA75B}"/>
               </a:ext>
             </a:extLst>
           </p:cNvPr>
@@ -10553,7 +10553,7 @@
           <p:cNvPr id="12" name="">
             <a:extLst xmlns:a="http://schemas.openxmlformats.org/drawingml/2006/main">
               <a:ext uri="{FF2B5EF4-FFF2-40B4-BE49-F238E27FC236}">
-                <a16:creationId xmlns:a16="http://schemas.microsoft.com/office/drawing/2014/main" id="{92BFD08D-7808-4655-8BBA-3F67D6A42287}"/>
+                <a16:creationId xmlns:a16="http://schemas.microsoft.com/office/drawing/2014/main" id="{7095F05D-6D6C-45EC-B771-A17B20002E6B}"/>
               </a:ext>
             </a:extLst>
           </p:cNvPr>
@@ -10709,7 +10709,7 @@
           <p:cNvPr id="13" name="">
             <a:extLst xmlns:a="http://schemas.openxmlformats.org/drawingml/2006/main">
               <a:ext uri="{FF2B5EF4-FFF2-40B4-BE49-F238E27FC236}">
-                <a16:creationId xmlns:a16="http://schemas.microsoft.com/office/drawing/2014/main" id="{A13B371A-ADBC-4607-85D4-92DE7A5B9384}"/>
+                <a16:creationId xmlns:a16="http://schemas.microsoft.com/office/drawing/2014/main" id="{5334BB41-AA59-4EC1-BE8D-5BB46DF57B14}"/>
               </a:ext>
             </a:extLst>
           </p:cNvPr>
@@ -10865,7 +10865,7 @@
           <p:cNvPr id="14" name="">
             <a:extLst xmlns:a="http://schemas.openxmlformats.org/drawingml/2006/main">
               <a:ext uri="{FF2B5EF4-FFF2-40B4-BE49-F238E27FC236}">
-                <a16:creationId xmlns:a16="http://schemas.microsoft.com/office/drawing/2014/main" id="{8792BFD0-8E02-4D81-AD7F-83FA1EFB9946}"/>
+                <a16:creationId xmlns:a16="http://schemas.microsoft.com/office/drawing/2014/main" id="{18C40541-9B10-4EC9-9E89-DD281AE11011}"/>
               </a:ext>
             </a:extLst>
           </p:cNvPr>
@@ -11021,7 +11021,7 @@
           <p:cNvPr id="15" name="">
             <a:extLst xmlns:a="http://schemas.openxmlformats.org/drawingml/2006/main">
               <a:ext uri="{FF2B5EF4-FFF2-40B4-BE49-F238E27FC236}">
-                <a16:creationId xmlns:a16="http://schemas.microsoft.com/office/drawing/2014/main" id="{1B12F8F9-BB91-41BE-A15A-DBFED154CA04}"/>
+                <a16:creationId xmlns:a16="http://schemas.microsoft.com/office/drawing/2014/main" id="{110E938A-775B-4C31-A006-7250B629DA64}"/>
               </a:ext>
             </a:extLst>
           </p:cNvPr>
@@ -11051,7 +11051,7 @@
           <p:cNvPr id="16" name="">
             <a:extLst xmlns:a="http://schemas.openxmlformats.org/drawingml/2006/main">
               <a:ext uri="{FF2B5EF4-FFF2-40B4-BE49-F238E27FC236}">
-                <a16:creationId xmlns:a16="http://schemas.microsoft.com/office/drawing/2014/main" id="{2321BEBA-61AC-4B9B-940E-DFAF903725F7}"/>
+                <a16:creationId xmlns:a16="http://schemas.microsoft.com/office/drawing/2014/main" id="{FF618207-14A7-4AE1-9253-C101AF510BF3}"/>
               </a:ext>
             </a:extLst>
           </p:cNvPr>
@@ -11081,7 +11081,7 @@
           <p:cNvPr id="17" name="">
             <a:extLst xmlns:a="http://schemas.openxmlformats.org/drawingml/2006/main">
               <a:ext uri="{FF2B5EF4-FFF2-40B4-BE49-F238E27FC236}">
-                <a16:creationId xmlns:a16="http://schemas.microsoft.com/office/drawing/2014/main" id="{65D65BF1-101A-4670-9E2F-1A36DC5A0C6E}"/>
+                <a16:creationId xmlns:a16="http://schemas.microsoft.com/office/drawing/2014/main" id="{66EC592A-18B2-4921-971D-197634916F74}"/>
               </a:ext>
             </a:extLst>
           </p:cNvPr>
@@ -11237,7 +11237,7 @@
           <p:cNvPr id="18" name="">
             <a:extLst xmlns:a="http://schemas.openxmlformats.org/drawingml/2006/main">
               <a:ext uri="{FF2B5EF4-FFF2-40B4-BE49-F238E27FC236}">
-                <a16:creationId xmlns:a16="http://schemas.microsoft.com/office/drawing/2014/main" id="{7F7FA6B5-D366-4BAF-BDC2-B9B216CA07D1}"/>
+                <a16:creationId xmlns:a16="http://schemas.microsoft.com/office/drawing/2014/main" id="{86542604-59A8-4145-A13D-9C3008C477C6}"/>
               </a:ext>
             </a:extLst>
           </p:cNvPr>
@@ -11393,7 +11393,7 @@
           <p:cNvPr id="19" name="">
             <a:extLst xmlns:a="http://schemas.openxmlformats.org/drawingml/2006/main">
               <a:ext uri="{FF2B5EF4-FFF2-40B4-BE49-F238E27FC236}">
-                <a16:creationId xmlns:a16="http://schemas.microsoft.com/office/drawing/2014/main" id="{9B8B9721-5057-43B9-B1DC-01BC60F0EAEC}"/>
+                <a16:creationId xmlns:a16="http://schemas.microsoft.com/office/drawing/2014/main" id="{73D2AB65-9B96-425A-9494-341181020DD5}"/>
               </a:ext>
             </a:extLst>
           </p:cNvPr>
@@ -11423,7 +11423,7 @@
           <p:cNvPr id="20" name="">
             <a:extLst xmlns:a="http://schemas.openxmlformats.org/drawingml/2006/main">
               <a:ext uri="{FF2B5EF4-FFF2-40B4-BE49-F238E27FC236}">
-                <a16:creationId xmlns:a16="http://schemas.microsoft.com/office/drawing/2014/main" id="{F63B3ABC-25C4-4AAC-A8D9-01144EC4BD78}"/>
+                <a16:creationId xmlns:a16="http://schemas.microsoft.com/office/drawing/2014/main" id="{502CA9E0-D16B-4F21-99EC-893C63E3ABB5}"/>
               </a:ext>
             </a:extLst>
           </p:cNvPr>
@@ -11579,7 +11579,7 @@
           <p:cNvPr id="21" name="">
             <a:extLst xmlns:a="http://schemas.openxmlformats.org/drawingml/2006/main">
               <a:ext uri="{FF2B5EF4-FFF2-40B4-BE49-F238E27FC236}">
-                <a16:creationId xmlns:a16="http://schemas.microsoft.com/office/drawing/2014/main" id="{F71DEB2A-8403-4CDF-8DED-AF8D60F3E7F6}"/>
+                <a16:creationId xmlns:a16="http://schemas.microsoft.com/office/drawing/2014/main" id="{DB51EE77-495B-42C3-8C80-7340C9399B7D}"/>
               </a:ext>
             </a:extLst>
           </p:cNvPr>
@@ -11735,7 +11735,7 @@
           <p:cNvPr id="22" name="">
             <a:extLst xmlns:a="http://schemas.openxmlformats.org/drawingml/2006/main">
               <a:ext uri="{FF2B5EF4-FFF2-40B4-BE49-F238E27FC236}">
-                <a16:creationId xmlns:a16="http://schemas.microsoft.com/office/drawing/2014/main" id="{1C0A6224-E8D5-46FA-958A-8CF76EB86323}"/>
+                <a16:creationId xmlns:a16="http://schemas.microsoft.com/office/drawing/2014/main" id="{2BDE5F31-3719-4303-8D79-01840019330A}"/>
               </a:ext>
             </a:extLst>
           </p:cNvPr>
@@ -11765,7 +11765,7 @@
           <p:cNvPr id="23" name="">
             <a:extLst xmlns:a="http://schemas.openxmlformats.org/drawingml/2006/main">
               <a:ext uri="{FF2B5EF4-FFF2-40B4-BE49-F238E27FC236}">
-                <a16:creationId xmlns:a16="http://schemas.microsoft.com/office/drawing/2014/main" id="{BBDF80CD-AD84-4316-9C3C-D87ABE318F1A}"/>
+                <a16:creationId xmlns:a16="http://schemas.microsoft.com/office/drawing/2014/main" id="{2D7ABA00-B46E-4942-92B2-6538692F2DC5}"/>
               </a:ext>
             </a:extLst>
           </p:cNvPr>
@@ -11795,7 +11795,7 @@
           <p:cNvPr id="24" name="">
             <a:extLst xmlns:a="http://schemas.openxmlformats.org/drawingml/2006/main">
               <a:ext uri="{FF2B5EF4-FFF2-40B4-BE49-F238E27FC236}">
-                <a16:creationId xmlns:a16="http://schemas.microsoft.com/office/drawing/2014/main" id="{0495208C-AB94-44A4-8F86-A49163A5AE87}"/>
+                <a16:creationId xmlns:a16="http://schemas.microsoft.com/office/drawing/2014/main" id="{B429D3C5-79BB-4F1C-82C3-F65F95D0BAB1}"/>
               </a:ext>
             </a:extLst>
           </p:cNvPr>
@@ -11951,7 +11951,7 @@
           <p:cNvPr id="25" name="">
             <a:extLst xmlns:a="http://schemas.openxmlformats.org/drawingml/2006/main">
               <a:ext uri="{FF2B5EF4-FFF2-40B4-BE49-F238E27FC236}">
-                <a16:creationId xmlns:a16="http://schemas.microsoft.com/office/drawing/2014/main" id="{42C92DCC-9ECE-4C17-A3BD-22F5EC5700E0}"/>
+                <a16:creationId xmlns:a16="http://schemas.microsoft.com/office/drawing/2014/main" id="{A1E655B5-BA41-4E71-8D91-3EAB741A864D}"/>
               </a:ext>
             </a:extLst>
           </p:cNvPr>
@@ -11981,7 +11981,7 @@
           <p:cNvPr id="26" name="">
             <a:extLst xmlns:a="http://schemas.openxmlformats.org/drawingml/2006/main">
               <a:ext uri="{FF2B5EF4-FFF2-40B4-BE49-F238E27FC236}">
-                <a16:creationId xmlns:a16="http://schemas.microsoft.com/office/drawing/2014/main" id="{2B46D7C8-8976-491C-B230-E593B5CCFCF4}"/>
+                <a16:creationId xmlns:a16="http://schemas.microsoft.com/office/drawing/2014/main" id="{E2E3377E-4CDF-41FB-80DE-943A61AC617E}"/>
               </a:ext>
             </a:extLst>
           </p:cNvPr>
@@ -12137,7 +12137,7 @@
           <p:cNvPr id="27" name="">
             <a:extLst xmlns:a="http://schemas.openxmlformats.org/drawingml/2006/main">
               <a:ext uri="{FF2B5EF4-FFF2-40B4-BE49-F238E27FC236}">
-                <a16:creationId xmlns:a16="http://schemas.microsoft.com/office/drawing/2014/main" id="{361FDF0E-B55E-4CAB-A653-2DD22927B55C}"/>
+                <a16:creationId xmlns:a16="http://schemas.microsoft.com/office/drawing/2014/main" id="{8DF9AE9E-EC58-40B9-BBA9-4651D3F1F334}"/>
               </a:ext>
             </a:extLst>
           </p:cNvPr>
@@ -12167,7 +12167,7 @@
           <p:cNvPr id="28" name="">
             <a:extLst xmlns:a="http://schemas.openxmlformats.org/drawingml/2006/main">
               <a:ext uri="{FF2B5EF4-FFF2-40B4-BE49-F238E27FC236}">
-                <a16:creationId xmlns:a16="http://schemas.microsoft.com/office/drawing/2014/main" id="{35B2D4FA-B50E-46CC-B706-B5BD01137878}"/>
+                <a16:creationId xmlns:a16="http://schemas.microsoft.com/office/drawing/2014/main" id="{D9457FD5-805E-4DBB-BD10-4F92D653C2E8}"/>
               </a:ext>
             </a:extLst>
           </p:cNvPr>
@@ -12323,7 +12323,7 @@
           <p:cNvPr id="29" name="">
             <a:extLst xmlns:a="http://schemas.openxmlformats.org/drawingml/2006/main">
               <a:ext uri="{FF2B5EF4-FFF2-40B4-BE49-F238E27FC236}">
-                <a16:creationId xmlns:a16="http://schemas.microsoft.com/office/drawing/2014/main" id="{D31DA114-1F12-4B22-BA64-356AEF452365}"/>
+                <a16:creationId xmlns:a16="http://schemas.microsoft.com/office/drawing/2014/main" id="{F4238D89-7EE0-4C37-9F3D-8B74FF5D65D9}"/>
               </a:ext>
             </a:extLst>
           </p:cNvPr>
@@ -12353,7 +12353,7 @@
           <p:cNvPr id="30" name="">
             <a:extLst xmlns:a="http://schemas.openxmlformats.org/drawingml/2006/main">
               <a:ext uri="{FF2B5EF4-FFF2-40B4-BE49-F238E27FC236}">
-                <a16:creationId xmlns:a16="http://schemas.microsoft.com/office/drawing/2014/main" id="{45D9EFDE-A1A6-49DA-AB73-97A5CE9B8D96}"/>
+                <a16:creationId xmlns:a16="http://schemas.microsoft.com/office/drawing/2014/main" id="{5921E925-66C8-4116-8297-D7DDE515B3F6}"/>
               </a:ext>
             </a:extLst>
           </p:cNvPr>
@@ -12509,7 +12509,7 @@
           <p:cNvPr id="31" name="">
             <a:extLst xmlns:a="http://schemas.openxmlformats.org/drawingml/2006/main">
               <a:ext uri="{FF2B5EF4-FFF2-40B4-BE49-F238E27FC236}">
-                <a16:creationId xmlns:a16="http://schemas.microsoft.com/office/drawing/2014/main" id="{C8C304CD-C85D-431A-ABC4-4EEF5351FB6F}"/>
+                <a16:creationId xmlns:a16="http://schemas.microsoft.com/office/drawing/2014/main" id="{5BC168AA-A8F0-456B-9B00-EEB6EED14563}"/>
               </a:ext>
             </a:extLst>
           </p:cNvPr>
@@ -12539,7 +12539,7 @@
           <p:cNvPr id="32" name="">
             <a:extLst xmlns:a="http://schemas.openxmlformats.org/drawingml/2006/main">
               <a:ext uri="{FF2B5EF4-FFF2-40B4-BE49-F238E27FC236}">
-                <a16:creationId xmlns:a16="http://schemas.microsoft.com/office/drawing/2014/main" id="{1D487875-084A-4764-82D9-4276252C4C18}"/>
+                <a16:creationId xmlns:a16="http://schemas.microsoft.com/office/drawing/2014/main" id="{ADD2D8E2-3369-4858-BEA3-F0169218F365}"/>
               </a:ext>
             </a:extLst>
           </p:cNvPr>
@@ -12695,7 +12695,7 @@
           <p:cNvPr id="33" name="">
             <a:extLst xmlns:a="http://schemas.openxmlformats.org/drawingml/2006/main">
               <a:ext uri="{FF2B5EF4-FFF2-40B4-BE49-F238E27FC236}">
-                <a16:creationId xmlns:a16="http://schemas.microsoft.com/office/drawing/2014/main" id="{5687F098-90BB-45A8-9BBF-CA99D8429143}"/>
+                <a16:creationId xmlns:a16="http://schemas.microsoft.com/office/drawing/2014/main" id="{F3EA5E49-B157-43D6-A88F-A752E7C70799}"/>
               </a:ext>
             </a:extLst>
           </p:cNvPr>
@@ -12725,7 +12725,7 @@
           <p:cNvPr id="34" name="">
             <a:extLst xmlns:a="http://schemas.openxmlformats.org/drawingml/2006/main">
               <a:ext uri="{FF2B5EF4-FFF2-40B4-BE49-F238E27FC236}">
-                <a16:creationId xmlns:a16="http://schemas.microsoft.com/office/drawing/2014/main" id="{6931471C-32C0-40CA-B56B-6DA9EF9E48D6}"/>
+                <a16:creationId xmlns:a16="http://schemas.microsoft.com/office/drawing/2014/main" id="{6684212F-9929-4F27-9B6D-057E0C5B9815}"/>
               </a:ext>
             </a:extLst>
           </p:cNvPr>
@@ -12881,7 +12881,7 @@
           <p:cNvPr id="35" name="">
             <a:extLst xmlns:a="http://schemas.openxmlformats.org/drawingml/2006/main">
               <a:ext uri="{FF2B5EF4-FFF2-40B4-BE49-F238E27FC236}">
-                <a16:creationId xmlns:a16="http://schemas.microsoft.com/office/drawing/2014/main" id="{40491F1B-CA5F-4081-84FA-BF6C5FD8E5ED}"/>
+                <a16:creationId xmlns:a16="http://schemas.microsoft.com/office/drawing/2014/main" id="{0E073665-9E69-44C5-A8DF-9FE07A060C85}"/>
               </a:ext>
             </a:extLst>
           </p:cNvPr>
@@ -13037,7 +13037,7 @@
           <p:cNvPr id="36" name="">
             <a:extLst xmlns:a="http://schemas.openxmlformats.org/drawingml/2006/main">
               <a:ext uri="{FF2B5EF4-FFF2-40B4-BE49-F238E27FC236}">
-                <a16:creationId xmlns:a16="http://schemas.microsoft.com/office/drawing/2014/main" id="{AA21469C-DAA4-43DD-812E-E7E59DDFD53D}"/>
+                <a16:creationId xmlns:a16="http://schemas.microsoft.com/office/drawing/2014/main" id="{7A47CE2E-7FB9-4386-AA01-3461EF743B2B}"/>
               </a:ext>
             </a:extLst>
           </p:cNvPr>
@@ -13193,7 +13193,7 @@
           <p:cNvPr id="37" name="">
             <a:extLst xmlns:a="http://schemas.openxmlformats.org/drawingml/2006/main">
               <a:ext uri="{FF2B5EF4-FFF2-40B4-BE49-F238E27FC236}">
-                <a16:creationId xmlns:a16="http://schemas.microsoft.com/office/drawing/2014/main" id="{504330D0-4D57-4B6F-8561-48E4BA29BACB}"/>
+                <a16:creationId xmlns:a16="http://schemas.microsoft.com/office/drawing/2014/main" id="{CD83BBC3-717E-498D-9C90-501E73C0A1D7}"/>
               </a:ext>
             </a:extLst>
           </p:cNvPr>
@@ -13347,7 +13347,7 @@
     </p:spTree>
     <p:extLst>
       <p:ext uri="{BB962C8B-B14F-4D97-AF65-F5344CB8AC3E}">
-        <p14:creationId xmlns:p14="http://schemas.microsoft.com/office/powerpoint/2010/main" val="1459161322"/>
+        <p14:creationId xmlns:p14="http://schemas.microsoft.com/office/powerpoint/2010/main" val="1029791291"/>
       </p:ext>
     </p:extLst>
   </p:cSld>
@@ -13378,7 +13378,7 @@
           <p:cNvPr id="8" name="">
             <a:extLst xmlns:a="http://schemas.openxmlformats.org/drawingml/2006/main">
               <a:ext uri="{FF2B5EF4-FFF2-40B4-BE49-F238E27FC236}">
-                <a16:creationId xmlns:a16="http://schemas.microsoft.com/office/drawing/2014/main" id="{921AF454-E8EA-436A-A72B-05990D96267B}"/>
+                <a16:creationId xmlns:a16="http://schemas.microsoft.com/office/drawing/2014/main" id="{D70A614F-8DA2-4085-B45D-0757A44FC379}"/>
               </a:ext>
             </a:extLst>
           </p:cNvPr>
@@ -13534,7 +13534,7 @@
           <p:cNvPr id="2" name="">
             <a:extLst xmlns:a="http://schemas.openxmlformats.org/drawingml/2006/main">
               <a:ext uri="{FF2B5EF4-FFF2-40B4-BE49-F238E27FC236}">
-                <a16:creationId xmlns:a16="http://schemas.microsoft.com/office/drawing/2014/main" id="{471FD946-01B4-463D-A93B-CE57E67B5C78}"/>
+                <a16:creationId xmlns:a16="http://schemas.microsoft.com/office/drawing/2014/main" id="{623C30A6-6256-40C6-A1B4-656A805011D6}"/>
               </a:ext>
             </a:extLst>
           </p:cNvPr>
@@ -13690,7 +13690,7 @@
           <p:cNvPr id="3" name="">
             <a:extLst xmlns:a="http://schemas.openxmlformats.org/drawingml/2006/main">
               <a:ext uri="{FF2B5EF4-FFF2-40B4-BE49-F238E27FC236}">
-                <a16:creationId xmlns:a16="http://schemas.microsoft.com/office/drawing/2014/main" id="{235D1FCA-F60B-4E9A-BE58-71C635D25835}"/>
+                <a16:creationId xmlns:a16="http://schemas.microsoft.com/office/drawing/2014/main" id="{84E19A3E-598A-4380-9640-8EF8C1864994}"/>
               </a:ext>
             </a:extLst>
           </p:cNvPr>
@@ -13846,7 +13846,7 @@
           <p:cNvPr id="4" name="">
             <a:extLst xmlns:a="http://schemas.openxmlformats.org/drawingml/2006/main">
               <a:ext uri="{FF2B5EF4-FFF2-40B4-BE49-F238E27FC236}">
-                <a16:creationId xmlns:a16="http://schemas.microsoft.com/office/drawing/2014/main" id="{79FE5F4A-7FAA-4901-90DC-1737E2654854}"/>
+                <a16:creationId xmlns:a16="http://schemas.microsoft.com/office/drawing/2014/main" id="{63667682-C114-4A1A-8ED2-DCE58F36FB73}"/>
               </a:ext>
             </a:extLst>
           </p:cNvPr>
@@ -14002,7 +14002,7 @@
           <p:cNvPr id="5" name="">
             <a:extLst xmlns:a="http://schemas.openxmlformats.org/drawingml/2006/main">
               <a:ext uri="{FF2B5EF4-FFF2-40B4-BE49-F238E27FC236}">
-                <a16:creationId xmlns:a16="http://schemas.microsoft.com/office/drawing/2014/main" id="{9C50457A-109A-4239-B400-0C22113C0335}"/>
+                <a16:creationId xmlns:a16="http://schemas.microsoft.com/office/drawing/2014/main" id="{EE276A3C-8D32-4A3C-A4CD-878349FDBD98}"/>
               </a:ext>
             </a:extLst>
           </p:cNvPr>
@@ -14664,7 +14664,7 @@
           <p:cNvPr id="6" name="">
             <a:extLst xmlns:a="http://schemas.openxmlformats.org/drawingml/2006/main">
               <a:ext uri="{FF2B5EF4-FFF2-40B4-BE49-F238E27FC236}">
-                <a16:creationId xmlns:a16="http://schemas.microsoft.com/office/drawing/2014/main" id="{5F262E7E-A7A3-4D86-98C4-5F15216551C0}"/>
+                <a16:creationId xmlns:a16="http://schemas.microsoft.com/office/drawing/2014/main" id="{0AFBC6CF-28FD-445D-B9D6-4C3BDA40CB73}"/>
               </a:ext>
             </a:extLst>
           </p:cNvPr>
@@ -14820,7 +14820,7 @@
           <p:cNvPr id="7" name="">
             <a:extLst xmlns:a="http://schemas.openxmlformats.org/drawingml/2006/main">
               <a:ext uri="{FF2B5EF4-FFF2-40B4-BE49-F238E27FC236}">
-                <a16:creationId xmlns:a16="http://schemas.microsoft.com/office/drawing/2014/main" id="{85EC959A-578D-4E15-B208-17DFD1150C81}"/>
+                <a16:creationId xmlns:a16="http://schemas.microsoft.com/office/drawing/2014/main" id="{C46A79DD-CA52-4A83-AFE7-66BC0A0BC1F9}"/>
               </a:ext>
             </a:extLst>
           </p:cNvPr>
@@ -14974,7 +14974,7 @@
     </p:spTree>
     <p:extLst>
       <p:ext uri="{BB962C8B-B14F-4D97-AF65-F5344CB8AC3E}">
-        <p14:creationId xmlns:p14="http://schemas.microsoft.com/office/powerpoint/2010/main" val="23098504"/>
+        <p14:creationId xmlns:p14="http://schemas.microsoft.com/office/powerpoint/2010/main" val="761706347"/>
       </p:ext>
     </p:extLst>
   </p:cSld>
@@ -15005,7 +15005,7 @@
           <p:cNvPr id="7" name="">
             <a:extLst xmlns:a="http://schemas.openxmlformats.org/drawingml/2006/main">
               <a:ext uri="{FF2B5EF4-FFF2-40B4-BE49-F238E27FC236}">
-                <a16:creationId xmlns:a16="http://schemas.microsoft.com/office/drawing/2014/main" id="{77FCD4AB-2E88-4160-B4BB-DB1FE3F41425}"/>
+                <a16:creationId xmlns:a16="http://schemas.microsoft.com/office/drawing/2014/main" id="{12B3768D-2DA2-421A-A4AC-EC3F3AA65325}"/>
               </a:ext>
             </a:extLst>
           </p:cNvPr>
@@ -15161,7 +15161,7 @@
           <p:cNvPr id="2" name="">
             <a:extLst xmlns:a="http://schemas.openxmlformats.org/drawingml/2006/main">
               <a:ext uri="{FF2B5EF4-FFF2-40B4-BE49-F238E27FC236}">
-                <a16:creationId xmlns:a16="http://schemas.microsoft.com/office/drawing/2014/main" id="{ED8D83E5-9A46-4B3D-9018-FE2C9FA4B479}"/>
+                <a16:creationId xmlns:a16="http://schemas.microsoft.com/office/drawing/2014/main" id="{468E4093-D0D1-4536-BF13-8361523237D3}"/>
               </a:ext>
             </a:extLst>
           </p:cNvPr>
@@ -15317,7 +15317,7 @@
           <p:cNvPr id="3" name="">
             <a:extLst xmlns:a="http://schemas.openxmlformats.org/drawingml/2006/main">
               <a:ext uri="{FF2B5EF4-FFF2-40B4-BE49-F238E27FC236}">
-                <a16:creationId xmlns:a16="http://schemas.microsoft.com/office/drawing/2014/main" id="{68389BF4-C202-4EE9-98BA-B3F6AF1E2B3E}"/>
+                <a16:creationId xmlns:a16="http://schemas.microsoft.com/office/drawing/2014/main" id="{67C5DC55-7884-40D8-9119-F8954E2A6B3C}"/>
               </a:ext>
             </a:extLst>
           </p:cNvPr>
@@ -15473,7 +15473,7 @@
           <p:cNvPr id="4" name="">
             <a:extLst xmlns:a="http://schemas.openxmlformats.org/drawingml/2006/main">
               <a:ext uri="{FF2B5EF4-FFF2-40B4-BE49-F238E27FC236}">
-                <a16:creationId xmlns:a16="http://schemas.microsoft.com/office/drawing/2014/main" id="{51B954D0-9B3A-437E-85BF-7E1F8988765B}"/>
+                <a16:creationId xmlns:a16="http://schemas.microsoft.com/office/drawing/2014/main" id="{19987E6D-D76B-480D-8B84-772F8F8F3AD0}"/>
               </a:ext>
             </a:extLst>
           </p:cNvPr>
@@ -15629,7 +15629,7 @@
           <p:cNvPr id="5" name="">
             <a:extLst xmlns:a="http://schemas.openxmlformats.org/drawingml/2006/main">
               <a:ext uri="{FF2B5EF4-FFF2-40B4-BE49-F238E27FC236}">
-                <a16:creationId xmlns:a16="http://schemas.microsoft.com/office/drawing/2014/main" id="{B8F960F3-0FA4-4639-8DE6-97B7A78C19A2}"/>
+                <a16:creationId xmlns:a16="http://schemas.microsoft.com/office/drawing/2014/main" id="{150CBA5D-8F6E-443E-94B3-4D9FCA65E370}"/>
               </a:ext>
             </a:extLst>
           </p:cNvPr>
@@ -16179,7 +16179,7 @@
           <p:cNvPr id="6" name="">
             <a:extLst xmlns:a="http://schemas.openxmlformats.org/drawingml/2006/main">
               <a:ext uri="{FF2B5EF4-FFF2-40B4-BE49-F238E27FC236}">
-                <a16:creationId xmlns:a16="http://schemas.microsoft.com/office/drawing/2014/main" id="{74420EF0-CB3F-4605-8EF6-62B08B3A870D}"/>
+                <a16:creationId xmlns:a16="http://schemas.microsoft.com/office/drawing/2014/main" id="{CF37702C-18D8-42B2-8DCA-C115C0E0B760}"/>
               </a:ext>
             </a:extLst>
           </p:cNvPr>
@@ -16333,7 +16333,7 @@
     </p:spTree>
     <p:extLst>
       <p:ext uri="{BB962C8B-B14F-4D97-AF65-F5344CB8AC3E}">
-        <p14:creationId xmlns:p14="http://schemas.microsoft.com/office/powerpoint/2010/main" val="851423433"/>
+        <p14:creationId xmlns:p14="http://schemas.microsoft.com/office/powerpoint/2010/main" val="1434793610"/>
       </p:ext>
     </p:extLst>
   </p:cSld>
@@ -16364,7 +16364,7 @@
           <p:cNvPr id="7" name="">
             <a:extLst xmlns:a="http://schemas.openxmlformats.org/drawingml/2006/main">
               <a:ext uri="{FF2B5EF4-FFF2-40B4-BE49-F238E27FC236}">
-                <a16:creationId xmlns:a16="http://schemas.microsoft.com/office/drawing/2014/main" id="{B5442DA7-4B15-4174-9039-382BD51B617A}"/>
+                <a16:creationId xmlns:a16="http://schemas.microsoft.com/office/drawing/2014/main" id="{FD0D153C-F6FC-46A6-945A-B3E51AA045CC}"/>
               </a:ext>
             </a:extLst>
           </p:cNvPr>
@@ -16520,7 +16520,7 @@
           <p:cNvPr id="2" name="">
             <a:extLst xmlns:a="http://schemas.openxmlformats.org/drawingml/2006/main">
               <a:ext uri="{FF2B5EF4-FFF2-40B4-BE49-F238E27FC236}">
-                <a16:creationId xmlns:a16="http://schemas.microsoft.com/office/drawing/2014/main" id="{E82474D1-8808-4E4E-A8DD-B09C449E321C}"/>
+                <a16:creationId xmlns:a16="http://schemas.microsoft.com/office/drawing/2014/main" id="{9A4DCAEA-B361-4037-AB66-1F3C3A79B51F}"/>
               </a:ext>
             </a:extLst>
           </p:cNvPr>
@@ -16676,7 +16676,7 @@
           <p:cNvPr id="3" name="">
             <a:extLst xmlns:a="http://schemas.openxmlformats.org/drawingml/2006/main">
               <a:ext uri="{FF2B5EF4-FFF2-40B4-BE49-F238E27FC236}">
-                <a16:creationId xmlns:a16="http://schemas.microsoft.com/office/drawing/2014/main" id="{AF3C3190-5BAC-43AE-8214-A299613D4EFD}"/>
+                <a16:creationId xmlns:a16="http://schemas.microsoft.com/office/drawing/2014/main" id="{C32B3A03-64B1-467D-A583-9210222AF43D}"/>
               </a:ext>
             </a:extLst>
           </p:cNvPr>
@@ -16832,7 +16832,7 @@
           <p:cNvPr id="4" name="">
             <a:extLst xmlns:a="http://schemas.openxmlformats.org/drawingml/2006/main">
               <a:ext uri="{FF2B5EF4-FFF2-40B4-BE49-F238E27FC236}">
-                <a16:creationId xmlns:a16="http://schemas.microsoft.com/office/drawing/2014/main" id="{73EE66FE-424A-4F93-9FCA-2FF3A3ACAED1}"/>
+                <a16:creationId xmlns:a16="http://schemas.microsoft.com/office/drawing/2014/main" id="{41F0B763-4BBB-48C3-8CC2-E5EC95DC5865}"/>
               </a:ext>
             </a:extLst>
           </p:cNvPr>
@@ -16988,7 +16988,7 @@
           <p:cNvPr id="5" name="">
             <a:extLst xmlns:a="http://schemas.openxmlformats.org/drawingml/2006/main">
               <a:ext uri="{FF2B5EF4-FFF2-40B4-BE49-F238E27FC236}">
-                <a16:creationId xmlns:a16="http://schemas.microsoft.com/office/drawing/2014/main" id="{192D67DD-532F-451A-9D8C-D7C28BCAECC8}"/>
+                <a16:creationId xmlns:a16="http://schemas.microsoft.com/office/drawing/2014/main" id="{F7EFD3A4-BE92-44E6-8153-34B0F381ED6B}"/>
               </a:ext>
             </a:extLst>
           </p:cNvPr>
@@ -17847,7 +17847,7 @@
           <p:cNvPr id="6" name="">
             <a:extLst xmlns:a="http://schemas.openxmlformats.org/drawingml/2006/main">
               <a:ext uri="{FF2B5EF4-FFF2-40B4-BE49-F238E27FC236}">
-                <a16:creationId xmlns:a16="http://schemas.microsoft.com/office/drawing/2014/main" id="{9557ED52-8856-4DEB-AD17-910DE4EAA242}"/>
+                <a16:creationId xmlns:a16="http://schemas.microsoft.com/office/drawing/2014/main" id="{7273ABF6-CA6A-48A2-9393-68CD03B8ED9C}"/>
               </a:ext>
             </a:extLst>
           </p:cNvPr>
@@ -18001,7 +18001,7 @@
     </p:spTree>
     <p:extLst>
       <p:ext uri="{BB962C8B-B14F-4D97-AF65-F5344CB8AC3E}">
-        <p14:creationId xmlns:p14="http://schemas.microsoft.com/office/powerpoint/2010/main" val="1349816262"/>
+        <p14:creationId xmlns:p14="http://schemas.microsoft.com/office/powerpoint/2010/main" val="663071422"/>
       </p:ext>
     </p:extLst>
   </p:cSld>
@@ -18032,7 +18032,7 @@
           <p:cNvPr id="8" name="">
             <a:extLst xmlns:a="http://schemas.openxmlformats.org/drawingml/2006/main">
               <a:ext uri="{FF2B5EF4-FFF2-40B4-BE49-F238E27FC236}">
-                <a16:creationId xmlns:a16="http://schemas.microsoft.com/office/drawing/2014/main" id="{CC1DC34A-25EA-42C2-9EB4-43A790C64925}"/>
+                <a16:creationId xmlns:a16="http://schemas.microsoft.com/office/drawing/2014/main" id="{943F2D0D-06FC-4C96-B018-69C462B9BF0E}"/>
               </a:ext>
             </a:extLst>
           </p:cNvPr>
@@ -18188,7 +18188,7 @@
           <p:cNvPr id="2" name="">
             <a:extLst xmlns:a="http://schemas.openxmlformats.org/drawingml/2006/main">
               <a:ext uri="{FF2B5EF4-FFF2-40B4-BE49-F238E27FC236}">
-                <a16:creationId xmlns:a16="http://schemas.microsoft.com/office/drawing/2014/main" id="{5859C2C0-A988-48AD-A304-1044EBCE2F16}"/>
+                <a16:creationId xmlns:a16="http://schemas.microsoft.com/office/drawing/2014/main" id="{31681FEA-FE72-4B66-8D0B-5012DC844442}"/>
               </a:ext>
             </a:extLst>
           </p:cNvPr>
@@ -18344,7 +18344,7 @@
           <p:cNvPr id="3" name="">
             <a:extLst xmlns:a="http://schemas.openxmlformats.org/drawingml/2006/main">
               <a:ext uri="{FF2B5EF4-FFF2-40B4-BE49-F238E27FC236}">
-                <a16:creationId xmlns:a16="http://schemas.microsoft.com/office/drawing/2014/main" id="{7A46B50D-27EE-4081-9332-8517EFC60386}"/>
+                <a16:creationId xmlns:a16="http://schemas.microsoft.com/office/drawing/2014/main" id="{50903330-7D38-4589-9DED-F6283E4D1989}"/>
               </a:ext>
             </a:extLst>
           </p:cNvPr>
@@ -18500,7 +18500,7 @@
           <p:cNvPr id="4" name="">
             <a:extLst xmlns:a="http://schemas.openxmlformats.org/drawingml/2006/main">
               <a:ext uri="{FF2B5EF4-FFF2-40B4-BE49-F238E27FC236}">
-                <a16:creationId xmlns:a16="http://schemas.microsoft.com/office/drawing/2014/main" id="{AF86ABE5-B3B7-4127-9388-02D450D13514}"/>
+                <a16:creationId xmlns:a16="http://schemas.microsoft.com/office/drawing/2014/main" id="{680D7F1C-8822-4267-B95B-51D894B44A4C}"/>
               </a:ext>
             </a:extLst>
           </p:cNvPr>
@@ -18656,7 +18656,7 @@
           <p:cNvPr id="5" name="">
             <a:extLst xmlns:a="http://schemas.openxmlformats.org/drawingml/2006/main">
               <a:ext uri="{FF2B5EF4-FFF2-40B4-BE49-F238E27FC236}">
-                <a16:creationId xmlns:a16="http://schemas.microsoft.com/office/drawing/2014/main" id="{751EBAA4-F235-4148-BFDE-BA9F7F946201}"/>
+                <a16:creationId xmlns:a16="http://schemas.microsoft.com/office/drawing/2014/main" id="{4CA4185A-4DCD-4274-A4E0-B786D5E804D3}"/>
               </a:ext>
             </a:extLst>
           </p:cNvPr>
@@ -18812,7 +18812,7 @@
           <p:cNvPr id="6" name="">
             <a:extLst xmlns:a="http://schemas.openxmlformats.org/drawingml/2006/main">
               <a:ext uri="{FF2B5EF4-FFF2-40B4-BE49-F238E27FC236}">
-                <a16:creationId xmlns:a16="http://schemas.microsoft.com/office/drawing/2014/main" id="{BD6BE399-C4FD-4E01-B944-4C2E32D2CBB7}"/>
+                <a16:creationId xmlns:a16="http://schemas.microsoft.com/office/drawing/2014/main" id="{C4884882-8256-4FCF-A5C0-516C16735A38}"/>
               </a:ext>
             </a:extLst>
           </p:cNvPr>
@@ -19439,7 +19439,7 @@
           <p:cNvPr id="7" name="">
             <a:extLst xmlns:a="http://schemas.openxmlformats.org/drawingml/2006/main">
               <a:ext uri="{FF2B5EF4-FFF2-40B4-BE49-F238E27FC236}">
-                <a16:creationId xmlns:a16="http://schemas.microsoft.com/office/drawing/2014/main" id="{5B9ADEEA-476C-4060-ACF8-AFAB66449FB7}"/>
+                <a16:creationId xmlns:a16="http://schemas.microsoft.com/office/drawing/2014/main" id="{491FBEB4-B89A-452D-932A-6444735FE72B}"/>
               </a:ext>
             </a:extLst>
           </p:cNvPr>
@@ -19593,7 +19593,7 @@
     </p:spTree>
     <p:extLst>
       <p:ext uri="{BB962C8B-B14F-4D97-AF65-F5344CB8AC3E}">
-        <p14:creationId xmlns:p14="http://schemas.microsoft.com/office/powerpoint/2010/main" val="829871527"/>
+        <p14:creationId xmlns:p14="http://schemas.microsoft.com/office/powerpoint/2010/main" val="1010540443"/>
       </p:ext>
     </p:extLst>
   </p:cSld>
@@ -19624,7 +19624,7 @@
           <p:cNvPr id="7" name="">
             <a:extLst xmlns:a="http://schemas.openxmlformats.org/drawingml/2006/main">
               <a:ext uri="{FF2B5EF4-FFF2-40B4-BE49-F238E27FC236}">
-                <a16:creationId xmlns:a16="http://schemas.microsoft.com/office/drawing/2014/main" id="{D2D9EADE-410F-4EF7-A23D-92AAC1C6EDC7}"/>
+                <a16:creationId xmlns:a16="http://schemas.microsoft.com/office/drawing/2014/main" id="{DC5F2527-2E54-4718-AF9D-14BB4C8CD7CE}"/>
               </a:ext>
             </a:extLst>
           </p:cNvPr>
@@ -19780,7 +19780,7 @@
           <p:cNvPr id="2" name="">
             <a:extLst xmlns:a="http://schemas.openxmlformats.org/drawingml/2006/main">
               <a:ext uri="{FF2B5EF4-FFF2-40B4-BE49-F238E27FC236}">
-                <a16:creationId xmlns:a16="http://schemas.microsoft.com/office/drawing/2014/main" id="{E0651B6D-D428-4401-B718-972D545F52FF}"/>
+                <a16:creationId xmlns:a16="http://schemas.microsoft.com/office/drawing/2014/main" id="{62CFA0D8-8FAB-46D6-AEBD-4B83EA82984F}"/>
               </a:ext>
             </a:extLst>
           </p:cNvPr>
@@ -19936,7 +19936,7 @@
           <p:cNvPr id="3" name="">
             <a:extLst xmlns:a="http://schemas.openxmlformats.org/drawingml/2006/main">
               <a:ext uri="{FF2B5EF4-FFF2-40B4-BE49-F238E27FC236}">
-                <a16:creationId xmlns:a16="http://schemas.microsoft.com/office/drawing/2014/main" id="{12669F91-F4B8-4BDC-916D-0CD302EC7071}"/>
+                <a16:creationId xmlns:a16="http://schemas.microsoft.com/office/drawing/2014/main" id="{E2B1DC7E-7AB4-403E-B29F-2C7DF0016277}"/>
               </a:ext>
             </a:extLst>
           </p:cNvPr>
@@ -20092,7 +20092,7 @@
           <p:cNvPr id="4" name="">
             <a:extLst xmlns:a="http://schemas.openxmlformats.org/drawingml/2006/main">
               <a:ext uri="{FF2B5EF4-FFF2-40B4-BE49-F238E27FC236}">
-                <a16:creationId xmlns:a16="http://schemas.microsoft.com/office/drawing/2014/main" id="{9D4E96D4-B496-4418-88F1-FAA99CDDC38F}"/>
+                <a16:creationId xmlns:a16="http://schemas.microsoft.com/office/drawing/2014/main" id="{D229CBE9-059C-4B0F-A60D-059B35C2D357}"/>
               </a:ext>
             </a:extLst>
           </p:cNvPr>
@@ -20248,7 +20248,7 @@
           <p:cNvPr id="5" name="">
             <a:extLst xmlns:a="http://schemas.openxmlformats.org/drawingml/2006/main">
               <a:ext uri="{FF2B5EF4-FFF2-40B4-BE49-F238E27FC236}">
-                <a16:creationId xmlns:a16="http://schemas.microsoft.com/office/drawing/2014/main" id="{54CA6661-8B13-4085-ACEF-4006DD084652}"/>
+                <a16:creationId xmlns:a16="http://schemas.microsoft.com/office/drawing/2014/main" id="{AF10A039-D0D0-4659-9034-649C82D7BB83}"/>
               </a:ext>
             </a:extLst>
           </p:cNvPr>
@@ -21062,7 +21062,7 @@
           <p:cNvPr id="6" name="">
             <a:extLst xmlns:a="http://schemas.openxmlformats.org/drawingml/2006/main">
               <a:ext uri="{FF2B5EF4-FFF2-40B4-BE49-F238E27FC236}">
-                <a16:creationId xmlns:a16="http://schemas.microsoft.com/office/drawing/2014/main" id="{DA813AD1-F7D4-4C94-8A7E-9E22590868CA}"/>
+                <a16:creationId xmlns:a16="http://schemas.microsoft.com/office/drawing/2014/main" id="{23A8B71E-2C3F-4786-BC8C-00A8AC24709D}"/>
               </a:ext>
             </a:extLst>
           </p:cNvPr>
@@ -21216,7 +21216,7 @@
     </p:spTree>
     <p:extLst>
       <p:ext uri="{BB962C8B-B14F-4D97-AF65-F5344CB8AC3E}">
-        <p14:creationId xmlns:p14="http://schemas.microsoft.com/office/powerpoint/2010/main" val="1002504885"/>
+        <p14:creationId xmlns:p14="http://schemas.microsoft.com/office/powerpoint/2010/main" val="56031793"/>
       </p:ext>
     </p:extLst>
   </p:cSld>

</xml_diff>

<commit_message>
Add reference solutions for all nine satellite tasks
</commit_message>
<xml_diff>
--- a/submission_bundle/defense-deck.pptx
+++ b/submission_bundle/defense-deck.pptx
@@ -2,28 +2,30 @@
 <file path=ppt/presentation.xml><?xml version="1.0" encoding="utf-8"?>
 <p:presentation xmlns:p="http://schemas.openxmlformats.org/presentationml/2006/main">
   <p:sldMasterIdLst>
-    <p:sldMasterId xmlns:r="http://schemas.openxmlformats.org/officeDocument/2006/relationships" id="2147483648" r:id="R64d6eec2f0ef43af"/>
+    <p:sldMasterId xmlns:r="http://schemas.openxmlformats.org/officeDocument/2006/relationships" id="2147483648" r:id="Rd38f03cf38bb4668"/>
   </p:sldMasterIdLst>
   <p:notesMasterIdLst>
-    <p:notesMasterId xmlns:r="http://schemas.openxmlformats.org/officeDocument/2006/relationships" r:id="Rea49fe285bdd4f91"/>
+    <p:notesMasterId xmlns:r="http://schemas.openxmlformats.org/officeDocument/2006/relationships" r:id="Rf641673ac8884ac7"/>
   </p:notesMasterIdLst>
   <p:sldIdLst>
-    <p:sldId xmlns:r="http://schemas.openxmlformats.org/officeDocument/2006/relationships" id="256" r:id="R33c6f6436af34c62"/>
-    <p:sldId xmlns:r="http://schemas.openxmlformats.org/officeDocument/2006/relationships" id="257" r:id="Rc599b55236d14465"/>
-    <p:sldId xmlns:r="http://schemas.openxmlformats.org/officeDocument/2006/relationships" id="258" r:id="R9b9980c833e9465e"/>
-    <p:sldId xmlns:r="http://schemas.openxmlformats.org/officeDocument/2006/relationships" id="259" r:id="R15b2521067b84d5b"/>
-    <p:sldId xmlns:r="http://schemas.openxmlformats.org/officeDocument/2006/relationships" id="260" r:id="R5af06f4f73cc4657"/>
-    <p:sldId xmlns:r="http://schemas.openxmlformats.org/officeDocument/2006/relationships" id="261" r:id="Reaacac910fa04641"/>
-    <p:sldId xmlns:r="http://schemas.openxmlformats.org/officeDocument/2006/relationships" id="262" r:id="Rfb36a2b5875f4156"/>
-    <p:sldId xmlns:r="http://schemas.openxmlformats.org/officeDocument/2006/relationships" id="263" r:id="R367cd3d9aab94d4e"/>
-    <p:sldId xmlns:r="http://schemas.openxmlformats.org/officeDocument/2006/relationships" id="264" r:id="R9b5c97a866154298"/>
-    <p:sldId xmlns:r="http://schemas.openxmlformats.org/officeDocument/2006/relationships" id="265" r:id="R1ab4c8629aef4ee7"/>
-    <p:sldId xmlns:r="http://schemas.openxmlformats.org/officeDocument/2006/relationships" id="266" r:id="Rc3462644cb534154"/>
-    <p:sldId xmlns:r="http://schemas.openxmlformats.org/officeDocument/2006/relationships" id="267" r:id="Re7aab7dfd12942d2"/>
-    <p:sldId xmlns:r="http://schemas.openxmlformats.org/officeDocument/2006/relationships" id="268" r:id="R25ff3b35e63643f4"/>
-    <p:sldId xmlns:r="http://schemas.openxmlformats.org/officeDocument/2006/relationships" id="269" r:id="Rf63678046c7d4638"/>
-    <p:sldId xmlns:r="http://schemas.openxmlformats.org/officeDocument/2006/relationships" id="270" r:id="R02e17aec808a4275"/>
-    <p:sldId xmlns:r="http://schemas.openxmlformats.org/officeDocument/2006/relationships" id="271" r:id="R9c44ded1d65f4659"/>
+    <p:sldId xmlns:r="http://schemas.openxmlformats.org/officeDocument/2006/relationships" id="256" r:id="R5f48b557774d46f9"/>
+    <p:sldId xmlns:r="http://schemas.openxmlformats.org/officeDocument/2006/relationships" id="257" r:id="R7b2c4efbe1a54994"/>
+    <p:sldId xmlns:r="http://schemas.openxmlformats.org/officeDocument/2006/relationships" id="258" r:id="R2bbfbd6f7bd14823"/>
+    <p:sldId xmlns:r="http://schemas.openxmlformats.org/officeDocument/2006/relationships" id="259" r:id="R9e8a1dc8bcf349d1"/>
+    <p:sldId xmlns:r="http://schemas.openxmlformats.org/officeDocument/2006/relationships" id="260" r:id="Re1821ed1f7034f02"/>
+    <p:sldId xmlns:r="http://schemas.openxmlformats.org/officeDocument/2006/relationships" id="261" r:id="R36c322c59501453e"/>
+    <p:sldId xmlns:r="http://schemas.openxmlformats.org/officeDocument/2006/relationships" id="262" r:id="R24fa4ebc40d74623"/>
+    <p:sldId xmlns:r="http://schemas.openxmlformats.org/officeDocument/2006/relationships" id="263" r:id="R868920d4969840f5"/>
+    <p:sldId xmlns:r="http://schemas.openxmlformats.org/officeDocument/2006/relationships" id="264" r:id="Rac5ed012b6234d6e"/>
+    <p:sldId xmlns:r="http://schemas.openxmlformats.org/officeDocument/2006/relationships" id="265" r:id="R6797d908f2dd41e1"/>
+    <p:sldId xmlns:r="http://schemas.openxmlformats.org/officeDocument/2006/relationships" id="266" r:id="R0e66c25b78d24e82"/>
+    <p:sldId xmlns:r="http://schemas.openxmlformats.org/officeDocument/2006/relationships" id="267" r:id="R7ec1a327c1394b65"/>
+    <p:sldId xmlns:r="http://schemas.openxmlformats.org/officeDocument/2006/relationships" id="268" r:id="R189702346e2341e8"/>
+    <p:sldId xmlns:r="http://schemas.openxmlformats.org/officeDocument/2006/relationships" id="269" r:id="R86c0bfb56b4343ed"/>
+    <p:sldId xmlns:r="http://schemas.openxmlformats.org/officeDocument/2006/relationships" id="270" r:id="R98234efc0e2748f9"/>
+    <p:sldId xmlns:r="http://schemas.openxmlformats.org/officeDocument/2006/relationships" id="271" r:id="R5f777ed0f79d4631"/>
+    <p:sldId xmlns:r="http://schemas.openxmlformats.org/officeDocument/2006/relationships" id="272" r:id="Rf6af93a2e94d421d"/>
+    <p:sldId xmlns:r="http://schemas.openxmlformats.org/officeDocument/2006/relationships" id="273" r:id="R82e5a93bd2234534"/>
   </p:sldIdLst>
   <p:sldSz cx="12192000" cy="6858000"/>
   <p:notesSz cx="6858000" cy="9144000"/>
@@ -1082,6 +1084,166 @@
 </p:notes>
 </file>
 
+<file path=ppt/notesSlides/notesSlide17.xml><?xml version="1.0" encoding="utf-8"?>
+<p:notes xmlns:p="http://schemas.openxmlformats.org/presentationml/2006/main">
+  <p:cSld>
+    <p:spTree>
+      <p:nvGrpSpPr>
+        <p:cNvPr id="1" name=""/>
+        <p:cNvGrpSpPr/>
+        <p:nvPr/>
+      </p:nvGrpSpPr>
+      <p:grpSpPr>
+        <a:xfrm xmlns:a="http://schemas.openxmlformats.org/drawingml/2006/main"/>
+      </p:grpSpPr>
+      <p:sp>
+        <p:nvSpPr>
+          <p:cNvPr id="2" name="Slide Image Placeholder 1"/>
+          <p:cNvSpPr>
+            <a:spLocks xmlns:a="http://schemas.openxmlformats.org/drawingml/2006/main" noGrp="1"/>
+          </p:cNvSpPr>
+          <p:nvPr>
+            <p:ph type="sldImg" idx="0"/>
+          </p:nvPr>
+        </p:nvSpPr>
+        <p:spPr/>
+      </p:sp>
+      <p:sp>
+        <p:nvSpPr>
+          <p:cNvPr id="3" name="Notes Placeholder 2"/>
+          <p:cNvSpPr>
+            <a:spLocks xmlns:a="http://schemas.openxmlformats.org/drawingml/2006/main" noGrp="1"/>
+          </p:cNvSpPr>
+          <p:nvPr>
+            <p:ph type="body" idx="1"/>
+          </p:nvPr>
+        </p:nvSpPr>
+        <p:spPr/>
+        <p:txBody>
+          <a:bodyPr xmlns:a="http://schemas.openxmlformats.org/drawingml/2006/main"/>
+          <a:lstStyle xmlns:a="http://schemas.openxmlformats.org/drawingml/2006/main"/>
+          <a:p xmlns:a="http://schemas.openxmlformats.org/drawingml/2006/main">
+            <a:r>
+              <a:t>Reference solution, not model-performance evidence. These corrective settings are read from build_task(task_id, seed=0). Read the current manual and protected mission targets on other seeds. Accept any configuration that meets all protected checks. Apply changes through write_file, verify using run_python or step_orbit, then finish. Never alter fixed hardware or mission requirements.</a:t>
+            </a:r>
+          </a:p>
+          <a:p xmlns:a="http://schemas.openxmlformats.org/drawingml/2006/main">
+            <a:r>
+              <a:t/>
+            </a:r>
+          </a:p>
+          <a:p xmlns:a="http://schemas.openxmlformats.org/drawingml/2006/main">
+            <a:r>
+              <a:t>Sources: supplied RL_Hackathon_by_2une_PS.pdf (sections 03-09); README.md; harness/tasks.py; harness/tools.py; harness/runner.py; submission_bundle/validation-evidence.json. Current harness hash b75030d6ecd33e8f80f5cdda39f2690a2a31688faad3f17d928f27c108e5507b.</a:t>
+            </a:r>
+          </a:p>
+        </p:txBody>
+      </p:sp>
+      <p:sp>
+        <p:nvSpPr>
+          <p:cNvPr id="4" name="Slide Number Placeholder 3"/>
+          <p:cNvSpPr>
+            <a:spLocks xmlns:a="http://schemas.openxmlformats.org/drawingml/2006/main" noGrp="1"/>
+          </p:cNvSpPr>
+          <p:nvPr>
+            <p:ph type="sldNum" idx="5"/>
+          </p:nvPr>
+        </p:nvSpPr>
+        <p:spPr/>
+        <p:txBody>
+          <a:bodyPr xmlns:a="http://schemas.openxmlformats.org/drawingml/2006/main"/>
+          <a:lstStyle xmlns:a="http://schemas.openxmlformats.org/drawingml/2006/main"/>
+          <a:p xmlns:a="http://schemas.openxmlformats.org/drawingml/2006/main"/>
+        </p:txBody>
+      </p:sp>
+    </p:spTree>
+  </p:cSld>
+  <p:clrMapOvr>
+    <a:masterClrMapping xmlns:a="http://schemas.openxmlformats.org/drawingml/2006/main"/>
+  </p:clrMapOvr>
+</p:notes>
+</file>
+
+<file path=ppt/notesSlides/notesSlide18.xml><?xml version="1.0" encoding="utf-8"?>
+<p:notes xmlns:p="http://schemas.openxmlformats.org/presentationml/2006/main">
+  <p:cSld>
+    <p:spTree>
+      <p:nvGrpSpPr>
+        <p:cNvPr id="1" name=""/>
+        <p:cNvGrpSpPr/>
+        <p:nvPr/>
+      </p:nvGrpSpPr>
+      <p:grpSpPr>
+        <a:xfrm xmlns:a="http://schemas.openxmlformats.org/drawingml/2006/main"/>
+      </p:grpSpPr>
+      <p:sp>
+        <p:nvSpPr>
+          <p:cNvPr id="2" name="Slide Image Placeholder 1"/>
+          <p:cNvSpPr>
+            <a:spLocks xmlns:a="http://schemas.openxmlformats.org/drawingml/2006/main" noGrp="1"/>
+          </p:cNvSpPr>
+          <p:nvPr>
+            <p:ph type="sldImg" idx="0"/>
+          </p:nvPr>
+        </p:nvSpPr>
+        <p:spPr/>
+      </p:sp>
+      <p:sp>
+        <p:nvSpPr>
+          <p:cNvPr id="3" name="Notes Placeholder 2"/>
+          <p:cNvSpPr>
+            <a:spLocks xmlns:a="http://schemas.openxmlformats.org/drawingml/2006/main" noGrp="1"/>
+          </p:cNvSpPr>
+          <p:nvPr>
+            <p:ph type="body" idx="1"/>
+          </p:nvPr>
+        </p:nvSpPr>
+        <p:spPr/>
+        <p:txBody>
+          <a:bodyPr xmlns:a="http://schemas.openxmlformats.org/drawingml/2006/main"/>
+          <a:lstStyle xmlns:a="http://schemas.openxmlformats.org/drawingml/2006/main"/>
+          <a:p xmlns:a="http://schemas.openxmlformats.org/drawingml/2006/main">
+            <a:r>
+              <a:t>Reference solution approach. RF rate must carry the target volume during available contact while meeting link margin and energy. Seed-0 reference RF is 38400 bps and 32 dBm. Seed-0 early recovery uses control_gain 5.5 and tx 31.4 dBm. Observation needs duty zero before the window, one during useful exposure, then zero, including tool-time costs. Science needs acquisition one, drain one, acquisition two, drain two, with rate/power chosen for that seed. Do not transplant exact timings between seeds. These are privileged/reference or analytical solution approaches, not new model runs.</a:t>
+            </a:r>
+          </a:p>
+          <a:p xmlns:a="http://schemas.openxmlformats.org/drawingml/2006/main">
+            <a:r>
+              <a:t/>
+            </a:r>
+          </a:p>
+          <a:p xmlns:a="http://schemas.openxmlformats.org/drawingml/2006/main">
+            <a:r>
+              <a:t>Sources: supplied RL_Hackathon_by_2une_PS.pdf (sections 03-09); README.md; harness/tasks.py; harness/tools.py; harness/runner.py; submission_bundle/validation-evidence.json. Current harness hash b75030d6ecd33e8f80f5cdda39f2690a2a31688faad3f17d928f27c108e5507b.</a:t>
+            </a:r>
+          </a:p>
+        </p:txBody>
+      </p:sp>
+      <p:sp>
+        <p:nvSpPr>
+          <p:cNvPr id="4" name="Slide Number Placeholder 3"/>
+          <p:cNvSpPr>
+            <a:spLocks xmlns:a="http://schemas.openxmlformats.org/drawingml/2006/main" noGrp="1"/>
+          </p:cNvSpPr>
+          <p:nvPr>
+            <p:ph type="sldNum" idx="5"/>
+          </p:nvPr>
+        </p:nvSpPr>
+        <p:spPr/>
+        <p:txBody>
+          <a:bodyPr xmlns:a="http://schemas.openxmlformats.org/drawingml/2006/main"/>
+          <a:lstStyle xmlns:a="http://schemas.openxmlformats.org/drawingml/2006/main"/>
+          <a:p xmlns:a="http://schemas.openxmlformats.org/drawingml/2006/main"/>
+        </p:txBody>
+      </p:sp>
+    </p:spTree>
+  </p:cSld>
+  <p:clrMapOvr>
+    <a:masterClrMapping xmlns:a="http://schemas.openxmlformats.org/drawingml/2006/main"/>
+  </p:clrMapOvr>
+</p:notes>
+</file>
+
 <file path=ppt/notesSlides/notesSlide2.xml><?xml version="1.0" encoding="utf-8"?>
 <p:notes xmlns:p="http://schemas.openxmlformats.org/presentationml/2006/main">
   <p:cSld>
@@ -1779,7 +1941,7 @@
           <p:cNvPr id="3" name="Title">
             <a:extLst xmlns:a="http://schemas.openxmlformats.org/drawingml/2006/main">
               <a:ext uri="{FF2B5EF4-FFF2-40B4-BE49-F238E27FC236}">
-                <a16:creationId xmlns:a16="http://schemas.microsoft.com/office/drawing/2014/main" id="{BD9DB312-E019-4440-8134-73A19B6DA7BB}"/>
+                <a16:creationId xmlns:a16="http://schemas.microsoft.com/office/drawing/2014/main" id="{7ED142C0-91E1-4FD2-B5BA-47C029DC87F1}"/>
               </a:ext>
             </a:extLst>
           </p:cNvPr>
@@ -2008,7 +2170,7 @@
           <p:cNvPr id="2" name="Subtitle">
             <a:extLst xmlns:a="http://schemas.openxmlformats.org/drawingml/2006/main">
               <a:ext uri="{FF2B5EF4-FFF2-40B4-BE49-F238E27FC236}">
-                <a16:creationId xmlns:a16="http://schemas.microsoft.com/office/drawing/2014/main" id="{C265C4C5-B64F-4F3A-A722-4E200E364D5D}"/>
+                <a16:creationId xmlns:a16="http://schemas.microsoft.com/office/drawing/2014/main" id="{BB2993E9-2A3D-4A4C-80FE-048152FF7EAD}"/>
               </a:ext>
             </a:extLst>
           </p:cNvPr>
@@ -2254,7 +2416,7 @@
           <p:cNvPr id="2" name="Section title">
             <a:extLst xmlns:a="http://schemas.openxmlformats.org/drawingml/2006/main">
               <a:ext uri="{FF2B5EF4-FFF2-40B4-BE49-F238E27FC236}">
-                <a16:creationId xmlns:a16="http://schemas.microsoft.com/office/drawing/2014/main" id="{9BD6031B-EAD6-4A75-B4BC-85D71EF67F14}"/>
+                <a16:creationId xmlns:a16="http://schemas.microsoft.com/office/drawing/2014/main" id="{4445294B-6064-4C29-AAA9-EA03B68CFC80}"/>
               </a:ext>
             </a:extLst>
           </p:cNvPr>
@@ -2500,7 +2662,7 @@
           <p:cNvPr id="3" name="Title">
             <a:extLst xmlns:a="http://schemas.openxmlformats.org/drawingml/2006/main">
               <a:ext uri="{FF2B5EF4-FFF2-40B4-BE49-F238E27FC236}">
-                <a16:creationId xmlns:a16="http://schemas.microsoft.com/office/drawing/2014/main" id="{C96DDBD2-B146-456A-9510-8E0E69DD0CAF}"/>
+                <a16:creationId xmlns:a16="http://schemas.microsoft.com/office/drawing/2014/main" id="{863D4C2C-8DAF-4456-B0F0-F0DE1767BF1C}"/>
               </a:ext>
             </a:extLst>
           </p:cNvPr>
@@ -2729,7 +2891,7 @@
           <p:cNvPr id="2" name="Body">
             <a:extLst xmlns:a="http://schemas.openxmlformats.org/drawingml/2006/main">
               <a:ext uri="{FF2B5EF4-FFF2-40B4-BE49-F238E27FC236}">
-                <a16:creationId xmlns:a16="http://schemas.microsoft.com/office/drawing/2014/main" id="{D2A5EFF7-087A-4795-8FBD-A9A48F789352}"/>
+                <a16:creationId xmlns:a16="http://schemas.microsoft.com/office/drawing/2014/main" id="{1E3CEAF2-9BF7-4D35-AE96-95B236A835B7}"/>
               </a:ext>
             </a:extLst>
           </p:cNvPr>
@@ -2975,7 +3137,7 @@
           <p:cNvPr id="4" name="Title">
             <a:extLst xmlns:a="http://schemas.openxmlformats.org/drawingml/2006/main">
               <a:ext uri="{FF2B5EF4-FFF2-40B4-BE49-F238E27FC236}">
-                <a16:creationId xmlns:a16="http://schemas.microsoft.com/office/drawing/2014/main" id="{1ABA16FD-04E5-4C17-B649-AC6D344A6E61}"/>
+                <a16:creationId xmlns:a16="http://schemas.microsoft.com/office/drawing/2014/main" id="{3F788E29-D141-4563-A0B7-6695218A4AEA}"/>
               </a:ext>
             </a:extLst>
           </p:cNvPr>
@@ -3204,7 +3366,7 @@
           <p:cNvPr id="2" name="Left column">
             <a:extLst xmlns:a="http://schemas.openxmlformats.org/drawingml/2006/main">
               <a:ext uri="{FF2B5EF4-FFF2-40B4-BE49-F238E27FC236}">
-                <a16:creationId xmlns:a16="http://schemas.microsoft.com/office/drawing/2014/main" id="{8E5DED94-BB02-4E23-AAFC-AD219407D9BC}"/>
+                <a16:creationId xmlns:a16="http://schemas.microsoft.com/office/drawing/2014/main" id="{B3FD6767-EC1E-445F-B62A-A0DB345A744E}"/>
               </a:ext>
             </a:extLst>
           </p:cNvPr>
@@ -3433,7 +3595,7 @@
           <p:cNvPr id="3" name="Right column">
             <a:extLst xmlns:a="http://schemas.openxmlformats.org/drawingml/2006/main">
               <a:ext uri="{FF2B5EF4-FFF2-40B4-BE49-F238E27FC236}">
-                <a16:creationId xmlns:a16="http://schemas.microsoft.com/office/drawing/2014/main" id="{F7E1F37E-753D-47D4-8D40-F915352FE869}"/>
+                <a16:creationId xmlns:a16="http://schemas.microsoft.com/office/drawing/2014/main" id="{C1AC5666-AF86-42FD-9829-8DD855309BBA}"/>
               </a:ext>
             </a:extLst>
           </p:cNvPr>
@@ -3679,7 +3841,7 @@
           <p:cNvPr id="3" name="Title">
             <a:extLst xmlns:a="http://schemas.openxmlformats.org/drawingml/2006/main">
               <a:ext uri="{FF2B5EF4-FFF2-40B4-BE49-F238E27FC236}">
-                <a16:creationId xmlns:a16="http://schemas.microsoft.com/office/drawing/2014/main" id="{6A41057F-21EE-468F-82BF-F6BD469671E9}"/>
+                <a16:creationId xmlns:a16="http://schemas.microsoft.com/office/drawing/2014/main" id="{507E7C2C-6BB6-4FC2-9449-36FAA69F837A}"/>
               </a:ext>
             </a:extLst>
           </p:cNvPr>
@@ -3908,7 +4070,7 @@
           <p:cNvPr id="2" name="Left column">
             <a:extLst xmlns:a="http://schemas.openxmlformats.org/drawingml/2006/main">
               <a:ext uri="{FF2B5EF4-FFF2-40B4-BE49-F238E27FC236}">
-                <a16:creationId xmlns:a16="http://schemas.microsoft.com/office/drawing/2014/main" id="{E774128A-47CF-4D33-BE02-8E8FA0376BEE}"/>
+                <a16:creationId xmlns:a16="http://schemas.microsoft.com/office/drawing/2014/main" id="{A9D728E6-C061-4036-AAD6-C3F9C15C1BE2}"/>
               </a:ext>
             </a:extLst>
           </p:cNvPr>
@@ -4175,12 +4337,12 @@
   </p:cSld>
   <p:clrMap bg1="lt1" tx1="dk1" bg2="lt2" tx2="dk2" accent1="accent1" accent2="accent2" accent3="accent3" accent4="accent4" accent5="accent5" accent6="accent6" hlink="hlink" folHlink="folHlink"/>
   <p:sldLayoutIdLst>
-    <p:sldLayoutId xmlns:r="http://schemas.openxmlformats.org/officeDocument/2006/relationships" id="2147483649" r:id="R3530d6805bcb41ac"/>
-    <p:sldLayoutId xmlns:r="http://schemas.openxmlformats.org/officeDocument/2006/relationships" id="2147483650" r:id="R10aec4772c3b43eb"/>
-    <p:sldLayoutId xmlns:r="http://schemas.openxmlformats.org/officeDocument/2006/relationships" id="2147483651" r:id="Rd5112e8db8994684"/>
-    <p:sldLayoutId xmlns:r="http://schemas.openxmlformats.org/officeDocument/2006/relationships" id="2147483652" r:id="R3d178a5c18ec419f"/>
-    <p:sldLayoutId xmlns:r="http://schemas.openxmlformats.org/officeDocument/2006/relationships" id="2147483653" r:id="R575d11cf5d5c4a5a"/>
-    <p:sldLayoutId xmlns:r="http://schemas.openxmlformats.org/officeDocument/2006/relationships" id="2147483654" r:id="Ra21bbb42f27642f9"/>
+    <p:sldLayoutId xmlns:r="http://schemas.openxmlformats.org/officeDocument/2006/relationships" id="2147483649" r:id="R6c5c4ada44334e07"/>
+    <p:sldLayoutId xmlns:r="http://schemas.openxmlformats.org/officeDocument/2006/relationships" id="2147483650" r:id="Rf9da2ca2274945b2"/>
+    <p:sldLayoutId xmlns:r="http://schemas.openxmlformats.org/officeDocument/2006/relationships" id="2147483651" r:id="R4bbfbb29b423421d"/>
+    <p:sldLayoutId xmlns:r="http://schemas.openxmlformats.org/officeDocument/2006/relationships" id="2147483652" r:id="R9b5d0a8f01b94c09"/>
+    <p:sldLayoutId xmlns:r="http://schemas.openxmlformats.org/officeDocument/2006/relationships" id="2147483653" r:id="Rbaf0a6e7a46d40c9"/>
+    <p:sldLayoutId xmlns:r="http://schemas.openxmlformats.org/officeDocument/2006/relationships" id="2147483654" r:id="R9f1f3c56869e4e00"/>
   </p:sldLayoutIdLst>
   <p:txStyles>
     <p:titleStyle>
@@ -4731,7 +4893,7 @@
           <p:cNvPr id="8" name="">
             <a:extLst xmlns:a="http://schemas.openxmlformats.org/drawingml/2006/main">
               <a:ext uri="{FF2B5EF4-FFF2-40B4-BE49-F238E27FC236}">
-                <a16:creationId xmlns:a16="http://schemas.microsoft.com/office/drawing/2014/main" id="{88C8F1AE-E721-48D8-9DC5-54281C50A677}"/>
+                <a16:creationId xmlns:a16="http://schemas.microsoft.com/office/drawing/2014/main" id="{A734EBE9-0271-4433-9E2C-B613A8E61284}"/>
               </a:ext>
             </a:extLst>
           </p:cNvPr>
@@ -4741,7 +4903,7 @@
           <p:nvPr/>
         </p:nvPicPr>
         <p:blipFill>
-          <a:blip xmlns:r="http://schemas.openxmlformats.org/officeDocument/2006/relationships" xmlns:a="http://schemas.openxmlformats.org/drawingml/2006/main" r:embed="Rc1f417b7f5254378"/>
+          <a:blip xmlns:r="http://schemas.openxmlformats.org/officeDocument/2006/relationships" xmlns:a="http://schemas.openxmlformats.org/drawingml/2006/main" r:embed="Rdef1e53e9b8e40f2"/>
           <a:srcRect xmlns:a="http://schemas.openxmlformats.org/drawingml/2006/main" l="27037" t="0" r="27037" b="0"/>
           <a:stretch xmlns:a="http://schemas.openxmlformats.org/drawingml/2006/main">
             <a:fillRect l="0" t="0" r="0" b="0"/>
@@ -4762,7 +4924,7 @@
           <p:cNvPr id="2" name="">
             <a:extLst xmlns:a="http://schemas.openxmlformats.org/drawingml/2006/main">
               <a:ext uri="{FF2B5EF4-FFF2-40B4-BE49-F238E27FC236}">
-                <a16:creationId xmlns:a16="http://schemas.microsoft.com/office/drawing/2014/main" id="{FC0BCF02-8C5A-4856-92AA-AAA34AB1EE23}"/>
+                <a16:creationId xmlns:a16="http://schemas.microsoft.com/office/drawing/2014/main" id="{4E6366EC-24F5-4A98-8DAC-126727165208}"/>
               </a:ext>
             </a:extLst>
           </p:cNvPr>
@@ -4918,7 +5080,7 @@
           <p:cNvPr id="3" name="">
             <a:extLst xmlns:a="http://schemas.openxmlformats.org/drawingml/2006/main">
               <a:ext uri="{FF2B5EF4-FFF2-40B4-BE49-F238E27FC236}">
-                <a16:creationId xmlns:a16="http://schemas.microsoft.com/office/drawing/2014/main" id="{5D9C8CC0-5F98-464F-A5F0-7B9EE2866ADD}"/>
+                <a16:creationId xmlns:a16="http://schemas.microsoft.com/office/drawing/2014/main" id="{2B3F5818-84C8-4E15-A7B0-B7632B329F39}"/>
               </a:ext>
             </a:extLst>
           </p:cNvPr>
@@ -5074,7 +5236,7 @@
           <p:cNvPr id="4" name="">
             <a:extLst xmlns:a="http://schemas.openxmlformats.org/drawingml/2006/main">
               <a:ext uri="{FF2B5EF4-FFF2-40B4-BE49-F238E27FC236}">
-                <a16:creationId xmlns:a16="http://schemas.microsoft.com/office/drawing/2014/main" id="{B3F2A3C6-58F2-4F06-9BA4-6FD241D9E9BB}"/>
+                <a16:creationId xmlns:a16="http://schemas.microsoft.com/office/drawing/2014/main" id="{A49B9C26-41C4-42DA-9019-0F6ED8B87969}"/>
               </a:ext>
             </a:extLst>
           </p:cNvPr>
@@ -5253,7 +5415,7 @@
           <p:cNvPr id="5" name="">
             <a:extLst xmlns:a="http://schemas.openxmlformats.org/drawingml/2006/main">
               <a:ext uri="{FF2B5EF4-FFF2-40B4-BE49-F238E27FC236}">
-                <a16:creationId xmlns:a16="http://schemas.microsoft.com/office/drawing/2014/main" id="{9942698E-CCCF-4B3C-81DF-000C19A9CA5A}"/>
+                <a16:creationId xmlns:a16="http://schemas.microsoft.com/office/drawing/2014/main" id="{3C18653C-1FB2-421A-B445-41EDA6594163}"/>
               </a:ext>
             </a:extLst>
           </p:cNvPr>
@@ -5432,7 +5594,7 @@
           <p:cNvPr id="6" name="">
             <a:extLst xmlns:a="http://schemas.openxmlformats.org/drawingml/2006/main">
               <a:ext uri="{FF2B5EF4-FFF2-40B4-BE49-F238E27FC236}">
-                <a16:creationId xmlns:a16="http://schemas.microsoft.com/office/drawing/2014/main" id="{58D04097-A814-4E80-BA85-E6107B0EB949}"/>
+                <a16:creationId xmlns:a16="http://schemas.microsoft.com/office/drawing/2014/main" id="{E1C624BC-B731-4B03-8EEB-26FAA329EF8B}"/>
               </a:ext>
             </a:extLst>
           </p:cNvPr>
@@ -5588,7 +5750,7 @@
           <p:cNvPr id="7" name="">
             <a:extLst xmlns:a="http://schemas.openxmlformats.org/drawingml/2006/main">
               <a:ext uri="{FF2B5EF4-FFF2-40B4-BE49-F238E27FC236}">
-                <a16:creationId xmlns:a16="http://schemas.microsoft.com/office/drawing/2014/main" id="{E287AD70-E12D-4BB7-AFAE-B128AD41E5E1}"/>
+                <a16:creationId xmlns:a16="http://schemas.microsoft.com/office/drawing/2014/main" id="{9212FEF3-9883-4372-9330-71D1C5FBAA07}"/>
               </a:ext>
             </a:extLst>
           </p:cNvPr>
@@ -5734,7 +5896,7 @@
                 <a:ea typeface="Arial"/>
                 <a:cs typeface="Arial"/>
               </a:rPr>
-              <a:t>10-minute talk + 3 reference slides</a:t>
+              <a:t>10-minute talk + 5 reference slides</a:t>
             </a:r>
           </a:p>
         </p:txBody>
@@ -5742,7 +5904,7 @@
     </p:spTree>
     <p:extLst>
       <p:ext uri="{BB962C8B-B14F-4D97-AF65-F5344CB8AC3E}">
-        <p14:creationId xmlns:p14="http://schemas.microsoft.com/office/powerpoint/2010/main" val="352263310"/>
+        <p14:creationId xmlns:p14="http://schemas.microsoft.com/office/powerpoint/2010/main" val="674237412"/>
       </p:ext>
     </p:extLst>
   </p:cSld>
@@ -5773,7 +5935,7 @@
           <p:cNvPr id="6" name="">
             <a:extLst xmlns:a="http://schemas.openxmlformats.org/drawingml/2006/main">
               <a:ext uri="{FF2B5EF4-FFF2-40B4-BE49-F238E27FC236}">
-                <a16:creationId xmlns:a16="http://schemas.microsoft.com/office/drawing/2014/main" id="{B2835473-8B27-4F62-A1BA-08C8A917B3AC}"/>
+                <a16:creationId xmlns:a16="http://schemas.microsoft.com/office/drawing/2014/main" id="{E9DE33BF-D23D-4C45-8DCA-047745708316}"/>
               </a:ext>
             </a:extLst>
           </p:cNvPr>
@@ -5929,7 +6091,7 @@
           <p:cNvPr id="2" name="">
             <a:extLst xmlns:a="http://schemas.openxmlformats.org/drawingml/2006/main">
               <a:ext uri="{FF2B5EF4-FFF2-40B4-BE49-F238E27FC236}">
-                <a16:creationId xmlns:a16="http://schemas.microsoft.com/office/drawing/2014/main" id="{B7366048-A00D-4196-942E-9BFA3C844E90}"/>
+                <a16:creationId xmlns:a16="http://schemas.microsoft.com/office/drawing/2014/main" id="{E43D3C71-8721-4ECA-AA59-7991ACBD0D08}"/>
               </a:ext>
             </a:extLst>
           </p:cNvPr>
@@ -6085,7 +6247,7 @@
           <p:cNvPr id="3" name="">
             <a:extLst xmlns:a="http://schemas.openxmlformats.org/drawingml/2006/main">
               <a:ext uri="{FF2B5EF4-FFF2-40B4-BE49-F238E27FC236}">
-                <a16:creationId xmlns:a16="http://schemas.microsoft.com/office/drawing/2014/main" id="{A0217F01-5956-4D24-9477-C788B0E41110}"/>
+                <a16:creationId xmlns:a16="http://schemas.microsoft.com/office/drawing/2014/main" id="{5733F7EF-07D5-4F24-9B15-7BCDFD002390}"/>
               </a:ext>
             </a:extLst>
           </p:cNvPr>
@@ -6241,7 +6403,7 @@
           <p:cNvPr id="4" name="">
             <a:extLst xmlns:a="http://schemas.openxmlformats.org/drawingml/2006/main">
               <a:ext uri="{FF2B5EF4-FFF2-40B4-BE49-F238E27FC236}">
-                <a16:creationId xmlns:a16="http://schemas.microsoft.com/office/drawing/2014/main" id="{7C826990-1117-43C3-965F-726D09158AA4}"/>
+                <a16:creationId xmlns:a16="http://schemas.microsoft.com/office/drawing/2014/main" id="{4EE6BA56-AFA1-45D8-A3F4-57AC41C86B24}"/>
               </a:ext>
             </a:extLst>
           </p:cNvPr>
@@ -7049,7 +7211,7 @@
           <p:cNvPr id="5" name="">
             <a:extLst xmlns:a="http://schemas.openxmlformats.org/drawingml/2006/main">
               <a:ext uri="{FF2B5EF4-FFF2-40B4-BE49-F238E27FC236}">
-                <a16:creationId xmlns:a16="http://schemas.microsoft.com/office/drawing/2014/main" id="{52523281-50C6-4EED-9DB3-BD1C2EC6E2C1}"/>
+                <a16:creationId xmlns:a16="http://schemas.microsoft.com/office/drawing/2014/main" id="{BA20FA99-F527-4A16-A8CF-23E9C55EEB99}"/>
               </a:ext>
             </a:extLst>
           </p:cNvPr>
@@ -7203,7 +7365,7 @@
     </p:spTree>
     <p:extLst>
       <p:ext uri="{BB962C8B-B14F-4D97-AF65-F5344CB8AC3E}">
-        <p14:creationId xmlns:p14="http://schemas.microsoft.com/office/powerpoint/2010/main" val="1524552351"/>
+        <p14:creationId xmlns:p14="http://schemas.microsoft.com/office/powerpoint/2010/main" val="1700046153"/>
       </p:ext>
     </p:extLst>
   </p:cSld>
@@ -7234,7 +7396,7 @@
           <p:cNvPr id="12" name="">
             <a:extLst xmlns:a="http://schemas.openxmlformats.org/drawingml/2006/main">
               <a:ext uri="{FF2B5EF4-FFF2-40B4-BE49-F238E27FC236}">
-                <a16:creationId xmlns:a16="http://schemas.microsoft.com/office/drawing/2014/main" id="{2B72CB07-4850-42A8-B086-470FB7655416}"/>
+                <a16:creationId xmlns:a16="http://schemas.microsoft.com/office/drawing/2014/main" id="{7EC5121B-BCFE-49B3-A6EA-7E5C4176987A}"/>
               </a:ext>
             </a:extLst>
           </p:cNvPr>
@@ -7390,7 +7552,7 @@
           <p:cNvPr id="2" name="">
             <a:extLst xmlns:a="http://schemas.openxmlformats.org/drawingml/2006/main">
               <a:ext uri="{FF2B5EF4-FFF2-40B4-BE49-F238E27FC236}">
-                <a16:creationId xmlns:a16="http://schemas.microsoft.com/office/drawing/2014/main" id="{D4E2C38F-66BA-45E2-B082-EC0BA40BCF3E}"/>
+                <a16:creationId xmlns:a16="http://schemas.microsoft.com/office/drawing/2014/main" id="{7F9BBCCA-C5FC-4794-8825-2CD197A7FE05}"/>
               </a:ext>
             </a:extLst>
           </p:cNvPr>
@@ -7546,7 +7708,7 @@
           <p:cNvPr id="3" name="">
             <a:extLst xmlns:a="http://schemas.openxmlformats.org/drawingml/2006/main">
               <a:ext uri="{FF2B5EF4-FFF2-40B4-BE49-F238E27FC236}">
-                <a16:creationId xmlns:a16="http://schemas.microsoft.com/office/drawing/2014/main" id="{959F9A43-EB61-4AD0-972E-F6271FDE1CCC}"/>
+                <a16:creationId xmlns:a16="http://schemas.microsoft.com/office/drawing/2014/main" id="{39E21276-B3A0-4960-B6F9-D8729CC76294}"/>
               </a:ext>
             </a:extLst>
           </p:cNvPr>
@@ -7702,7 +7864,7 @@
           <p:cNvPr id="4" name="">
             <a:extLst xmlns:a="http://schemas.openxmlformats.org/drawingml/2006/main">
               <a:ext uri="{FF2B5EF4-FFF2-40B4-BE49-F238E27FC236}">
-                <a16:creationId xmlns:a16="http://schemas.microsoft.com/office/drawing/2014/main" id="{7A908433-A74C-4ACA-928C-70C64959A90A}"/>
+                <a16:creationId xmlns:a16="http://schemas.microsoft.com/office/drawing/2014/main" id="{C5A946DB-590B-46E7-882A-58BF70CCB305}"/>
               </a:ext>
             </a:extLst>
           </p:cNvPr>
@@ -7858,7 +8020,7 @@
           <p:cNvPr id="5" name="">
             <a:extLst xmlns:a="http://schemas.openxmlformats.org/drawingml/2006/main">
               <a:ext uri="{FF2B5EF4-FFF2-40B4-BE49-F238E27FC236}">
-                <a16:creationId xmlns:a16="http://schemas.microsoft.com/office/drawing/2014/main" id="{8844DFE4-2DA5-4790-B743-263E44A9EDC1}"/>
+                <a16:creationId xmlns:a16="http://schemas.microsoft.com/office/drawing/2014/main" id="{C048F3B3-DC6A-492F-963E-D2F2E0C32A91}"/>
               </a:ext>
             </a:extLst>
           </p:cNvPr>
@@ -8060,7 +8222,7 @@
           <p:cNvPr id="6" name="">
             <a:extLst xmlns:a="http://schemas.openxmlformats.org/drawingml/2006/main">
               <a:ext uri="{FF2B5EF4-FFF2-40B4-BE49-F238E27FC236}">
-                <a16:creationId xmlns:a16="http://schemas.microsoft.com/office/drawing/2014/main" id="{606DADC8-20EA-4E17-AA62-DCE445E054D8}"/>
+                <a16:creationId xmlns:a16="http://schemas.microsoft.com/office/drawing/2014/main" id="{504CCA4D-32B0-4B79-A619-FF1B166FD064}"/>
               </a:ext>
             </a:extLst>
           </p:cNvPr>
@@ -8216,7 +8378,7 @@
           <p:cNvPr id="7" name="">
             <a:extLst xmlns:a="http://schemas.openxmlformats.org/drawingml/2006/main">
               <a:ext uri="{FF2B5EF4-FFF2-40B4-BE49-F238E27FC236}">
-                <a16:creationId xmlns:a16="http://schemas.microsoft.com/office/drawing/2014/main" id="{41129E20-6434-451F-A204-50855EAE5A50}"/>
+                <a16:creationId xmlns:a16="http://schemas.microsoft.com/office/drawing/2014/main" id="{55D6E9CA-1DB3-4372-896E-865679FABCD1}"/>
               </a:ext>
             </a:extLst>
           </p:cNvPr>
@@ -8510,7 +8672,7 @@
           <p:cNvPr id="8" name="">
             <a:extLst xmlns:a="http://schemas.openxmlformats.org/drawingml/2006/main">
               <a:ext uri="{FF2B5EF4-FFF2-40B4-BE49-F238E27FC236}">
-                <a16:creationId xmlns:a16="http://schemas.microsoft.com/office/drawing/2014/main" id="{083C9A81-7F59-4736-AA9D-65008C3592A0}"/>
+                <a16:creationId xmlns:a16="http://schemas.microsoft.com/office/drawing/2014/main" id="{BAEBA36A-075C-4546-B9AD-4B43A5835EDA}"/>
               </a:ext>
             </a:extLst>
           </p:cNvPr>
@@ -8666,7 +8828,7 @@
           <p:cNvPr id="9" name="">
             <a:extLst xmlns:a="http://schemas.openxmlformats.org/drawingml/2006/main">
               <a:ext uri="{FF2B5EF4-FFF2-40B4-BE49-F238E27FC236}">
-                <a16:creationId xmlns:a16="http://schemas.microsoft.com/office/drawing/2014/main" id="{DD3EE1EE-367F-4039-9397-ADFA2903788F}"/>
+                <a16:creationId xmlns:a16="http://schemas.microsoft.com/office/drawing/2014/main" id="{BDB0EE67-E409-4792-A419-DE60C598C3F0}"/>
               </a:ext>
             </a:extLst>
           </p:cNvPr>
@@ -8868,7 +9030,7 @@
           <p:cNvPr id="10" name="">
             <a:extLst xmlns:a="http://schemas.openxmlformats.org/drawingml/2006/main">
               <a:ext uri="{FF2B5EF4-FFF2-40B4-BE49-F238E27FC236}">
-                <a16:creationId xmlns:a16="http://schemas.microsoft.com/office/drawing/2014/main" id="{B1A83F6A-EB29-4E16-AC98-BF2E7223C94C}"/>
+                <a16:creationId xmlns:a16="http://schemas.microsoft.com/office/drawing/2014/main" id="{22E6A143-CD3D-40C3-BDDB-0856860D071E}"/>
               </a:ext>
             </a:extLst>
           </p:cNvPr>
@@ -9047,7 +9209,7 @@
           <p:cNvPr id="11" name="">
             <a:extLst xmlns:a="http://schemas.openxmlformats.org/drawingml/2006/main">
               <a:ext uri="{FF2B5EF4-FFF2-40B4-BE49-F238E27FC236}">
-                <a16:creationId xmlns:a16="http://schemas.microsoft.com/office/drawing/2014/main" id="{E0FA2562-7E91-4E9C-BFBC-2FBB26527D68}"/>
+                <a16:creationId xmlns:a16="http://schemas.microsoft.com/office/drawing/2014/main" id="{C74CD5B4-2DB3-4065-B102-3E927EE95059}"/>
               </a:ext>
             </a:extLst>
           </p:cNvPr>
@@ -9201,7 +9363,7 @@
     </p:spTree>
     <p:extLst>
       <p:ext uri="{BB962C8B-B14F-4D97-AF65-F5344CB8AC3E}">
-        <p14:creationId xmlns:p14="http://schemas.microsoft.com/office/powerpoint/2010/main" val="544440654"/>
+        <p14:creationId xmlns:p14="http://schemas.microsoft.com/office/powerpoint/2010/main" val="1732494048"/>
       </p:ext>
     </p:extLst>
   </p:cSld>
@@ -9232,7 +9394,7 @@
           <p:cNvPr id="8" name="">
             <a:extLst xmlns:a="http://schemas.openxmlformats.org/drawingml/2006/main">
               <a:ext uri="{FF2B5EF4-FFF2-40B4-BE49-F238E27FC236}">
-                <a16:creationId xmlns:a16="http://schemas.microsoft.com/office/drawing/2014/main" id="{65BFA623-04C4-4553-90D0-B3B5F84E1D76}"/>
+                <a16:creationId xmlns:a16="http://schemas.microsoft.com/office/drawing/2014/main" id="{9574F4E6-4102-4DA0-AE05-C6A5EE4D07D8}"/>
               </a:ext>
             </a:extLst>
           </p:cNvPr>
@@ -9388,7 +9550,7 @@
           <p:cNvPr id="2" name="">
             <a:extLst xmlns:a="http://schemas.openxmlformats.org/drawingml/2006/main">
               <a:ext uri="{FF2B5EF4-FFF2-40B4-BE49-F238E27FC236}">
-                <a16:creationId xmlns:a16="http://schemas.microsoft.com/office/drawing/2014/main" id="{F8861C33-E136-444C-B9FB-5900746E8805}"/>
+                <a16:creationId xmlns:a16="http://schemas.microsoft.com/office/drawing/2014/main" id="{6E9303DC-2CCA-4673-BE9B-227AC92470C4}"/>
               </a:ext>
             </a:extLst>
           </p:cNvPr>
@@ -9544,7 +9706,7 @@
           <p:cNvPr id="3" name="">
             <a:extLst xmlns:a="http://schemas.openxmlformats.org/drawingml/2006/main">
               <a:ext uri="{FF2B5EF4-FFF2-40B4-BE49-F238E27FC236}">
-                <a16:creationId xmlns:a16="http://schemas.microsoft.com/office/drawing/2014/main" id="{00A67298-6ADB-49B7-9E4B-27E2A810DF92}"/>
+                <a16:creationId xmlns:a16="http://schemas.microsoft.com/office/drawing/2014/main" id="{CB6466F6-26D4-4790-958A-9070DF2FC958}"/>
               </a:ext>
             </a:extLst>
           </p:cNvPr>
@@ -9700,7 +9862,7 @@
           <p:cNvPr id="4" name="">
             <a:extLst xmlns:a="http://schemas.openxmlformats.org/drawingml/2006/main">
               <a:ext uri="{FF2B5EF4-FFF2-40B4-BE49-F238E27FC236}">
-                <a16:creationId xmlns:a16="http://schemas.microsoft.com/office/drawing/2014/main" id="{4CE4243E-A12C-4070-9DFF-E6EDF67EACC7}"/>
+                <a16:creationId xmlns:a16="http://schemas.microsoft.com/office/drawing/2014/main" id="{EDCF0E0C-F7FD-4EB9-82AB-D69AB3DB8C0C}"/>
               </a:ext>
             </a:extLst>
           </p:cNvPr>
@@ -9856,7 +10018,7 @@
           <p:cNvPr id="5" name="">
             <a:extLst xmlns:a="http://schemas.openxmlformats.org/drawingml/2006/main">
               <a:ext uri="{FF2B5EF4-FFF2-40B4-BE49-F238E27FC236}">
-                <a16:creationId xmlns:a16="http://schemas.microsoft.com/office/drawing/2014/main" id="{B48A3475-3CC6-4557-9A44-9090CAAF4030}"/>
+                <a16:creationId xmlns:a16="http://schemas.microsoft.com/office/drawing/2014/main" id="{909DC945-80EF-4C86-9C82-DF13130937BD}"/>
               </a:ext>
             </a:extLst>
           </p:cNvPr>
@@ -10670,7 +10832,7 @@
           <p:cNvPr id="6" name="">
             <a:extLst xmlns:a="http://schemas.openxmlformats.org/drawingml/2006/main">
               <a:ext uri="{FF2B5EF4-FFF2-40B4-BE49-F238E27FC236}">
-                <a16:creationId xmlns:a16="http://schemas.microsoft.com/office/drawing/2014/main" id="{92C663E4-8475-415F-A461-8E9EAF9DACE8}"/>
+                <a16:creationId xmlns:a16="http://schemas.microsoft.com/office/drawing/2014/main" id="{82FE9737-3B37-4EAC-AA4C-0A3228086EEC}"/>
               </a:ext>
             </a:extLst>
           </p:cNvPr>
@@ -10826,7 +10988,7 @@
           <p:cNvPr id="7" name="">
             <a:extLst xmlns:a="http://schemas.openxmlformats.org/drawingml/2006/main">
               <a:ext uri="{FF2B5EF4-FFF2-40B4-BE49-F238E27FC236}">
-                <a16:creationId xmlns:a16="http://schemas.microsoft.com/office/drawing/2014/main" id="{7A7226CF-9E78-4114-8266-D7C7F627E398}"/>
+                <a16:creationId xmlns:a16="http://schemas.microsoft.com/office/drawing/2014/main" id="{8B7A7FBD-B173-4A72-B6EC-7538868FFA5E}"/>
               </a:ext>
             </a:extLst>
           </p:cNvPr>
@@ -10980,7 +11142,7 @@
     </p:spTree>
     <p:extLst>
       <p:ext uri="{BB962C8B-B14F-4D97-AF65-F5344CB8AC3E}">
-        <p14:creationId xmlns:p14="http://schemas.microsoft.com/office/powerpoint/2010/main" val="1860539431"/>
+        <p14:creationId xmlns:p14="http://schemas.microsoft.com/office/powerpoint/2010/main" val="1401950114"/>
       </p:ext>
     </p:extLst>
   </p:cSld>
@@ -11011,7 +11173,7 @@
           <p:cNvPr id="8" name="">
             <a:extLst xmlns:a="http://schemas.openxmlformats.org/drawingml/2006/main">
               <a:ext uri="{FF2B5EF4-FFF2-40B4-BE49-F238E27FC236}">
-                <a16:creationId xmlns:a16="http://schemas.microsoft.com/office/drawing/2014/main" id="{CA815EAB-5D7F-459D-A133-20CDB4F08AA4}"/>
+                <a16:creationId xmlns:a16="http://schemas.microsoft.com/office/drawing/2014/main" id="{C8E4ADD2-4232-4FFE-A7C9-00BE1D1E2A45}"/>
               </a:ext>
             </a:extLst>
           </p:cNvPr>
@@ -11167,7 +11329,7 @@
           <p:cNvPr id="2" name="">
             <a:extLst xmlns:a="http://schemas.openxmlformats.org/drawingml/2006/main">
               <a:ext uri="{FF2B5EF4-FFF2-40B4-BE49-F238E27FC236}">
-                <a16:creationId xmlns:a16="http://schemas.microsoft.com/office/drawing/2014/main" id="{57FA1EBC-7A1F-4914-91F9-154A0BFE0E22}"/>
+                <a16:creationId xmlns:a16="http://schemas.microsoft.com/office/drawing/2014/main" id="{B384D554-68BA-4AA3-8E47-C1E46129FF7C}"/>
               </a:ext>
             </a:extLst>
           </p:cNvPr>
@@ -11323,7 +11485,7 @@
           <p:cNvPr id="3" name="">
             <a:extLst xmlns:a="http://schemas.openxmlformats.org/drawingml/2006/main">
               <a:ext uri="{FF2B5EF4-FFF2-40B4-BE49-F238E27FC236}">
-                <a16:creationId xmlns:a16="http://schemas.microsoft.com/office/drawing/2014/main" id="{2D49534E-427A-4224-B26C-D457ECF0959E}"/>
+                <a16:creationId xmlns:a16="http://schemas.microsoft.com/office/drawing/2014/main" id="{07187D22-740D-4C8B-AA39-65047D9451D2}"/>
               </a:ext>
             </a:extLst>
           </p:cNvPr>
@@ -11479,7 +11641,7 @@
           <p:cNvPr id="4" name="">
             <a:extLst xmlns:a="http://schemas.openxmlformats.org/drawingml/2006/main">
               <a:ext uri="{FF2B5EF4-FFF2-40B4-BE49-F238E27FC236}">
-                <a16:creationId xmlns:a16="http://schemas.microsoft.com/office/drawing/2014/main" id="{BC4E5A35-6CA6-4B2F-9C37-96FEEF600056}"/>
+                <a16:creationId xmlns:a16="http://schemas.microsoft.com/office/drawing/2014/main" id="{6C6E30E4-ABBA-4D2D-81BA-F4539A26ADFE}"/>
               </a:ext>
             </a:extLst>
           </p:cNvPr>
@@ -11887,7 +12049,7 @@
           <p:cNvPr id="5" name="">
             <a:extLst xmlns:a="http://schemas.openxmlformats.org/drawingml/2006/main">
               <a:ext uri="{FF2B5EF4-FFF2-40B4-BE49-F238E27FC236}">
-                <a16:creationId xmlns:a16="http://schemas.microsoft.com/office/drawing/2014/main" id="{FC3C661A-F6CF-4945-8DF8-AC7CF994B68E}"/>
+                <a16:creationId xmlns:a16="http://schemas.microsoft.com/office/drawing/2014/main" id="{D7E8E17E-1E26-49C4-AA4F-B350426D4866}"/>
               </a:ext>
             </a:extLst>
           </p:cNvPr>
@@ -12066,7 +12228,7 @@
           <p:cNvPr id="6" name="">
             <a:extLst xmlns:a="http://schemas.openxmlformats.org/drawingml/2006/main">
               <a:ext uri="{FF2B5EF4-FFF2-40B4-BE49-F238E27FC236}">
-                <a16:creationId xmlns:a16="http://schemas.microsoft.com/office/drawing/2014/main" id="{FF5D421A-11C1-4AD0-AC31-BC00522E601F}"/>
+                <a16:creationId xmlns:a16="http://schemas.microsoft.com/office/drawing/2014/main" id="{7DE2B1B0-9A89-4CCF-95B1-76F3A82924F0}"/>
               </a:ext>
             </a:extLst>
           </p:cNvPr>
@@ -12245,7 +12407,7 @@
           <p:cNvPr id="7" name="">
             <a:extLst xmlns:a="http://schemas.openxmlformats.org/drawingml/2006/main">
               <a:ext uri="{FF2B5EF4-FFF2-40B4-BE49-F238E27FC236}">
-                <a16:creationId xmlns:a16="http://schemas.microsoft.com/office/drawing/2014/main" id="{9EBDB71F-C296-4661-B7FA-A96FFDF28DD5}"/>
+                <a16:creationId xmlns:a16="http://schemas.microsoft.com/office/drawing/2014/main" id="{F6451DC6-88A3-47E9-925D-D02A2602DA30}"/>
               </a:ext>
             </a:extLst>
           </p:cNvPr>
@@ -12399,7 +12561,7 @@
     </p:spTree>
     <p:extLst>
       <p:ext uri="{BB962C8B-B14F-4D97-AF65-F5344CB8AC3E}">
-        <p14:creationId xmlns:p14="http://schemas.microsoft.com/office/powerpoint/2010/main" val="866835194"/>
+        <p14:creationId xmlns:p14="http://schemas.microsoft.com/office/powerpoint/2010/main" val="2100601490"/>
       </p:ext>
     </p:extLst>
   </p:cSld>
@@ -12430,7 +12592,7 @@
           <p:cNvPr id="6" name="">
             <a:extLst xmlns:a="http://schemas.openxmlformats.org/drawingml/2006/main">
               <a:ext uri="{FF2B5EF4-FFF2-40B4-BE49-F238E27FC236}">
-                <a16:creationId xmlns:a16="http://schemas.microsoft.com/office/drawing/2014/main" id="{3CEB0891-B689-432C-B68E-50F216FA8B33}"/>
+                <a16:creationId xmlns:a16="http://schemas.microsoft.com/office/drawing/2014/main" id="{3045D820-4B06-4141-AB46-36D69A6CC8CE}"/>
               </a:ext>
             </a:extLst>
           </p:cNvPr>
@@ -12586,7 +12748,7 @@
           <p:cNvPr id="2" name="">
             <a:extLst xmlns:a="http://schemas.openxmlformats.org/drawingml/2006/main">
               <a:ext uri="{FF2B5EF4-FFF2-40B4-BE49-F238E27FC236}">
-                <a16:creationId xmlns:a16="http://schemas.microsoft.com/office/drawing/2014/main" id="{00688B16-EE02-4BC7-82A5-E9558C3B39EB}"/>
+                <a16:creationId xmlns:a16="http://schemas.microsoft.com/office/drawing/2014/main" id="{8AC65639-1DD5-4072-A248-24CC8D6A53E4}"/>
               </a:ext>
             </a:extLst>
           </p:cNvPr>
@@ -12742,7 +12904,7 @@
           <p:cNvPr id="3" name="">
             <a:extLst xmlns:a="http://schemas.openxmlformats.org/drawingml/2006/main">
               <a:ext uri="{FF2B5EF4-FFF2-40B4-BE49-F238E27FC236}">
-                <a16:creationId xmlns:a16="http://schemas.microsoft.com/office/drawing/2014/main" id="{52E5E2D7-38CC-4A0A-A618-118140E7D172}"/>
+                <a16:creationId xmlns:a16="http://schemas.microsoft.com/office/drawing/2014/main" id="{EB543611-8DBF-4EF4-88BD-4E2B664A1164}"/>
               </a:ext>
             </a:extLst>
           </p:cNvPr>
@@ -12898,7 +13060,7 @@
           <p:cNvPr id="4" name="">
             <a:extLst xmlns:a="http://schemas.openxmlformats.org/drawingml/2006/main">
               <a:ext uri="{FF2B5EF4-FFF2-40B4-BE49-F238E27FC236}">
-                <a16:creationId xmlns:a16="http://schemas.microsoft.com/office/drawing/2014/main" id="{A9ACD3D3-8D03-4F05-8BED-8EC4448BCAF3}"/>
+                <a16:creationId xmlns:a16="http://schemas.microsoft.com/office/drawing/2014/main" id="{30BF14CD-E6B1-4728-8308-D8638396D8D1}"/>
               </a:ext>
             </a:extLst>
           </p:cNvPr>
@@ -14105,7 +14267,7 @@
           <p:cNvPr id="5" name="">
             <a:extLst xmlns:a="http://schemas.openxmlformats.org/drawingml/2006/main">
               <a:ext uri="{FF2B5EF4-FFF2-40B4-BE49-F238E27FC236}">
-                <a16:creationId xmlns:a16="http://schemas.microsoft.com/office/drawing/2014/main" id="{CF4366BB-049E-47DD-A0FD-7ECBEDE706AF}"/>
+                <a16:creationId xmlns:a16="http://schemas.microsoft.com/office/drawing/2014/main" id="{277CFDB6-B441-4023-9153-8DE33D38355E}"/>
               </a:ext>
             </a:extLst>
           </p:cNvPr>
@@ -14259,7 +14421,7 @@
     </p:spTree>
     <p:extLst>
       <p:ext uri="{BB962C8B-B14F-4D97-AF65-F5344CB8AC3E}">
-        <p14:creationId xmlns:p14="http://schemas.microsoft.com/office/powerpoint/2010/main" val="1376204573"/>
+        <p14:creationId xmlns:p14="http://schemas.microsoft.com/office/powerpoint/2010/main" val="1481043437"/>
       </p:ext>
     </p:extLst>
   </p:cSld>
@@ -14290,7 +14452,7 @@
           <p:cNvPr id="6" name="">
             <a:extLst xmlns:a="http://schemas.openxmlformats.org/drawingml/2006/main">
               <a:ext uri="{FF2B5EF4-FFF2-40B4-BE49-F238E27FC236}">
-                <a16:creationId xmlns:a16="http://schemas.microsoft.com/office/drawing/2014/main" id="{EB8DEEAC-D7BC-4F9B-882D-78D6238849B1}"/>
+                <a16:creationId xmlns:a16="http://schemas.microsoft.com/office/drawing/2014/main" id="{663FE007-8972-440E-9EB2-D4B1BAB99E12}"/>
               </a:ext>
             </a:extLst>
           </p:cNvPr>
@@ -14446,7 +14608,7 @@
           <p:cNvPr id="2" name="">
             <a:extLst xmlns:a="http://schemas.openxmlformats.org/drawingml/2006/main">
               <a:ext uri="{FF2B5EF4-FFF2-40B4-BE49-F238E27FC236}">
-                <a16:creationId xmlns:a16="http://schemas.microsoft.com/office/drawing/2014/main" id="{6D18778D-D9BE-4B5B-9B01-77AAAAEF94A8}"/>
+                <a16:creationId xmlns:a16="http://schemas.microsoft.com/office/drawing/2014/main" id="{1C20DF78-5DAE-435A-885D-B1ABC4B98A6C}"/>
               </a:ext>
             </a:extLst>
           </p:cNvPr>
@@ -14602,7 +14764,7 @@
           <p:cNvPr id="3" name="">
             <a:extLst xmlns:a="http://schemas.openxmlformats.org/drawingml/2006/main">
               <a:ext uri="{FF2B5EF4-FFF2-40B4-BE49-F238E27FC236}">
-                <a16:creationId xmlns:a16="http://schemas.microsoft.com/office/drawing/2014/main" id="{4ED448EE-8C91-4160-BE53-6E0D7F9872EC}"/>
+                <a16:creationId xmlns:a16="http://schemas.microsoft.com/office/drawing/2014/main" id="{D6042201-2037-4E49-8993-F83DD3BDD94B}"/>
               </a:ext>
             </a:extLst>
           </p:cNvPr>
@@ -14758,7 +14920,7 @@
           <p:cNvPr id="4" name="">
             <a:extLst xmlns:a="http://schemas.openxmlformats.org/drawingml/2006/main">
               <a:ext uri="{FF2B5EF4-FFF2-40B4-BE49-F238E27FC236}">
-                <a16:creationId xmlns:a16="http://schemas.microsoft.com/office/drawing/2014/main" id="{8212F6CE-6C50-4759-8CDA-C54BCCD89DA0}"/>
+                <a16:creationId xmlns:a16="http://schemas.microsoft.com/office/drawing/2014/main" id="{6A364852-683E-4162-ABF2-E317A19B1C07}"/>
               </a:ext>
             </a:extLst>
           </p:cNvPr>
@@ -15451,7 +15613,7 @@
           <p:cNvPr id="5" name="">
             <a:extLst xmlns:a="http://schemas.openxmlformats.org/drawingml/2006/main">
               <a:ext uri="{FF2B5EF4-FFF2-40B4-BE49-F238E27FC236}">
-                <a16:creationId xmlns:a16="http://schemas.microsoft.com/office/drawing/2014/main" id="{D8F97D7A-EB70-4355-AED4-84A0D9DB0748}"/>
+                <a16:creationId xmlns:a16="http://schemas.microsoft.com/office/drawing/2014/main" id="{48794E66-6190-42FA-A5F4-38F8F181F91B}"/>
               </a:ext>
             </a:extLst>
           </p:cNvPr>
@@ -15605,7 +15767,7 @@
     </p:spTree>
     <p:extLst>
       <p:ext uri="{BB962C8B-B14F-4D97-AF65-F5344CB8AC3E}">
-        <p14:creationId xmlns:p14="http://schemas.microsoft.com/office/powerpoint/2010/main" val="102968783"/>
+        <p14:creationId xmlns:p14="http://schemas.microsoft.com/office/powerpoint/2010/main" val="734852637"/>
       </p:ext>
     </p:extLst>
   </p:cSld>
@@ -15636,7 +15798,7 @@
           <p:cNvPr id="6" name="">
             <a:extLst xmlns:a="http://schemas.openxmlformats.org/drawingml/2006/main">
               <a:ext uri="{FF2B5EF4-FFF2-40B4-BE49-F238E27FC236}">
-                <a16:creationId xmlns:a16="http://schemas.microsoft.com/office/drawing/2014/main" id="{A27D376F-CB19-44E8-9660-B6D61296A100}"/>
+                <a16:creationId xmlns:a16="http://schemas.microsoft.com/office/drawing/2014/main" id="{A929042E-5A23-4ED5-BA80-9EF073FCAE38}"/>
               </a:ext>
             </a:extLst>
           </p:cNvPr>
@@ -15792,7 +15954,7 @@
           <p:cNvPr id="2" name="">
             <a:extLst xmlns:a="http://schemas.openxmlformats.org/drawingml/2006/main">
               <a:ext uri="{FF2B5EF4-FFF2-40B4-BE49-F238E27FC236}">
-                <a16:creationId xmlns:a16="http://schemas.microsoft.com/office/drawing/2014/main" id="{F5460C41-5BA1-4387-B4B3-A11FD49CABE5}"/>
+                <a16:creationId xmlns:a16="http://schemas.microsoft.com/office/drawing/2014/main" id="{CBA855F9-5834-49EE-958A-B393E63B92E0}"/>
               </a:ext>
             </a:extLst>
           </p:cNvPr>
@@ -15948,7 +16110,7 @@
           <p:cNvPr id="3" name="">
             <a:extLst xmlns:a="http://schemas.openxmlformats.org/drawingml/2006/main">
               <a:ext uri="{FF2B5EF4-FFF2-40B4-BE49-F238E27FC236}">
-                <a16:creationId xmlns:a16="http://schemas.microsoft.com/office/drawing/2014/main" id="{D81C8752-8D5E-4837-82B6-76EE70F160FF}"/>
+                <a16:creationId xmlns:a16="http://schemas.microsoft.com/office/drawing/2014/main" id="{9BE36B56-CD52-4371-8FE1-BA6206E2F1FD}"/>
               </a:ext>
             </a:extLst>
           </p:cNvPr>
@@ -16104,7 +16266,7 @@
           <p:cNvPr id="4" name="">
             <a:extLst xmlns:a="http://schemas.openxmlformats.org/drawingml/2006/main">
               <a:ext uri="{FF2B5EF4-FFF2-40B4-BE49-F238E27FC236}">
-                <a16:creationId xmlns:a16="http://schemas.microsoft.com/office/drawing/2014/main" id="{7F406792-759B-4492-9351-D393D5B3267F}"/>
+                <a16:creationId xmlns:a16="http://schemas.microsoft.com/office/drawing/2014/main" id="{618D36CA-569D-4972-957F-BB509C9D379D}"/>
               </a:ext>
             </a:extLst>
           </p:cNvPr>
@@ -16976,7 +17138,7 @@
           <p:cNvPr id="5" name="">
             <a:extLst xmlns:a="http://schemas.openxmlformats.org/drawingml/2006/main">
               <a:ext uri="{FF2B5EF4-FFF2-40B4-BE49-F238E27FC236}">
-                <a16:creationId xmlns:a16="http://schemas.microsoft.com/office/drawing/2014/main" id="{0EDBF9AF-5935-415F-A59B-CBD905E3E8FA}"/>
+                <a16:creationId xmlns:a16="http://schemas.microsoft.com/office/drawing/2014/main" id="{265598D3-F2D8-42FA-9879-F1EE6FC05C20}"/>
               </a:ext>
             </a:extLst>
           </p:cNvPr>
@@ -17130,7 +17292,2917 @@
     </p:spTree>
     <p:extLst>
       <p:ext uri="{BB962C8B-B14F-4D97-AF65-F5344CB8AC3E}">
-        <p14:creationId xmlns:p14="http://schemas.microsoft.com/office/powerpoint/2010/main" val="1832600177"/>
+        <p14:creationId xmlns:p14="http://schemas.microsoft.com/office/powerpoint/2010/main" val="1218785141"/>
+      </p:ext>
+    </p:extLst>
+  </p:cSld>
+</p:sld>
+</file>
+
+<file path=ppt/slides/slide17.xml><?xml version="1.0" encoding="utf-8"?>
+<p:sld xmlns:p="http://schemas.openxmlformats.org/presentationml/2006/main">
+  <p:cSld>
+    <p:bg>
+      <p:bgPr>
+        <a:solidFill xmlns:a="http://schemas.openxmlformats.org/drawingml/2006/main">
+          <a:srgbClr val="F7F6F2"/>
+        </a:solidFill>
+      </p:bgPr>
+    </p:bg>
+    <p:spTree>
+      <p:nvGrpSpPr>
+        <p:cNvPr id="1" name=""/>
+        <p:cNvGrpSpPr/>
+        <p:nvPr/>
+      </p:nvGrpSpPr>
+      <p:grpSpPr>
+        <a:xfrm xmlns:a="http://schemas.openxmlformats.org/drawingml/2006/main"/>
+      </p:grpSpPr>
+      <p:sp>
+        <p:nvSpPr>
+          <p:cNvPr id="6" name="">
+            <a:extLst xmlns:a="http://schemas.openxmlformats.org/drawingml/2006/main">
+              <a:ext uri="{FF2B5EF4-FFF2-40B4-BE49-F238E27FC236}">
+                <a16:creationId xmlns:a16="http://schemas.microsoft.com/office/drawing/2014/main" id="{5DC14DAE-4F9C-4785-9B71-3460359CCF49}"/>
+              </a:ext>
+            </a:extLst>
+          </p:cNvPr>
+          <p:cNvSpPr>
+            <a:spLocks xmlns:a="http://schemas.openxmlformats.org/drawingml/2006/main" noGrp="1"/>
+          </p:cNvSpPr>
+          <p:nvPr/>
+        </p:nvSpPr>
+        <p:spPr>
+          <a:xfrm xmlns:a="http://schemas.openxmlformats.org/drawingml/2006/main">
+            <a:off x="495300" y="381000"/>
+            <a:ext cx="11201400" cy="723900"/>
+          </a:xfrm>
+          <a:prstGeom xmlns:a="http://schemas.openxmlformats.org/drawingml/2006/main" prst="rect">
+            <a:avLst/>
+          </a:prstGeom>
+          <a:noFill xmlns:a="http://schemas.openxmlformats.org/drawingml/2006/main"/>
+          <a:ln xmlns:a="http://schemas.openxmlformats.org/drawingml/2006/main" w="0">
+            <a:noFill/>
+          </a:ln>
+        </p:spPr>
+        <p:txBody>
+          <a:bodyPr xmlns:a="http://schemas.openxmlformats.org/drawingml/2006/main" lIns="0" tIns="0" rIns="0" bIns="0"/>
+          <a:lstStyle xmlns:a="http://schemas.openxmlformats.org/drawingml/2006/main">
+            <a:defPPr>
+              <a:defRPr sz="3000" b="1">
+                <a:solidFill>
+                  <a:srgbClr val="172B3A"/>
+                </a:solidFill>
+                <a:latin typeface="Arial"/>
+                <a:ea typeface="Arial"/>
+                <a:cs typeface="Arial"/>
+              </a:defRPr>
+            </a:defPPr>
+            <a:lvl1pPr>
+              <a:defRPr sz="3000" b="1">
+                <a:solidFill>
+                  <a:srgbClr val="172B3A"/>
+                </a:solidFill>
+                <a:latin typeface="Arial"/>
+                <a:ea typeface="Arial"/>
+                <a:cs typeface="Arial"/>
+              </a:defRPr>
+            </a:lvl1pPr>
+            <a:lvl2pPr>
+              <a:defRPr sz="3000" b="1">
+                <a:solidFill>
+                  <a:srgbClr val="172B3A"/>
+                </a:solidFill>
+                <a:latin typeface="Arial"/>
+                <a:ea typeface="Arial"/>
+                <a:cs typeface="Arial"/>
+              </a:defRPr>
+            </a:lvl2pPr>
+            <a:lvl3pPr>
+              <a:defRPr sz="3000" b="1">
+                <a:solidFill>
+                  <a:srgbClr val="172B3A"/>
+                </a:solidFill>
+                <a:latin typeface="Arial"/>
+                <a:ea typeface="Arial"/>
+                <a:cs typeface="Arial"/>
+              </a:defRPr>
+            </a:lvl3pPr>
+            <a:lvl4pPr>
+              <a:defRPr sz="3000" b="1">
+                <a:solidFill>
+                  <a:srgbClr val="172B3A"/>
+                </a:solidFill>
+                <a:latin typeface="Arial"/>
+                <a:ea typeface="Arial"/>
+                <a:cs typeface="Arial"/>
+              </a:defRPr>
+            </a:lvl4pPr>
+            <a:lvl5pPr>
+              <a:defRPr sz="3000" b="1">
+                <a:solidFill>
+                  <a:srgbClr val="172B3A"/>
+                </a:solidFill>
+                <a:latin typeface="Arial"/>
+                <a:ea typeface="Arial"/>
+                <a:cs typeface="Arial"/>
+              </a:defRPr>
+            </a:lvl5pPr>
+            <a:lvl6pPr>
+              <a:defRPr sz="3000" b="1">
+                <a:solidFill>
+                  <a:srgbClr val="172B3A"/>
+                </a:solidFill>
+                <a:latin typeface="Arial"/>
+                <a:ea typeface="Arial"/>
+                <a:cs typeface="Arial"/>
+              </a:defRPr>
+            </a:lvl6pPr>
+            <a:lvl7pPr>
+              <a:defRPr sz="3000" b="1">
+                <a:solidFill>
+                  <a:srgbClr val="172B3A"/>
+                </a:solidFill>
+                <a:latin typeface="Arial"/>
+                <a:ea typeface="Arial"/>
+                <a:cs typeface="Arial"/>
+              </a:defRPr>
+            </a:lvl7pPr>
+            <a:lvl8pPr>
+              <a:defRPr sz="3000" b="1">
+                <a:solidFill>
+                  <a:srgbClr val="172B3A"/>
+                </a:solidFill>
+                <a:latin typeface="Arial"/>
+                <a:ea typeface="Arial"/>
+                <a:cs typeface="Arial"/>
+              </a:defRPr>
+            </a:lvl8pPr>
+            <a:lvl9pPr>
+              <a:defRPr sz="3000" b="1">
+                <a:solidFill>
+                  <a:srgbClr val="172B3A"/>
+                </a:solidFill>
+                <a:latin typeface="Arial"/>
+                <a:ea typeface="Arial"/>
+                <a:cs typeface="Arial"/>
+              </a:defRPr>
+            </a:lvl9pPr>
+          </a:lstStyle>
+          <a:p xmlns:a="http://schemas.openxmlformats.org/drawingml/2006/main">
+            <a:pPr>
+              <a:defRPr sz="3000" b="1">
+                <a:solidFill>
+                  <a:srgbClr val="172B3A"/>
+                </a:solidFill>
+                <a:latin typeface="Arial"/>
+                <a:ea typeface="Arial"/>
+                <a:cs typeface="Arial"/>
+              </a:defRPr>
+            </a:pPr>
+            <a:r>
+              <a:rPr sz="3000" b="1">
+                <a:solidFill>
+                  <a:srgbClr val="172B3A"/>
+                </a:solidFill>
+                <a:latin typeface="Arial"/>
+                <a:ea typeface="Arial"/>
+                <a:cs typeface="Arial"/>
+              </a:rPr>
+              <a:t>Solutions: the five guided recovery tasks</a:t>
+            </a:r>
+          </a:p>
+        </p:txBody>
+      </p:sp>
+      <p:sp>
+        <p:nvSpPr>
+          <p:cNvPr id="2" name="">
+            <a:extLst xmlns:a="http://schemas.openxmlformats.org/drawingml/2006/main">
+              <a:ext uri="{FF2B5EF4-FFF2-40B4-BE49-F238E27FC236}">
+                <a16:creationId xmlns:a16="http://schemas.microsoft.com/office/drawing/2014/main" id="{D602469F-6A05-49C8-A622-CD2D02ED9A87}"/>
+              </a:ext>
+            </a:extLst>
+          </p:cNvPr>
+          <p:cNvSpPr>
+            <a:spLocks xmlns:a="http://schemas.openxmlformats.org/drawingml/2006/main" noGrp="1"/>
+          </p:cNvSpPr>
+          <p:nvPr/>
+        </p:nvSpPr>
+        <p:spPr>
+          <a:xfrm xmlns:a="http://schemas.openxmlformats.org/drawingml/2006/main">
+            <a:off x="495300" y="6467475"/>
+            <a:ext cx="6667500" cy="209550"/>
+          </a:xfrm>
+          <a:prstGeom xmlns:a="http://schemas.openxmlformats.org/drawingml/2006/main" prst="rect">
+            <a:avLst/>
+          </a:prstGeom>
+          <a:noFill xmlns:a="http://schemas.openxmlformats.org/drawingml/2006/main"/>
+          <a:ln xmlns:a="http://schemas.openxmlformats.org/drawingml/2006/main" w="0">
+            <a:noFill/>
+          </a:ln>
+        </p:spPr>
+        <p:txBody>
+          <a:bodyPr xmlns:a="http://schemas.openxmlformats.org/drawingml/2006/main" lIns="0" tIns="0" rIns="0" bIns="0"/>
+          <a:lstStyle xmlns:a="http://schemas.openxmlformats.org/drawingml/2006/main">
+            <a:defPPr>
+              <a:defRPr sz="1050" b="1">
+                <a:solidFill>
+                  <a:srgbClr val="566A73"/>
+                </a:solidFill>
+                <a:latin typeface="Arial"/>
+                <a:ea typeface="Arial"/>
+                <a:cs typeface="Arial"/>
+              </a:defRPr>
+            </a:defPPr>
+            <a:lvl1pPr>
+              <a:defRPr sz="1050" b="1">
+                <a:solidFill>
+                  <a:srgbClr val="566A73"/>
+                </a:solidFill>
+                <a:latin typeface="Arial"/>
+                <a:ea typeface="Arial"/>
+                <a:cs typeface="Arial"/>
+              </a:defRPr>
+            </a:lvl1pPr>
+            <a:lvl2pPr>
+              <a:defRPr sz="1050" b="1">
+                <a:solidFill>
+                  <a:srgbClr val="566A73"/>
+                </a:solidFill>
+                <a:latin typeface="Arial"/>
+                <a:ea typeface="Arial"/>
+                <a:cs typeface="Arial"/>
+              </a:defRPr>
+            </a:lvl2pPr>
+            <a:lvl3pPr>
+              <a:defRPr sz="1050" b="1">
+                <a:solidFill>
+                  <a:srgbClr val="566A73"/>
+                </a:solidFill>
+                <a:latin typeface="Arial"/>
+                <a:ea typeface="Arial"/>
+                <a:cs typeface="Arial"/>
+              </a:defRPr>
+            </a:lvl3pPr>
+            <a:lvl4pPr>
+              <a:defRPr sz="1050" b="1">
+                <a:solidFill>
+                  <a:srgbClr val="566A73"/>
+                </a:solidFill>
+                <a:latin typeface="Arial"/>
+                <a:ea typeface="Arial"/>
+                <a:cs typeface="Arial"/>
+              </a:defRPr>
+            </a:lvl4pPr>
+            <a:lvl5pPr>
+              <a:defRPr sz="1050" b="1">
+                <a:solidFill>
+                  <a:srgbClr val="566A73"/>
+                </a:solidFill>
+                <a:latin typeface="Arial"/>
+                <a:ea typeface="Arial"/>
+                <a:cs typeface="Arial"/>
+              </a:defRPr>
+            </a:lvl5pPr>
+            <a:lvl6pPr>
+              <a:defRPr sz="1050" b="1">
+                <a:solidFill>
+                  <a:srgbClr val="566A73"/>
+                </a:solidFill>
+                <a:latin typeface="Arial"/>
+                <a:ea typeface="Arial"/>
+                <a:cs typeface="Arial"/>
+              </a:defRPr>
+            </a:lvl6pPr>
+            <a:lvl7pPr>
+              <a:defRPr sz="1050" b="1">
+                <a:solidFill>
+                  <a:srgbClr val="566A73"/>
+                </a:solidFill>
+                <a:latin typeface="Arial"/>
+                <a:ea typeface="Arial"/>
+                <a:cs typeface="Arial"/>
+              </a:defRPr>
+            </a:lvl7pPr>
+            <a:lvl8pPr>
+              <a:defRPr sz="1050" b="1">
+                <a:solidFill>
+                  <a:srgbClr val="566A73"/>
+                </a:solidFill>
+                <a:latin typeface="Arial"/>
+                <a:ea typeface="Arial"/>
+                <a:cs typeface="Arial"/>
+              </a:defRPr>
+            </a:lvl8pPr>
+            <a:lvl9pPr>
+              <a:defRPr sz="1050" b="1">
+                <a:solidFill>
+                  <a:srgbClr val="566A73"/>
+                </a:solidFill>
+                <a:latin typeface="Arial"/>
+                <a:ea typeface="Arial"/>
+                <a:cs typeface="Arial"/>
+              </a:defRPr>
+            </a:lvl9pPr>
+          </a:lstStyle>
+          <a:p xmlns:a="http://schemas.openxmlformats.org/drawingml/2006/main">
+            <a:pPr>
+              <a:defRPr sz="1050" b="1">
+                <a:solidFill>
+                  <a:srgbClr val="566A73"/>
+                </a:solidFill>
+                <a:latin typeface="Arial"/>
+                <a:ea typeface="Arial"/>
+                <a:cs typeface="Arial"/>
+              </a:defRPr>
+            </a:pPr>
+            <a:r>
+              <a:rPr sz="1050" b="1">
+                <a:solidFill>
+                  <a:srgbClr val="566A73"/>
+                </a:solidFill>
+                <a:latin typeface="Arial"/>
+                <a:ea typeface="Arial"/>
+                <a:cs typeface="Arial"/>
+              </a:rPr>
+              <a:t>ASTRO / Reference</a:t>
+            </a:r>
+          </a:p>
+        </p:txBody>
+      </p:sp>
+      <p:sp>
+        <p:nvSpPr>
+          <p:cNvPr id="3" name="">
+            <a:extLst xmlns:a="http://schemas.openxmlformats.org/drawingml/2006/main">
+              <a:ext uri="{FF2B5EF4-FFF2-40B4-BE49-F238E27FC236}">
+                <a16:creationId xmlns:a16="http://schemas.microsoft.com/office/drawing/2014/main" id="{48794595-9560-4219-B249-AE25A8FDD56B}"/>
+              </a:ext>
+            </a:extLst>
+          </p:cNvPr>
+          <p:cNvSpPr>
+            <a:spLocks xmlns:a="http://schemas.openxmlformats.org/drawingml/2006/main" noGrp="1"/>
+          </p:cNvSpPr>
+          <p:nvPr/>
+        </p:nvSpPr>
+        <p:spPr>
+          <a:xfrm xmlns:a="http://schemas.openxmlformats.org/drawingml/2006/main">
+            <a:off x="11334750" y="6467475"/>
+            <a:ext cx="361950" cy="209550"/>
+          </a:xfrm>
+          <a:prstGeom xmlns:a="http://schemas.openxmlformats.org/drawingml/2006/main" prst="rect">
+            <a:avLst/>
+          </a:prstGeom>
+          <a:noFill xmlns:a="http://schemas.openxmlformats.org/drawingml/2006/main"/>
+          <a:ln xmlns:a="http://schemas.openxmlformats.org/drawingml/2006/main" w="0">
+            <a:noFill/>
+          </a:ln>
+        </p:spPr>
+        <p:txBody>
+          <a:bodyPr xmlns:a="http://schemas.openxmlformats.org/drawingml/2006/main" lIns="0" tIns="0" rIns="0" bIns="0"/>
+          <a:lstStyle xmlns:a="http://schemas.openxmlformats.org/drawingml/2006/main">
+            <a:defPPr>
+              <a:defRPr sz="1050" b="0">
+                <a:solidFill>
+                  <a:srgbClr val="566A73"/>
+                </a:solidFill>
+                <a:latin typeface="Arial"/>
+                <a:ea typeface="Arial"/>
+                <a:cs typeface="Arial"/>
+              </a:defRPr>
+            </a:defPPr>
+            <a:lvl1pPr>
+              <a:defRPr sz="1050" b="0">
+                <a:solidFill>
+                  <a:srgbClr val="566A73"/>
+                </a:solidFill>
+                <a:latin typeface="Arial"/>
+                <a:ea typeface="Arial"/>
+                <a:cs typeface="Arial"/>
+              </a:defRPr>
+            </a:lvl1pPr>
+            <a:lvl2pPr>
+              <a:defRPr sz="1050" b="0">
+                <a:solidFill>
+                  <a:srgbClr val="566A73"/>
+                </a:solidFill>
+                <a:latin typeface="Arial"/>
+                <a:ea typeface="Arial"/>
+                <a:cs typeface="Arial"/>
+              </a:defRPr>
+            </a:lvl2pPr>
+            <a:lvl3pPr>
+              <a:defRPr sz="1050" b="0">
+                <a:solidFill>
+                  <a:srgbClr val="566A73"/>
+                </a:solidFill>
+                <a:latin typeface="Arial"/>
+                <a:ea typeface="Arial"/>
+                <a:cs typeface="Arial"/>
+              </a:defRPr>
+            </a:lvl3pPr>
+            <a:lvl4pPr>
+              <a:defRPr sz="1050" b="0">
+                <a:solidFill>
+                  <a:srgbClr val="566A73"/>
+                </a:solidFill>
+                <a:latin typeface="Arial"/>
+                <a:ea typeface="Arial"/>
+                <a:cs typeface="Arial"/>
+              </a:defRPr>
+            </a:lvl4pPr>
+            <a:lvl5pPr>
+              <a:defRPr sz="1050" b="0">
+                <a:solidFill>
+                  <a:srgbClr val="566A73"/>
+                </a:solidFill>
+                <a:latin typeface="Arial"/>
+                <a:ea typeface="Arial"/>
+                <a:cs typeface="Arial"/>
+              </a:defRPr>
+            </a:lvl5pPr>
+            <a:lvl6pPr>
+              <a:defRPr sz="1050" b="0">
+                <a:solidFill>
+                  <a:srgbClr val="566A73"/>
+                </a:solidFill>
+                <a:latin typeface="Arial"/>
+                <a:ea typeface="Arial"/>
+                <a:cs typeface="Arial"/>
+              </a:defRPr>
+            </a:lvl6pPr>
+            <a:lvl7pPr>
+              <a:defRPr sz="1050" b="0">
+                <a:solidFill>
+                  <a:srgbClr val="566A73"/>
+                </a:solidFill>
+                <a:latin typeface="Arial"/>
+                <a:ea typeface="Arial"/>
+                <a:cs typeface="Arial"/>
+              </a:defRPr>
+            </a:lvl7pPr>
+            <a:lvl8pPr>
+              <a:defRPr sz="1050" b="0">
+                <a:solidFill>
+                  <a:srgbClr val="566A73"/>
+                </a:solidFill>
+                <a:latin typeface="Arial"/>
+                <a:ea typeface="Arial"/>
+                <a:cs typeface="Arial"/>
+              </a:defRPr>
+            </a:lvl8pPr>
+            <a:lvl9pPr>
+              <a:defRPr sz="1050" b="0">
+                <a:solidFill>
+                  <a:srgbClr val="566A73"/>
+                </a:solidFill>
+                <a:latin typeface="Arial"/>
+                <a:ea typeface="Arial"/>
+                <a:cs typeface="Arial"/>
+              </a:defRPr>
+            </a:lvl9pPr>
+          </a:lstStyle>
+          <a:p xmlns:a="http://schemas.openxmlformats.org/drawingml/2006/main">
+            <a:pPr>
+              <a:defRPr sz="1050" b="0">
+                <a:solidFill>
+                  <a:srgbClr val="566A73"/>
+                </a:solidFill>
+                <a:latin typeface="Arial"/>
+                <a:ea typeface="Arial"/>
+                <a:cs typeface="Arial"/>
+              </a:defRPr>
+            </a:pPr>
+            <a:r>
+              <a:rPr sz="1050" b="0">
+                <a:solidFill>
+                  <a:srgbClr val="566A73"/>
+                </a:solidFill>
+                <a:latin typeface="Arial"/>
+                <a:ea typeface="Arial"/>
+                <a:cs typeface="Arial"/>
+              </a:rPr>
+              <a:t>17</a:t>
+            </a:r>
+          </a:p>
+        </p:txBody>
+      </p:sp>
+      <p:graphicFrame>
+        <p:nvGraphicFramePr>
+          <p:cNvPr id="4" name="">
+            <a:extLst xmlns:a="http://schemas.openxmlformats.org/drawingml/2006/main">
+              <a:ext uri="{FF2B5EF4-FFF2-40B4-BE49-F238E27FC236}">
+                <a16:creationId xmlns:a16="http://schemas.microsoft.com/office/drawing/2014/main" id="{2CA66CDE-10E1-4D72-AB55-F29A524FC6E4}"/>
+              </a:ext>
+            </a:extLst>
+          </p:cNvPr>
+          <p:cNvGraphicFramePr/>
+          <p:nvPr/>
+        </p:nvGraphicFramePr>
+        <p:xfrm>
+          <a:off xmlns:a="http://schemas.openxmlformats.org/drawingml/2006/main" x="495300" y="1390650"/>
+          <a:ext xmlns:a="http://schemas.openxmlformats.org/drawingml/2006/main" cx="11201400" cy="4229100"/>
+        </p:xfrm>
+        <a:graphic xmlns:a="http://schemas.openxmlformats.org/drawingml/2006/main">
+          <a:graphicData uri="http://schemas.openxmlformats.org/drawingml/2006/table">
+            <a:tbl>
+              <a:tblPr/>
+              <a:tblGrid>
+                <a:gridCol w="2724150"/>
+                <a:gridCol w="5619750"/>
+                <a:gridCol w="2857500"/>
+              </a:tblGrid>
+              <a:tr h="704850">
+                <a:tc>
+                  <a:txBody>
+                    <a:bodyPr/>
+                    <a:lstStyle/>
+                    <a:p>
+                      <a:r>
+                        <a:rPr sz="1425" b="1">
+                          <a:solidFill>
+                            <a:srgbClr val="FFFFFF"/>
+                          </a:solidFill>
+                          <a:latin typeface="Arial"/>
+                          <a:ea typeface="Arial"/>
+                          <a:cs typeface="Arial"/>
+                        </a:rPr>
+                        <a:t>Task</a:t>
+                      </a:r>
+                    </a:p>
+                  </a:txBody>
+                  <a:tcPr marL="123825" marR="114300" marT="57150" marB="57150" anchor="ctr">
+                    <a:lnL w="6668">
+                      <a:solidFill>
+                        <a:srgbClr val="CED7D3"/>
+                      </a:solidFill>
+                      <a:prstDash val="solid"/>
+                    </a:lnL>
+                    <a:lnR w="6668">
+                      <a:solidFill>
+                        <a:srgbClr val="CED7D3"/>
+                      </a:solidFill>
+                      <a:prstDash val="solid"/>
+                    </a:lnR>
+                    <a:lnT w="6668">
+                      <a:solidFill>
+                        <a:srgbClr val="CED7D3"/>
+                      </a:solidFill>
+                      <a:prstDash val="solid"/>
+                    </a:lnT>
+                    <a:lnB w="6668">
+                      <a:solidFill>
+                        <a:srgbClr val="CED7D3"/>
+                      </a:solidFill>
+                      <a:prstDash val="solid"/>
+                    </a:lnB>
+                    <a:solidFill>
+                      <a:srgbClr val="172B3A"/>
+                    </a:solidFill>
+                  </a:tcPr>
+                </a:tc>
+                <a:tc>
+                  <a:txBody>
+                    <a:bodyPr/>
+                    <a:lstStyle/>
+                    <a:p>
+                      <a:r>
+                        <a:rPr sz="1425" b="1">
+                          <a:solidFill>
+                            <a:srgbClr val="FFFFFF"/>
+                          </a:solidFill>
+                          <a:latin typeface="Arial"/>
+                          <a:ea typeface="Arial"/>
+                          <a:cs typeface="Arial"/>
+                        </a:rPr>
+                        <a:t>Corrective action / seed-0 reference</a:t>
+                      </a:r>
+                    </a:p>
+                  </a:txBody>
+                  <a:tcPr marL="123825" marR="114300" marT="57150" marB="57150" anchor="ctr">
+                    <a:lnR w="6668">
+                      <a:solidFill>
+                        <a:srgbClr val="CED7D3"/>
+                      </a:solidFill>
+                      <a:prstDash val="solid"/>
+                    </a:lnR>
+                    <a:lnT w="6668">
+                      <a:solidFill>
+                        <a:srgbClr val="CED7D3"/>
+                      </a:solidFill>
+                      <a:prstDash val="solid"/>
+                    </a:lnT>
+                    <a:lnB w="6668">
+                      <a:solidFill>
+                        <a:srgbClr val="CED7D3"/>
+                      </a:solidFill>
+                      <a:prstDash val="solid"/>
+                    </a:lnB>
+                    <a:solidFill>
+                      <a:srgbClr val="172B3A"/>
+                    </a:solidFill>
+                  </a:tcPr>
+                </a:tc>
+                <a:tc>
+                  <a:txBody>
+                    <a:bodyPr/>
+                    <a:lstStyle/>
+                    <a:p>
+                      <a:r>
+                        <a:rPr sz="1425" b="1">
+                          <a:solidFill>
+                            <a:srgbClr val="FFFFFF"/>
+                          </a:solidFill>
+                          <a:latin typeface="Arial"/>
+                          <a:ea typeface="Arial"/>
+                          <a:cs typeface="Arial"/>
+                        </a:rPr>
+                        <a:t>Verify before finish</a:t>
+                      </a:r>
+                    </a:p>
+                  </a:txBody>
+                  <a:tcPr marL="123825" marR="114300" marT="57150" marB="57150" anchor="ctr">
+                    <a:lnR w="6668">
+                      <a:solidFill>
+                        <a:srgbClr val="CED7D3"/>
+                      </a:solidFill>
+                      <a:prstDash val="solid"/>
+                    </a:lnR>
+                    <a:lnT w="6668">
+                      <a:solidFill>
+                        <a:srgbClr val="CED7D3"/>
+                      </a:solidFill>
+                      <a:prstDash val="solid"/>
+                    </a:lnT>
+                    <a:lnB w="6668">
+                      <a:solidFill>
+                        <a:srgbClr val="CED7D3"/>
+                      </a:solidFill>
+                      <a:prstDash val="solid"/>
+                    </a:lnB>
+                    <a:solidFill>
+                      <a:srgbClr val="172B3A"/>
+                    </a:solidFill>
+                  </a:tcPr>
+                </a:tc>
+              </a:tr>
+              <a:tr h="704850">
+                <a:tc>
+                  <a:txBody>
+                    <a:bodyPr/>
+                    <a:lstStyle/>
+                    <a:p>
+                      <a:r>
+                        <a:rPr sz="1650" b="0">
+                          <a:solidFill>
+                            <a:srgbClr val="172B3A"/>
+                          </a:solidFill>
+                          <a:latin typeface="Arial"/>
+                          <a:ea typeface="Arial"/>
+                          <a:cs typeface="Arial"/>
+                        </a:rPr>
+                        <a:t>EPS eclipse recovery</a:t>
+                      </a:r>
+                    </a:p>
+                  </a:txBody>
+                  <a:tcPr marL="123825" marR="114300" marT="57150" marB="57150" anchor="ctr">
+                    <a:lnL w="6668">
+                      <a:solidFill>
+                        <a:srgbClr val="CED7D3"/>
+                      </a:solidFill>
+                      <a:prstDash val="solid"/>
+                    </a:lnL>
+                    <a:lnR w="6668">
+                      <a:solidFill>
+                        <a:srgbClr val="CED7D3"/>
+                      </a:solidFill>
+                      <a:prstDash val="solid"/>
+                    </a:lnR>
+                    <a:lnB w="6668">
+                      <a:solidFill>
+                        <a:srgbClr val="CED7D3"/>
+                      </a:solidFill>
+                      <a:prstDash val="solid"/>
+                    </a:lnB>
+                    <a:solidFill>
+                      <a:srgbClr val="E9EEEA"/>
+                    </a:solidFill>
+                  </a:tcPr>
+                </a:tc>
+                <a:tc>
+                  <a:txBody>
+                    <a:bodyPr/>
+                    <a:lstStyle/>
+                    <a:p>
+                      <a:r>
+                        <a:rPr sz="1650" b="0">
+                          <a:solidFill>
+                            <a:srgbClr val="172B3A"/>
+                          </a:solidFill>
+                          <a:latin typeface="Arial"/>
+                          <a:ea typeface="Arial"/>
+                          <a:cs typeface="Arial"/>
+                        </a:rPr>
+                        <a:t>solar_efficiency = 0.72</a:t>
+                      </a:r>
+                    </a:p>
+                    <a:p>
+                      <a:r>
+                        <a:rPr sz="1650" b="0">
+                          <a:solidFill>
+                            <a:srgbClr val="172B3A"/>
+                          </a:solidFill>
+                          <a:latin typeface="Arial"/>
+                          <a:ea typeface="Arial"/>
+                          <a:cs typeface="Arial"/>
+                        </a:rPr>
+                        <a:t>undervoltage_threshold = 3.20</a:t>
+                      </a:r>
+                    </a:p>
+                  </a:txBody>
+                  <a:tcPr marL="123825" marR="114300" marT="57150" marB="57150" anchor="ctr">
+                    <a:lnR w="6668">
+                      <a:solidFill>
+                        <a:srgbClr val="CED7D3"/>
+                      </a:solidFill>
+                      <a:prstDash val="solid"/>
+                    </a:lnR>
+                    <a:lnB w="6668">
+                      <a:solidFill>
+                        <a:srgbClr val="CED7D3"/>
+                      </a:solidFill>
+                      <a:prstDash val="solid"/>
+                    </a:lnB>
+                    <a:solidFill>
+                      <a:srgbClr val="E9EEEA"/>
+                    </a:solidFill>
+                  </a:tcPr>
+                </a:tc>
+                <a:tc>
+                  <a:txBody>
+                    <a:bodyPr/>
+                    <a:lstStyle/>
+                    <a:p>
+                      <a:r>
+                        <a:rPr sz="1650" b="0">
+                          <a:solidFill>
+                            <a:srgbClr val="172B3A"/>
+                          </a:solidFill>
+                          <a:latin typeface="Arial"/>
+                          <a:ea typeface="Arial"/>
+                          <a:cs typeface="Arial"/>
+                        </a:rPr>
+                        <a:t>Battery reserve and voltage safety</a:t>
+                      </a:r>
+                    </a:p>
+                  </a:txBody>
+                  <a:tcPr marL="123825" marR="114300" marT="57150" marB="57150" anchor="ctr">
+                    <a:lnR w="6668">
+                      <a:solidFill>
+                        <a:srgbClr val="CED7D3"/>
+                      </a:solidFill>
+                      <a:prstDash val="solid"/>
+                    </a:lnR>
+                    <a:lnB w="6668">
+                      <a:solidFill>
+                        <a:srgbClr val="CED7D3"/>
+                      </a:solidFill>
+                      <a:prstDash val="solid"/>
+                    </a:lnB>
+                    <a:solidFill>
+                      <a:srgbClr val="E9EEEA"/>
+                    </a:solidFill>
+                  </a:tcPr>
+                </a:tc>
+              </a:tr>
+              <a:tr h="704850">
+                <a:tc>
+                  <a:txBody>
+                    <a:bodyPr/>
+                    <a:lstStyle/>
+                    <a:p>
+                      <a:r>
+                        <a:rPr sz="1650" b="0">
+                          <a:solidFill>
+                            <a:srgbClr val="172B3A"/>
+                          </a:solidFill>
+                          <a:latin typeface="Arial"/>
+                          <a:ea typeface="Arial"/>
+                          <a:cs typeface="Arial"/>
+                        </a:rPr>
+                        <a:t>ADCS detumble / pointing</a:t>
+                      </a:r>
+                    </a:p>
+                  </a:txBody>
+                  <a:tcPr marL="123825" marR="114300" marT="57150" marB="57150" anchor="ctr">
+                    <a:lnL w="6668">
+                      <a:solidFill>
+                        <a:srgbClr val="CED7D3"/>
+                      </a:solidFill>
+                      <a:prstDash val="solid"/>
+                    </a:lnL>
+                    <a:lnR w="6668">
+                      <a:solidFill>
+                        <a:srgbClr val="CED7D3"/>
+                      </a:solidFill>
+                      <a:prstDash val="solid"/>
+                    </a:lnR>
+                    <a:lnB w="6668">
+                      <a:solidFill>
+                        <a:srgbClr val="CED7D3"/>
+                      </a:solidFill>
+                      <a:prstDash val="solid"/>
+                    </a:lnB>
+                    <a:solidFill>
+                      <a:srgbClr val="F7F6F2"/>
+                    </a:solidFill>
+                  </a:tcPr>
+                </a:tc>
+                <a:tc>
+                  <a:txBody>
+                    <a:bodyPr/>
+                    <a:lstStyle/>
+                    <a:p>
+                      <a:r>
+                        <a:rPr sz="1650" b="0">
+                          <a:solidFill>
+                            <a:srgbClr val="172B3A"/>
+                          </a:solidFill>
+                          <a:latin typeface="Arial"/>
+                          <a:ea typeface="Arial"/>
+                          <a:cs typeface="Arial"/>
+                        </a:rPr>
+                        <a:t>wheel_bias_rpm = 0; control_gain = 2.0</a:t>
+                      </a:r>
+                    </a:p>
+                    <a:p>
+                      <a:r>
+                        <a:rPr sz="1650" b="0">
+                          <a:solidFill>
+                            <a:srgbClr val="172B3A"/>
+                          </a:solidFill>
+                          <a:latin typeface="Arial"/>
+                          <a:ea typeface="Arial"/>
+                          <a:cs typeface="Arial"/>
+                        </a:rPr>
+                        <a:t>pointing_deadband_deg = 0.05</a:t>
+                      </a:r>
+                    </a:p>
+                  </a:txBody>
+                  <a:tcPr marL="123825" marR="114300" marT="57150" marB="57150" anchor="ctr">
+                    <a:lnR w="6668">
+                      <a:solidFill>
+                        <a:srgbClr val="CED7D3"/>
+                      </a:solidFill>
+                      <a:prstDash val="solid"/>
+                    </a:lnR>
+                    <a:lnB w="6668">
+                      <a:solidFill>
+                        <a:srgbClr val="CED7D3"/>
+                      </a:solidFill>
+                      <a:prstDash val="solid"/>
+                    </a:lnB>
+                    <a:solidFill>
+                      <a:srgbClr val="F7F6F2"/>
+                    </a:solidFill>
+                  </a:tcPr>
+                </a:tc>
+                <a:tc>
+                  <a:txBody>
+                    <a:bodyPr/>
+                    <a:lstStyle/>
+                    <a:p>
+                      <a:r>
+                        <a:rPr sz="1650" b="0">
+                          <a:solidFill>
+                            <a:srgbClr val="172B3A"/>
+                          </a:solidFill>
+                          <a:latin typeface="Arial"/>
+                          <a:ea typeface="Arial"/>
+                          <a:cs typeface="Arial"/>
+                        </a:rPr>
+                        <a:t>Protected pointing requirement</a:t>
+                      </a:r>
+                    </a:p>
+                  </a:txBody>
+                  <a:tcPr marL="123825" marR="114300" marT="57150" marB="57150" anchor="ctr">
+                    <a:lnR w="6668">
+                      <a:solidFill>
+                        <a:srgbClr val="CED7D3"/>
+                      </a:solidFill>
+                      <a:prstDash val="solid"/>
+                    </a:lnR>
+                    <a:lnB w="6668">
+                      <a:solidFill>
+                        <a:srgbClr val="CED7D3"/>
+                      </a:solidFill>
+                      <a:prstDash val="solid"/>
+                    </a:lnB>
+                    <a:solidFill>
+                      <a:srgbClr val="F7F6F2"/>
+                    </a:solidFill>
+                  </a:tcPr>
+                </a:tc>
+              </a:tr>
+              <a:tr h="704850">
+                <a:tc>
+                  <a:txBody>
+                    <a:bodyPr/>
+                    <a:lstStyle/>
+                    <a:p>
+                      <a:r>
+                        <a:rPr sz="1650" b="0">
+                          <a:solidFill>
+                            <a:srgbClr val="172B3A"/>
+                          </a:solidFill>
+                          <a:latin typeface="Arial"/>
+                          <a:ea typeface="Arial"/>
+                          <a:cs typeface="Arial"/>
+                        </a:rPr>
+                        <a:t>Thermal preservation</a:t>
+                      </a:r>
+                    </a:p>
+                  </a:txBody>
+                  <a:tcPr marL="123825" marR="114300" marT="57150" marB="57150" anchor="ctr">
+                    <a:lnL w="6668">
+                      <a:solidFill>
+                        <a:srgbClr val="CED7D3"/>
+                      </a:solidFill>
+                      <a:prstDash val="solid"/>
+                    </a:lnL>
+                    <a:lnR w="6668">
+                      <a:solidFill>
+                        <a:srgbClr val="CED7D3"/>
+                      </a:solidFill>
+                      <a:prstDash val="solid"/>
+                    </a:lnR>
+                    <a:lnB w="6668">
+                      <a:solidFill>
+                        <a:srgbClr val="CED7D3"/>
+                      </a:solidFill>
+                      <a:prstDash val="solid"/>
+                    </a:lnB>
+                    <a:solidFill>
+                      <a:srgbClr val="E9EEEA"/>
+                    </a:solidFill>
+                  </a:tcPr>
+                </a:tc>
+                <a:tc>
+                  <a:txBody>
+                    <a:bodyPr/>
+                    <a:lstStyle/>
+                    <a:p>
+                      <a:r>
+                        <a:rPr sz="1650" b="0">
+                          <a:solidFill>
+                            <a:srgbClr val="172B3A"/>
+                          </a:solidFill>
+                          <a:latin typeface="Arial"/>
+                          <a:ea typeface="Arial"/>
+                          <a:cs typeface="Arial"/>
+                        </a:rPr>
+                        <a:t>battery_heater_setpoint = 15.0</a:t>
+                      </a:r>
+                    </a:p>
+                    <a:p>
+                      <a:r>
+                        <a:rPr sz="1650" b="0">
+                          <a:solidFill>
+                            <a:srgbClr val="172B3A"/>
+                          </a:solidFill>
+                          <a:latin typeface="Arial"/>
+                          <a:ea typeface="Arial"/>
+                          <a:cs typeface="Arial"/>
+                        </a:rPr>
+                        <a:t>thermal_cutoff_temp = 45.0</a:t>
+                      </a:r>
+                    </a:p>
+                  </a:txBody>
+                  <a:tcPr marL="123825" marR="114300" marT="57150" marB="57150" anchor="ctr">
+                    <a:lnR w="6668">
+                      <a:solidFill>
+                        <a:srgbClr val="CED7D3"/>
+                      </a:solidFill>
+                      <a:prstDash val="solid"/>
+                    </a:lnR>
+                    <a:lnB w="6668">
+                      <a:solidFill>
+                        <a:srgbClr val="CED7D3"/>
+                      </a:solidFill>
+                      <a:prstDash val="solid"/>
+                    </a:lnB>
+                    <a:solidFill>
+                      <a:srgbClr val="E9EEEA"/>
+                    </a:solidFill>
+                  </a:tcPr>
+                </a:tc>
+                <a:tc>
+                  <a:txBody>
+                    <a:bodyPr/>
+                    <a:lstStyle/>
+                    <a:p>
+                      <a:r>
+                        <a:rPr sz="1650" b="0">
+                          <a:solidFill>
+                            <a:srgbClr val="172B3A"/>
+                          </a:solidFill>
+                          <a:latin typeface="Arial"/>
+                          <a:ea typeface="Arial"/>
+                          <a:cs typeface="Arial"/>
+                        </a:rPr>
+                        <a:t>Whole trajectory and final temperature</a:t>
+                      </a:r>
+                    </a:p>
+                  </a:txBody>
+                  <a:tcPr marL="123825" marR="114300" marT="57150" marB="57150" anchor="ctr">
+                    <a:lnR w="6668">
+                      <a:solidFill>
+                        <a:srgbClr val="CED7D3"/>
+                      </a:solidFill>
+                      <a:prstDash val="solid"/>
+                    </a:lnR>
+                    <a:lnB w="6668">
+                      <a:solidFill>
+                        <a:srgbClr val="CED7D3"/>
+                      </a:solidFill>
+                      <a:prstDash val="solid"/>
+                    </a:lnB>
+                    <a:solidFill>
+                      <a:srgbClr val="E9EEEA"/>
+                    </a:solidFill>
+                  </a:tcPr>
+                </a:tc>
+              </a:tr>
+              <a:tr h="704850">
+                <a:tc>
+                  <a:txBody>
+                    <a:bodyPr/>
+                    <a:lstStyle/>
+                    <a:p>
+                      <a:r>
+                        <a:rPr sz="1650" b="0">
+                          <a:solidFill>
+                            <a:srgbClr val="172B3A"/>
+                          </a:solidFill>
+                          <a:latin typeface="Arial"/>
+                          <a:ea typeface="Arial"/>
+                          <a:cs typeface="Arial"/>
+                        </a:rPr>
+                        <a:t>RF downlink closure</a:t>
+                      </a:r>
+                    </a:p>
+                  </a:txBody>
+                  <a:tcPr marL="123825" marR="114300" marT="57150" marB="57150" anchor="ctr">
+                    <a:lnL w="6668">
+                      <a:solidFill>
+                        <a:srgbClr val="CED7D3"/>
+                      </a:solidFill>
+                      <a:prstDash val="solid"/>
+                    </a:lnL>
+                    <a:lnR w="6668">
+                      <a:solidFill>
+                        <a:srgbClr val="CED7D3"/>
+                      </a:solidFill>
+                      <a:prstDash val="solid"/>
+                    </a:lnR>
+                    <a:lnB w="6668">
+                      <a:solidFill>
+                        <a:srgbClr val="CED7D3"/>
+                      </a:solidFill>
+                      <a:prstDash val="solid"/>
+                    </a:lnB>
+                    <a:solidFill>
+                      <a:srgbClr val="F7F6F2"/>
+                    </a:solidFill>
+                  </a:tcPr>
+                </a:tc>
+                <a:tc>
+                  <a:txBody>
+                    <a:bodyPr/>
+                    <a:lstStyle/>
+                    <a:p>
+                      <a:r>
+                        <a:rPr sz="1650" b="0">
+                          <a:solidFill>
+                            <a:srgbClr val="172B3A"/>
+                          </a:solidFill>
+                          <a:latin typeface="Arial"/>
+                          <a:ea typeface="Arial"/>
+                          <a:cs typeface="Arial"/>
+                        </a:rPr>
+                        <a:t>tx_power_dbm = 30.0; repair calc_margin()</a:t>
+                      </a:r>
+                    </a:p>
+                    <a:p>
+                      <a:r>
+                        <a:rPr sz="1650" b="0">
+                          <a:solidFill>
+                            <a:srgbClr val="172B3A"/>
+                          </a:solidFill>
+                          <a:latin typeface="Arial"/>
+                          <a:ea typeface="Arial"/>
+                          <a:cs typeface="Arial"/>
+                        </a:rPr>
+                        <a:t>Read baud rate and path loss from comms.cfg</a:t>
+                      </a:r>
+                    </a:p>
+                  </a:txBody>
+                  <a:tcPr marL="123825" marR="114300" marT="57150" marB="57150" anchor="ctr">
+                    <a:lnR w="6668">
+                      <a:solidFill>
+                        <a:srgbClr val="CED7D3"/>
+                      </a:solidFill>
+                      <a:prstDash val="solid"/>
+                    </a:lnR>
+                    <a:lnB w="6668">
+                      <a:solidFill>
+                        <a:srgbClr val="CED7D3"/>
+                      </a:solidFill>
+                      <a:prstDash val="solid"/>
+                    </a:lnB>
+                    <a:solidFill>
+                      <a:srgbClr val="F7F6F2"/>
+                    </a:solidFill>
+                  </a:tcPr>
+                </a:tc>
+                <a:tc>
+                  <a:txBody>
+                    <a:bodyPr/>
+                    <a:lstStyle/>
+                    <a:p>
+                      <a:r>
+                        <a:rPr sz="1650" b="0">
+                          <a:solidFill>
+                            <a:srgbClr val="172B3A"/>
+                          </a:solidFill>
+                          <a:latin typeface="Arial"/>
+                          <a:ea typeface="Arial"/>
+                          <a:cs typeface="Arial"/>
+                        </a:rPr>
+                        <a:t>Live link margin, delivery and script checks</a:t>
+                      </a:r>
+                    </a:p>
+                  </a:txBody>
+                  <a:tcPr marL="123825" marR="114300" marT="57150" marB="57150" anchor="ctr">
+                    <a:lnR w="6668">
+                      <a:solidFill>
+                        <a:srgbClr val="CED7D3"/>
+                      </a:solidFill>
+                      <a:prstDash val="solid"/>
+                    </a:lnR>
+                    <a:lnB w="6668">
+                      <a:solidFill>
+                        <a:srgbClr val="CED7D3"/>
+                      </a:solidFill>
+                      <a:prstDash val="solid"/>
+                    </a:lnB>
+                    <a:solidFill>
+                      <a:srgbClr val="F7F6F2"/>
+                    </a:solidFill>
+                  </a:tcPr>
+                </a:tc>
+              </a:tr>
+              <a:tr h="704850">
+                <a:tc>
+                  <a:txBody>
+                    <a:bodyPr/>
+                    <a:lstStyle/>
+                    <a:p>
+                      <a:r>
+                        <a:rPr sz="1650" b="0">
+                          <a:solidFill>
+                            <a:srgbClr val="172B3A"/>
+                          </a:solidFill>
+                          <a:latin typeface="Arial"/>
+                          <a:ea typeface="Arial"/>
+                          <a:cs typeface="Arial"/>
+                        </a:rPr>
+                        <a:t>Safe-mode cascade</a:t>
+                      </a:r>
+                    </a:p>
+                  </a:txBody>
+                  <a:tcPr marL="123825" marR="114300" marT="57150" marB="57150" anchor="ctr">
+                    <a:lnL w="6668">
+                      <a:solidFill>
+                        <a:srgbClr val="CED7D3"/>
+                      </a:solidFill>
+                      <a:prstDash val="solid"/>
+                    </a:lnL>
+                    <a:lnR w="6668">
+                      <a:solidFill>
+                        <a:srgbClr val="CED7D3"/>
+                      </a:solidFill>
+                      <a:prstDash val="solid"/>
+                    </a:lnR>
+                    <a:lnB w="6668">
+                      <a:solidFill>
+                        <a:srgbClr val="CED7D3"/>
+                      </a:solidFill>
+                      <a:prstDash val="solid"/>
+                    </a:lnB>
+                    <a:solidFill>
+                      <a:srgbClr val="E9EEEA"/>
+                    </a:solidFill>
+                  </a:tcPr>
+                </a:tc>
+                <a:tc>
+                  <a:txBody>
+                    <a:bodyPr/>
+                    <a:lstStyle/>
+                    <a:p>
+                      <a:r>
+                        <a:rPr sz="1650" b="0">
+                          <a:solidFill>
+                            <a:srgbClr val="172B3A"/>
+                          </a:solidFill>
+                          <a:latin typeface="Arial"/>
+                          <a:ea typeface="Arial"/>
+                          <a:cs typeface="Arial"/>
+                        </a:rPr>
+                        <a:t>Repair both seeded faults.</a:t>
+                      </a:r>
+                    </a:p>
+                    <a:p>
+                      <a:r>
+                        <a:rPr sz="1650" b="0">
+                          <a:solidFill>
+                            <a:srgbClr val="172B3A"/>
+                          </a:solidFill>
+                          <a:latin typeface="Arial"/>
+                          <a:ea typeface="Arial"/>
+                          <a:cs typeface="Arial"/>
+                        </a:rPr>
+                        <a:t>Seed 0: ADCS defaults plus tx_power_dbm = 30.0</a:t>
+                      </a:r>
+                    </a:p>
+                  </a:txBody>
+                  <a:tcPr marL="123825" marR="114300" marT="57150" marB="57150" anchor="ctr">
+                    <a:lnR w="6668">
+                      <a:solidFill>
+                        <a:srgbClr val="CED7D3"/>
+                      </a:solidFill>
+                      <a:prstDash val="solid"/>
+                    </a:lnR>
+                    <a:lnB w="6668">
+                      <a:solidFill>
+                        <a:srgbClr val="CED7D3"/>
+                      </a:solidFill>
+                      <a:prstDash val="solid"/>
+                    </a:lnB>
+                    <a:solidFill>
+                      <a:srgbClr val="E9EEEA"/>
+                    </a:solidFill>
+                  </a:tcPr>
+                </a:tc>
+                <a:tc>
+                  <a:txBody>
+                    <a:bodyPr/>
+                    <a:lstStyle/>
+                    <a:p>
+                      <a:r>
+                        <a:rPr sz="1650" b="0">
+                          <a:solidFill>
+                            <a:srgbClr val="172B3A"/>
+                          </a:solidFill>
+                          <a:latin typeface="Arial"/>
+                          <a:ea typeface="Arial"/>
+                          <a:cs typeface="Arial"/>
+                        </a:rPr>
+                        <a:t>All affected subsystem checks; no safety failure</a:t>
+                      </a:r>
+                    </a:p>
+                  </a:txBody>
+                  <a:tcPr marL="123825" marR="114300" marT="57150" marB="57150" anchor="ctr">
+                    <a:lnR w="6668">
+                      <a:solidFill>
+                        <a:srgbClr val="CED7D3"/>
+                      </a:solidFill>
+                      <a:prstDash val="solid"/>
+                    </a:lnR>
+                    <a:lnB w="6668">
+                      <a:solidFill>
+                        <a:srgbClr val="CED7D3"/>
+                      </a:solidFill>
+                      <a:prstDash val="solid"/>
+                    </a:lnB>
+                    <a:solidFill>
+                      <a:srgbClr val="E9EEEA"/>
+                    </a:solidFill>
+                  </a:tcPr>
+                </a:tc>
+              </a:tr>
+            </a:tbl>
+          </a:graphicData>
+        </a:graphic>
+      </p:graphicFrame>
+      <p:sp>
+        <p:nvSpPr>
+          <p:cNvPr id="5" name="">
+            <a:extLst xmlns:a="http://schemas.openxmlformats.org/drawingml/2006/main">
+              <a:ext uri="{FF2B5EF4-FFF2-40B4-BE49-F238E27FC236}">
+                <a16:creationId xmlns:a16="http://schemas.microsoft.com/office/drawing/2014/main" id="{7FA9EA75-A700-4239-8BD3-761EB7E3705B}"/>
+              </a:ext>
+            </a:extLst>
+          </p:cNvPr>
+          <p:cNvSpPr>
+            <a:spLocks xmlns:a="http://schemas.openxmlformats.org/drawingml/2006/main" noGrp="1"/>
+          </p:cNvSpPr>
+          <p:nvPr/>
+        </p:nvSpPr>
+        <p:spPr>
+          <a:xfrm xmlns:a="http://schemas.openxmlformats.org/drawingml/2006/main">
+            <a:off x="495300" y="5915025"/>
+            <a:ext cx="11201400" cy="523875"/>
+          </a:xfrm>
+          <a:prstGeom xmlns:a="http://schemas.openxmlformats.org/drawingml/2006/main" prst="rect">
+            <a:avLst/>
+          </a:prstGeom>
+          <a:noFill xmlns:a="http://schemas.openxmlformats.org/drawingml/2006/main"/>
+          <a:ln xmlns:a="http://schemas.openxmlformats.org/drawingml/2006/main" w="0">
+            <a:noFill/>
+          </a:ln>
+        </p:spPr>
+        <p:txBody>
+          <a:bodyPr xmlns:a="http://schemas.openxmlformats.org/drawingml/2006/main" lIns="0" tIns="0" rIns="0" bIns="0"/>
+          <a:lstStyle xmlns:a="http://schemas.openxmlformats.org/drawingml/2006/main">
+            <a:defPPr>
+              <a:defRPr sz="1725" b="1">
+                <a:solidFill>
+                  <a:srgbClr val="20776D"/>
+                </a:solidFill>
+                <a:latin typeface="Arial"/>
+                <a:ea typeface="Arial"/>
+                <a:cs typeface="Arial"/>
+              </a:defRPr>
+            </a:defPPr>
+            <a:lvl1pPr>
+              <a:defRPr sz="1725" b="1">
+                <a:solidFill>
+                  <a:srgbClr val="20776D"/>
+                </a:solidFill>
+                <a:latin typeface="Arial"/>
+                <a:ea typeface="Arial"/>
+                <a:cs typeface="Arial"/>
+              </a:defRPr>
+            </a:lvl1pPr>
+            <a:lvl2pPr>
+              <a:defRPr sz="1725" b="1">
+                <a:solidFill>
+                  <a:srgbClr val="20776D"/>
+                </a:solidFill>
+                <a:latin typeface="Arial"/>
+                <a:ea typeface="Arial"/>
+                <a:cs typeface="Arial"/>
+              </a:defRPr>
+            </a:lvl2pPr>
+            <a:lvl3pPr>
+              <a:defRPr sz="1725" b="1">
+                <a:solidFill>
+                  <a:srgbClr val="20776D"/>
+                </a:solidFill>
+                <a:latin typeface="Arial"/>
+                <a:ea typeface="Arial"/>
+                <a:cs typeface="Arial"/>
+              </a:defRPr>
+            </a:lvl3pPr>
+            <a:lvl4pPr>
+              <a:defRPr sz="1725" b="1">
+                <a:solidFill>
+                  <a:srgbClr val="20776D"/>
+                </a:solidFill>
+                <a:latin typeface="Arial"/>
+                <a:ea typeface="Arial"/>
+                <a:cs typeface="Arial"/>
+              </a:defRPr>
+            </a:lvl4pPr>
+            <a:lvl5pPr>
+              <a:defRPr sz="1725" b="1">
+                <a:solidFill>
+                  <a:srgbClr val="20776D"/>
+                </a:solidFill>
+                <a:latin typeface="Arial"/>
+                <a:ea typeface="Arial"/>
+                <a:cs typeface="Arial"/>
+              </a:defRPr>
+            </a:lvl5pPr>
+            <a:lvl6pPr>
+              <a:defRPr sz="1725" b="1">
+                <a:solidFill>
+                  <a:srgbClr val="20776D"/>
+                </a:solidFill>
+                <a:latin typeface="Arial"/>
+                <a:ea typeface="Arial"/>
+                <a:cs typeface="Arial"/>
+              </a:defRPr>
+            </a:lvl6pPr>
+            <a:lvl7pPr>
+              <a:defRPr sz="1725" b="1">
+                <a:solidFill>
+                  <a:srgbClr val="20776D"/>
+                </a:solidFill>
+                <a:latin typeface="Arial"/>
+                <a:ea typeface="Arial"/>
+                <a:cs typeface="Arial"/>
+              </a:defRPr>
+            </a:lvl7pPr>
+            <a:lvl8pPr>
+              <a:defRPr sz="1725" b="1">
+                <a:solidFill>
+                  <a:srgbClr val="20776D"/>
+                </a:solidFill>
+                <a:latin typeface="Arial"/>
+                <a:ea typeface="Arial"/>
+                <a:cs typeface="Arial"/>
+              </a:defRPr>
+            </a:lvl8pPr>
+            <a:lvl9pPr>
+              <a:defRPr sz="1725" b="1">
+                <a:solidFill>
+                  <a:srgbClr val="20776D"/>
+                </a:solidFill>
+                <a:latin typeface="Arial"/>
+                <a:ea typeface="Arial"/>
+                <a:cs typeface="Arial"/>
+              </a:defRPr>
+            </a:lvl9pPr>
+          </a:lstStyle>
+          <a:p xmlns:a="http://schemas.openxmlformats.org/drawingml/2006/main">
+            <a:pPr>
+              <a:defRPr sz="1725" b="1">
+                <a:solidFill>
+                  <a:srgbClr val="20776D"/>
+                </a:solidFill>
+                <a:latin typeface="Arial"/>
+                <a:ea typeface="Arial"/>
+                <a:cs typeface="Arial"/>
+              </a:defRPr>
+            </a:pPr>
+            <a:r>
+              <a:rPr sz="1725" b="1">
+                <a:solidFill>
+                  <a:srgbClr val="20776D"/>
+                </a:solidFill>
+                <a:latin typeface="Arial"/>
+                <a:ea typeface="Arial"/>
+                <a:cs typeface="Arial"/>
+              </a:rPr>
+              <a:t>Seed-0 reference values shown. Other seeds must meet their own mission targets; equivalent valid repairs are accepted.</a:t>
+            </a:r>
+          </a:p>
+        </p:txBody>
+      </p:sp>
+    </p:spTree>
+    <p:extLst>
+      <p:ext uri="{BB962C8B-B14F-4D97-AF65-F5344CB8AC3E}">
+        <p14:creationId xmlns:p14="http://schemas.microsoft.com/office/powerpoint/2010/main" val="261748953"/>
+      </p:ext>
+    </p:extLst>
+  </p:cSld>
+</p:sld>
+</file>
+
+<file path=ppt/slides/slide18.xml><?xml version="1.0" encoding="utf-8"?>
+<p:sld xmlns:p="http://schemas.openxmlformats.org/presentationml/2006/main">
+  <p:cSld>
+    <p:bg>
+      <p:bgPr>
+        <a:solidFill xmlns:a="http://schemas.openxmlformats.org/drawingml/2006/main">
+          <a:srgbClr val="F7F6F2"/>
+        </a:solidFill>
+      </p:bgPr>
+    </p:bg>
+    <p:spTree>
+      <p:nvGrpSpPr>
+        <p:cNvPr id="1" name=""/>
+        <p:cNvGrpSpPr/>
+        <p:nvPr/>
+      </p:nvGrpSpPr>
+      <p:grpSpPr>
+        <a:xfrm xmlns:a="http://schemas.openxmlformats.org/drawingml/2006/main"/>
+      </p:grpSpPr>
+      <p:sp>
+        <p:nvSpPr>
+          <p:cNvPr id="6" name="">
+            <a:extLst xmlns:a="http://schemas.openxmlformats.org/drawingml/2006/main">
+              <a:ext uri="{FF2B5EF4-FFF2-40B4-BE49-F238E27FC236}">
+                <a16:creationId xmlns:a16="http://schemas.microsoft.com/office/drawing/2014/main" id="{B458ABEB-500C-4D6F-B2EF-9B1DAF3CE09C}"/>
+              </a:ext>
+            </a:extLst>
+          </p:cNvPr>
+          <p:cNvSpPr>
+            <a:spLocks xmlns:a="http://schemas.openxmlformats.org/drawingml/2006/main" noGrp="1"/>
+          </p:cNvSpPr>
+          <p:nvPr/>
+        </p:nvSpPr>
+        <p:spPr>
+          <a:xfrm xmlns:a="http://schemas.openxmlformats.org/drawingml/2006/main">
+            <a:off x="495300" y="381000"/>
+            <a:ext cx="11201400" cy="723900"/>
+          </a:xfrm>
+          <a:prstGeom xmlns:a="http://schemas.openxmlformats.org/drawingml/2006/main" prst="rect">
+            <a:avLst/>
+          </a:prstGeom>
+          <a:noFill xmlns:a="http://schemas.openxmlformats.org/drawingml/2006/main"/>
+          <a:ln xmlns:a="http://schemas.openxmlformats.org/drawingml/2006/main" w="0">
+            <a:noFill/>
+          </a:ln>
+        </p:spPr>
+        <p:txBody>
+          <a:bodyPr xmlns:a="http://schemas.openxmlformats.org/drawingml/2006/main" lIns="0" tIns="0" rIns="0" bIns="0"/>
+          <a:lstStyle xmlns:a="http://schemas.openxmlformats.org/drawingml/2006/main">
+            <a:defPPr>
+              <a:defRPr sz="3000" b="1">
+                <a:solidFill>
+                  <a:srgbClr val="172B3A"/>
+                </a:solidFill>
+                <a:latin typeface="Arial"/>
+                <a:ea typeface="Arial"/>
+                <a:cs typeface="Arial"/>
+              </a:defRPr>
+            </a:defPPr>
+            <a:lvl1pPr>
+              <a:defRPr sz="3000" b="1">
+                <a:solidFill>
+                  <a:srgbClr val="172B3A"/>
+                </a:solidFill>
+                <a:latin typeface="Arial"/>
+                <a:ea typeface="Arial"/>
+                <a:cs typeface="Arial"/>
+              </a:defRPr>
+            </a:lvl1pPr>
+            <a:lvl2pPr>
+              <a:defRPr sz="3000" b="1">
+                <a:solidFill>
+                  <a:srgbClr val="172B3A"/>
+                </a:solidFill>
+                <a:latin typeface="Arial"/>
+                <a:ea typeface="Arial"/>
+                <a:cs typeface="Arial"/>
+              </a:defRPr>
+            </a:lvl2pPr>
+            <a:lvl3pPr>
+              <a:defRPr sz="3000" b="1">
+                <a:solidFill>
+                  <a:srgbClr val="172B3A"/>
+                </a:solidFill>
+                <a:latin typeface="Arial"/>
+                <a:ea typeface="Arial"/>
+                <a:cs typeface="Arial"/>
+              </a:defRPr>
+            </a:lvl3pPr>
+            <a:lvl4pPr>
+              <a:defRPr sz="3000" b="1">
+                <a:solidFill>
+                  <a:srgbClr val="172B3A"/>
+                </a:solidFill>
+                <a:latin typeface="Arial"/>
+                <a:ea typeface="Arial"/>
+                <a:cs typeface="Arial"/>
+              </a:defRPr>
+            </a:lvl4pPr>
+            <a:lvl5pPr>
+              <a:defRPr sz="3000" b="1">
+                <a:solidFill>
+                  <a:srgbClr val="172B3A"/>
+                </a:solidFill>
+                <a:latin typeface="Arial"/>
+                <a:ea typeface="Arial"/>
+                <a:cs typeface="Arial"/>
+              </a:defRPr>
+            </a:lvl5pPr>
+            <a:lvl6pPr>
+              <a:defRPr sz="3000" b="1">
+                <a:solidFill>
+                  <a:srgbClr val="172B3A"/>
+                </a:solidFill>
+                <a:latin typeface="Arial"/>
+                <a:ea typeface="Arial"/>
+                <a:cs typeface="Arial"/>
+              </a:defRPr>
+            </a:lvl6pPr>
+            <a:lvl7pPr>
+              <a:defRPr sz="3000" b="1">
+                <a:solidFill>
+                  <a:srgbClr val="172B3A"/>
+                </a:solidFill>
+                <a:latin typeface="Arial"/>
+                <a:ea typeface="Arial"/>
+                <a:cs typeface="Arial"/>
+              </a:defRPr>
+            </a:lvl7pPr>
+            <a:lvl8pPr>
+              <a:defRPr sz="3000" b="1">
+                <a:solidFill>
+                  <a:srgbClr val="172B3A"/>
+                </a:solidFill>
+                <a:latin typeface="Arial"/>
+                <a:ea typeface="Arial"/>
+                <a:cs typeface="Arial"/>
+              </a:defRPr>
+            </a:lvl8pPr>
+            <a:lvl9pPr>
+              <a:defRPr sz="3000" b="1">
+                <a:solidFill>
+                  <a:srgbClr val="172B3A"/>
+                </a:solidFill>
+                <a:latin typeface="Arial"/>
+                <a:ea typeface="Arial"/>
+                <a:cs typeface="Arial"/>
+              </a:defRPr>
+            </a:lvl9pPr>
+          </a:lstStyle>
+          <a:p xmlns:a="http://schemas.openxmlformats.org/drawingml/2006/main">
+            <a:pPr>
+              <a:defRPr sz="3000" b="1">
+                <a:solidFill>
+                  <a:srgbClr val="172B3A"/>
+                </a:solidFill>
+                <a:latin typeface="Arial"/>
+                <a:ea typeface="Arial"/>
+                <a:cs typeface="Arial"/>
+              </a:defRPr>
+            </a:pPr>
+            <a:r>
+              <a:rPr sz="3000" b="1">
+                <a:solidFill>
+                  <a:srgbClr val="172B3A"/>
+                </a:solidFill>
+                <a:latin typeface="Arial"/>
+                <a:ea typeface="Arial"/>
+                <a:cs typeface="Arial"/>
+              </a:rPr>
+              <a:t>Solutions: the four hard planning tasks</a:t>
+            </a:r>
+          </a:p>
+        </p:txBody>
+      </p:sp>
+      <p:sp>
+        <p:nvSpPr>
+          <p:cNvPr id="2" name="">
+            <a:extLst xmlns:a="http://schemas.openxmlformats.org/drawingml/2006/main">
+              <a:ext uri="{FF2B5EF4-FFF2-40B4-BE49-F238E27FC236}">
+                <a16:creationId xmlns:a16="http://schemas.microsoft.com/office/drawing/2014/main" id="{9A2DD122-F8AC-40F8-AD20-C8FB9E20B72F}"/>
+              </a:ext>
+            </a:extLst>
+          </p:cNvPr>
+          <p:cNvSpPr>
+            <a:spLocks xmlns:a="http://schemas.openxmlformats.org/drawingml/2006/main" noGrp="1"/>
+          </p:cNvSpPr>
+          <p:nvPr/>
+        </p:nvSpPr>
+        <p:spPr>
+          <a:xfrm xmlns:a="http://schemas.openxmlformats.org/drawingml/2006/main">
+            <a:off x="495300" y="6467475"/>
+            <a:ext cx="6667500" cy="209550"/>
+          </a:xfrm>
+          <a:prstGeom xmlns:a="http://schemas.openxmlformats.org/drawingml/2006/main" prst="rect">
+            <a:avLst/>
+          </a:prstGeom>
+          <a:noFill xmlns:a="http://schemas.openxmlformats.org/drawingml/2006/main"/>
+          <a:ln xmlns:a="http://schemas.openxmlformats.org/drawingml/2006/main" w="0">
+            <a:noFill/>
+          </a:ln>
+        </p:spPr>
+        <p:txBody>
+          <a:bodyPr xmlns:a="http://schemas.openxmlformats.org/drawingml/2006/main" lIns="0" tIns="0" rIns="0" bIns="0"/>
+          <a:lstStyle xmlns:a="http://schemas.openxmlformats.org/drawingml/2006/main">
+            <a:defPPr>
+              <a:defRPr sz="1050" b="1">
+                <a:solidFill>
+                  <a:srgbClr val="566A73"/>
+                </a:solidFill>
+                <a:latin typeface="Arial"/>
+                <a:ea typeface="Arial"/>
+                <a:cs typeface="Arial"/>
+              </a:defRPr>
+            </a:defPPr>
+            <a:lvl1pPr>
+              <a:defRPr sz="1050" b="1">
+                <a:solidFill>
+                  <a:srgbClr val="566A73"/>
+                </a:solidFill>
+                <a:latin typeface="Arial"/>
+                <a:ea typeface="Arial"/>
+                <a:cs typeface="Arial"/>
+              </a:defRPr>
+            </a:lvl1pPr>
+            <a:lvl2pPr>
+              <a:defRPr sz="1050" b="1">
+                <a:solidFill>
+                  <a:srgbClr val="566A73"/>
+                </a:solidFill>
+                <a:latin typeface="Arial"/>
+                <a:ea typeface="Arial"/>
+                <a:cs typeface="Arial"/>
+              </a:defRPr>
+            </a:lvl2pPr>
+            <a:lvl3pPr>
+              <a:defRPr sz="1050" b="1">
+                <a:solidFill>
+                  <a:srgbClr val="566A73"/>
+                </a:solidFill>
+                <a:latin typeface="Arial"/>
+                <a:ea typeface="Arial"/>
+                <a:cs typeface="Arial"/>
+              </a:defRPr>
+            </a:lvl3pPr>
+            <a:lvl4pPr>
+              <a:defRPr sz="1050" b="1">
+                <a:solidFill>
+                  <a:srgbClr val="566A73"/>
+                </a:solidFill>
+                <a:latin typeface="Arial"/>
+                <a:ea typeface="Arial"/>
+                <a:cs typeface="Arial"/>
+              </a:defRPr>
+            </a:lvl4pPr>
+            <a:lvl5pPr>
+              <a:defRPr sz="1050" b="1">
+                <a:solidFill>
+                  <a:srgbClr val="566A73"/>
+                </a:solidFill>
+                <a:latin typeface="Arial"/>
+                <a:ea typeface="Arial"/>
+                <a:cs typeface="Arial"/>
+              </a:defRPr>
+            </a:lvl5pPr>
+            <a:lvl6pPr>
+              <a:defRPr sz="1050" b="1">
+                <a:solidFill>
+                  <a:srgbClr val="566A73"/>
+                </a:solidFill>
+                <a:latin typeface="Arial"/>
+                <a:ea typeface="Arial"/>
+                <a:cs typeface="Arial"/>
+              </a:defRPr>
+            </a:lvl6pPr>
+            <a:lvl7pPr>
+              <a:defRPr sz="1050" b="1">
+                <a:solidFill>
+                  <a:srgbClr val="566A73"/>
+                </a:solidFill>
+                <a:latin typeface="Arial"/>
+                <a:ea typeface="Arial"/>
+                <a:cs typeface="Arial"/>
+              </a:defRPr>
+            </a:lvl7pPr>
+            <a:lvl8pPr>
+              <a:defRPr sz="1050" b="1">
+                <a:solidFill>
+                  <a:srgbClr val="566A73"/>
+                </a:solidFill>
+                <a:latin typeface="Arial"/>
+                <a:ea typeface="Arial"/>
+                <a:cs typeface="Arial"/>
+              </a:defRPr>
+            </a:lvl8pPr>
+            <a:lvl9pPr>
+              <a:defRPr sz="1050" b="1">
+                <a:solidFill>
+                  <a:srgbClr val="566A73"/>
+                </a:solidFill>
+                <a:latin typeface="Arial"/>
+                <a:ea typeface="Arial"/>
+                <a:cs typeface="Arial"/>
+              </a:defRPr>
+            </a:lvl9pPr>
+          </a:lstStyle>
+          <a:p xmlns:a="http://schemas.openxmlformats.org/drawingml/2006/main">
+            <a:pPr>
+              <a:defRPr sz="1050" b="1">
+                <a:solidFill>
+                  <a:srgbClr val="566A73"/>
+                </a:solidFill>
+                <a:latin typeface="Arial"/>
+                <a:ea typeface="Arial"/>
+                <a:cs typeface="Arial"/>
+              </a:defRPr>
+            </a:pPr>
+            <a:r>
+              <a:rPr sz="1050" b="1">
+                <a:solidFill>
+                  <a:srgbClr val="566A73"/>
+                </a:solidFill>
+                <a:latin typeface="Arial"/>
+                <a:ea typeface="Arial"/>
+                <a:cs typeface="Arial"/>
+              </a:rPr>
+              <a:t>ASTRO / Reference</a:t>
+            </a:r>
+          </a:p>
+        </p:txBody>
+      </p:sp>
+      <p:sp>
+        <p:nvSpPr>
+          <p:cNvPr id="3" name="">
+            <a:extLst xmlns:a="http://schemas.openxmlformats.org/drawingml/2006/main">
+              <a:ext uri="{FF2B5EF4-FFF2-40B4-BE49-F238E27FC236}">
+                <a16:creationId xmlns:a16="http://schemas.microsoft.com/office/drawing/2014/main" id="{22711B4A-BC67-4F34-A728-43F197C8DD16}"/>
+              </a:ext>
+            </a:extLst>
+          </p:cNvPr>
+          <p:cNvSpPr>
+            <a:spLocks xmlns:a="http://schemas.openxmlformats.org/drawingml/2006/main" noGrp="1"/>
+          </p:cNvSpPr>
+          <p:nvPr/>
+        </p:nvSpPr>
+        <p:spPr>
+          <a:xfrm xmlns:a="http://schemas.openxmlformats.org/drawingml/2006/main">
+            <a:off x="11334750" y="6467475"/>
+            <a:ext cx="361950" cy="209550"/>
+          </a:xfrm>
+          <a:prstGeom xmlns:a="http://schemas.openxmlformats.org/drawingml/2006/main" prst="rect">
+            <a:avLst/>
+          </a:prstGeom>
+          <a:noFill xmlns:a="http://schemas.openxmlformats.org/drawingml/2006/main"/>
+          <a:ln xmlns:a="http://schemas.openxmlformats.org/drawingml/2006/main" w="0">
+            <a:noFill/>
+          </a:ln>
+        </p:spPr>
+        <p:txBody>
+          <a:bodyPr xmlns:a="http://schemas.openxmlformats.org/drawingml/2006/main" lIns="0" tIns="0" rIns="0" bIns="0"/>
+          <a:lstStyle xmlns:a="http://schemas.openxmlformats.org/drawingml/2006/main">
+            <a:defPPr>
+              <a:defRPr sz="1050" b="0">
+                <a:solidFill>
+                  <a:srgbClr val="566A73"/>
+                </a:solidFill>
+                <a:latin typeface="Arial"/>
+                <a:ea typeface="Arial"/>
+                <a:cs typeface="Arial"/>
+              </a:defRPr>
+            </a:defPPr>
+            <a:lvl1pPr>
+              <a:defRPr sz="1050" b="0">
+                <a:solidFill>
+                  <a:srgbClr val="566A73"/>
+                </a:solidFill>
+                <a:latin typeface="Arial"/>
+                <a:ea typeface="Arial"/>
+                <a:cs typeface="Arial"/>
+              </a:defRPr>
+            </a:lvl1pPr>
+            <a:lvl2pPr>
+              <a:defRPr sz="1050" b="0">
+                <a:solidFill>
+                  <a:srgbClr val="566A73"/>
+                </a:solidFill>
+                <a:latin typeface="Arial"/>
+                <a:ea typeface="Arial"/>
+                <a:cs typeface="Arial"/>
+              </a:defRPr>
+            </a:lvl2pPr>
+            <a:lvl3pPr>
+              <a:defRPr sz="1050" b="0">
+                <a:solidFill>
+                  <a:srgbClr val="566A73"/>
+                </a:solidFill>
+                <a:latin typeface="Arial"/>
+                <a:ea typeface="Arial"/>
+                <a:cs typeface="Arial"/>
+              </a:defRPr>
+            </a:lvl3pPr>
+            <a:lvl4pPr>
+              <a:defRPr sz="1050" b="0">
+                <a:solidFill>
+                  <a:srgbClr val="566A73"/>
+                </a:solidFill>
+                <a:latin typeface="Arial"/>
+                <a:ea typeface="Arial"/>
+                <a:cs typeface="Arial"/>
+              </a:defRPr>
+            </a:lvl4pPr>
+            <a:lvl5pPr>
+              <a:defRPr sz="1050" b="0">
+                <a:solidFill>
+                  <a:srgbClr val="566A73"/>
+                </a:solidFill>
+                <a:latin typeface="Arial"/>
+                <a:ea typeface="Arial"/>
+                <a:cs typeface="Arial"/>
+              </a:defRPr>
+            </a:lvl5pPr>
+            <a:lvl6pPr>
+              <a:defRPr sz="1050" b="0">
+                <a:solidFill>
+                  <a:srgbClr val="566A73"/>
+                </a:solidFill>
+                <a:latin typeface="Arial"/>
+                <a:ea typeface="Arial"/>
+                <a:cs typeface="Arial"/>
+              </a:defRPr>
+            </a:lvl6pPr>
+            <a:lvl7pPr>
+              <a:defRPr sz="1050" b="0">
+                <a:solidFill>
+                  <a:srgbClr val="566A73"/>
+                </a:solidFill>
+                <a:latin typeface="Arial"/>
+                <a:ea typeface="Arial"/>
+                <a:cs typeface="Arial"/>
+              </a:defRPr>
+            </a:lvl7pPr>
+            <a:lvl8pPr>
+              <a:defRPr sz="1050" b="0">
+                <a:solidFill>
+                  <a:srgbClr val="566A73"/>
+                </a:solidFill>
+                <a:latin typeface="Arial"/>
+                <a:ea typeface="Arial"/>
+                <a:cs typeface="Arial"/>
+              </a:defRPr>
+            </a:lvl8pPr>
+            <a:lvl9pPr>
+              <a:defRPr sz="1050" b="0">
+                <a:solidFill>
+                  <a:srgbClr val="566A73"/>
+                </a:solidFill>
+                <a:latin typeface="Arial"/>
+                <a:ea typeface="Arial"/>
+                <a:cs typeface="Arial"/>
+              </a:defRPr>
+            </a:lvl9pPr>
+          </a:lstStyle>
+          <a:p xmlns:a="http://schemas.openxmlformats.org/drawingml/2006/main">
+            <a:pPr>
+              <a:defRPr sz="1050" b="0">
+                <a:solidFill>
+                  <a:srgbClr val="566A73"/>
+                </a:solidFill>
+                <a:latin typeface="Arial"/>
+                <a:ea typeface="Arial"/>
+                <a:cs typeface="Arial"/>
+              </a:defRPr>
+            </a:pPr>
+            <a:r>
+              <a:rPr sz="1050" b="0">
+                <a:solidFill>
+                  <a:srgbClr val="566A73"/>
+                </a:solidFill>
+                <a:latin typeface="Arial"/>
+                <a:ea typeface="Arial"/>
+                <a:cs typeface="Arial"/>
+              </a:rPr>
+              <a:t>18</a:t>
+            </a:r>
+          </a:p>
+        </p:txBody>
+      </p:sp>
+      <p:graphicFrame>
+        <p:nvGraphicFramePr>
+          <p:cNvPr id="4" name="">
+            <a:extLst xmlns:a="http://schemas.openxmlformats.org/drawingml/2006/main">
+              <a:ext uri="{FF2B5EF4-FFF2-40B4-BE49-F238E27FC236}">
+                <a16:creationId xmlns:a16="http://schemas.microsoft.com/office/drawing/2014/main" id="{C3037F88-97A0-4937-80AF-296DDF86CFCE}"/>
+              </a:ext>
+            </a:extLst>
+          </p:cNvPr>
+          <p:cNvGraphicFramePr/>
+          <p:nvPr/>
+        </p:nvGraphicFramePr>
+        <p:xfrm>
+          <a:off xmlns:a="http://schemas.openxmlformats.org/drawingml/2006/main" x="495300" y="1390650"/>
+          <a:ext xmlns:a="http://schemas.openxmlformats.org/drawingml/2006/main" cx="11201400" cy="4295775"/>
+        </p:xfrm>
+        <a:graphic xmlns:a="http://schemas.openxmlformats.org/drawingml/2006/main">
+          <a:graphicData uri="http://schemas.openxmlformats.org/drawingml/2006/table">
+            <a:tbl>
+              <a:tblPr/>
+              <a:tblGrid>
+                <a:gridCol w="2609850"/>
+                <a:gridCol w="5391150"/>
+                <a:gridCol w="3200400"/>
+              </a:tblGrid>
+              <a:tr h="859155">
+                <a:tc>
+                  <a:txBody>
+                    <a:bodyPr/>
+                    <a:lstStyle/>
+                    <a:p>
+                      <a:r>
+                        <a:rPr sz="1425" b="1">
+                          <a:solidFill>
+                            <a:srgbClr val="FFFFFF"/>
+                          </a:solidFill>
+                          <a:latin typeface="Arial"/>
+                          <a:ea typeface="Arial"/>
+                          <a:cs typeface="Arial"/>
+                        </a:rPr>
+                        <a:t>Hard task</a:t>
+                      </a:r>
+                    </a:p>
+                  </a:txBody>
+                  <a:tcPr marL="123825" marR="114300" marT="57150" marB="57150" anchor="ctr">
+                    <a:lnL w="6668">
+                      <a:solidFill>
+                        <a:srgbClr val="CED7D3"/>
+                      </a:solidFill>
+                      <a:prstDash val="solid"/>
+                    </a:lnL>
+                    <a:lnR w="6668">
+                      <a:solidFill>
+                        <a:srgbClr val="CED7D3"/>
+                      </a:solidFill>
+                      <a:prstDash val="solid"/>
+                    </a:lnR>
+                    <a:lnT w="6668">
+                      <a:solidFill>
+                        <a:srgbClr val="CED7D3"/>
+                      </a:solidFill>
+                      <a:prstDash val="solid"/>
+                    </a:lnT>
+                    <a:lnB w="6668">
+                      <a:solidFill>
+                        <a:srgbClr val="CED7D3"/>
+                      </a:solidFill>
+                      <a:prstDash val="solid"/>
+                    </a:lnB>
+                    <a:solidFill>
+                      <a:srgbClr val="172B3A"/>
+                    </a:solidFill>
+                  </a:tcPr>
+                </a:tc>
+                <a:tc>
+                  <a:txBody>
+                    <a:bodyPr/>
+                    <a:lstStyle/>
+                    <a:p>
+                      <a:r>
+                        <a:rPr sz="1425" b="1">
+                          <a:solidFill>
+                            <a:srgbClr val="FFFFFF"/>
+                          </a:solidFill>
+                          <a:latin typeface="Arial"/>
+                          <a:ea typeface="Arial"/>
+                          <a:cs typeface="Arial"/>
+                        </a:rPr>
+                        <a:t>Solution sequence</a:t>
+                      </a:r>
+                    </a:p>
+                  </a:txBody>
+                  <a:tcPr marL="123825" marR="114300" marT="57150" marB="57150" anchor="ctr">
+                    <a:lnR w="6668">
+                      <a:solidFill>
+                        <a:srgbClr val="CED7D3"/>
+                      </a:solidFill>
+                      <a:prstDash val="solid"/>
+                    </a:lnR>
+                    <a:lnT w="6668">
+                      <a:solidFill>
+                        <a:srgbClr val="CED7D3"/>
+                      </a:solidFill>
+                      <a:prstDash val="solid"/>
+                    </a:lnT>
+                    <a:lnB w="6668">
+                      <a:solidFill>
+                        <a:srgbClr val="CED7D3"/>
+                      </a:solidFill>
+                      <a:prstDash val="solid"/>
+                    </a:lnB>
+                    <a:solidFill>
+                      <a:srgbClr val="172B3A"/>
+                    </a:solidFill>
+                  </a:tcPr>
+                </a:tc>
+                <a:tc>
+                  <a:txBody>
+                    <a:bodyPr/>
+                    <a:lstStyle/>
+                    <a:p>
+                      <a:r>
+                        <a:rPr sz="1425" b="1">
+                          <a:solidFill>
+                            <a:srgbClr val="FFFFFF"/>
+                          </a:solidFill>
+                          <a:latin typeface="Arial"/>
+                          <a:ea typeface="Arial"/>
+                          <a:cs typeface="Arial"/>
+                        </a:rPr>
+                        <a:t>Required checks</a:t>
+                      </a:r>
+                    </a:p>
+                  </a:txBody>
+                  <a:tcPr marL="123825" marR="114300" marT="57150" marB="57150" anchor="ctr">
+                    <a:lnR w="6668">
+                      <a:solidFill>
+                        <a:srgbClr val="CED7D3"/>
+                      </a:solidFill>
+                      <a:prstDash val="solid"/>
+                    </a:lnR>
+                    <a:lnT w="6668">
+                      <a:solidFill>
+                        <a:srgbClr val="CED7D3"/>
+                      </a:solidFill>
+                      <a:prstDash val="solid"/>
+                    </a:lnT>
+                    <a:lnB w="6668">
+                      <a:solidFill>
+                        <a:srgbClr val="CED7D3"/>
+                      </a:solidFill>
+                      <a:prstDash val="solid"/>
+                    </a:lnB>
+                    <a:solidFill>
+                      <a:srgbClr val="172B3A"/>
+                    </a:solidFill>
+                  </a:tcPr>
+                </a:tc>
+              </a:tr>
+              <a:tr h="859155">
+                <a:tc>
+                  <a:txBody>
+                    <a:bodyPr/>
+                    <a:lstStyle/>
+                    <a:p>
+                      <a:r>
+                        <a:rPr sz="1575" b="0">
+                          <a:solidFill>
+                            <a:srgbClr val="172B3A"/>
+                          </a:solidFill>
+                          <a:latin typeface="Arial"/>
+                          <a:ea typeface="Arial"/>
+                          <a:cs typeface="Arial"/>
+                        </a:rPr>
+                        <a:t>RF energy tradeoff</a:t>
+                      </a:r>
+                    </a:p>
+                  </a:txBody>
+                  <a:tcPr marL="123825" marR="114300" marT="57150" marB="57150" anchor="ctr">
+                    <a:lnL w="6668">
+                      <a:solidFill>
+                        <a:srgbClr val="CED7D3"/>
+                      </a:solidFill>
+                      <a:prstDash val="solid"/>
+                    </a:lnL>
+                    <a:lnR w="6668">
+                      <a:solidFill>
+                        <a:srgbClr val="CED7D3"/>
+                      </a:solidFill>
+                      <a:prstDash val="solid"/>
+                    </a:lnR>
+                    <a:lnB w="6668">
+                      <a:solidFill>
+                        <a:srgbClr val="CED7D3"/>
+                      </a:solidFill>
+                      <a:prstDash val="solid"/>
+                    </a:lnB>
+                    <a:solidFill>
+                      <a:srgbClr val="E9EEEA"/>
+                    </a:solidFill>
+                  </a:tcPr>
+                </a:tc>
+                <a:tc>
+                  <a:txBody>
+                    <a:bodyPr/>
+                    <a:lstStyle/>
+                    <a:p>
+                      <a:r>
+                        <a:rPr sz="1575" b="0">
+                          <a:solidFill>
+                            <a:srgbClr val="172B3A"/>
+                          </a:solidFill>
+                          <a:latin typeface="Arial"/>
+                          <a:ea typeface="Arial"/>
+                          <a:cs typeface="Arial"/>
+                        </a:rPr>
+                        <a:t>Derive required rate from target / contact time;</a:t>
+                      </a:r>
+                    </a:p>
+                    <a:p>
+                      <a:r>
+                        <a:rPr sz="1575" b="0">
+                          <a:solidFill>
+                            <a:srgbClr val="172B3A"/>
+                          </a:solidFill>
+                          <a:latin typeface="Arial"/>
+                          <a:ea typeface="Arial"/>
+                          <a:cs typeface="Arial"/>
+                        </a:rPr>
+                        <a:t>choose feasible baud rate and transmitter power.</a:t>
+                      </a:r>
+                    </a:p>
+                    <a:p>
+                      <a:r>
+                        <a:rPr sz="1575" b="0">
+                          <a:solidFill>
+                            <a:srgbClr val="172B3A"/>
+                          </a:solidFill>
+                          <a:latin typeface="Arial"/>
+                          <a:ea typeface="Arial"/>
+                          <a:cs typeface="Arial"/>
+                        </a:rPr>
+                        <a:t>Seed 0: 38,400 bps, 32.0 dBm.</a:t>
+                      </a:r>
+                    </a:p>
+                  </a:txBody>
+                  <a:tcPr marL="123825" marR="114300" marT="57150" marB="57150" anchor="ctr">
+                    <a:lnR w="6668">
+                      <a:solidFill>
+                        <a:srgbClr val="CED7D3"/>
+                      </a:solidFill>
+                      <a:prstDash val="solid"/>
+                    </a:lnR>
+                    <a:lnB w="6668">
+                      <a:solidFill>
+                        <a:srgbClr val="CED7D3"/>
+                      </a:solidFill>
+                      <a:prstDash val="solid"/>
+                    </a:lnB>
+                    <a:solidFill>
+                      <a:srgbClr val="E9EEEA"/>
+                    </a:solidFill>
+                  </a:tcPr>
+                </a:tc>
+                <a:tc>
+                  <a:txBody>
+                    <a:bodyPr/>
+                    <a:lstStyle/>
+                    <a:p>
+                      <a:r>
+                        <a:rPr sz="1575" b="0">
+                          <a:solidFill>
+                            <a:srgbClr val="172B3A"/>
+                          </a:solidFill>
+                          <a:latin typeface="Arial"/>
+                          <a:ea typeface="Arial"/>
+                          <a:cs typeface="Arial"/>
+                        </a:rPr>
+                        <a:t>Delivered data, link margin</a:t>
+                      </a:r>
+                    </a:p>
+                    <a:p>
+                      <a:r>
+                        <a:rPr sz="1575" b="0">
+                          <a:solidFill>
+                            <a:srgbClr val="172B3A"/>
+                          </a:solidFill>
+                          <a:latin typeface="Arial"/>
+                          <a:ea typeface="Arial"/>
+                          <a:cs typeface="Arial"/>
+                        </a:rPr>
+                        <a:t>and RF energy allocation</a:t>
+                      </a:r>
+                    </a:p>
+                  </a:txBody>
+                  <a:tcPr marL="123825" marR="114300" marT="57150" marB="57150" anchor="ctr">
+                    <a:lnR w="6668">
+                      <a:solidFill>
+                        <a:srgbClr val="CED7D3"/>
+                      </a:solidFill>
+                      <a:prstDash val="solid"/>
+                    </a:lnR>
+                    <a:lnB w="6668">
+                      <a:solidFill>
+                        <a:srgbClr val="CED7D3"/>
+                      </a:solidFill>
+                      <a:prstDash val="solid"/>
+                    </a:lnB>
+                    <a:solidFill>
+                      <a:srgbClr val="E9EEEA"/>
+                    </a:solidFill>
+                  </a:tcPr>
+                </a:tc>
+              </a:tr>
+              <a:tr h="859155">
+                <a:tc>
+                  <a:txBody>
+                    <a:bodyPr/>
+                    <a:lstStyle/>
+                    <a:p>
+                      <a:r>
+                        <a:rPr sz="1575" b="0">
+                          <a:solidFill>
+                            <a:srgbClr val="172B3A"/>
+                          </a:solidFill>
+                          <a:latin typeface="Arial"/>
+                          <a:ea typeface="Arial"/>
+                          <a:cs typeface="Arial"/>
+                        </a:rPr>
+                        <a:t>Early pass recovery</a:t>
+                      </a:r>
+                    </a:p>
+                  </a:txBody>
+                  <a:tcPr marL="123825" marR="114300" marT="57150" marB="57150" anchor="ctr">
+                    <a:lnL w="6668">
+                      <a:solidFill>
+                        <a:srgbClr val="CED7D3"/>
+                      </a:solidFill>
+                      <a:prstDash val="solid"/>
+                    </a:lnL>
+                    <a:lnR w="6668">
+                      <a:solidFill>
+                        <a:srgbClr val="CED7D3"/>
+                      </a:solidFill>
+                      <a:prstDash val="solid"/>
+                    </a:lnR>
+                    <a:lnB w="6668">
+                      <a:solidFill>
+                        <a:srgbClr val="CED7D3"/>
+                      </a:solidFill>
+                      <a:prstDash val="solid"/>
+                    </a:lnB>
+                    <a:solidFill>
+                      <a:srgbClr val="F7F6F2"/>
+                    </a:solidFill>
+                  </a:tcPr>
+                </a:tc>
+                <a:tc>
+                  <a:txBody>
+                    <a:bodyPr/>
+                    <a:lstStyle/>
+                    <a:p>
+                      <a:r>
+                        <a:rPr sz="1575" b="0">
+                          <a:solidFill>
+                            <a:srgbClr val="172B3A"/>
+                          </a:solidFill>
+                          <a:latin typeface="Arial"/>
+                          <a:ea typeface="Arial"/>
+                          <a:cs typeface="Arial"/>
+                        </a:rPr>
+                        <a:t>Repair pointing and radio before contact.</a:t>
+                      </a:r>
+                    </a:p>
+                    <a:p>
+                      <a:r>
+                        <a:rPr sz="1575" b="0">
+                          <a:solidFill>
+                            <a:srgbClr val="172B3A"/>
+                          </a:solidFill>
+                          <a:latin typeface="Arial"/>
+                          <a:ea typeface="Arial"/>
+                          <a:cs typeface="Arial"/>
+                        </a:rPr>
+                        <a:t>Seed 0: control_gain 5.5; tx_power_dbm 31.4.</a:t>
+                      </a:r>
+                    </a:p>
+                    <a:p>
+                      <a:r>
+                        <a:rPr sz="1575" b="0">
+                          <a:solidFill>
+                            <a:srgbClr val="172B3A"/>
+                          </a:solidFill>
+                          <a:latin typeface="Arial"/>
+                          <a:ea typeface="Arial"/>
+                          <a:cs typeface="Arial"/>
+                        </a:rPr>
+                        <a:t>Respect the protected maximum transmitter power.</a:t>
+                      </a:r>
+                    </a:p>
+                  </a:txBody>
+                  <a:tcPr marL="123825" marR="114300" marT="57150" marB="57150" anchor="ctr">
+                    <a:lnR w="6668">
+                      <a:solidFill>
+                        <a:srgbClr val="CED7D3"/>
+                      </a:solidFill>
+                      <a:prstDash val="solid"/>
+                    </a:lnR>
+                    <a:lnB w="6668">
+                      <a:solidFill>
+                        <a:srgbClr val="CED7D3"/>
+                      </a:solidFill>
+                      <a:prstDash val="solid"/>
+                    </a:lnB>
+                    <a:solidFill>
+                      <a:srgbClr val="F7F6F2"/>
+                    </a:solidFill>
+                  </a:tcPr>
+                </a:tc>
+                <a:tc>
+                  <a:txBody>
+                    <a:bodyPr/>
+                    <a:lstStyle/>
+                    <a:p>
+                      <a:r>
+                        <a:rPr sz="1575" b="0">
+                          <a:solidFill>
+                            <a:srgbClr val="172B3A"/>
+                          </a:solidFill>
+                          <a:latin typeface="Arial"/>
+                          <a:ea typeface="Arial"/>
+                          <a:cs typeface="Arial"/>
+                        </a:rPr>
+                        <a:t>Recover before pass closes;</a:t>
+                      </a:r>
+                    </a:p>
+                    <a:p>
+                      <a:r>
+                        <a:rPr sz="1575" b="0">
+                          <a:solidFill>
+                            <a:srgbClr val="172B3A"/>
+                          </a:solidFill>
+                          <a:latin typeface="Arial"/>
+                          <a:ea typeface="Arial"/>
+                          <a:cs typeface="Arial"/>
+                        </a:rPr>
+                        <a:t>delivery and power constraints</a:t>
+                      </a:r>
+                    </a:p>
+                  </a:txBody>
+                  <a:tcPr marL="123825" marR="114300" marT="57150" marB="57150" anchor="ctr">
+                    <a:lnR w="6668">
+                      <a:solidFill>
+                        <a:srgbClr val="CED7D3"/>
+                      </a:solidFill>
+                      <a:prstDash val="solid"/>
+                    </a:lnR>
+                    <a:lnB w="6668">
+                      <a:solidFill>
+                        <a:srgbClr val="CED7D3"/>
+                      </a:solidFill>
+                      <a:prstDash val="solid"/>
+                    </a:lnB>
+                    <a:solidFill>
+                      <a:srgbClr val="F7F6F2"/>
+                    </a:solidFill>
+                  </a:tcPr>
+                </a:tc>
+              </a:tr>
+              <a:tr h="859155">
+                <a:tc>
+                  <a:txBody>
+                    <a:bodyPr/>
+                    <a:lstStyle/>
+                    <a:p>
+                      <a:r>
+                        <a:rPr sz="1575" b="0">
+                          <a:solidFill>
+                            <a:srgbClr val="172B3A"/>
+                          </a:solidFill>
+                          <a:latin typeface="Arial"/>
+                          <a:ea typeface="Arial"/>
+                          <a:cs typeface="Arial"/>
+                        </a:rPr>
+                        <a:t>Observation scheduling</a:t>
+                      </a:r>
+                    </a:p>
+                  </a:txBody>
+                  <a:tcPr marL="123825" marR="114300" marT="57150" marB="57150" anchor="ctr">
+                    <a:lnL w="6668">
+                      <a:solidFill>
+                        <a:srgbClr val="CED7D3"/>
+                      </a:solidFill>
+                      <a:prstDash val="solid"/>
+                    </a:lnL>
+                    <a:lnR w="6668">
+                      <a:solidFill>
+                        <a:srgbClr val="CED7D3"/>
+                      </a:solidFill>
+                      <a:prstDash val="solid"/>
+                    </a:lnR>
+                    <a:lnB w="6668">
+                      <a:solidFill>
+                        <a:srgbClr val="CED7D3"/>
+                      </a:solidFill>
+                      <a:prstDash val="solid"/>
+                    </a:lnB>
+                    <a:solidFill>
+                      <a:srgbClr val="E9EEEA"/>
+                    </a:solidFill>
+                  </a:tcPr>
+                </a:tc>
+                <a:tc>
+                  <a:txBody>
+                    <a:bodyPr/>
+                    <a:lstStyle/>
+                    <a:p>
+                      <a:r>
+                        <a:rPr sz="1575" b="0">
+                          <a:solidFill>
+                            <a:srgbClr val="172B3A"/>
+                          </a:solidFill>
+                          <a:latin typeface="Arial"/>
+                          <a:ea typeface="Arial"/>
+                          <a:cs typeface="Arial"/>
+                        </a:rPr>
+                        <a:t>Duty: 0 before window, 1 during, then 0.</a:t>
+                      </a:r>
+                    </a:p>
+                    <a:p>
+                      <a:r>
+                        <a:rPr sz="1575" b="0">
+                          <a:solidFill>
+                            <a:srgbClr val="172B3A"/>
+                          </a:solidFill>
+                          <a:latin typeface="Arial"/>
+                          <a:ea typeface="Arial"/>
+                          <a:cs typeface="Arial"/>
+                        </a:rPr>
+                        <a:t>Account for 30-second ordinary tool costs.</a:t>
+                      </a:r>
+                    </a:p>
+                    <a:p>
+                      <a:r>
+                        <a:rPr sz="1575" b="0">
+                          <a:solidFill>
+                            <a:srgbClr val="172B3A"/>
+                          </a:solidFill>
+                          <a:latin typeface="Arial"/>
+                          <a:ea typeface="Arial"/>
+                          <a:cs typeface="Arial"/>
+                        </a:rPr>
+                        <a:t>Meet useful exposure and payload energy.</a:t>
+                      </a:r>
+                    </a:p>
+                  </a:txBody>
+                  <a:tcPr marL="123825" marR="114300" marT="57150" marB="57150" anchor="ctr">
+                    <a:lnR w="6668">
+                      <a:solidFill>
+                        <a:srgbClr val="CED7D3"/>
+                      </a:solidFill>
+                      <a:prstDash val="solid"/>
+                    </a:lnR>
+                    <a:lnB w="6668">
+                      <a:solidFill>
+                        <a:srgbClr val="CED7D3"/>
+                      </a:solidFill>
+                      <a:prstDash val="solid"/>
+                    </a:lnB>
+                    <a:solidFill>
+                      <a:srgbClr val="E9EEEA"/>
+                    </a:solidFill>
+                  </a:tcPr>
+                </a:tc>
+                <a:tc>
+                  <a:txBody>
+                    <a:bodyPr/>
+                    <a:lstStyle/>
+                    <a:p>
+                      <a:r>
+                        <a:rPr sz="1575" b="0">
+                          <a:solidFill>
+                            <a:srgbClr val="172B3A"/>
+                          </a:solidFill>
+                          <a:latin typeface="Arial"/>
+                          <a:ea typeface="Arial"/>
+                          <a:cs typeface="Arial"/>
+                        </a:rPr>
+                        <a:t>Exposure quota and</a:t>
+                      </a:r>
+                    </a:p>
+                    <a:p>
+                      <a:r>
+                        <a:rPr sz="1575" b="0">
+                          <a:solidFill>
+                            <a:srgbClr val="172B3A"/>
+                          </a:solidFill>
+                          <a:latin typeface="Arial"/>
+                          <a:ea typeface="Arial"/>
+                          <a:cs typeface="Arial"/>
+                        </a:rPr>
+                        <a:t>payload energy allocation</a:t>
+                      </a:r>
+                    </a:p>
+                  </a:txBody>
+                  <a:tcPr marL="123825" marR="114300" marT="57150" marB="57150" anchor="ctr">
+                    <a:lnR w="6668">
+                      <a:solidFill>
+                        <a:srgbClr val="CED7D3"/>
+                      </a:solidFill>
+                      <a:prstDash val="solid"/>
+                    </a:lnR>
+                    <a:lnB w="6668">
+                      <a:solidFill>
+                        <a:srgbClr val="CED7D3"/>
+                      </a:solidFill>
+                      <a:prstDash val="solid"/>
+                    </a:lnB>
+                    <a:solidFill>
+                      <a:srgbClr val="E9EEEA"/>
+                    </a:solidFill>
+                  </a:tcPr>
+                </a:tc>
+              </a:tr>
+              <a:tr h="859155">
+                <a:tc>
+                  <a:txBody>
+                    <a:bodyPr/>
+                    <a:lstStyle/>
+                    <a:p>
+                      <a:r>
+                        <a:rPr sz="1575" b="0">
+                          <a:solidFill>
+                            <a:srgbClr val="172B3A"/>
+                          </a:solidFill>
+                          <a:latin typeface="Arial"/>
+                          <a:ea typeface="Arial"/>
+                          <a:cs typeface="Arial"/>
+                        </a:rPr>
+                        <a:t>Science store and forward</a:t>
+                      </a:r>
+                    </a:p>
+                  </a:txBody>
+                  <a:tcPr marL="123825" marR="114300" marT="57150" marB="57150" anchor="ctr">
+                    <a:lnL w="6668">
+                      <a:solidFill>
+                        <a:srgbClr val="CED7D3"/>
+                      </a:solidFill>
+                      <a:prstDash val="solid"/>
+                    </a:lnL>
+                    <a:lnR w="6668">
+                      <a:solidFill>
+                        <a:srgbClr val="CED7D3"/>
+                      </a:solidFill>
+                      <a:prstDash val="solid"/>
+                    </a:lnR>
+                    <a:lnB w="6668">
+                      <a:solidFill>
+                        <a:srgbClr val="CED7D3"/>
+                      </a:solidFill>
+                      <a:prstDash val="solid"/>
+                    </a:lnB>
+                    <a:solidFill>
+                      <a:srgbClr val="F7F6F2"/>
+                    </a:solidFill>
+                  </a:tcPr>
+                </a:tc>
+                <a:tc>
+                  <a:txBody>
+                    <a:bodyPr/>
+                    <a:lstStyle/>
+                    <a:p>
+                      <a:r>
+                        <a:rPr sz="1575" b="0">
+                          <a:solidFill>
+                            <a:srgbClr val="172B3A"/>
+                          </a:solidFill>
+                          <a:latin typeface="Arial"/>
+                          <a:ea typeface="Arial"/>
+                          <a:cs typeface="Arial"/>
+                        </a:rPr>
+                        <a:t>Collect window 1; switch off; drain at contact 1.</a:t>
+                      </a:r>
+                    </a:p>
+                    <a:p>
+                      <a:r>
+                        <a:rPr sz="1575" b="0">
+                          <a:solidFill>
+                            <a:srgbClr val="172B3A"/>
+                          </a:solidFill>
+                          <a:latin typeface="Arial"/>
+                          <a:ea typeface="Arial"/>
+                          <a:cs typeface="Arial"/>
+                        </a:rPr>
+                        <a:t>Collect window 2; switch off; drain at contact 2.</a:t>
+                      </a:r>
+                    </a:p>
+                    <a:p>
+                      <a:r>
+                        <a:rPr sz="1575" b="0">
+                          <a:solidFill>
+                            <a:srgbClr val="172B3A"/>
+                          </a:solidFill>
+                          <a:latin typeface="Arial"/>
+                          <a:ea typeface="Arial"/>
+                          <a:cs typeface="Arial"/>
+                        </a:rPr>
+                        <a:t>Choose rate/power within the RF energy budget.</a:t>
+                      </a:r>
+                    </a:p>
+                  </a:txBody>
+                  <a:tcPr marL="123825" marR="114300" marT="57150" marB="57150" anchor="ctr">
+                    <a:lnR w="6668">
+                      <a:solidFill>
+                        <a:srgbClr val="CED7D3"/>
+                      </a:solidFill>
+                      <a:prstDash val="solid"/>
+                    </a:lnR>
+                    <a:lnB w="6668">
+                      <a:solidFill>
+                        <a:srgbClr val="CED7D3"/>
+                      </a:solidFill>
+                      <a:prstDash val="solid"/>
+                    </a:lnB>
+                    <a:solidFill>
+                      <a:srgbClr val="F7F6F2"/>
+                    </a:solidFill>
+                  </a:tcPr>
+                </a:tc>
+                <a:tc>
+                  <a:txBody>
+                    <a:bodyPr/>
+                    <a:lstStyle/>
+                    <a:p>
+                      <a:r>
+                        <a:rPr sz="1575" b="0">
+                          <a:solidFill>
+                            <a:srgbClr val="172B3A"/>
+                          </a:solidFill>
+                          <a:latin typeface="Arial"/>
+                          <a:ea typeface="Arial"/>
+                          <a:cs typeface="Arial"/>
+                        </a:rPr>
+                        <a:t>Every window quota; zero loss;</a:t>
+                      </a:r>
+                    </a:p>
+                    <a:p>
+                      <a:r>
+                        <a:rPr sz="1575" b="0">
+                          <a:solidFill>
+                            <a:srgbClr val="172B3A"/>
+                          </a:solidFill>
+                          <a:latin typeface="Arial"/>
+                          <a:ea typeface="Arial"/>
+                          <a:cs typeface="Arial"/>
+                        </a:rPr>
+                        <a:t>delivery, buffer and both</a:t>
+                      </a:r>
+                    </a:p>
+                    <a:p>
+                      <a:r>
+                        <a:rPr sz="1575" b="0">
+                          <a:solidFill>
+                            <a:srgbClr val="172B3A"/>
+                          </a:solidFill>
+                          <a:latin typeface="Arial"/>
+                          <a:ea typeface="Arial"/>
+                          <a:cs typeface="Arial"/>
+                        </a:rPr>
+                        <a:t>energy allocations</a:t>
+                      </a:r>
+                    </a:p>
+                  </a:txBody>
+                  <a:tcPr marL="123825" marR="114300" marT="57150" marB="57150" anchor="ctr">
+                    <a:lnR w="6668">
+                      <a:solidFill>
+                        <a:srgbClr val="CED7D3"/>
+                      </a:solidFill>
+                      <a:prstDash val="solid"/>
+                    </a:lnR>
+                    <a:lnB w="6668">
+                      <a:solidFill>
+                        <a:srgbClr val="CED7D3"/>
+                      </a:solidFill>
+                      <a:prstDash val="solid"/>
+                    </a:lnB>
+                    <a:solidFill>
+                      <a:srgbClr val="F7F6F2"/>
+                    </a:solidFill>
+                  </a:tcPr>
+                </a:tc>
+              </a:tr>
+            </a:tbl>
+          </a:graphicData>
+        </a:graphic>
+      </p:graphicFrame>
+      <p:sp>
+        <p:nvSpPr>
+          <p:cNvPr id="5" name="">
+            <a:extLst xmlns:a="http://schemas.openxmlformats.org/drawingml/2006/main">
+              <a:ext uri="{FF2B5EF4-FFF2-40B4-BE49-F238E27FC236}">
+                <a16:creationId xmlns:a16="http://schemas.microsoft.com/office/drawing/2014/main" id="{A96A3119-B00A-44EA-9C44-CDDB7FADA3F1}"/>
+              </a:ext>
+            </a:extLst>
+          </p:cNvPr>
+          <p:cNvSpPr>
+            <a:spLocks xmlns:a="http://schemas.openxmlformats.org/drawingml/2006/main" noGrp="1"/>
+          </p:cNvSpPr>
+          <p:nvPr/>
+        </p:nvSpPr>
+        <p:spPr>
+          <a:xfrm xmlns:a="http://schemas.openxmlformats.org/drawingml/2006/main">
+            <a:off x="495300" y="5915025"/>
+            <a:ext cx="11201400" cy="523875"/>
+          </a:xfrm>
+          <a:prstGeom xmlns:a="http://schemas.openxmlformats.org/drawingml/2006/main" prst="rect">
+            <a:avLst/>
+          </a:prstGeom>
+          <a:noFill xmlns:a="http://schemas.openxmlformats.org/drawingml/2006/main"/>
+          <a:ln xmlns:a="http://schemas.openxmlformats.org/drawingml/2006/main" w="0">
+            <a:noFill/>
+          </a:ln>
+        </p:spPr>
+        <p:txBody>
+          <a:bodyPr xmlns:a="http://schemas.openxmlformats.org/drawingml/2006/main" lIns="0" tIns="0" rIns="0" bIns="0"/>
+          <a:lstStyle xmlns:a="http://schemas.openxmlformats.org/drawingml/2006/main">
+            <a:defPPr>
+              <a:defRPr sz="1725" b="1">
+                <a:solidFill>
+                  <a:srgbClr val="20776D"/>
+                </a:solidFill>
+                <a:latin typeface="Arial"/>
+                <a:ea typeface="Arial"/>
+                <a:cs typeface="Arial"/>
+              </a:defRPr>
+            </a:defPPr>
+            <a:lvl1pPr>
+              <a:defRPr sz="1725" b="1">
+                <a:solidFill>
+                  <a:srgbClr val="20776D"/>
+                </a:solidFill>
+                <a:latin typeface="Arial"/>
+                <a:ea typeface="Arial"/>
+                <a:cs typeface="Arial"/>
+              </a:defRPr>
+            </a:lvl1pPr>
+            <a:lvl2pPr>
+              <a:defRPr sz="1725" b="1">
+                <a:solidFill>
+                  <a:srgbClr val="20776D"/>
+                </a:solidFill>
+                <a:latin typeface="Arial"/>
+                <a:ea typeface="Arial"/>
+                <a:cs typeface="Arial"/>
+              </a:defRPr>
+            </a:lvl2pPr>
+            <a:lvl3pPr>
+              <a:defRPr sz="1725" b="1">
+                <a:solidFill>
+                  <a:srgbClr val="20776D"/>
+                </a:solidFill>
+                <a:latin typeface="Arial"/>
+                <a:ea typeface="Arial"/>
+                <a:cs typeface="Arial"/>
+              </a:defRPr>
+            </a:lvl3pPr>
+            <a:lvl4pPr>
+              <a:defRPr sz="1725" b="1">
+                <a:solidFill>
+                  <a:srgbClr val="20776D"/>
+                </a:solidFill>
+                <a:latin typeface="Arial"/>
+                <a:ea typeface="Arial"/>
+                <a:cs typeface="Arial"/>
+              </a:defRPr>
+            </a:lvl4pPr>
+            <a:lvl5pPr>
+              <a:defRPr sz="1725" b="1">
+                <a:solidFill>
+                  <a:srgbClr val="20776D"/>
+                </a:solidFill>
+                <a:latin typeface="Arial"/>
+                <a:ea typeface="Arial"/>
+                <a:cs typeface="Arial"/>
+              </a:defRPr>
+            </a:lvl5pPr>
+            <a:lvl6pPr>
+              <a:defRPr sz="1725" b="1">
+                <a:solidFill>
+                  <a:srgbClr val="20776D"/>
+                </a:solidFill>
+                <a:latin typeface="Arial"/>
+                <a:ea typeface="Arial"/>
+                <a:cs typeface="Arial"/>
+              </a:defRPr>
+            </a:lvl6pPr>
+            <a:lvl7pPr>
+              <a:defRPr sz="1725" b="1">
+                <a:solidFill>
+                  <a:srgbClr val="20776D"/>
+                </a:solidFill>
+                <a:latin typeface="Arial"/>
+                <a:ea typeface="Arial"/>
+                <a:cs typeface="Arial"/>
+              </a:defRPr>
+            </a:lvl7pPr>
+            <a:lvl8pPr>
+              <a:defRPr sz="1725" b="1">
+                <a:solidFill>
+                  <a:srgbClr val="20776D"/>
+                </a:solidFill>
+                <a:latin typeface="Arial"/>
+                <a:ea typeface="Arial"/>
+                <a:cs typeface="Arial"/>
+              </a:defRPr>
+            </a:lvl8pPr>
+            <a:lvl9pPr>
+              <a:defRPr sz="1725" b="1">
+                <a:solidFill>
+                  <a:srgbClr val="20776D"/>
+                </a:solidFill>
+                <a:latin typeface="Arial"/>
+                <a:ea typeface="Arial"/>
+                <a:cs typeface="Arial"/>
+              </a:defRPr>
+            </a:lvl9pPr>
+          </a:lstStyle>
+          <a:p xmlns:a="http://schemas.openxmlformats.org/drawingml/2006/main">
+            <a:pPr>
+              <a:defRPr sz="1725" b="1">
+                <a:solidFill>
+                  <a:srgbClr val="20776D"/>
+                </a:solidFill>
+                <a:latin typeface="Arial"/>
+                <a:ea typeface="Arial"/>
+                <a:cs typeface="Arial"/>
+              </a:defRPr>
+            </a:pPr>
+            <a:r>
+              <a:rPr sz="1725" b="1">
+                <a:solidFill>
+                  <a:srgbClr val="20776D"/>
+                </a:solidFill>
+                <a:latin typeface="Arial"/>
+                <a:ea typeface="Arial"/>
+                <a:cs typeface="Arial"/>
+              </a:rPr>
+              <a:t>Derive timings and budgets from docs/mission.json for the active seed. Fixed schedules from another seed may fail.</a:t>
+            </a:r>
+          </a:p>
+        </p:txBody>
+      </p:sp>
+    </p:spTree>
+    <p:extLst>
+      <p:ext uri="{BB962C8B-B14F-4D97-AF65-F5344CB8AC3E}">
+        <p14:creationId xmlns:p14="http://schemas.microsoft.com/office/powerpoint/2010/main" val="964016892"/>
       </p:ext>
     </p:extLst>
   </p:cSld>
@@ -17161,7 +20233,7 @@
           <p:cNvPr id="6" name="">
             <a:extLst xmlns:a="http://schemas.openxmlformats.org/drawingml/2006/main">
               <a:ext uri="{FF2B5EF4-FFF2-40B4-BE49-F238E27FC236}">
-                <a16:creationId xmlns:a16="http://schemas.microsoft.com/office/drawing/2014/main" id="{77F1A28C-F138-4E82-8B2A-D603EC125315}"/>
+                <a16:creationId xmlns:a16="http://schemas.microsoft.com/office/drawing/2014/main" id="{B64EBA59-E94C-4E79-A8F1-4E231A50210B}"/>
               </a:ext>
             </a:extLst>
           </p:cNvPr>
@@ -17317,7 +20389,7 @@
           <p:cNvPr id="2" name="">
             <a:extLst xmlns:a="http://schemas.openxmlformats.org/drawingml/2006/main">
               <a:ext uri="{FF2B5EF4-FFF2-40B4-BE49-F238E27FC236}">
-                <a16:creationId xmlns:a16="http://schemas.microsoft.com/office/drawing/2014/main" id="{9BFA94EE-E61D-43BD-BBB1-78396DEB8B98}"/>
+                <a16:creationId xmlns:a16="http://schemas.microsoft.com/office/drawing/2014/main" id="{EBFBBB9C-D4F5-4F8A-853F-B958D596317D}"/>
               </a:ext>
             </a:extLst>
           </p:cNvPr>
@@ -17473,7 +20545,7 @@
           <p:cNvPr id="3" name="">
             <a:extLst xmlns:a="http://schemas.openxmlformats.org/drawingml/2006/main">
               <a:ext uri="{FF2B5EF4-FFF2-40B4-BE49-F238E27FC236}">
-                <a16:creationId xmlns:a16="http://schemas.microsoft.com/office/drawing/2014/main" id="{7905B3A5-66F2-4337-9908-DE994E6D23CA}"/>
+                <a16:creationId xmlns:a16="http://schemas.microsoft.com/office/drawing/2014/main" id="{C20594A8-D529-4514-A80F-1E0EF13B4D6E}"/>
               </a:ext>
             </a:extLst>
           </p:cNvPr>
@@ -17629,7 +20701,7 @@
           <p:cNvPr id="4" name="">
             <a:extLst xmlns:a="http://schemas.openxmlformats.org/drawingml/2006/main">
               <a:ext uri="{FF2B5EF4-FFF2-40B4-BE49-F238E27FC236}">
-                <a16:creationId xmlns:a16="http://schemas.microsoft.com/office/drawing/2014/main" id="{E3322BFC-F846-4573-8DA6-BC391ACD19DF}"/>
+                <a16:creationId xmlns:a16="http://schemas.microsoft.com/office/drawing/2014/main" id="{3D5BC69A-1FF1-46B0-A2E6-6382A5452BAF}"/>
               </a:ext>
             </a:extLst>
           </p:cNvPr>
@@ -18836,7 +21908,7 @@
           <p:cNvPr id="5" name="">
             <a:extLst xmlns:a="http://schemas.openxmlformats.org/drawingml/2006/main">
               <a:ext uri="{FF2B5EF4-FFF2-40B4-BE49-F238E27FC236}">
-                <a16:creationId xmlns:a16="http://schemas.microsoft.com/office/drawing/2014/main" id="{60A619B7-15BC-4E19-971D-9A50135DD760}"/>
+                <a16:creationId xmlns:a16="http://schemas.microsoft.com/office/drawing/2014/main" id="{A1857DCC-FA0E-49EC-96A6-E3EA1E65DCE2}"/>
               </a:ext>
             </a:extLst>
           </p:cNvPr>
@@ -18990,7 +22062,7 @@
     </p:spTree>
     <p:extLst>
       <p:ext uri="{BB962C8B-B14F-4D97-AF65-F5344CB8AC3E}">
-        <p14:creationId xmlns:p14="http://schemas.microsoft.com/office/powerpoint/2010/main" val="367443736"/>
+        <p14:creationId xmlns:p14="http://schemas.microsoft.com/office/powerpoint/2010/main" val="2136865949"/>
       </p:ext>
     </p:extLst>
   </p:cSld>
@@ -19021,7 +22093,7 @@
           <p:cNvPr id="6" name="">
             <a:extLst xmlns:a="http://schemas.openxmlformats.org/drawingml/2006/main">
               <a:ext uri="{FF2B5EF4-FFF2-40B4-BE49-F238E27FC236}">
-                <a16:creationId xmlns:a16="http://schemas.microsoft.com/office/drawing/2014/main" id="{46690AFF-01F1-4C68-8B25-C8EFA1022D16}"/>
+                <a16:creationId xmlns:a16="http://schemas.microsoft.com/office/drawing/2014/main" id="{0DCB66D9-5B20-4788-B7EC-017799AD78AD}"/>
               </a:ext>
             </a:extLst>
           </p:cNvPr>
@@ -19177,7 +22249,7 @@
           <p:cNvPr id="2" name="">
             <a:extLst xmlns:a="http://schemas.openxmlformats.org/drawingml/2006/main">
               <a:ext uri="{FF2B5EF4-FFF2-40B4-BE49-F238E27FC236}">
-                <a16:creationId xmlns:a16="http://schemas.microsoft.com/office/drawing/2014/main" id="{C5088241-D94E-4A17-9A7E-AFEE86530759}"/>
+                <a16:creationId xmlns:a16="http://schemas.microsoft.com/office/drawing/2014/main" id="{E2CE6B00-E901-42FF-A1F5-B5690C1E162A}"/>
               </a:ext>
             </a:extLst>
           </p:cNvPr>
@@ -19333,7 +22405,7 @@
           <p:cNvPr id="3" name="">
             <a:extLst xmlns:a="http://schemas.openxmlformats.org/drawingml/2006/main">
               <a:ext uri="{FF2B5EF4-FFF2-40B4-BE49-F238E27FC236}">
-                <a16:creationId xmlns:a16="http://schemas.microsoft.com/office/drawing/2014/main" id="{C01CFDFB-43C6-488A-9DC4-8F2A7F8FC0D5}"/>
+                <a16:creationId xmlns:a16="http://schemas.microsoft.com/office/drawing/2014/main" id="{604A593A-ABA2-475F-9485-954C8B7EB153}"/>
               </a:ext>
             </a:extLst>
           </p:cNvPr>
@@ -19489,7 +22561,7 @@
           <p:cNvPr id="4" name="">
             <a:extLst xmlns:a="http://schemas.openxmlformats.org/drawingml/2006/main">
               <a:ext uri="{FF2B5EF4-FFF2-40B4-BE49-F238E27FC236}">
-                <a16:creationId xmlns:a16="http://schemas.microsoft.com/office/drawing/2014/main" id="{FAE01919-0354-4DA3-90C2-40AB1F5506C4}"/>
+                <a16:creationId xmlns:a16="http://schemas.microsoft.com/office/drawing/2014/main" id="{C6676F5A-26A7-40E2-939E-18C87C5F750D}"/>
               </a:ext>
             </a:extLst>
           </p:cNvPr>
@@ -20297,7 +23369,7 @@
           <p:cNvPr id="5" name="">
             <a:extLst xmlns:a="http://schemas.openxmlformats.org/drawingml/2006/main">
               <a:ext uri="{FF2B5EF4-FFF2-40B4-BE49-F238E27FC236}">
-                <a16:creationId xmlns:a16="http://schemas.microsoft.com/office/drawing/2014/main" id="{20A7AE87-AA51-4F41-85CB-039E002D290E}"/>
+                <a16:creationId xmlns:a16="http://schemas.microsoft.com/office/drawing/2014/main" id="{11E5B11C-D270-43C9-A3A8-9E369C0B482A}"/>
               </a:ext>
             </a:extLst>
           </p:cNvPr>
@@ -20451,7 +23523,7 @@
     </p:spTree>
     <p:extLst>
       <p:ext uri="{BB962C8B-B14F-4D97-AF65-F5344CB8AC3E}">
-        <p14:creationId xmlns:p14="http://schemas.microsoft.com/office/powerpoint/2010/main" val="334257445"/>
+        <p14:creationId xmlns:p14="http://schemas.microsoft.com/office/powerpoint/2010/main" val="1106653228"/>
       </p:ext>
     </p:extLst>
   </p:cSld>
@@ -20482,7 +23554,7 @@
           <p:cNvPr id="6" name="">
             <a:extLst xmlns:a="http://schemas.openxmlformats.org/drawingml/2006/main">
               <a:ext uri="{FF2B5EF4-FFF2-40B4-BE49-F238E27FC236}">
-                <a16:creationId xmlns:a16="http://schemas.microsoft.com/office/drawing/2014/main" id="{067786CE-D6CB-4131-AAB5-561DEE6300C2}"/>
+                <a16:creationId xmlns:a16="http://schemas.microsoft.com/office/drawing/2014/main" id="{0E43B6DE-A381-48F7-96C0-6E96520494E3}"/>
               </a:ext>
             </a:extLst>
           </p:cNvPr>
@@ -20638,7 +23710,7 @@
           <p:cNvPr id="2" name="">
             <a:extLst xmlns:a="http://schemas.openxmlformats.org/drawingml/2006/main">
               <a:ext uri="{FF2B5EF4-FFF2-40B4-BE49-F238E27FC236}">
-                <a16:creationId xmlns:a16="http://schemas.microsoft.com/office/drawing/2014/main" id="{0A3BDB72-248A-4A2B-A95C-7135AEC78F63}"/>
+                <a16:creationId xmlns:a16="http://schemas.microsoft.com/office/drawing/2014/main" id="{5CEDB0C9-9D68-4B6C-9328-094F116044DE}"/>
               </a:ext>
             </a:extLst>
           </p:cNvPr>
@@ -20794,7 +23866,7 @@
           <p:cNvPr id="3" name="">
             <a:extLst xmlns:a="http://schemas.openxmlformats.org/drawingml/2006/main">
               <a:ext uri="{FF2B5EF4-FFF2-40B4-BE49-F238E27FC236}">
-                <a16:creationId xmlns:a16="http://schemas.microsoft.com/office/drawing/2014/main" id="{E23D9DC7-9BE8-477F-9F68-8E0EE9709596}"/>
+                <a16:creationId xmlns:a16="http://schemas.microsoft.com/office/drawing/2014/main" id="{E4D497F4-21BD-412C-8DAB-4B5C94BEC005}"/>
               </a:ext>
             </a:extLst>
           </p:cNvPr>
@@ -20950,7 +24022,7 @@
           <p:cNvPr id="4" name="">
             <a:extLst xmlns:a="http://schemas.openxmlformats.org/drawingml/2006/main">
               <a:ext uri="{FF2B5EF4-FFF2-40B4-BE49-F238E27FC236}">
-                <a16:creationId xmlns:a16="http://schemas.microsoft.com/office/drawing/2014/main" id="{5CC10B68-3A30-4308-95A9-956189EC9DE0}"/>
+                <a16:creationId xmlns:a16="http://schemas.microsoft.com/office/drawing/2014/main" id="{69056706-DD7F-4F30-BF50-96D513B27564}"/>
               </a:ext>
             </a:extLst>
           </p:cNvPr>
@@ -21629,7 +24701,7 @@
           <p:cNvPr id="5" name="">
             <a:extLst xmlns:a="http://schemas.openxmlformats.org/drawingml/2006/main">
               <a:ext uri="{FF2B5EF4-FFF2-40B4-BE49-F238E27FC236}">
-                <a16:creationId xmlns:a16="http://schemas.microsoft.com/office/drawing/2014/main" id="{3C070566-3A79-4684-AEFB-A43D8B966106}"/>
+                <a16:creationId xmlns:a16="http://schemas.microsoft.com/office/drawing/2014/main" id="{51389EA8-0320-40C6-A578-9723A400996E}"/>
               </a:ext>
             </a:extLst>
           </p:cNvPr>
@@ -21783,7 +24855,7 @@
     </p:spTree>
     <p:extLst>
       <p:ext uri="{BB962C8B-B14F-4D97-AF65-F5344CB8AC3E}">
-        <p14:creationId xmlns:p14="http://schemas.microsoft.com/office/powerpoint/2010/main" val="444868152"/>
+        <p14:creationId xmlns:p14="http://schemas.microsoft.com/office/powerpoint/2010/main" val="660001587"/>
       </p:ext>
     </p:extLst>
   </p:cSld>
@@ -21814,7 +24886,7 @@
           <p:cNvPr id="7" name="">
             <a:extLst xmlns:a="http://schemas.openxmlformats.org/drawingml/2006/main">
               <a:ext uri="{FF2B5EF4-FFF2-40B4-BE49-F238E27FC236}">
-                <a16:creationId xmlns:a16="http://schemas.microsoft.com/office/drawing/2014/main" id="{24BE6C5A-395E-497D-87FD-61E7E4E34EF5}"/>
+                <a16:creationId xmlns:a16="http://schemas.microsoft.com/office/drawing/2014/main" id="{B4848AEF-D02B-4A11-9923-F144C1F44163}"/>
               </a:ext>
             </a:extLst>
           </p:cNvPr>
@@ -21970,7 +25042,7 @@
           <p:cNvPr id="2" name="">
             <a:extLst xmlns:a="http://schemas.openxmlformats.org/drawingml/2006/main">
               <a:ext uri="{FF2B5EF4-FFF2-40B4-BE49-F238E27FC236}">
-                <a16:creationId xmlns:a16="http://schemas.microsoft.com/office/drawing/2014/main" id="{BA2236A4-144D-4F51-AC7A-773843CEA985}"/>
+                <a16:creationId xmlns:a16="http://schemas.microsoft.com/office/drawing/2014/main" id="{9049E558-FF4A-40EF-BEE0-0E5EF41EACE4}"/>
               </a:ext>
             </a:extLst>
           </p:cNvPr>
@@ -22126,7 +25198,7 @@
           <p:cNvPr id="3" name="">
             <a:extLst xmlns:a="http://schemas.openxmlformats.org/drawingml/2006/main">
               <a:ext uri="{FF2B5EF4-FFF2-40B4-BE49-F238E27FC236}">
-                <a16:creationId xmlns:a16="http://schemas.microsoft.com/office/drawing/2014/main" id="{4AE52639-AB8B-423E-8F26-3316423D65FD}"/>
+                <a16:creationId xmlns:a16="http://schemas.microsoft.com/office/drawing/2014/main" id="{74872943-8511-47E5-BCC9-C5A35B1770C0}"/>
               </a:ext>
             </a:extLst>
           </p:cNvPr>
@@ -22282,7 +25354,7 @@
           <p:cNvPr id="4" name="">
             <a:extLst xmlns:a="http://schemas.openxmlformats.org/drawingml/2006/main">
               <a:ext uri="{FF2B5EF4-FFF2-40B4-BE49-F238E27FC236}">
-                <a16:creationId xmlns:a16="http://schemas.microsoft.com/office/drawing/2014/main" id="{224942F6-AE98-4C26-A187-7AC2F2542F46}"/>
+                <a16:creationId xmlns:a16="http://schemas.microsoft.com/office/drawing/2014/main" id="{9E4AF18E-16B0-44C6-948D-CDADA41C11EE}"/>
               </a:ext>
             </a:extLst>
           </p:cNvPr>
@@ -22438,7 +25510,7 @@
           <p:cNvPr id="5" name="">
             <a:extLst xmlns:a="http://schemas.openxmlformats.org/drawingml/2006/main">
               <a:ext uri="{FF2B5EF4-FFF2-40B4-BE49-F238E27FC236}">
-                <a16:creationId xmlns:a16="http://schemas.microsoft.com/office/drawing/2014/main" id="{B7A89358-CD16-4B77-A988-86F96376997D}"/>
+                <a16:creationId xmlns:a16="http://schemas.microsoft.com/office/drawing/2014/main" id="{FB1D1005-268A-45A8-9B50-270922C67DD0}"/>
               </a:ext>
             </a:extLst>
           </p:cNvPr>
@@ -23181,7 +26253,7 @@
           <p:cNvPr id="6" name="">
             <a:extLst xmlns:a="http://schemas.openxmlformats.org/drawingml/2006/main">
               <a:ext uri="{FF2B5EF4-FFF2-40B4-BE49-F238E27FC236}">
-                <a16:creationId xmlns:a16="http://schemas.microsoft.com/office/drawing/2014/main" id="{280680A0-3EBB-45B2-9D7F-62A8248A5DD2}"/>
+                <a16:creationId xmlns:a16="http://schemas.microsoft.com/office/drawing/2014/main" id="{A6DBCDCE-20B7-4001-9F5C-EDDC7D592EC3}"/>
               </a:ext>
             </a:extLst>
           </p:cNvPr>
@@ -23335,7 +26407,7 @@
     </p:spTree>
     <p:extLst>
       <p:ext uri="{BB962C8B-B14F-4D97-AF65-F5344CB8AC3E}">
-        <p14:creationId xmlns:p14="http://schemas.microsoft.com/office/powerpoint/2010/main" val="1863969228"/>
+        <p14:creationId xmlns:p14="http://schemas.microsoft.com/office/powerpoint/2010/main" val="95713222"/>
       </p:ext>
     </p:extLst>
   </p:cSld>
@@ -23366,7 +26438,7 @@
           <p:cNvPr id="7" name="">
             <a:extLst xmlns:a="http://schemas.openxmlformats.org/drawingml/2006/main">
               <a:ext uri="{FF2B5EF4-FFF2-40B4-BE49-F238E27FC236}">
-                <a16:creationId xmlns:a16="http://schemas.microsoft.com/office/drawing/2014/main" id="{F603ACCC-473C-4584-A2F2-6F65758617D3}"/>
+                <a16:creationId xmlns:a16="http://schemas.microsoft.com/office/drawing/2014/main" id="{D0B2F86F-F45D-46A6-8E3E-D1CB2D19DDA1}"/>
               </a:ext>
             </a:extLst>
           </p:cNvPr>
@@ -23522,7 +26594,7 @@
           <p:cNvPr id="2" name="">
             <a:extLst xmlns:a="http://schemas.openxmlformats.org/drawingml/2006/main">
               <a:ext uri="{FF2B5EF4-FFF2-40B4-BE49-F238E27FC236}">
-                <a16:creationId xmlns:a16="http://schemas.microsoft.com/office/drawing/2014/main" id="{ED1859C6-6747-42DD-9D1B-D942CCB73C11}"/>
+                <a16:creationId xmlns:a16="http://schemas.microsoft.com/office/drawing/2014/main" id="{C3AF9841-EC49-40A1-B199-1D044D3B0780}"/>
               </a:ext>
             </a:extLst>
           </p:cNvPr>
@@ -23678,7 +26750,7 @@
           <p:cNvPr id="3" name="">
             <a:extLst xmlns:a="http://schemas.openxmlformats.org/drawingml/2006/main">
               <a:ext uri="{FF2B5EF4-FFF2-40B4-BE49-F238E27FC236}">
-                <a16:creationId xmlns:a16="http://schemas.microsoft.com/office/drawing/2014/main" id="{C8D2B879-D404-4B5E-A783-B4EBF4A4E7FC}"/>
+                <a16:creationId xmlns:a16="http://schemas.microsoft.com/office/drawing/2014/main" id="{1B05309D-7A3B-4091-8547-21DAB31C9FDC}"/>
               </a:ext>
             </a:extLst>
           </p:cNvPr>
@@ -23834,7 +26906,7 @@
           <p:cNvPr id="4" name="">
             <a:extLst xmlns:a="http://schemas.openxmlformats.org/drawingml/2006/main">
               <a:ext uri="{FF2B5EF4-FFF2-40B4-BE49-F238E27FC236}">
-                <a16:creationId xmlns:a16="http://schemas.microsoft.com/office/drawing/2014/main" id="{04C8DFEC-D4B0-4710-BF36-513B87FACACC}"/>
+                <a16:creationId xmlns:a16="http://schemas.microsoft.com/office/drawing/2014/main" id="{F692805C-796E-47ED-A5F2-76C084551495}"/>
               </a:ext>
             </a:extLst>
           </p:cNvPr>
@@ -23990,7 +27062,7 @@
           <p:cNvPr id="5" name="">
             <a:extLst xmlns:a="http://schemas.openxmlformats.org/drawingml/2006/main">
               <a:ext uri="{FF2B5EF4-FFF2-40B4-BE49-F238E27FC236}">
-                <a16:creationId xmlns:a16="http://schemas.microsoft.com/office/drawing/2014/main" id="{7CFF20C9-DBDC-4769-89DC-62D9EEA5C17C}"/>
+                <a16:creationId xmlns:a16="http://schemas.microsoft.com/office/drawing/2014/main" id="{86E34773-F9E7-45DC-A972-F50E06D165EB}"/>
               </a:ext>
             </a:extLst>
           </p:cNvPr>
@@ -24849,7 +27921,7 @@
           <p:cNvPr id="6" name="">
             <a:extLst xmlns:a="http://schemas.openxmlformats.org/drawingml/2006/main">
               <a:ext uri="{FF2B5EF4-FFF2-40B4-BE49-F238E27FC236}">
-                <a16:creationId xmlns:a16="http://schemas.microsoft.com/office/drawing/2014/main" id="{743D8DB6-DE2B-437E-9B11-B54C5D02F738}"/>
+                <a16:creationId xmlns:a16="http://schemas.microsoft.com/office/drawing/2014/main" id="{F1AC5F69-CB31-4F55-A527-A5F32DAEFA7B}"/>
               </a:ext>
             </a:extLst>
           </p:cNvPr>
@@ -25003,7 +28075,7 @@
     </p:spTree>
     <p:extLst>
       <p:ext uri="{BB962C8B-B14F-4D97-AF65-F5344CB8AC3E}">
-        <p14:creationId xmlns:p14="http://schemas.microsoft.com/office/powerpoint/2010/main" val="1392333134"/>
+        <p14:creationId xmlns:p14="http://schemas.microsoft.com/office/powerpoint/2010/main" val="43359552"/>
       </p:ext>
     </p:extLst>
   </p:cSld>
@@ -25034,7 +28106,7 @@
           <p:cNvPr id="10" name="">
             <a:extLst xmlns:a="http://schemas.openxmlformats.org/drawingml/2006/main">
               <a:ext uri="{FF2B5EF4-FFF2-40B4-BE49-F238E27FC236}">
-                <a16:creationId xmlns:a16="http://schemas.microsoft.com/office/drawing/2014/main" id="{523CE05F-FC1A-4958-A9D5-204EE84CEEF4}"/>
+                <a16:creationId xmlns:a16="http://schemas.microsoft.com/office/drawing/2014/main" id="{C98CAA57-F200-47FF-926C-2B9F25DEAE10}"/>
               </a:ext>
             </a:extLst>
           </p:cNvPr>
@@ -25190,7 +28262,7 @@
           <p:cNvPr id="2" name="">
             <a:extLst xmlns:a="http://schemas.openxmlformats.org/drawingml/2006/main">
               <a:ext uri="{FF2B5EF4-FFF2-40B4-BE49-F238E27FC236}">
-                <a16:creationId xmlns:a16="http://schemas.microsoft.com/office/drawing/2014/main" id="{323CECB3-8FC1-42B1-9855-6E49E253B10B}"/>
+                <a16:creationId xmlns:a16="http://schemas.microsoft.com/office/drawing/2014/main" id="{F03B62F8-18AD-40DF-AECB-2B4BD2B0CB59}"/>
               </a:ext>
             </a:extLst>
           </p:cNvPr>
@@ -25346,7 +28418,7 @@
           <p:cNvPr id="3" name="">
             <a:extLst xmlns:a="http://schemas.openxmlformats.org/drawingml/2006/main">
               <a:ext uri="{FF2B5EF4-FFF2-40B4-BE49-F238E27FC236}">
-                <a16:creationId xmlns:a16="http://schemas.microsoft.com/office/drawing/2014/main" id="{59D5B38E-6969-40C4-8C9F-C6474653E7FD}"/>
+                <a16:creationId xmlns:a16="http://schemas.microsoft.com/office/drawing/2014/main" id="{B0F41A1C-C352-486B-9E89-3ECF08A8B0E4}"/>
               </a:ext>
             </a:extLst>
           </p:cNvPr>
@@ -25502,7 +28574,7 @@
           <p:cNvPr id="4" name="">
             <a:extLst xmlns:a="http://schemas.openxmlformats.org/drawingml/2006/main">
               <a:ext uri="{FF2B5EF4-FFF2-40B4-BE49-F238E27FC236}">
-                <a16:creationId xmlns:a16="http://schemas.microsoft.com/office/drawing/2014/main" id="{77441082-7285-49DB-BD90-9B2E4D3E6364}"/>
+                <a16:creationId xmlns:a16="http://schemas.microsoft.com/office/drawing/2014/main" id="{29135182-4A7C-4F44-84AE-AF16207AE575}"/>
               </a:ext>
             </a:extLst>
           </p:cNvPr>
@@ -25658,7 +28730,7 @@
           <p:cNvPr id="5" name="">
             <a:extLst xmlns:a="http://schemas.openxmlformats.org/drawingml/2006/main">
               <a:ext uri="{FF2B5EF4-FFF2-40B4-BE49-F238E27FC236}">
-                <a16:creationId xmlns:a16="http://schemas.microsoft.com/office/drawing/2014/main" id="{9B758C8E-300A-464B-88F0-0DA987BBFAF3}"/>
+                <a16:creationId xmlns:a16="http://schemas.microsoft.com/office/drawing/2014/main" id="{180ACE25-8C1A-4590-A4CD-00674B122108}"/>
               </a:ext>
             </a:extLst>
           </p:cNvPr>
@@ -26053,7 +29125,7 @@
           <p:cNvPr id="6" name="">
             <a:extLst xmlns:a="http://schemas.openxmlformats.org/drawingml/2006/main">
               <a:ext uri="{FF2B5EF4-FFF2-40B4-BE49-F238E27FC236}">
-                <a16:creationId xmlns:a16="http://schemas.microsoft.com/office/drawing/2014/main" id="{967A8F31-EC1D-4329-9FEC-076B2836096C}"/>
+                <a16:creationId xmlns:a16="http://schemas.microsoft.com/office/drawing/2014/main" id="{018A0D14-673F-4931-A93D-D35623354A09}"/>
               </a:ext>
             </a:extLst>
           </p:cNvPr>
@@ -26209,7 +29281,7 @@
           <p:cNvPr id="7" name="">
             <a:extLst xmlns:a="http://schemas.openxmlformats.org/drawingml/2006/main">
               <a:ext uri="{FF2B5EF4-FFF2-40B4-BE49-F238E27FC236}">
-                <a16:creationId xmlns:a16="http://schemas.microsoft.com/office/drawing/2014/main" id="{2CC997EE-E6CE-42B8-A87D-5615656D9DB0}"/>
+                <a16:creationId xmlns:a16="http://schemas.microsoft.com/office/drawing/2014/main" id="{CF107B37-640A-4FF0-A741-230238EFC4B8}"/>
               </a:ext>
             </a:extLst>
           </p:cNvPr>
@@ -26365,7 +29437,7 @@
           <p:cNvPr id="8" name="">
             <a:extLst xmlns:a="http://schemas.openxmlformats.org/drawingml/2006/main">
               <a:ext uri="{FF2B5EF4-FFF2-40B4-BE49-F238E27FC236}">
-                <a16:creationId xmlns:a16="http://schemas.microsoft.com/office/drawing/2014/main" id="{4283B2C2-8315-40DA-B541-D16F24546E8B}"/>
+                <a16:creationId xmlns:a16="http://schemas.microsoft.com/office/drawing/2014/main" id="{F74B7825-A634-4997-AB5A-B70B11CDCFFB}"/>
               </a:ext>
             </a:extLst>
           </p:cNvPr>
@@ -26521,7 +29593,7 @@
           <p:cNvPr id="9" name="">
             <a:extLst xmlns:a="http://schemas.openxmlformats.org/drawingml/2006/main">
               <a:ext uri="{FF2B5EF4-FFF2-40B4-BE49-F238E27FC236}">
-                <a16:creationId xmlns:a16="http://schemas.microsoft.com/office/drawing/2014/main" id="{AB31B526-EAA9-4616-BAFA-795CE0487240}"/>
+                <a16:creationId xmlns:a16="http://schemas.microsoft.com/office/drawing/2014/main" id="{01A891D0-3D9C-41AD-B895-094A4D95D68B}"/>
               </a:ext>
             </a:extLst>
           </p:cNvPr>
@@ -26675,7 +29747,7 @@
     </p:spTree>
     <p:extLst>
       <p:ext uri="{BB962C8B-B14F-4D97-AF65-F5344CB8AC3E}">
-        <p14:creationId xmlns:p14="http://schemas.microsoft.com/office/powerpoint/2010/main" val="82552690"/>
+        <p14:creationId xmlns:p14="http://schemas.microsoft.com/office/powerpoint/2010/main" val="680775775"/>
       </p:ext>
     </p:extLst>
   </p:cSld>
@@ -26706,7 +29778,7 @@
           <p:cNvPr id="6" name="">
             <a:extLst xmlns:a="http://schemas.openxmlformats.org/drawingml/2006/main">
               <a:ext uri="{FF2B5EF4-FFF2-40B4-BE49-F238E27FC236}">
-                <a16:creationId xmlns:a16="http://schemas.microsoft.com/office/drawing/2014/main" id="{82D9A800-8366-4CDB-A927-8C51A9FA4091}"/>
+                <a16:creationId xmlns:a16="http://schemas.microsoft.com/office/drawing/2014/main" id="{264B34F0-C061-4604-A2EE-74EC0F243E55}"/>
               </a:ext>
             </a:extLst>
           </p:cNvPr>
@@ -26862,7 +29934,7 @@
           <p:cNvPr id="2" name="">
             <a:extLst xmlns:a="http://schemas.openxmlformats.org/drawingml/2006/main">
               <a:ext uri="{FF2B5EF4-FFF2-40B4-BE49-F238E27FC236}">
-                <a16:creationId xmlns:a16="http://schemas.microsoft.com/office/drawing/2014/main" id="{5D789F29-E6EB-4AA6-B034-18398F641468}"/>
+                <a16:creationId xmlns:a16="http://schemas.microsoft.com/office/drawing/2014/main" id="{D9FB45D6-3413-412C-A9E7-776F1E4FDFD5}"/>
               </a:ext>
             </a:extLst>
           </p:cNvPr>
@@ -27018,7 +30090,7 @@
           <p:cNvPr id="3" name="">
             <a:extLst xmlns:a="http://schemas.openxmlformats.org/drawingml/2006/main">
               <a:ext uri="{FF2B5EF4-FFF2-40B4-BE49-F238E27FC236}">
-                <a16:creationId xmlns:a16="http://schemas.microsoft.com/office/drawing/2014/main" id="{DC0938D6-B322-4FFA-AD14-22AA33A4FAC4}"/>
+                <a16:creationId xmlns:a16="http://schemas.microsoft.com/office/drawing/2014/main" id="{FD75418F-09D6-44C2-BF2F-4007C8AB410F}"/>
               </a:ext>
             </a:extLst>
           </p:cNvPr>
@@ -27174,7 +30246,7 @@
           <p:cNvPr id="4" name="">
             <a:extLst xmlns:a="http://schemas.openxmlformats.org/drawingml/2006/main">
               <a:ext uri="{FF2B5EF4-FFF2-40B4-BE49-F238E27FC236}">
-                <a16:creationId xmlns:a16="http://schemas.microsoft.com/office/drawing/2014/main" id="{FC6136D8-61A3-4D8E-97BB-07AD9BD6357C}"/>
+                <a16:creationId xmlns:a16="http://schemas.microsoft.com/office/drawing/2014/main" id="{D8CAC7C0-2D02-4A33-9EEC-D17C518324D8}"/>
               </a:ext>
             </a:extLst>
           </p:cNvPr>
@@ -27930,7 +31002,7 @@
           <p:cNvPr id="5" name="">
             <a:extLst xmlns:a="http://schemas.openxmlformats.org/drawingml/2006/main">
               <a:ext uri="{FF2B5EF4-FFF2-40B4-BE49-F238E27FC236}">
-                <a16:creationId xmlns:a16="http://schemas.microsoft.com/office/drawing/2014/main" id="{C1FB3F01-C105-456A-A2A3-2CC6EBB747F7}"/>
+                <a16:creationId xmlns:a16="http://schemas.microsoft.com/office/drawing/2014/main" id="{A012BAFF-8FB5-4775-97A3-67B479637266}"/>
               </a:ext>
             </a:extLst>
           </p:cNvPr>
@@ -28084,7 +31156,7 @@
     </p:spTree>
     <p:extLst>
       <p:ext uri="{BB962C8B-B14F-4D97-AF65-F5344CB8AC3E}">
-        <p14:creationId xmlns:p14="http://schemas.microsoft.com/office/powerpoint/2010/main" val="1467752706"/>
+        <p14:creationId xmlns:p14="http://schemas.microsoft.com/office/powerpoint/2010/main" val="848746032"/>
       </p:ext>
     </p:extLst>
   </p:cSld>
@@ -28115,7 +31187,7 @@
           <p:cNvPr id="8" name="">
             <a:extLst xmlns:a="http://schemas.openxmlformats.org/drawingml/2006/main">
               <a:ext uri="{FF2B5EF4-FFF2-40B4-BE49-F238E27FC236}">
-                <a16:creationId xmlns:a16="http://schemas.microsoft.com/office/drawing/2014/main" id="{257D7855-EBE8-4402-B9AA-316E432B5510}"/>
+                <a16:creationId xmlns:a16="http://schemas.microsoft.com/office/drawing/2014/main" id="{015316F6-247B-4F7C-A6B0-2D365A1FCB95}"/>
               </a:ext>
             </a:extLst>
           </p:cNvPr>
@@ -28271,7 +31343,7 @@
           <p:cNvPr id="2" name="">
             <a:extLst xmlns:a="http://schemas.openxmlformats.org/drawingml/2006/main">
               <a:ext uri="{FF2B5EF4-FFF2-40B4-BE49-F238E27FC236}">
-                <a16:creationId xmlns:a16="http://schemas.microsoft.com/office/drawing/2014/main" id="{15CB4624-C523-4F9B-96EF-C9681AF07A37}"/>
+                <a16:creationId xmlns:a16="http://schemas.microsoft.com/office/drawing/2014/main" id="{4880C672-E9F9-45DA-8B6B-9531EA5D8039}"/>
               </a:ext>
             </a:extLst>
           </p:cNvPr>
@@ -28427,7 +31499,7 @@
           <p:cNvPr id="3" name="">
             <a:extLst xmlns:a="http://schemas.openxmlformats.org/drawingml/2006/main">
               <a:ext uri="{FF2B5EF4-FFF2-40B4-BE49-F238E27FC236}">
-                <a16:creationId xmlns:a16="http://schemas.microsoft.com/office/drawing/2014/main" id="{55A5F09E-7AAC-4AC3-9603-FB3A40A40D30}"/>
+                <a16:creationId xmlns:a16="http://schemas.microsoft.com/office/drawing/2014/main" id="{5C122B0D-32CF-4002-8A2A-E711D43623A8}"/>
               </a:ext>
             </a:extLst>
           </p:cNvPr>
@@ -28583,7 +31655,7 @@
           <p:cNvPr id="4" name="">
             <a:extLst xmlns:a="http://schemas.openxmlformats.org/drawingml/2006/main">
               <a:ext uri="{FF2B5EF4-FFF2-40B4-BE49-F238E27FC236}">
-                <a16:creationId xmlns:a16="http://schemas.microsoft.com/office/drawing/2014/main" id="{021F4242-891C-4624-896B-8E4EDCD32ADA}"/>
+                <a16:creationId xmlns:a16="http://schemas.microsoft.com/office/drawing/2014/main" id="{75854C8F-5585-4893-8C96-D7A700CAFD45}"/>
               </a:ext>
             </a:extLst>
           </p:cNvPr>
@@ -29245,7 +32317,7 @@
           <p:cNvPr id="5" name="">
             <a:extLst xmlns:a="http://schemas.openxmlformats.org/drawingml/2006/main">
               <a:ext uri="{FF2B5EF4-FFF2-40B4-BE49-F238E27FC236}">
-                <a16:creationId xmlns:a16="http://schemas.microsoft.com/office/drawing/2014/main" id="{B673DCF4-298D-48F6-A5E3-BE1AD8F4ADF4}"/>
+                <a16:creationId xmlns:a16="http://schemas.microsoft.com/office/drawing/2014/main" id="{8560E17C-7900-448B-81B4-2359C6BA3B4E}"/>
               </a:ext>
             </a:extLst>
           </p:cNvPr>
@@ -29401,7 +32473,7 @@
           <p:cNvPr id="6" name="">
             <a:extLst xmlns:a="http://schemas.openxmlformats.org/drawingml/2006/main">
               <a:ext uri="{FF2B5EF4-FFF2-40B4-BE49-F238E27FC236}">
-                <a16:creationId xmlns:a16="http://schemas.microsoft.com/office/drawing/2014/main" id="{6BEE77EF-5471-4521-8D15-65AAC6C72C29}"/>
+                <a16:creationId xmlns:a16="http://schemas.microsoft.com/office/drawing/2014/main" id="{7550B166-63B1-4E00-8155-6B171763DD21}"/>
               </a:ext>
             </a:extLst>
           </p:cNvPr>
@@ -29557,7 +32629,7 @@
           <p:cNvPr id="7" name="">
             <a:extLst xmlns:a="http://schemas.openxmlformats.org/drawingml/2006/main">
               <a:ext uri="{FF2B5EF4-FFF2-40B4-BE49-F238E27FC236}">
-                <a16:creationId xmlns:a16="http://schemas.microsoft.com/office/drawing/2014/main" id="{5870CAC5-4972-4B65-B70F-A10372ACD4C1}"/>
+                <a16:creationId xmlns:a16="http://schemas.microsoft.com/office/drawing/2014/main" id="{3F31370E-C1C3-4918-9DE0-05F11A3036AB}"/>
               </a:ext>
             </a:extLst>
           </p:cNvPr>
@@ -29711,7 +32783,7 @@
     </p:spTree>
     <p:extLst>
       <p:ext uri="{BB962C8B-B14F-4D97-AF65-F5344CB8AC3E}">
-        <p14:creationId xmlns:p14="http://schemas.microsoft.com/office/powerpoint/2010/main" val="1576582428"/>
+        <p14:creationId xmlns:p14="http://schemas.microsoft.com/office/powerpoint/2010/main" val="1923120848"/>
       </p:ext>
     </p:extLst>
   </p:cSld>

</xml_diff>